<commit_message>
improve ASGSR poster architecture and readability
</commit_message>
<xml_diff>
--- a/paper/asgsr_expimap_hvg/poster/asgsr_expimap_poster.pptx
+++ b/paper/asgsr_expimap_hvg/poster/asgsr_expimap_poster.pptx
@@ -3173,7 +3173,7 @@
               </a:spcAft>
             </a:pPr>
             <a:r>
-              <a:rPr sz="1500" b="0" i="0">
+              <a:rPr sz="1600" b="0" i="0">
                 <a:solidFill>
                   <a:srgbClr val="697889"/>
                 </a:solidFill>
@@ -3218,7 +3218,7 @@
               </a:spcAft>
             </a:pPr>
             <a:r>
-              <a:rPr sz="5000" b="1" i="0">
+              <a:rPr sz="5400" b="1" i="0">
                 <a:solidFill>
                   <a:srgbClr val="111111"/>
                 </a:solidFill>
@@ -3264,7 +3264,7 @@
               </a:spcAft>
             </a:pPr>
             <a:r>
-              <a:rPr sz="2400" b="1" i="0">
+              <a:rPr sz="2600" b="1" i="0">
                 <a:solidFill>
                   <a:srgbClr val="697889"/>
                 </a:solidFill>
@@ -3421,7 +3421,7 @@
               </a:spcAft>
             </a:pPr>
             <a:r>
-              <a:rPr sz="2200" b="1" i="0">
+              <a:rPr sz="2600" b="1" i="0">
                 <a:solidFill>
                   <a:srgbClr val="111111"/>
                 </a:solidFill>
@@ -3441,7 +3441,7 @@
         <p:spPr>
           <a:xfrm>
             <a:off x="777240" y="5925312"/>
-            <a:ext cx="12938760" cy="2148840"/>
+            <a:ext cx="12938760" cy="2212848"/>
           </a:xfrm>
           <a:prstGeom prst="rect">
             <a:avLst/>
@@ -3466,13 +3466,13 @@
               </a:spcAft>
             </a:pPr>
             <a:r>
-              <a:rPr sz="1850" b="0" i="0">
+              <a:rPr sz="2000" b="0" i="0">
                 <a:solidFill>
                   <a:srgbClr val="33445D"/>
                 </a:solidFill>
                 <a:latin typeface="Arial"/>
               </a:rPr>
-              <a:t>Spaceflight affects multiple organs, but mission differences can obscure responses that recur across studies. We mapped NASA OSDR mouse bulk RNA-seq samples into tissue-matched expiMap references trained on ARCHS4 and constrained by current mouse Reactome programs. Project-balanced flight-ground shifts were checked with conventional enrichment, held-out projects, three complete trainings, composition proxies, and member-gene review. Thymus, skin, liver, and spleen produced reproducible tissue-specific patterns; spleen had the strongest multi-pathway evidence.</a:t>
+              <a:t>Spaceflight affects multiple organs, but differences among missions can obscure responses that recur across studies. We asked whether pathway-constrained expiMap models could identify reproducible programs in NASA OSDR mouse bulk RNA-seq. Samples were mapped into tissue-matched ARCHS4 references using approximately 2,000 highly variable genes linked to current mouse Reactome pathways. Project-balanced flight-ground shifts were evaluated with enrichment, held-out projects, three complete trainings, composition proxies, and member-gene review. Retained patterns included lower repair and cytoskeletal programs in thymus, lower maintenance and barrier programs in skin, lower adaptive-immune programs in liver, and coordinated lower adaptive and innate immune programs in spleen, the strongest multi-pathway result.</a:t>
             </a:r>
           </a:p>
         </p:txBody>
@@ -3599,7 +3599,7 @@
               </a:spcAft>
             </a:pPr>
             <a:r>
-              <a:rPr sz="2200" b="1" i="0">
+              <a:rPr sz="2600" b="1" i="0">
                 <a:solidFill>
                   <a:srgbClr val="111111"/>
                 </a:solidFill>
@@ -3644,7 +3644,7 @@
               </a:spcAft>
             </a:pPr>
             <a:r>
-              <a:rPr sz="1700" b="1" i="0">
+              <a:rPr sz="1900" b="1" i="0">
                 <a:solidFill>
                   <a:srgbClr val="9A6D1D"/>
                 </a:solidFill>
@@ -3689,13 +3689,13 @@
               </a:spcAft>
             </a:pPr>
             <a:r>
-              <a:rPr sz="2300" b="1" i="0">
+              <a:rPr sz="2600" b="1" i="0">
                 <a:solidFill>
                   <a:srgbClr val="071C3F"/>
                 </a:solidFill>
                 <a:latin typeface="Arial"/>
               </a:rPr>
-              <a:t>Learn how spaceflight changes living systems by asking which gene programs shift consistently across missions.</a:t>
+              <a:t>Identify gene programs that respond consistently to spaceflight across missions.</a:t>
             </a:r>
           </a:p>
         </p:txBody>
@@ -3734,7 +3734,7 @@
               </a:spcAft>
             </a:pPr>
             <a:r>
-              <a:rPr sz="1700" b="1" i="0">
+              <a:rPr sz="1900" b="1" i="0">
                 <a:solidFill>
                   <a:srgbClr val="9A6D1D"/>
                 </a:solidFill>
@@ -3779,7 +3779,7 @@
               </a:spcAft>
             </a:pPr>
             <a:r>
-              <a:rPr sz="1600" b="1" i="0">
+              <a:rPr sz="1800" b="1" i="0">
                 <a:solidFill>
                   <a:srgbClr val="071C3F"/>
                 </a:solidFill>
@@ -3867,7 +3867,7 @@
               </a:spcAft>
             </a:pPr>
             <a:r>
-              <a:rPr sz="1400" b="1" i="0">
+              <a:rPr sz="1550" b="1" i="0">
                 <a:solidFill>
                   <a:srgbClr val="FFFFFF"/>
                 </a:solidFill>
@@ -3912,7 +3912,7 @@
               </a:spcAft>
             </a:pPr>
             <a:r>
-              <a:rPr sz="2100" b="1" i="0">
+              <a:rPr sz="2200" b="1" i="0">
                 <a:solidFill>
                   <a:srgbClr val="697889"/>
                 </a:solidFill>
@@ -4000,7 +4000,7 @@
               </a:spcAft>
             </a:pPr>
             <a:r>
-              <a:rPr sz="1400" b="1" i="0">
+              <a:rPr sz="1550" b="1" i="0">
                 <a:solidFill>
                   <a:srgbClr val="FFFFFF"/>
                 </a:solidFill>
@@ -4045,7 +4045,7 @@
               </a:spcAft>
             </a:pPr>
             <a:r>
-              <a:rPr sz="2100" b="1" i="0">
+              <a:rPr sz="2200" b="1" i="0">
                 <a:solidFill>
                   <a:srgbClr val="697889"/>
                 </a:solidFill>
@@ -4133,7 +4133,7 @@
               </a:spcAft>
             </a:pPr>
             <a:r>
-              <a:rPr sz="1400" b="1" i="0">
+              <a:rPr sz="1550" b="1" i="0">
                 <a:solidFill>
                   <a:srgbClr val="FFFFFF"/>
                 </a:solidFill>
@@ -4178,7 +4178,7 @@
               </a:spcAft>
             </a:pPr>
             <a:r>
-              <a:rPr sz="2100" b="1" i="0">
+              <a:rPr sz="2200" b="1" i="0">
                 <a:solidFill>
                   <a:srgbClr val="697889"/>
                 </a:solidFill>
@@ -4266,7 +4266,7 @@
               </a:spcAft>
             </a:pPr>
             <a:r>
-              <a:rPr sz="1400" b="1" i="0">
+              <a:rPr sz="1550" b="1" i="0">
                 <a:solidFill>
                   <a:srgbClr val="FFFFFF"/>
                 </a:solidFill>
@@ -4311,7 +4311,7 @@
               </a:spcAft>
             </a:pPr>
             <a:r>
-              <a:rPr sz="1700" b="0" i="0">
+              <a:rPr sz="1900" b="0" i="0">
                 <a:solidFill>
                   <a:srgbClr val="33445D"/>
                 </a:solidFill>
@@ -4356,7 +4356,7 @@
               </a:spcAft>
             </a:pPr>
             <a:r>
-              <a:rPr sz="1700" b="1" i="0">
+              <a:rPr sz="1900" b="1" i="0">
                 <a:solidFill>
                   <a:srgbClr val="9A6D1D"/>
                 </a:solidFill>
@@ -4400,7 +4400,7 @@
                     <a:p>
                       <a:pPr algn="l"/>
                       <a:r>
-                        <a:rPr sz="1400" b="1">
+                        <a:rPr sz="1600" b="1">
                           <a:solidFill>
                             <a:srgbClr val="FFFFFF"/>
                           </a:solidFill>
@@ -4423,7 +4423,7 @@
                     <a:p>
                       <a:pPr algn="ctr"/>
                       <a:r>
-                        <a:rPr sz="1400" b="1">
+                        <a:rPr sz="1600" b="1">
                           <a:solidFill>
                             <a:srgbClr val="FFFFFF"/>
                           </a:solidFill>
@@ -4446,7 +4446,7 @@
                     <a:p>
                       <a:pPr algn="ctr"/>
                       <a:r>
-                        <a:rPr sz="1400" b="1">
+                        <a:rPr sz="1600" b="1">
                           <a:solidFill>
                             <a:srgbClr val="FFFFFF"/>
                           </a:solidFill>
@@ -4469,7 +4469,7 @@
                     <a:p>
                       <a:pPr algn="ctr"/>
                       <a:r>
-                        <a:rPr sz="1400" b="1">
+                        <a:rPr sz="1600" b="1">
                           <a:solidFill>
                             <a:srgbClr val="FFFFFF"/>
                           </a:solidFill>
@@ -4492,7 +4492,7 @@
                     <a:p>
                       <a:pPr algn="ctr"/>
                       <a:r>
-                        <a:rPr sz="1400" b="1">
+                        <a:rPr sz="1600" b="1">
                           <a:solidFill>
                             <a:srgbClr val="FFFFFF"/>
                           </a:solidFill>
@@ -4517,7 +4517,7 @@
                     <a:p>
                       <a:pPr algn="l"/>
                       <a:r>
-                        <a:rPr sz="1450" b="1">
+                        <a:rPr sz="1650" b="1">
                           <a:solidFill>
                             <a:srgbClr val="6A4C93"/>
                           </a:solidFill>
@@ -4540,7 +4540,7 @@
                     <a:p>
                       <a:pPr algn="ctr"/>
                       <a:r>
-                        <a:rPr sz="1450" b="0">
+                        <a:rPr sz="1650" b="0">
                           <a:solidFill>
                             <a:srgbClr val="33445D"/>
                           </a:solidFill>
@@ -4563,7 +4563,7 @@
                     <a:p>
                       <a:pPr algn="ctr"/>
                       <a:r>
-                        <a:rPr sz="1450" b="0">
+                        <a:rPr sz="1650" b="0">
                           <a:solidFill>
                             <a:srgbClr val="33445D"/>
                           </a:solidFill>
@@ -4586,7 +4586,7 @@
                     <a:p>
                       <a:pPr algn="ctr"/>
                       <a:r>
-                        <a:rPr sz="1450" b="0">
+                        <a:rPr sz="1650" b="0">
                           <a:solidFill>
                             <a:srgbClr val="33445D"/>
                           </a:solidFill>
@@ -4609,7 +4609,7 @@
                     <a:p>
                       <a:pPr algn="ctr"/>
                       <a:r>
-                        <a:rPr sz="1450" b="0">
+                        <a:rPr sz="1650" b="0">
                           <a:solidFill>
                             <a:srgbClr val="33445D"/>
                           </a:solidFill>
@@ -4634,7 +4634,7 @@
                     <a:p>
                       <a:pPr algn="l"/>
                       <a:r>
-                        <a:rPr sz="1450" b="1">
+                        <a:rPr sz="1650" b="1">
                           <a:solidFill>
                             <a:srgbClr val="C65D37"/>
                           </a:solidFill>
@@ -4657,7 +4657,7 @@
                     <a:p>
                       <a:pPr algn="ctr"/>
                       <a:r>
-                        <a:rPr sz="1450" b="0">
+                        <a:rPr sz="1650" b="0">
                           <a:solidFill>
                             <a:srgbClr val="33445D"/>
                           </a:solidFill>
@@ -4680,7 +4680,7 @@
                     <a:p>
                       <a:pPr algn="ctr"/>
                       <a:r>
-                        <a:rPr sz="1450" b="0">
+                        <a:rPr sz="1650" b="0">
                           <a:solidFill>
                             <a:srgbClr val="33445D"/>
                           </a:solidFill>
@@ -4703,7 +4703,7 @@
                     <a:p>
                       <a:pPr algn="ctr"/>
                       <a:r>
-                        <a:rPr sz="1450" b="0">
+                        <a:rPr sz="1650" b="0">
                           <a:solidFill>
                             <a:srgbClr val="33445D"/>
                           </a:solidFill>
@@ -4726,7 +4726,7 @@
                     <a:p>
                       <a:pPr algn="ctr"/>
                       <a:r>
-                        <a:rPr sz="1450" b="0">
+                        <a:rPr sz="1650" b="0">
                           <a:solidFill>
                             <a:srgbClr val="33445D"/>
                           </a:solidFill>
@@ -4751,7 +4751,7 @@
                     <a:p>
                       <a:pPr algn="l"/>
                       <a:r>
-                        <a:rPr sz="1450" b="1">
+                        <a:rPr sz="1650" b="1">
                           <a:solidFill>
                             <a:srgbClr val="13877C"/>
                           </a:solidFill>
@@ -4774,7 +4774,7 @@
                     <a:p>
                       <a:pPr algn="ctr"/>
                       <a:r>
-                        <a:rPr sz="1450" b="0">
+                        <a:rPr sz="1650" b="0">
                           <a:solidFill>
                             <a:srgbClr val="33445D"/>
                           </a:solidFill>
@@ -4797,7 +4797,7 @@
                     <a:p>
                       <a:pPr algn="ctr"/>
                       <a:r>
-                        <a:rPr sz="1450" b="0">
+                        <a:rPr sz="1650" b="0">
                           <a:solidFill>
                             <a:srgbClr val="33445D"/>
                           </a:solidFill>
@@ -4820,7 +4820,7 @@
                     <a:p>
                       <a:pPr algn="ctr"/>
                       <a:r>
-                        <a:rPr sz="1450" b="0">
+                        <a:rPr sz="1650" b="0">
                           <a:solidFill>
                             <a:srgbClr val="33445D"/>
                           </a:solidFill>
@@ -4843,7 +4843,7 @@
                     <a:p>
                       <a:pPr algn="ctr"/>
                       <a:r>
-                        <a:rPr sz="1450" b="0">
+                        <a:rPr sz="1650" b="0">
                           <a:solidFill>
                             <a:srgbClr val="33445D"/>
                           </a:solidFill>
@@ -4868,7 +4868,7 @@
                     <a:p>
                       <a:pPr algn="l"/>
                       <a:r>
-                        <a:rPr sz="1450" b="1">
+                        <a:rPr sz="1650" b="1">
                           <a:solidFill>
                             <a:srgbClr val="A64D67"/>
                           </a:solidFill>
@@ -4891,7 +4891,7 @@
                     <a:p>
                       <a:pPr algn="ctr"/>
                       <a:r>
-                        <a:rPr sz="1450" b="0">
+                        <a:rPr sz="1650" b="0">
                           <a:solidFill>
                             <a:srgbClr val="33445D"/>
                           </a:solidFill>
@@ -4914,7 +4914,7 @@
                     <a:p>
                       <a:pPr algn="ctr"/>
                       <a:r>
-                        <a:rPr sz="1450" b="0">
+                        <a:rPr sz="1650" b="0">
                           <a:solidFill>
                             <a:srgbClr val="33445D"/>
                           </a:solidFill>
@@ -4937,7 +4937,7 @@
                     <a:p>
                       <a:pPr algn="ctr"/>
                       <a:r>
-                        <a:rPr sz="1450" b="0">
+                        <a:rPr sz="1650" b="0">
                           <a:solidFill>
                             <a:srgbClr val="33445D"/>
                           </a:solidFill>
@@ -4960,7 +4960,7 @@
                     <a:p>
                       <a:pPr algn="ctr"/>
                       <a:r>
-                        <a:rPr sz="1450" b="0">
+                        <a:rPr sz="1650" b="0">
                           <a:solidFill>
                             <a:srgbClr val="33445D"/>
                           </a:solidFill>
@@ -5015,7 +5015,7 @@
               </a:spcAft>
             </a:pPr>
             <a:r>
-              <a:rPr sz="1350" b="0" i="1">
+              <a:rPr sz="1450" b="0" i="1">
                 <a:solidFill>
                   <a:srgbClr val="697889"/>
                 </a:solidFill>
@@ -5060,7 +5060,7 @@
               </a:spcAft>
             </a:pPr>
             <a:r>
-              <a:rPr sz="1700" b="1" i="0">
+              <a:rPr sz="1900" b="1" i="0">
                 <a:solidFill>
                   <a:srgbClr val="9A6D1D"/>
                 </a:solidFill>
@@ -5152,7 +5152,7 @@
               </a:spcAft>
             </a:pPr>
             <a:r>
-              <a:rPr sz="1500" b="1" i="0">
+              <a:rPr sz="1700" b="1" i="0">
                 <a:solidFill>
                   <a:srgbClr val="236DA2"/>
                 </a:solidFill>
@@ -5244,7 +5244,7 @@
               </a:spcAft>
             </a:pPr>
             <a:r>
-              <a:rPr sz="1500" b="1" i="0">
+              <a:rPr sz="1700" b="1" i="0">
                 <a:solidFill>
                   <a:srgbClr val="236DA2"/>
                 </a:solidFill>
@@ -5336,7 +5336,7 @@
               </a:spcAft>
             </a:pPr>
             <a:r>
-              <a:rPr sz="1500" b="1" i="0">
+              <a:rPr sz="1700" b="1" i="0">
                 <a:solidFill>
                   <a:srgbClr val="6A4C93"/>
                 </a:solidFill>
@@ -5428,7 +5428,7 @@
               </a:spcAft>
             </a:pPr>
             <a:r>
-              <a:rPr sz="1500" b="1" i="0">
+              <a:rPr sz="1700" b="1" i="0">
                 <a:solidFill>
                   <a:srgbClr val="178C6A"/>
                 </a:solidFill>
@@ -5520,7 +5520,7 @@
               </a:spcAft>
             </a:pPr>
             <a:r>
-              <a:rPr sz="1500" b="1" i="0">
+              <a:rPr sz="1700" b="1" i="0">
                 <a:solidFill>
                   <a:srgbClr val="178C6A"/>
                 </a:solidFill>
@@ -5612,7 +5612,7 @@
               </a:spcAft>
             </a:pPr>
             <a:r>
-              <a:rPr sz="1500" b="1" i="0">
+              <a:rPr sz="1700" b="1" i="0">
                 <a:solidFill>
                   <a:srgbClr val="178C6A"/>
                 </a:solidFill>
@@ -5657,7 +5657,7 @@
               </a:spcAft>
             </a:pPr>
             <a:r>
-              <a:rPr sz="1550" b="0" i="0">
+              <a:rPr sz="1650" b="0" i="0">
                 <a:solidFill>
                   <a:srgbClr val="33445D"/>
                 </a:solidFill>
@@ -5790,7 +5790,7 @@
               </a:spcAft>
             </a:pPr>
             <a:r>
-              <a:rPr sz="2200" b="1" i="0">
+              <a:rPr sz="2600" b="1" i="0">
                 <a:solidFill>
                   <a:srgbClr val="111111"/>
                 </a:solidFill>
@@ -5810,7 +5810,7 @@
         <p:spPr>
           <a:xfrm>
             <a:off x="14859000" y="5870448"/>
-            <a:ext cx="13670280" cy="402336"/>
+            <a:ext cx="13670280" cy="457200"/>
           </a:xfrm>
           <a:prstGeom prst="rect">
             <a:avLst/>
@@ -5835,7 +5835,7 @@
               </a:spcAft>
             </a:pPr>
             <a:r>
-              <a:rPr sz="1850" b="1" i="0">
+              <a:rPr sz="2200" b="1" i="0">
                 <a:solidFill>
                   <a:srgbClr val="071C3F"/>
                 </a:solidFill>
@@ -5854,8 +5854,8 @@
         </p:nvSpPr>
         <p:spPr>
           <a:xfrm>
-            <a:off x="15179040" y="6300216"/>
-            <a:ext cx="13030200" cy="411480"/>
+            <a:off x="15179040" y="6345936"/>
+            <a:ext cx="13030200" cy="420624"/>
           </a:xfrm>
           <a:prstGeom prst="rect">
             <a:avLst/>
@@ -5880,7 +5880,7 @@
               </a:spcAft>
             </a:pPr>
             <a:r>
-              <a:rPr sz="1450" b="0" i="0">
+              <a:rPr sz="1600" b="0" i="0">
                 <a:solidFill>
                   <a:srgbClr val="697889"/>
                 </a:solidFill>
@@ -5893,14 +5893,59 @@
       </p:sp>
       <p:sp>
         <p:nvSpPr>
-          <p:cNvPr id="52" name="Rounded Rectangle 51"/>
+          <p:cNvPr id="52" name="TextBox 51"/>
+          <p:cNvSpPr txBox="1"/>
+          <p:nvPr/>
+        </p:nvSpPr>
+        <p:spPr>
+          <a:xfrm>
+            <a:off x="14996159" y="6812280"/>
+            <a:ext cx="3657600" cy="320040"/>
+          </a:xfrm>
+          <a:prstGeom prst="rect">
+            <a:avLst/>
+          </a:prstGeom>
+          <a:noFill/>
+        </p:spPr>
+        <p:txBody>
+          <a:bodyPr wrap="square" lIns="0" rIns="0" tIns="0" bIns="0" anchor="t">
+            <a:spAutoFit/>
+          </a:bodyPr>
+          <a:lstStyle/>
+          <a:p>
+            <a:pPr algn="l">
+              <a:lnSpc>
+                <a:spcPct val="100000"/>
+              </a:lnSpc>
+              <a:spcBef>
+                <a:spcPts val="0"/>
+              </a:spcBef>
+              <a:spcAft>
+                <a:spcPts val="0"/>
+              </a:spcAft>
+            </a:pPr>
+            <a:r>
+              <a:rPr sz="1700" b="1" i="0">
+                <a:solidFill>
+                  <a:srgbClr val="236DA2"/>
+                </a:solidFill>
+                <a:latin typeface="Arial"/>
+              </a:rPr>
+              <a:t>1  REFERENCE TRAINING</a:t>
+            </a:r>
+          </a:p>
+        </p:txBody>
+      </p:sp>
+      <p:sp>
+        <p:nvSpPr>
+          <p:cNvPr id="53" name="Rounded Rectangle 52"/>
           <p:cNvSpPr/>
           <p:nvPr/>
         </p:nvSpPr>
         <p:spPr>
           <a:xfrm>
-            <a:off x="15087600" y="6803136"/>
-            <a:ext cx="3977639" cy="822960"/>
+            <a:off x="14996159" y="7196328"/>
+            <a:ext cx="3246120" cy="1005840"/>
           </a:xfrm>
           <a:prstGeom prst="roundRect">
             <a:avLst>
@@ -5940,7 +5985,7 @@
               </a:spcAft>
             </a:pPr>
             <a:r>
-              <a:rPr sz="1600" b="1">
+              <a:rPr sz="1800" b="1">
                 <a:solidFill>
                   <a:srgbClr val="071C3F"/>
                 </a:solidFill>
@@ -5959,7 +6004,7 @@
               </a:spcAft>
             </a:pPr>
             <a:r>
-              <a:rPr sz="1250">
+              <a:rPr sz="1400">
                 <a:solidFill>
                   <a:srgbClr val="697889"/>
                 </a:solidFill>
@@ -5972,174 +6017,16 @@
       </p:sp>
       <p:sp>
         <p:nvSpPr>
-          <p:cNvPr id="53" name="Rounded Rectangle 52"/>
+          <p:cNvPr id="54" name="Right Arrow 53"/>
           <p:cNvSpPr/>
           <p:nvPr/>
         </p:nvSpPr>
         <p:spPr>
           <a:xfrm>
-            <a:off x="19568160" y="6803136"/>
-            <a:ext cx="3977639" cy="822960"/>
-          </a:xfrm>
-          <a:prstGeom prst="roundRect">
-            <a:avLst>
-              <a:gd name="adj" fmla="val 6000"/>
-            </a:avLst>
-          </a:prstGeom>
-          <a:solidFill>
-            <a:srgbClr val="E9F4EE"/>
-          </a:solidFill>
-          <a:ln w="17780">
-            <a:solidFill>
-              <a:srgbClr val="178C6A"/>
-            </a:solidFill>
-          </a:ln>
-        </p:spPr>
-        <p:style>
-          <a:lnRef idx="1">
-            <a:schemeClr val="accent1"/>
-          </a:lnRef>
-          <a:fillRef idx="3">
-            <a:schemeClr val="accent1"/>
-          </a:fillRef>
-          <a:effectRef idx="2">
-            <a:schemeClr val="accent1"/>
-          </a:effectRef>
-          <a:fontRef idx="minor">
-            <a:schemeClr val="lt1"/>
-          </a:fontRef>
-        </p:style>
-        <p:txBody>
-          <a:bodyPr rtlCol="0" anchor="ctr" wrap="square" bIns="36576"/>
-          <a:lstStyle/>
-          <a:p>
-            <a:pPr algn="ctr">
-              <a:spcAft>
-                <a:spcPts val="200"/>
-              </a:spcAft>
-            </a:pPr>
-            <a:r>
-              <a:rPr sz="1600" b="1">
-                <a:solidFill>
-                  <a:srgbClr val="071C3F"/>
-                </a:solidFill>
-                <a:latin typeface="Arial"/>
-              </a:rPr>
-              <a:t>Reactome mask</a:t>
-            </a:r>
-          </a:p>
-          <a:p>
-            <a:pPr algn="ctr">
-              <a:spcBef>
-                <a:spcPts val="0"/>
-              </a:spcBef>
-              <a:spcAft>
-                <a:spcPts val="0"/>
-              </a:spcAft>
-            </a:pPr>
-            <a:r>
-              <a:rPr sz="1250">
-                <a:solidFill>
-                  <a:srgbClr val="697889"/>
-                </a:solidFill>
-                <a:latin typeface="Arial"/>
-              </a:rPr>
-              <a:t>mouse gene-to-program memberships</a:t>
-            </a:r>
-          </a:p>
-        </p:txBody>
-      </p:sp>
-      <p:sp>
-        <p:nvSpPr>
-          <p:cNvPr id="54" name="Rounded Rectangle 53"/>
-          <p:cNvSpPr/>
-          <p:nvPr/>
-        </p:nvSpPr>
-        <p:spPr>
-          <a:xfrm>
-            <a:off x="24048720" y="6803136"/>
-            <a:ext cx="3977639" cy="822960"/>
-          </a:xfrm>
-          <a:prstGeom prst="roundRect">
-            <a:avLst>
-              <a:gd name="adj" fmla="val 6000"/>
-            </a:avLst>
-          </a:prstGeom>
-          <a:solidFill>
-            <a:srgbClr val="FAEFE7"/>
-          </a:solidFill>
-          <a:ln w="17780">
-            <a:solidFill>
-              <a:srgbClr val="D97800"/>
-            </a:solidFill>
-          </a:ln>
-        </p:spPr>
-        <p:style>
-          <a:lnRef idx="1">
-            <a:schemeClr val="accent1"/>
-          </a:lnRef>
-          <a:fillRef idx="3">
-            <a:schemeClr val="accent1"/>
-          </a:fillRef>
-          <a:effectRef idx="2">
-            <a:schemeClr val="accent1"/>
-          </a:effectRef>
-          <a:fontRef idx="minor">
-            <a:schemeClr val="lt1"/>
-          </a:fontRef>
-        </p:style>
-        <p:txBody>
-          <a:bodyPr rtlCol="0" anchor="ctr" wrap="square" bIns="36576"/>
-          <a:lstStyle/>
-          <a:p>
-            <a:pPr algn="ctr">
-              <a:spcAft>
-                <a:spcPts val="200"/>
-              </a:spcAft>
-            </a:pPr>
-            <a:r>
-              <a:rPr sz="1600" b="1">
-                <a:solidFill>
-                  <a:srgbClr val="071C3F"/>
-                </a:solidFill>
-                <a:latin typeface="Arial"/>
-              </a:rPr>
-              <a:t>NASA OSDR query</a:t>
-            </a:r>
-          </a:p>
-          <a:p>
-            <a:pPr algn="ctr">
-              <a:spcBef>
-                <a:spcPts val="0"/>
-              </a:spcBef>
-              <a:spcAft>
-                <a:spcPts val="0"/>
-              </a:spcAft>
-            </a:pPr>
-            <a:r>
-              <a:rPr sz="1250">
-                <a:solidFill>
-                  <a:srgbClr val="697889"/>
-                </a:solidFill>
-                <a:latin typeface="Arial"/>
-              </a:rPr>
-              <a:t>FLT and GC | accession conditioned</a:t>
-            </a:r>
-          </a:p>
-        </p:txBody>
-      </p:sp>
-      <p:sp>
-        <p:nvSpPr>
-          <p:cNvPr id="55" name="Down Arrow 54"/>
-          <p:cNvSpPr/>
-          <p:nvPr/>
-        </p:nvSpPr>
-        <p:spPr>
-          <a:xfrm>
-            <a:off x="16916400" y="7662671"/>
-            <a:ext cx="329184" cy="310896"/>
-          </a:xfrm>
-          <a:prstGeom prst="downArrow">
+            <a:off x="18406872" y="7507224"/>
+            <a:ext cx="502920" cy="329184"/>
+          </a:xfrm>
+          <a:prstGeom prst="rightArrow">
             <a:avLst/>
           </a:prstGeom>
           <a:solidFill>
@@ -6173,23 +6060,27 @@
       </p:sp>
       <p:sp>
         <p:nvSpPr>
-          <p:cNvPr id="56" name="Down Arrow 55"/>
+          <p:cNvPr id="55" name="Rounded Rectangle 54"/>
           <p:cNvSpPr/>
           <p:nvPr/>
         </p:nvSpPr>
         <p:spPr>
           <a:xfrm>
-            <a:off x="21396960" y="7662671"/>
-            <a:ext cx="329184" cy="310896"/>
-          </a:xfrm>
-          <a:prstGeom prst="downArrow">
-            <a:avLst/>
+            <a:off x="19019520" y="7040880"/>
+            <a:ext cx="9326880" cy="2423160"/>
+          </a:xfrm>
+          <a:prstGeom prst="roundRect">
+            <a:avLst>
+              <a:gd name="adj" fmla="val 4000"/>
+            </a:avLst>
           </a:prstGeom>
           <a:solidFill>
-            <a:srgbClr val="178C6A"/>
+            <a:srgbClr val="FFFFFF"/>
           </a:solidFill>
-          <a:ln>
-            <a:noFill/>
+          <a:ln w="15240">
+            <a:solidFill>
+              <a:srgbClr val="236DA2"/>
+            </a:solidFill>
           </a:ln>
         </p:spPr>
         <p:style>
@@ -6216,57 +6107,59 @@
       </p:sp>
       <p:sp>
         <p:nvSpPr>
-          <p:cNvPr id="57" name="Down Arrow 56"/>
+          <p:cNvPr id="56" name="TextBox 55"/>
+          <p:cNvSpPr txBox="1"/>
+          <p:nvPr/>
+        </p:nvSpPr>
+        <p:spPr>
+          <a:xfrm>
+            <a:off x="19266408" y="7168896"/>
+            <a:ext cx="4023360" cy="329184"/>
+          </a:xfrm>
+          <a:prstGeom prst="rect">
+            <a:avLst/>
+          </a:prstGeom>
+          <a:noFill/>
+        </p:spPr>
+        <p:txBody>
+          <a:bodyPr wrap="square" lIns="0" rIns="0" tIns="0" bIns="0" anchor="t">
+            <a:spAutoFit/>
+          </a:bodyPr>
+          <a:lstStyle/>
+          <a:p>
+            <a:pPr algn="l">
+              <a:lnSpc>
+                <a:spcPct val="100000"/>
+              </a:lnSpc>
+              <a:spcBef>
+                <a:spcPts val="0"/>
+              </a:spcBef>
+              <a:spcAft>
+                <a:spcPts val="0"/>
+              </a:spcAft>
+            </a:pPr>
+            <a:r>
+              <a:rPr sz="1750" b="1" i="0">
+                <a:solidFill>
+                  <a:srgbClr val="071C3F"/>
+                </a:solidFill>
+                <a:latin typeface="Arial"/>
+              </a:rPr>
+              <a:t>Tissue expiMap reference</a:t>
+            </a:r>
+          </a:p>
+        </p:txBody>
+      </p:sp>
+      <p:sp>
+        <p:nvSpPr>
+          <p:cNvPr id="57" name="Oval 56"/>
           <p:cNvSpPr/>
           <p:nvPr/>
         </p:nvSpPr>
         <p:spPr>
           <a:xfrm>
-            <a:off x="25877520" y="7662671"/>
-            <a:ext cx="329184" cy="310896"/>
-          </a:xfrm>
-          <a:prstGeom prst="downArrow">
-            <a:avLst/>
-          </a:prstGeom>
-          <a:solidFill>
-            <a:srgbClr val="D97800"/>
-          </a:solidFill>
-          <a:ln>
-            <a:noFill/>
-          </a:ln>
-        </p:spPr>
-        <p:style>
-          <a:lnRef idx="1">
-            <a:schemeClr val="accent1"/>
-          </a:lnRef>
-          <a:fillRef idx="3">
-            <a:schemeClr val="accent1"/>
-          </a:fillRef>
-          <a:effectRef idx="2">
-            <a:schemeClr val="accent1"/>
-          </a:effectRef>
-          <a:fontRef idx="minor">
-            <a:schemeClr val="lt1"/>
-          </a:fontRef>
-        </p:style>
-        <p:txBody>
-          <a:bodyPr rtlCol="0" anchor="ctr"/>
-          <a:lstStyle/>
-          <a:p>
-            <a:pPr algn="ctr"/>
-          </a:p>
-        </p:txBody>
-      </p:sp>
-      <p:sp>
-        <p:nvSpPr>
-          <p:cNvPr id="58" name="Oval 57"/>
-          <p:cNvSpPr/>
-          <p:nvPr/>
-        </p:nvSpPr>
-        <p:spPr>
-          <a:xfrm>
-            <a:off x="15636240" y="8183879"/>
-            <a:ext cx="256032" cy="256032"/>
+            <a:off x="19385280" y="7744967"/>
+            <a:ext cx="219456" cy="219456"/>
           </a:xfrm>
           <a:prstGeom prst="ellipse">
             <a:avLst/>
@@ -6302,14 +6195,14 @@
       </p:sp>
       <p:sp>
         <p:nvSpPr>
-          <p:cNvPr id="59" name="Oval 58"/>
+          <p:cNvPr id="58" name="Oval 57"/>
           <p:cNvSpPr/>
           <p:nvPr/>
         </p:nvSpPr>
         <p:spPr>
           <a:xfrm>
-            <a:off x="15636240" y="8686800"/>
-            <a:ext cx="256032" cy="256032"/>
+            <a:off x="19385280" y="8129015"/>
+            <a:ext cx="219456" cy="219456"/>
           </a:xfrm>
           <a:prstGeom prst="ellipse">
             <a:avLst/>
@@ -6345,14 +6238,14 @@
       </p:sp>
       <p:sp>
         <p:nvSpPr>
-          <p:cNvPr id="60" name="Oval 59"/>
+          <p:cNvPr id="59" name="Oval 58"/>
           <p:cNvSpPr/>
           <p:nvPr/>
         </p:nvSpPr>
         <p:spPr>
           <a:xfrm>
-            <a:off x="15636240" y="9189719"/>
-            <a:ext cx="256032" cy="256032"/>
+            <a:off x="19385280" y="8513063"/>
+            <a:ext cx="219456" cy="219456"/>
           </a:xfrm>
           <a:prstGeom prst="ellipse">
             <a:avLst/>
@@ -6388,14 +6281,14 @@
       </p:sp>
       <p:sp>
         <p:nvSpPr>
-          <p:cNvPr id="61" name="Oval 60"/>
+          <p:cNvPr id="60" name="Oval 59"/>
           <p:cNvSpPr/>
           <p:nvPr/>
         </p:nvSpPr>
         <p:spPr>
           <a:xfrm>
-            <a:off x="15636240" y="9692640"/>
-            <a:ext cx="256032" cy="256032"/>
+            <a:off x="19385280" y="8897111"/>
+            <a:ext cx="219456" cy="219456"/>
           </a:xfrm>
           <a:prstGeom prst="ellipse">
             <a:avLst/>
@@ -6431,57 +6324,14 @@
       </p:sp>
       <p:sp>
         <p:nvSpPr>
-          <p:cNvPr id="62" name="Oval 61"/>
+          <p:cNvPr id="61" name="Trapezoid 60"/>
           <p:cNvSpPr/>
           <p:nvPr/>
         </p:nvSpPr>
         <p:spPr>
           <a:xfrm>
-            <a:off x="15636240" y="10195559"/>
-            <a:ext cx="256032" cy="256032"/>
-          </a:xfrm>
-          <a:prstGeom prst="ellipse">
-            <a:avLst/>
-          </a:prstGeom>
-          <a:solidFill>
-            <a:srgbClr val="A9BBD0"/>
-          </a:solidFill>
-          <a:ln>
-            <a:noFill/>
-          </a:ln>
-        </p:spPr>
-        <p:style>
-          <a:lnRef idx="1">
-            <a:schemeClr val="accent1"/>
-          </a:lnRef>
-          <a:fillRef idx="3">
-            <a:schemeClr val="accent1"/>
-          </a:fillRef>
-          <a:effectRef idx="2">
-            <a:schemeClr val="accent1"/>
-          </a:effectRef>
-          <a:fontRef idx="minor">
-            <a:schemeClr val="lt1"/>
-          </a:fontRef>
-        </p:style>
-        <p:txBody>
-          <a:bodyPr rtlCol="0" anchor="ctr"/>
-          <a:lstStyle/>
-          <a:p>
-            <a:pPr algn="ctr"/>
-          </a:p>
-        </p:txBody>
-      </p:sp>
-      <p:sp>
-        <p:nvSpPr>
-          <p:cNvPr id="63" name="Trapezoid 62"/>
-          <p:cNvSpPr/>
-          <p:nvPr/>
-        </p:nvSpPr>
-        <p:spPr>
-          <a:xfrm>
-            <a:off x="16870680" y="8019288"/>
-            <a:ext cx="1920240" cy="2606040"/>
+            <a:off x="20089368" y="7626096"/>
+            <a:ext cx="1371600" cy="1298448"/>
           </a:xfrm>
           <a:prstGeom prst="trapezoid">
             <a:avLst/>
@@ -6519,14 +6369,14 @@
       </p:sp>
       <p:sp>
         <p:nvSpPr>
-          <p:cNvPr id="64" name="TextBox 63"/>
+          <p:cNvPr id="62" name="TextBox 61"/>
           <p:cNvSpPr txBox="1"/>
           <p:nvPr/>
         </p:nvSpPr>
         <p:spPr>
           <a:xfrm>
-            <a:off x="17108424" y="8750808"/>
-            <a:ext cx="1417320" cy="841248"/>
+            <a:off x="20272248" y="7863840"/>
+            <a:ext cx="1005840" cy="731520"/>
           </a:xfrm>
           <a:prstGeom prst="rect">
             <a:avLst/>
@@ -6551,7 +6401,7 @@
               </a:spcAft>
             </a:pPr>
             <a:r>
-              <a:rPr sz="1550" b="1" i="0">
+              <a:rPr sz="1600" b="1" i="0">
                 <a:solidFill>
                   <a:srgbClr val="071C3F"/>
                 </a:solidFill>
@@ -6565,14 +6415,84 @@
       </p:sp>
       <p:cxnSp>
         <p:nvCxnSpPr>
+          <p:cNvPr id="63" name="Connector 62"/>
+          <p:cNvCxnSpPr/>
+          <p:nvPr/>
+        </p:nvCxnSpPr>
+        <p:spPr>
+          <a:xfrm>
+            <a:off x="19604735" y="7854695"/>
+            <a:ext cx="649225" cy="420625"/>
+          </a:xfrm>
+          <a:prstGeom prst="line">
+            <a:avLst/>
+          </a:prstGeom>
+          <a:ln w="10160">
+            <a:solidFill>
+              <a:srgbClr val="A9BBD0"/>
+            </a:solidFill>
+          </a:ln>
+        </p:spPr>
+        <p:style>
+          <a:lnRef idx="2">
+            <a:schemeClr val="accent1"/>
+          </a:lnRef>
+          <a:fillRef idx="0">
+            <a:schemeClr val="accent1"/>
+          </a:fillRef>
+          <a:effectRef idx="1">
+            <a:schemeClr val="accent1"/>
+          </a:effectRef>
+          <a:fontRef idx="minor">
+            <a:schemeClr val="tx1"/>
+          </a:fontRef>
+        </p:style>
+      </p:cxnSp>
+      <p:cxnSp>
+        <p:nvCxnSpPr>
+          <p:cNvPr id="64" name="Connector 63"/>
+          <p:cNvCxnSpPr/>
+          <p:nvPr/>
+        </p:nvCxnSpPr>
+        <p:spPr>
+          <a:xfrm>
+            <a:off x="19604735" y="8238743"/>
+            <a:ext cx="649225" cy="36577"/>
+          </a:xfrm>
+          <a:prstGeom prst="line">
+            <a:avLst/>
+          </a:prstGeom>
+          <a:ln w="10160">
+            <a:solidFill>
+              <a:srgbClr val="A9BBD0"/>
+            </a:solidFill>
+          </a:ln>
+        </p:spPr>
+        <p:style>
+          <a:lnRef idx="2">
+            <a:schemeClr val="accent1"/>
+          </a:lnRef>
+          <a:fillRef idx="0">
+            <a:schemeClr val="accent1"/>
+          </a:fillRef>
+          <a:effectRef idx="1">
+            <a:schemeClr val="accent1"/>
+          </a:effectRef>
+          <a:fontRef idx="minor">
+            <a:schemeClr val="tx1"/>
+          </a:fontRef>
+        </p:style>
+      </p:cxnSp>
+      <p:cxnSp>
+        <p:nvCxnSpPr>
           <p:cNvPr id="65" name="Connector 64"/>
           <p:cNvCxnSpPr/>
           <p:nvPr/>
         </p:nvCxnSpPr>
         <p:spPr>
-          <a:xfrm>
-            <a:off x="15892272" y="8311896"/>
-            <a:ext cx="1207008" cy="1005840"/>
+          <a:xfrm flipV="1">
+            <a:off x="19604735" y="8275320"/>
+            <a:ext cx="649225" cy="347471"/>
           </a:xfrm>
           <a:prstGeom prst="line">
             <a:avLst/>
@@ -6605,9 +6525,9 @@
           <p:nvPr/>
         </p:nvCxnSpPr>
         <p:spPr>
-          <a:xfrm>
-            <a:off x="15892272" y="8814816"/>
-            <a:ext cx="1207008" cy="502920"/>
+          <a:xfrm flipV="1">
+            <a:off x="19604735" y="8275320"/>
+            <a:ext cx="649225" cy="731519"/>
           </a:xfrm>
           <a:prstGeom prst="line">
             <a:avLst/>
@@ -6640,14 +6560,14 @@
           <p:nvPr/>
         </p:nvCxnSpPr>
         <p:spPr>
-          <a:xfrm>
-            <a:off x="15892272" y="9317736"/>
-            <a:ext cx="1207008" cy="0"/>
+          <a:xfrm flipV="1">
+            <a:off x="21296376" y="7799831"/>
+            <a:ext cx="585216" cy="475489"/>
           </a:xfrm>
           <a:prstGeom prst="line">
             <a:avLst/>
           </a:prstGeom>
-          <a:ln w="10160">
+          <a:ln w="11430">
             <a:solidFill>
               <a:srgbClr val="A9BBD0"/>
             </a:solidFill>
@@ -6668,21 +6588,156 @@
           </a:fontRef>
         </p:style>
       </p:cxnSp>
+      <p:sp>
+        <p:nvSpPr>
+          <p:cNvPr id="68" name="Oval 67"/>
+          <p:cNvSpPr/>
+          <p:nvPr/>
+        </p:nvSpPr>
+        <p:spPr>
+          <a:xfrm>
+            <a:off x="21881592" y="7653527"/>
+            <a:ext cx="292608" cy="292608"/>
+          </a:xfrm>
+          <a:prstGeom prst="ellipse">
+            <a:avLst/>
+          </a:prstGeom>
+          <a:solidFill>
+            <a:srgbClr val="6A4C93"/>
+          </a:solidFill>
+          <a:ln>
+            <a:noFill/>
+          </a:ln>
+        </p:spPr>
+        <p:style>
+          <a:lnRef idx="1">
+            <a:schemeClr val="accent1"/>
+          </a:lnRef>
+          <a:fillRef idx="3">
+            <a:schemeClr val="accent1"/>
+          </a:fillRef>
+          <a:effectRef idx="2">
+            <a:schemeClr val="accent1"/>
+          </a:effectRef>
+          <a:fontRef idx="minor">
+            <a:schemeClr val="lt1"/>
+          </a:fontRef>
+        </p:style>
+        <p:txBody>
+          <a:bodyPr rtlCol="0" anchor="ctr"/>
+          <a:lstStyle/>
+          <a:p>
+            <a:pPr algn="ctr"/>
+          </a:p>
+        </p:txBody>
+      </p:sp>
+      <p:sp>
+        <p:nvSpPr>
+          <p:cNvPr id="69" name="Rounded Rectangle 68"/>
+          <p:cNvSpPr/>
+          <p:nvPr/>
+        </p:nvSpPr>
+        <p:spPr>
+          <a:xfrm>
+            <a:off x="22247352" y="7635240"/>
+            <a:ext cx="2029968" cy="329184"/>
+          </a:xfrm>
+          <a:prstGeom prst="roundRect">
+            <a:avLst>
+              <a:gd name="adj" fmla="val 8000"/>
+            </a:avLst>
+          </a:prstGeom>
+          <a:solidFill>
+            <a:srgbClr val="F8FAFC"/>
+          </a:solidFill>
+          <a:ln w="11430">
+            <a:solidFill>
+              <a:srgbClr val="6A4C93"/>
+            </a:solidFill>
+          </a:ln>
+        </p:spPr>
+        <p:style>
+          <a:lnRef idx="1">
+            <a:schemeClr val="accent1"/>
+          </a:lnRef>
+          <a:fillRef idx="3">
+            <a:schemeClr val="accent1"/>
+          </a:fillRef>
+          <a:effectRef idx="2">
+            <a:schemeClr val="accent1"/>
+          </a:effectRef>
+          <a:fontRef idx="minor">
+            <a:schemeClr val="lt1"/>
+          </a:fontRef>
+        </p:style>
+        <p:txBody>
+          <a:bodyPr rtlCol="0" anchor="ctr"/>
+          <a:lstStyle/>
+          <a:p>
+            <a:pPr algn="ctr"/>
+          </a:p>
+        </p:txBody>
+      </p:sp>
+      <p:sp>
+        <p:nvSpPr>
+          <p:cNvPr id="70" name="TextBox 69"/>
+          <p:cNvSpPr txBox="1"/>
+          <p:nvPr/>
+        </p:nvSpPr>
+        <p:spPr>
+          <a:xfrm>
+            <a:off x="22338792" y="7635240"/>
+            <a:ext cx="1847088" cy="329184"/>
+          </a:xfrm>
+          <a:prstGeom prst="rect">
+            <a:avLst/>
+          </a:prstGeom>
+          <a:noFill/>
+        </p:spPr>
+        <p:txBody>
+          <a:bodyPr wrap="square" lIns="0" rIns="0" tIns="0" bIns="0" anchor="ctr">
+            <a:spAutoFit/>
+          </a:bodyPr>
+          <a:lstStyle/>
+          <a:p>
+            <a:pPr algn="ctr">
+              <a:lnSpc>
+                <a:spcPct val="100000"/>
+              </a:lnSpc>
+              <a:spcBef>
+                <a:spcPts val="0"/>
+              </a:spcBef>
+              <a:spcAft>
+                <a:spcPts val="0"/>
+              </a:spcAft>
+            </a:pPr>
+            <a:r>
+              <a:rPr sz="1550" b="1" i="0">
+                <a:solidFill>
+                  <a:srgbClr val="6A4C93"/>
+                </a:solidFill>
+                <a:latin typeface="Arial"/>
+              </a:rPr>
+              <a:t>DNA repair</a:t>
+            </a:r>
+          </a:p>
+        </p:txBody>
+      </p:sp>
       <p:cxnSp>
         <p:nvCxnSpPr>
-          <p:cNvPr id="68" name="Connector 67"/>
+          <p:cNvPr id="71" name="Connector 70"/>
           <p:cNvCxnSpPr/>
           <p:nvPr/>
         </p:nvCxnSpPr>
         <p:spPr>
           <a:xfrm flipV="1">
-            <a:off x="15892272" y="9317736"/>
-            <a:ext cx="1207008" cy="502920"/>
+            <a:off x="21296376" y="8238744"/>
+            <a:ext cx="585216" cy="36576"/>
           </a:xfrm>
           <a:prstGeom prst="line">
             <a:avLst/>
           </a:prstGeom>
-          <a:ln w="10160">
+          <a:ln w="11430">
             <a:solidFill>
               <a:srgbClr val="A9BBD0"/>
             </a:solidFill>
@@ -6703,21 +6758,156 @@
           </a:fontRef>
         </p:style>
       </p:cxnSp>
+      <p:sp>
+        <p:nvSpPr>
+          <p:cNvPr id="72" name="Oval 71"/>
+          <p:cNvSpPr/>
+          <p:nvPr/>
+        </p:nvSpPr>
+        <p:spPr>
+          <a:xfrm>
+            <a:off x="21881592" y="8092440"/>
+            <a:ext cx="292608" cy="292608"/>
+          </a:xfrm>
+          <a:prstGeom prst="ellipse">
+            <a:avLst/>
+          </a:prstGeom>
+          <a:solidFill>
+            <a:srgbClr val="A64D67"/>
+          </a:solidFill>
+          <a:ln>
+            <a:noFill/>
+          </a:ln>
+        </p:spPr>
+        <p:style>
+          <a:lnRef idx="1">
+            <a:schemeClr val="accent1"/>
+          </a:lnRef>
+          <a:fillRef idx="3">
+            <a:schemeClr val="accent1"/>
+          </a:fillRef>
+          <a:effectRef idx="2">
+            <a:schemeClr val="accent1"/>
+          </a:effectRef>
+          <a:fontRef idx="minor">
+            <a:schemeClr val="lt1"/>
+          </a:fontRef>
+        </p:style>
+        <p:txBody>
+          <a:bodyPr rtlCol="0" anchor="ctr"/>
+          <a:lstStyle/>
+          <a:p>
+            <a:pPr algn="ctr"/>
+          </a:p>
+        </p:txBody>
+      </p:sp>
+      <p:sp>
+        <p:nvSpPr>
+          <p:cNvPr id="73" name="Rounded Rectangle 72"/>
+          <p:cNvSpPr/>
+          <p:nvPr/>
+        </p:nvSpPr>
+        <p:spPr>
+          <a:xfrm>
+            <a:off x="22247352" y="8074152"/>
+            <a:ext cx="2029968" cy="329184"/>
+          </a:xfrm>
+          <a:prstGeom prst="roundRect">
+            <a:avLst>
+              <a:gd name="adj" fmla="val 8000"/>
+            </a:avLst>
+          </a:prstGeom>
+          <a:solidFill>
+            <a:srgbClr val="F8FAFC"/>
+          </a:solidFill>
+          <a:ln w="11430">
+            <a:solidFill>
+              <a:srgbClr val="A64D67"/>
+            </a:solidFill>
+          </a:ln>
+        </p:spPr>
+        <p:style>
+          <a:lnRef idx="1">
+            <a:schemeClr val="accent1"/>
+          </a:lnRef>
+          <a:fillRef idx="3">
+            <a:schemeClr val="accent1"/>
+          </a:fillRef>
+          <a:effectRef idx="2">
+            <a:schemeClr val="accent1"/>
+          </a:effectRef>
+          <a:fontRef idx="minor">
+            <a:schemeClr val="lt1"/>
+          </a:fontRef>
+        </p:style>
+        <p:txBody>
+          <a:bodyPr rtlCol="0" anchor="ctr"/>
+          <a:lstStyle/>
+          <a:p>
+            <a:pPr algn="ctr"/>
+          </a:p>
+        </p:txBody>
+      </p:sp>
+      <p:sp>
+        <p:nvSpPr>
+          <p:cNvPr id="74" name="TextBox 73"/>
+          <p:cNvSpPr txBox="1"/>
+          <p:nvPr/>
+        </p:nvSpPr>
+        <p:spPr>
+          <a:xfrm>
+            <a:off x="22338792" y="8074152"/>
+            <a:ext cx="1847088" cy="329184"/>
+          </a:xfrm>
+          <a:prstGeom prst="rect">
+            <a:avLst/>
+          </a:prstGeom>
+          <a:noFill/>
+        </p:spPr>
+        <p:txBody>
+          <a:bodyPr wrap="square" lIns="0" rIns="0" tIns="0" bIns="0" anchor="ctr">
+            <a:spAutoFit/>
+          </a:bodyPr>
+          <a:lstStyle/>
+          <a:p>
+            <a:pPr algn="ctr">
+              <a:lnSpc>
+                <a:spcPct val="100000"/>
+              </a:lnSpc>
+              <a:spcBef>
+                <a:spcPts val="0"/>
+              </a:spcBef>
+              <a:spcAft>
+                <a:spcPts val="0"/>
+              </a:spcAft>
+            </a:pPr>
+            <a:r>
+              <a:rPr sz="1550" b="1" i="0">
+                <a:solidFill>
+                  <a:srgbClr val="A64D67"/>
+                </a:solidFill>
+                <a:latin typeface="Arial"/>
+              </a:rPr>
+              <a:t>T-cell signaling</a:t>
+            </a:r>
+          </a:p>
+        </p:txBody>
+      </p:sp>
       <p:cxnSp>
         <p:nvCxnSpPr>
-          <p:cNvPr id="69" name="Connector 68"/>
+          <p:cNvPr id="75" name="Connector 74"/>
           <p:cNvCxnSpPr/>
           <p:nvPr/>
         </p:nvCxnSpPr>
         <p:spPr>
-          <a:xfrm flipV="1">
-            <a:off x="15892272" y="9317736"/>
-            <a:ext cx="1207008" cy="1005840"/>
+          <a:xfrm>
+            <a:off x="21296376" y="8275320"/>
+            <a:ext cx="585216" cy="402336"/>
           </a:xfrm>
           <a:prstGeom prst="line">
             <a:avLst/>
           </a:prstGeom>
-          <a:ln w="10160">
+          <a:ln w="11430">
             <a:solidFill>
               <a:srgbClr val="A9BBD0"/>
             </a:solidFill>
@@ -6738,297 +6928,16 @@
           </a:fontRef>
         </p:style>
       </p:cxnSp>
-      <p:cxnSp>
-        <p:nvCxnSpPr>
-          <p:cNvPr id="70" name="Connector 69"/>
-          <p:cNvCxnSpPr/>
-          <p:nvPr/>
-        </p:nvCxnSpPr>
-        <p:spPr>
-          <a:xfrm flipV="1">
-            <a:off x="18562320" y="8412480"/>
-            <a:ext cx="1280160" cy="905256"/>
-          </a:xfrm>
-          <a:prstGeom prst="line">
-            <a:avLst/>
-          </a:prstGeom>
-          <a:ln w="11430">
-            <a:solidFill>
-              <a:srgbClr val="A9BBD0"/>
-            </a:solidFill>
-          </a:ln>
-        </p:spPr>
-        <p:style>
-          <a:lnRef idx="2">
-            <a:schemeClr val="accent1"/>
-          </a:lnRef>
-          <a:fillRef idx="0">
-            <a:schemeClr val="accent1"/>
-          </a:fillRef>
-          <a:effectRef idx="1">
-            <a:schemeClr val="accent1"/>
-          </a:effectRef>
-          <a:fontRef idx="minor">
-            <a:schemeClr val="tx1"/>
-          </a:fontRef>
-        </p:style>
-      </p:cxnSp>
-      <p:sp>
-        <p:nvSpPr>
-          <p:cNvPr id="71" name="Oval 70"/>
+      <p:sp>
+        <p:nvSpPr>
+          <p:cNvPr id="76" name="Oval 75"/>
           <p:cNvSpPr/>
           <p:nvPr/>
         </p:nvSpPr>
         <p:spPr>
           <a:xfrm>
-            <a:off x="19842480" y="8247888"/>
-            <a:ext cx="329184" cy="329184"/>
-          </a:xfrm>
-          <a:prstGeom prst="ellipse">
-            <a:avLst/>
-          </a:prstGeom>
-          <a:solidFill>
-            <a:srgbClr val="6A4C93"/>
-          </a:solidFill>
-          <a:ln>
-            <a:noFill/>
-          </a:ln>
-        </p:spPr>
-        <p:style>
-          <a:lnRef idx="1">
-            <a:schemeClr val="accent1"/>
-          </a:lnRef>
-          <a:fillRef idx="3">
-            <a:schemeClr val="accent1"/>
-          </a:fillRef>
-          <a:effectRef idx="2">
-            <a:schemeClr val="accent1"/>
-          </a:effectRef>
-          <a:fontRef idx="minor">
-            <a:schemeClr val="lt1"/>
-          </a:fontRef>
-        </p:style>
-        <p:txBody>
-          <a:bodyPr rtlCol="0" anchor="ctr"/>
-          <a:lstStyle/>
-          <a:p>
-            <a:pPr algn="ctr"/>
-          </a:p>
-        </p:txBody>
-      </p:sp>
-      <p:sp>
-        <p:nvSpPr>
-          <p:cNvPr id="72" name="TextBox 71"/>
-          <p:cNvSpPr txBox="1"/>
-          <p:nvPr/>
-        </p:nvSpPr>
-        <p:spPr>
-          <a:xfrm>
-            <a:off x="20281392" y="8220456"/>
-            <a:ext cx="1783080" cy="384048"/>
-          </a:xfrm>
-          <a:prstGeom prst="rect">
-            <a:avLst/>
-          </a:prstGeom>
-          <a:noFill/>
-        </p:spPr>
-        <p:txBody>
-          <a:bodyPr wrap="square" lIns="0" rIns="0" tIns="0" bIns="0" anchor="ctr">
-            <a:spAutoFit/>
-          </a:bodyPr>
-          <a:lstStyle/>
-          <a:p>
-            <a:pPr algn="l">
-              <a:lnSpc>
-                <a:spcPct val="100000"/>
-              </a:lnSpc>
-              <a:spcBef>
-                <a:spcPts val="0"/>
-              </a:spcBef>
-              <a:spcAft>
-                <a:spcPts val="0"/>
-              </a:spcAft>
-            </a:pPr>
-            <a:r>
-              <a:rPr sz="1350" b="1" i="0">
-                <a:solidFill>
-                  <a:srgbClr val="6A4C93"/>
-                </a:solidFill>
-                <a:latin typeface="Arial"/>
-              </a:rPr>
-              <a:t>DNA repair</a:t>
-            </a:r>
-          </a:p>
-        </p:txBody>
-      </p:sp>
-      <p:cxnSp>
-        <p:nvCxnSpPr>
-          <p:cNvPr id="73" name="Connector 72"/>
-          <p:cNvCxnSpPr/>
-          <p:nvPr/>
-        </p:nvCxnSpPr>
-        <p:spPr>
-          <a:xfrm flipV="1">
-            <a:off x="18562320" y="9235440"/>
-            <a:ext cx="1280160" cy="82296"/>
-          </a:xfrm>
-          <a:prstGeom prst="line">
-            <a:avLst/>
-          </a:prstGeom>
-          <a:ln w="11430">
-            <a:solidFill>
-              <a:srgbClr val="A9BBD0"/>
-            </a:solidFill>
-          </a:ln>
-        </p:spPr>
-        <p:style>
-          <a:lnRef idx="2">
-            <a:schemeClr val="accent1"/>
-          </a:lnRef>
-          <a:fillRef idx="0">
-            <a:schemeClr val="accent1"/>
-          </a:fillRef>
-          <a:effectRef idx="1">
-            <a:schemeClr val="accent1"/>
-          </a:effectRef>
-          <a:fontRef idx="minor">
-            <a:schemeClr val="tx1"/>
-          </a:fontRef>
-        </p:style>
-      </p:cxnSp>
-      <p:sp>
-        <p:nvSpPr>
-          <p:cNvPr id="74" name="Oval 73"/>
-          <p:cNvSpPr/>
-          <p:nvPr/>
-        </p:nvSpPr>
-        <p:spPr>
-          <a:xfrm>
-            <a:off x="19842480" y="9070848"/>
-            <a:ext cx="329184" cy="329184"/>
-          </a:xfrm>
-          <a:prstGeom prst="ellipse">
-            <a:avLst/>
-          </a:prstGeom>
-          <a:solidFill>
-            <a:srgbClr val="A64D67"/>
-          </a:solidFill>
-          <a:ln>
-            <a:noFill/>
-          </a:ln>
-        </p:spPr>
-        <p:style>
-          <a:lnRef idx="1">
-            <a:schemeClr val="accent1"/>
-          </a:lnRef>
-          <a:fillRef idx="3">
-            <a:schemeClr val="accent1"/>
-          </a:fillRef>
-          <a:effectRef idx="2">
-            <a:schemeClr val="accent1"/>
-          </a:effectRef>
-          <a:fontRef idx="minor">
-            <a:schemeClr val="lt1"/>
-          </a:fontRef>
-        </p:style>
-        <p:txBody>
-          <a:bodyPr rtlCol="0" anchor="ctr"/>
-          <a:lstStyle/>
-          <a:p>
-            <a:pPr algn="ctr"/>
-          </a:p>
-        </p:txBody>
-      </p:sp>
-      <p:sp>
-        <p:nvSpPr>
-          <p:cNvPr id="75" name="TextBox 74"/>
-          <p:cNvSpPr txBox="1"/>
-          <p:nvPr/>
-        </p:nvSpPr>
-        <p:spPr>
-          <a:xfrm>
-            <a:off x="20281392" y="9043416"/>
-            <a:ext cx="1783080" cy="384048"/>
-          </a:xfrm>
-          <a:prstGeom prst="rect">
-            <a:avLst/>
-          </a:prstGeom>
-          <a:noFill/>
-        </p:spPr>
-        <p:txBody>
-          <a:bodyPr wrap="square" lIns="0" rIns="0" tIns="0" bIns="0" anchor="ctr">
-            <a:spAutoFit/>
-          </a:bodyPr>
-          <a:lstStyle/>
-          <a:p>
-            <a:pPr algn="l">
-              <a:lnSpc>
-                <a:spcPct val="100000"/>
-              </a:lnSpc>
-              <a:spcBef>
-                <a:spcPts val="0"/>
-              </a:spcBef>
-              <a:spcAft>
-                <a:spcPts val="0"/>
-              </a:spcAft>
-            </a:pPr>
-            <a:r>
-              <a:rPr sz="1350" b="1" i="0">
-                <a:solidFill>
-                  <a:srgbClr val="A64D67"/>
-                </a:solidFill>
-                <a:latin typeface="Arial"/>
-              </a:rPr>
-              <a:t>T-cell signaling</a:t>
-            </a:r>
-          </a:p>
-        </p:txBody>
-      </p:sp>
-      <p:cxnSp>
-        <p:nvCxnSpPr>
-          <p:cNvPr id="76" name="Connector 75"/>
-          <p:cNvCxnSpPr/>
-          <p:nvPr/>
-        </p:nvCxnSpPr>
-        <p:spPr>
-          <a:xfrm>
-            <a:off x="18562320" y="9317736"/>
-            <a:ext cx="1280160" cy="740664"/>
-          </a:xfrm>
-          <a:prstGeom prst="line">
-            <a:avLst/>
-          </a:prstGeom>
-          <a:ln w="11430">
-            <a:solidFill>
-              <a:srgbClr val="A9BBD0"/>
-            </a:solidFill>
-          </a:ln>
-        </p:spPr>
-        <p:style>
-          <a:lnRef idx="2">
-            <a:schemeClr val="accent1"/>
-          </a:lnRef>
-          <a:fillRef idx="0">
-            <a:schemeClr val="accent1"/>
-          </a:fillRef>
-          <a:effectRef idx="1">
-            <a:schemeClr val="accent1"/>
-          </a:effectRef>
-          <a:fontRef idx="minor">
-            <a:schemeClr val="tx1"/>
-          </a:fontRef>
-        </p:style>
-      </p:cxnSp>
-      <p:sp>
-        <p:nvSpPr>
-          <p:cNvPr id="77" name="Oval 76"/>
-          <p:cNvSpPr/>
-          <p:nvPr/>
-        </p:nvSpPr>
-        <p:spPr>
-          <a:xfrm>
-            <a:off x="19842480" y="9893808"/>
-            <a:ext cx="329184" cy="329184"/>
+            <a:off x="21881592" y="8531352"/>
+            <a:ext cx="292608" cy="292608"/>
           </a:xfrm>
           <a:prstGeom prst="ellipse">
             <a:avLst/>
@@ -7064,14 +6973,61 @@
       </p:sp>
       <p:sp>
         <p:nvSpPr>
+          <p:cNvPr id="77" name="Rounded Rectangle 76"/>
+          <p:cNvSpPr/>
+          <p:nvPr/>
+        </p:nvSpPr>
+        <p:spPr>
+          <a:xfrm>
+            <a:off x="22247352" y="8513064"/>
+            <a:ext cx="2029968" cy="329184"/>
+          </a:xfrm>
+          <a:prstGeom prst="roundRect">
+            <a:avLst>
+              <a:gd name="adj" fmla="val 8000"/>
+            </a:avLst>
+          </a:prstGeom>
+          <a:solidFill>
+            <a:srgbClr val="F8FAFC"/>
+          </a:solidFill>
+          <a:ln w="11430">
+            <a:solidFill>
+              <a:srgbClr val="C65D37"/>
+            </a:solidFill>
+          </a:ln>
+        </p:spPr>
+        <p:style>
+          <a:lnRef idx="1">
+            <a:schemeClr val="accent1"/>
+          </a:lnRef>
+          <a:fillRef idx="3">
+            <a:schemeClr val="accent1"/>
+          </a:fillRef>
+          <a:effectRef idx="2">
+            <a:schemeClr val="accent1"/>
+          </a:effectRef>
+          <a:fontRef idx="minor">
+            <a:schemeClr val="lt1"/>
+          </a:fontRef>
+        </p:style>
+        <p:txBody>
+          <a:bodyPr rtlCol="0" anchor="ctr"/>
+          <a:lstStyle/>
+          <a:p>
+            <a:pPr algn="ctr"/>
+          </a:p>
+        </p:txBody>
+      </p:sp>
+      <p:sp>
+        <p:nvSpPr>
           <p:cNvPr id="78" name="TextBox 77"/>
           <p:cNvSpPr txBox="1"/>
           <p:nvPr/>
         </p:nvSpPr>
         <p:spPr>
           <a:xfrm>
-            <a:off x="20281392" y="9866376"/>
-            <a:ext cx="1783080" cy="384048"/>
+            <a:off x="22338792" y="8513064"/>
+            <a:ext cx="1847088" cy="329184"/>
           </a:xfrm>
           <a:prstGeom prst="rect">
             <a:avLst/>
@@ -7084,7 +7040,7 @@
           </a:bodyPr>
           <a:lstStyle/>
           <a:p>
-            <a:pPr algn="l">
+            <a:pPr algn="ctr">
               <a:lnSpc>
                 <a:spcPct val="100000"/>
               </a:lnSpc>
@@ -7096,7 +7052,7 @@
               </a:spcAft>
             </a:pPr>
             <a:r>
-              <a:rPr sz="1350" b="1" i="0">
+              <a:rPr sz="1550" b="1" i="0">
                 <a:solidFill>
                   <a:srgbClr val="C65D37"/>
                 </a:solidFill>
@@ -7109,14 +7065,147 @@
       </p:sp>
       <p:sp>
         <p:nvSpPr>
-          <p:cNvPr id="79" name="Oval 78"/>
+          <p:cNvPr id="79" name="Rounded Rectangle 78"/>
           <p:cNvSpPr/>
           <p:nvPr/>
         </p:nvSpPr>
         <p:spPr>
           <a:xfrm>
-            <a:off x="22357080" y="8110727"/>
-            <a:ext cx="256032" cy="256032"/>
+            <a:off x="24505920" y="7168896"/>
+            <a:ext cx="3246120" cy="530352"/>
+          </a:xfrm>
+          <a:prstGeom prst="roundRect">
+            <a:avLst/>
+          </a:prstGeom>
+          <a:solidFill>
+            <a:srgbClr val="E9F4EE"/>
+          </a:solidFill>
+          <a:ln w="13970">
+            <a:solidFill>
+              <a:srgbClr val="178C6A"/>
+            </a:solidFill>
+          </a:ln>
+        </p:spPr>
+        <p:style>
+          <a:lnRef idx="1">
+            <a:schemeClr val="accent1"/>
+          </a:lnRef>
+          <a:fillRef idx="3">
+            <a:schemeClr val="accent1"/>
+          </a:fillRef>
+          <a:effectRef idx="2">
+            <a:schemeClr val="accent1"/>
+          </a:effectRef>
+          <a:fontRef idx="minor">
+            <a:schemeClr val="lt1"/>
+          </a:fontRef>
+        </p:style>
+        <p:txBody>
+          <a:bodyPr rtlCol="0" anchor="ctr"/>
+          <a:lstStyle/>
+          <a:p>
+            <a:pPr algn="ctr"/>
+          </a:p>
+        </p:txBody>
+      </p:sp>
+      <p:sp>
+        <p:nvSpPr>
+          <p:cNvPr id="80" name="TextBox 79"/>
+          <p:cNvSpPr txBox="1"/>
+          <p:nvPr/>
+        </p:nvSpPr>
+        <p:spPr>
+          <a:xfrm>
+            <a:off x="24624792" y="7223760"/>
+            <a:ext cx="3008376" cy="402336"/>
+          </a:xfrm>
+          <a:prstGeom prst="rect">
+            <a:avLst/>
+          </a:prstGeom>
+          <a:noFill/>
+        </p:spPr>
+        <p:txBody>
+          <a:bodyPr wrap="square" lIns="0" rIns="0" tIns="0" bIns="0" anchor="ctr">
+            <a:spAutoFit/>
+          </a:bodyPr>
+          <a:lstStyle/>
+          <a:p>
+            <a:pPr algn="ctr">
+              <a:lnSpc>
+                <a:spcPct val="100000"/>
+              </a:lnSpc>
+              <a:spcBef>
+                <a:spcPts val="0"/>
+              </a:spcBef>
+              <a:spcAft>
+                <a:spcPts val="0"/>
+              </a:spcAft>
+            </a:pPr>
+            <a:r>
+              <a:rPr sz="1450" b="1" i="0">
+                <a:solidFill>
+                  <a:srgbClr val="178C6A"/>
+                </a:solidFill>
+                <a:latin typeface="Arial"/>
+              </a:rPr>
+              <a:t>Reactome gene-program mask</a:t>
+            </a:r>
+          </a:p>
+        </p:txBody>
+      </p:sp>
+      <p:sp>
+        <p:nvSpPr>
+          <p:cNvPr id="81" name="Down Arrow 80"/>
+          <p:cNvSpPr/>
+          <p:nvPr/>
+        </p:nvSpPr>
+        <p:spPr>
+          <a:xfrm>
+            <a:off x="25667208" y="7726679"/>
+            <a:ext cx="329184" cy="310896"/>
+          </a:xfrm>
+          <a:prstGeom prst="downArrow">
+            <a:avLst/>
+          </a:prstGeom>
+          <a:solidFill>
+            <a:srgbClr val="178C6A"/>
+          </a:solidFill>
+          <a:ln>
+            <a:noFill/>
+          </a:ln>
+        </p:spPr>
+        <p:style>
+          <a:lnRef idx="1">
+            <a:schemeClr val="accent1"/>
+          </a:lnRef>
+          <a:fillRef idx="3">
+            <a:schemeClr val="accent1"/>
+          </a:fillRef>
+          <a:effectRef idx="2">
+            <a:schemeClr val="accent1"/>
+          </a:effectRef>
+          <a:fontRef idx="minor">
+            <a:schemeClr val="lt1"/>
+          </a:fontRef>
+        </p:style>
+        <p:txBody>
+          <a:bodyPr rtlCol="0" anchor="ctr"/>
+          <a:lstStyle/>
+          <a:p>
+            <a:pPr algn="ctr"/>
+          </a:p>
+        </p:txBody>
+      </p:sp>
+      <p:sp>
+        <p:nvSpPr>
+          <p:cNvPr id="82" name="Oval 81"/>
+          <p:cNvSpPr/>
+          <p:nvPr/>
+        </p:nvSpPr>
+        <p:spPr>
+          <a:xfrm>
+            <a:off x="27249120" y="7726679"/>
+            <a:ext cx="219456" cy="219456"/>
           </a:xfrm>
           <a:prstGeom prst="ellipse">
             <a:avLst/>
@@ -7152,14 +7241,14 @@
       </p:sp>
       <p:sp>
         <p:nvSpPr>
-          <p:cNvPr id="80" name="Oval 79"/>
+          <p:cNvPr id="83" name="Oval 82"/>
           <p:cNvSpPr/>
           <p:nvPr/>
         </p:nvSpPr>
         <p:spPr>
           <a:xfrm>
-            <a:off x="22357080" y="8705088"/>
-            <a:ext cx="256032" cy="256032"/>
+            <a:off x="27249120" y="8074152"/>
+            <a:ext cx="219456" cy="219456"/>
           </a:xfrm>
           <a:prstGeom prst="ellipse">
             <a:avLst/>
@@ -7195,14 +7284,14 @@
       </p:sp>
       <p:sp>
         <p:nvSpPr>
-          <p:cNvPr id="81" name="Oval 80"/>
+          <p:cNvPr id="84" name="Oval 83"/>
           <p:cNvSpPr/>
           <p:nvPr/>
         </p:nvSpPr>
         <p:spPr>
           <a:xfrm>
-            <a:off x="22357080" y="9299448"/>
-            <a:ext cx="256032" cy="256032"/>
+            <a:off x="27249120" y="8421624"/>
+            <a:ext cx="219456" cy="219456"/>
           </a:xfrm>
           <a:prstGeom prst="ellipse">
             <a:avLst/>
@@ -7238,14 +7327,14 @@
       </p:sp>
       <p:sp>
         <p:nvSpPr>
-          <p:cNvPr id="82" name="Oval 81"/>
+          <p:cNvPr id="85" name="Oval 84"/>
           <p:cNvSpPr/>
           <p:nvPr/>
         </p:nvSpPr>
         <p:spPr>
           <a:xfrm>
-            <a:off x="22357080" y="9893808"/>
-            <a:ext cx="256032" cy="256032"/>
+            <a:off x="27249120" y="8769096"/>
+            <a:ext cx="219456" cy="219456"/>
           </a:xfrm>
           <a:prstGeom prst="ellipse">
             <a:avLst/>
@@ -7279,119 +7368,6 @@
           </a:p>
         </p:txBody>
       </p:sp>
-      <p:sp>
-        <p:nvSpPr>
-          <p:cNvPr id="83" name="Oval 82"/>
-          <p:cNvSpPr/>
-          <p:nvPr/>
-        </p:nvSpPr>
-        <p:spPr>
-          <a:xfrm>
-            <a:off x="22357080" y="10488167"/>
-            <a:ext cx="256032" cy="256032"/>
-          </a:xfrm>
-          <a:prstGeom prst="ellipse">
-            <a:avLst/>
-          </a:prstGeom>
-          <a:solidFill>
-            <a:srgbClr val="A9BBD0"/>
-          </a:solidFill>
-          <a:ln>
-            <a:noFill/>
-          </a:ln>
-        </p:spPr>
-        <p:style>
-          <a:lnRef idx="1">
-            <a:schemeClr val="accent1"/>
-          </a:lnRef>
-          <a:fillRef idx="3">
-            <a:schemeClr val="accent1"/>
-          </a:fillRef>
-          <a:effectRef idx="2">
-            <a:schemeClr val="accent1"/>
-          </a:effectRef>
-          <a:fontRef idx="minor">
-            <a:schemeClr val="lt1"/>
-          </a:fontRef>
-        </p:style>
-        <p:txBody>
-          <a:bodyPr rtlCol="0" anchor="ctr"/>
-          <a:lstStyle/>
-          <a:p>
-            <a:pPr algn="ctr"/>
-          </a:p>
-        </p:txBody>
-      </p:sp>
-      <p:cxnSp>
-        <p:nvCxnSpPr>
-          <p:cNvPr id="84" name="Connector 83"/>
-          <p:cNvCxnSpPr/>
-          <p:nvPr/>
-        </p:nvCxnSpPr>
-        <p:spPr>
-          <a:xfrm flipV="1">
-            <a:off x="20171664" y="8238744"/>
-            <a:ext cx="2185416" cy="173736"/>
-          </a:xfrm>
-          <a:prstGeom prst="line">
-            <a:avLst/>
-          </a:prstGeom>
-          <a:ln w="15240">
-            <a:solidFill>
-              <a:srgbClr val="6A4C93"/>
-            </a:solidFill>
-          </a:ln>
-        </p:spPr>
-        <p:style>
-          <a:lnRef idx="2">
-            <a:schemeClr val="accent1"/>
-          </a:lnRef>
-          <a:fillRef idx="0">
-            <a:schemeClr val="accent1"/>
-          </a:fillRef>
-          <a:effectRef idx="1">
-            <a:schemeClr val="accent1"/>
-          </a:effectRef>
-          <a:fontRef idx="minor">
-            <a:schemeClr val="tx1"/>
-          </a:fontRef>
-        </p:style>
-      </p:cxnSp>
-      <p:cxnSp>
-        <p:nvCxnSpPr>
-          <p:cNvPr id="85" name="Connector 84"/>
-          <p:cNvCxnSpPr/>
-          <p:nvPr/>
-        </p:nvCxnSpPr>
-        <p:spPr>
-          <a:xfrm>
-            <a:off x="20171664" y="8412480"/>
-            <a:ext cx="2185416" cy="1014984"/>
-          </a:xfrm>
-          <a:prstGeom prst="line">
-            <a:avLst/>
-          </a:prstGeom>
-          <a:ln w="15240">
-            <a:solidFill>
-              <a:srgbClr val="6A4C93"/>
-            </a:solidFill>
-          </a:ln>
-        </p:spPr>
-        <p:style>
-          <a:lnRef idx="2">
-            <a:schemeClr val="accent1"/>
-          </a:lnRef>
-          <a:fillRef idx="0">
-            <a:schemeClr val="accent1"/>
-          </a:fillRef>
-          <a:effectRef idx="1">
-            <a:schemeClr val="accent1"/>
-          </a:effectRef>
-          <a:fontRef idx="minor">
-            <a:schemeClr val="tx1"/>
-          </a:fontRef>
-        </p:style>
-      </p:cxnSp>
       <p:cxnSp>
         <p:nvCxnSpPr>
           <p:cNvPr id="86" name="Connector 85"/>
@@ -7399,16 +7375,16 @@
           <p:nvPr/>
         </p:nvCxnSpPr>
         <p:spPr>
-          <a:xfrm flipV="1">
-            <a:off x="20171664" y="8833104"/>
-            <a:ext cx="2185416" cy="402336"/>
+          <a:xfrm>
+            <a:off x="24277320" y="7799831"/>
+            <a:ext cx="2971800" cy="36576"/>
           </a:xfrm>
           <a:prstGeom prst="line">
             <a:avLst/>
           </a:prstGeom>
           <a:ln w="15240">
             <a:solidFill>
-              <a:srgbClr val="A64D67"/>
+              <a:srgbClr val="6A4C93"/>
             </a:solidFill>
           </a:ln>
         </p:spPr>
@@ -7435,15 +7411,15 @@
         </p:nvCxnSpPr>
         <p:spPr>
           <a:xfrm>
-            <a:off x="20171664" y="9235440"/>
-            <a:ext cx="2185416" cy="786384"/>
+            <a:off x="24277320" y="7799831"/>
+            <a:ext cx="2971800" cy="731520"/>
           </a:xfrm>
           <a:prstGeom prst="line">
             <a:avLst/>
           </a:prstGeom>
           <a:ln w="15240">
             <a:solidFill>
-              <a:srgbClr val="A64D67"/>
+              <a:srgbClr val="6A4C93"/>
             </a:solidFill>
           </a:ln>
         </p:spPr>
@@ -7470,15 +7446,15 @@
         </p:nvCxnSpPr>
         <p:spPr>
           <a:xfrm flipV="1">
-            <a:off x="20171664" y="9427464"/>
-            <a:ext cx="2185416" cy="630936"/>
+            <a:off x="24277320" y="8183879"/>
+            <a:ext cx="2971800" cy="54865"/>
           </a:xfrm>
           <a:prstGeom prst="line">
             <a:avLst/>
           </a:prstGeom>
           <a:ln w="15240">
             <a:solidFill>
-              <a:srgbClr val="C65D37"/>
+              <a:srgbClr val="A64D67"/>
             </a:solidFill>
           </a:ln>
         </p:spPr>
@@ -7505,15 +7481,15 @@
         </p:nvCxnSpPr>
         <p:spPr>
           <a:xfrm>
-            <a:off x="20171664" y="10058400"/>
-            <a:ext cx="2185416" cy="557784"/>
+            <a:off x="24277320" y="8238744"/>
+            <a:ext cx="2971800" cy="640080"/>
           </a:xfrm>
           <a:prstGeom prst="line">
             <a:avLst/>
           </a:prstGeom>
           <a:ln w="15240">
             <a:solidFill>
-              <a:srgbClr val="C65D37"/>
+              <a:srgbClr val="A64D67"/>
             </a:solidFill>
           </a:ln>
         </p:spPr>
@@ -7532,16 +7508,86 @@
           </a:fontRef>
         </p:style>
       </p:cxnSp>
-      <p:sp>
-        <p:nvSpPr>
-          <p:cNvPr id="90" name="TextBox 89"/>
+      <p:cxnSp>
+        <p:nvCxnSpPr>
+          <p:cNvPr id="90" name="Connector 89"/>
+          <p:cNvCxnSpPr/>
+          <p:nvPr/>
+        </p:nvCxnSpPr>
+        <p:spPr>
+          <a:xfrm flipV="1">
+            <a:off x="24277320" y="8531351"/>
+            <a:ext cx="2971800" cy="146305"/>
+          </a:xfrm>
+          <a:prstGeom prst="line">
+            <a:avLst/>
+          </a:prstGeom>
+          <a:ln w="15240">
+            <a:solidFill>
+              <a:srgbClr val="C65D37"/>
+            </a:solidFill>
+          </a:ln>
+        </p:spPr>
+        <p:style>
+          <a:lnRef idx="2">
+            <a:schemeClr val="accent1"/>
+          </a:lnRef>
+          <a:fillRef idx="0">
+            <a:schemeClr val="accent1"/>
+          </a:fillRef>
+          <a:effectRef idx="1">
+            <a:schemeClr val="accent1"/>
+          </a:effectRef>
+          <a:fontRef idx="minor">
+            <a:schemeClr val="tx1"/>
+          </a:fontRef>
+        </p:style>
+      </p:cxnSp>
+      <p:cxnSp>
+        <p:nvCxnSpPr>
+          <p:cNvPr id="91" name="Connector 90"/>
+          <p:cNvCxnSpPr/>
+          <p:nvPr/>
+        </p:nvCxnSpPr>
+        <p:spPr>
+          <a:xfrm>
+            <a:off x="24277320" y="8677656"/>
+            <a:ext cx="2971800" cy="201168"/>
+          </a:xfrm>
+          <a:prstGeom prst="line">
+            <a:avLst/>
+          </a:prstGeom>
+          <a:ln w="15240">
+            <a:solidFill>
+              <a:srgbClr val="C65D37"/>
+            </a:solidFill>
+          </a:ln>
+        </p:spPr>
+        <p:style>
+          <a:lnRef idx="2">
+            <a:schemeClr val="accent1"/>
+          </a:lnRef>
+          <a:fillRef idx="0">
+            <a:schemeClr val="accent1"/>
+          </a:fillRef>
+          <a:effectRef idx="1">
+            <a:schemeClr val="accent1"/>
+          </a:effectRef>
+          <a:fontRef idx="minor">
+            <a:schemeClr val="tx1"/>
+          </a:fontRef>
+        </p:style>
+      </p:cxnSp>
+      <p:sp>
+        <p:nvSpPr>
+          <p:cNvPr id="92" name="TextBox 91"/>
           <p:cNvSpPr txBox="1"/>
           <p:nvPr/>
         </p:nvSpPr>
         <p:spPr>
           <a:xfrm>
-            <a:off x="15453360" y="10671048"/>
-            <a:ext cx="658368" cy="320040"/>
+            <a:off x="19220688" y="9052560"/>
+            <a:ext cx="603504" cy="320040"/>
           </a:xfrm>
           <a:prstGeom prst="rect">
             <a:avLst/>
@@ -7566,7 +7612,7 @@
               </a:spcAft>
             </a:pPr>
             <a:r>
-              <a:rPr sz="1250" b="0" i="0">
+              <a:rPr sz="1400" b="0" i="0">
                 <a:solidFill>
                   <a:srgbClr val="697889"/>
                 </a:solidFill>
@@ -7579,14 +7625,14 @@
       </p:sp>
       <p:sp>
         <p:nvSpPr>
-          <p:cNvPr id="91" name="TextBox 90"/>
+          <p:cNvPr id="93" name="TextBox 92"/>
           <p:cNvSpPr txBox="1"/>
           <p:nvPr/>
         </p:nvSpPr>
         <p:spPr>
           <a:xfrm>
-            <a:off x="19659600" y="10671048"/>
-            <a:ext cx="2560320" cy="320040"/>
+            <a:off x="21607272" y="9052560"/>
+            <a:ext cx="2834640" cy="320040"/>
           </a:xfrm>
           <a:prstGeom prst="rect">
             <a:avLst/>
@@ -7611,27 +7657,27 @@
               </a:spcAft>
             </a:pPr>
             <a:r>
-              <a:rPr sz="1250" b="0" i="0">
+              <a:rPr sz="1400" b="0" i="0">
                 <a:solidFill>
                   <a:srgbClr val="697889"/>
                 </a:solidFill>
                 <a:latin typeface="Arial"/>
               </a:rPr>
-              <a:t>annotated latent programs</a:t>
-            </a:r>
-          </a:p>
-        </p:txBody>
-      </p:sp>
-      <p:sp>
-        <p:nvSpPr>
-          <p:cNvPr id="92" name="TextBox 91"/>
+              <a:t>annotated latent program scores</a:t>
+            </a:r>
+          </a:p>
+        </p:txBody>
+      </p:sp>
+      <p:sp>
+        <p:nvSpPr>
+          <p:cNvPr id="94" name="TextBox 93"/>
           <p:cNvSpPr txBox="1"/>
           <p:nvPr/>
         </p:nvSpPr>
         <p:spPr>
           <a:xfrm>
-            <a:off x="21854160" y="10671048"/>
-            <a:ext cx="1371600" cy="320040"/>
+            <a:off x="24597360" y="9052560"/>
+            <a:ext cx="2240280" cy="320040"/>
           </a:xfrm>
           <a:prstGeom prst="rect">
             <a:avLst/>
@@ -7656,7 +7702,7 @@
               </a:spcAft>
             </a:pPr>
             <a:r>
-              <a:rPr sz="1250" b="0" i="0">
+              <a:rPr sz="1400" b="0" i="0">
                 <a:solidFill>
                   <a:srgbClr val="697889"/>
                 </a:solidFill>
@@ -7669,14 +7715,305 @@
       </p:sp>
       <p:sp>
         <p:nvSpPr>
-          <p:cNvPr id="93" name="Right Arrow 92"/>
+          <p:cNvPr id="95" name="TextBox 94"/>
+          <p:cNvSpPr txBox="1"/>
+          <p:nvPr/>
+        </p:nvSpPr>
+        <p:spPr>
+          <a:xfrm>
+            <a:off x="26471880" y="9052560"/>
+            <a:ext cx="1691640" cy="320040"/>
+          </a:xfrm>
+          <a:prstGeom prst="rect">
+            <a:avLst/>
+          </a:prstGeom>
+          <a:noFill/>
+        </p:spPr>
+        <p:txBody>
+          <a:bodyPr wrap="square" lIns="0" rIns="0" tIns="0" bIns="0" anchor="t">
+            <a:spAutoFit/>
+          </a:bodyPr>
+          <a:lstStyle/>
+          <a:p>
+            <a:pPr algn="ctr">
+              <a:lnSpc>
+                <a:spcPct val="100000"/>
+              </a:lnSpc>
+              <a:spcBef>
+                <a:spcPts val="0"/>
+              </a:spcBef>
+              <a:spcAft>
+                <a:spcPts val="0"/>
+              </a:spcAft>
+            </a:pPr>
+            <a:r>
+              <a:rPr sz="1400" b="0" i="0">
+                <a:solidFill>
+                  <a:srgbClr val="697889"/>
+                </a:solidFill>
+                <a:latin typeface="Arial"/>
+              </a:rPr>
+              <a:t>reconstructed genes</a:t>
+            </a:r>
+          </a:p>
+        </p:txBody>
+      </p:sp>
+      <p:sp>
+        <p:nvSpPr>
+          <p:cNvPr id="96" name="TextBox 95"/>
+          <p:cNvSpPr txBox="1"/>
+          <p:nvPr/>
+        </p:nvSpPr>
+        <p:spPr>
+          <a:xfrm>
+            <a:off x="14996159" y="9601200"/>
+            <a:ext cx="7406640" cy="329184"/>
+          </a:xfrm>
+          <a:prstGeom prst="rect">
+            <a:avLst/>
+          </a:prstGeom>
+          <a:noFill/>
+        </p:spPr>
+        <p:txBody>
+          <a:bodyPr wrap="square" lIns="0" rIns="0" tIns="0" bIns="0" anchor="t">
+            <a:spAutoFit/>
+          </a:bodyPr>
+          <a:lstStyle/>
+          <a:p>
+            <a:pPr algn="l">
+              <a:lnSpc>
+                <a:spcPct val="100000"/>
+              </a:lnSpc>
+              <a:spcBef>
+                <a:spcPts val="0"/>
+              </a:spcBef>
+              <a:spcAft>
+                <a:spcPts val="0"/>
+              </a:spcAft>
+            </a:pPr>
+            <a:r>
+              <a:rPr sz="1700" b="1" i="0">
+                <a:solidFill>
+                  <a:srgbClr val="D97800"/>
+                </a:solidFill>
+                <a:latin typeface="Arial"/>
+              </a:rPr>
+              <a:t>2  QUERY MAPPING AND CROSS-MISSION COMPARISON</a:t>
+            </a:r>
+          </a:p>
+        </p:txBody>
+      </p:sp>
+      <p:sp>
+        <p:nvSpPr>
+          <p:cNvPr id="97" name="Rounded Rectangle 96"/>
           <p:cNvSpPr/>
           <p:nvPr/>
         </p:nvSpPr>
         <p:spPr>
           <a:xfrm>
-            <a:off x="22860000" y="9070848"/>
-            <a:ext cx="987552" cy="384048"/>
+            <a:off x="14996159" y="9966960"/>
+            <a:ext cx="2926080" cy="987552"/>
+          </a:xfrm>
+          <a:prstGeom prst="roundRect">
+            <a:avLst>
+              <a:gd name="adj" fmla="val 6000"/>
+            </a:avLst>
+          </a:prstGeom>
+          <a:solidFill>
+            <a:srgbClr val="FAEFE7"/>
+          </a:solidFill>
+          <a:ln w="17780">
+            <a:solidFill>
+              <a:srgbClr val="D97800"/>
+            </a:solidFill>
+          </a:ln>
+        </p:spPr>
+        <p:style>
+          <a:lnRef idx="1">
+            <a:schemeClr val="accent1"/>
+          </a:lnRef>
+          <a:fillRef idx="3">
+            <a:schemeClr val="accent1"/>
+          </a:fillRef>
+          <a:effectRef idx="2">
+            <a:schemeClr val="accent1"/>
+          </a:effectRef>
+          <a:fontRef idx="minor">
+            <a:schemeClr val="lt1"/>
+          </a:fontRef>
+        </p:style>
+        <p:txBody>
+          <a:bodyPr rtlCol="0" anchor="ctr" wrap="square" bIns="36576"/>
+          <a:lstStyle/>
+          <a:p>
+            <a:pPr algn="ctr">
+              <a:spcAft>
+                <a:spcPts val="200"/>
+              </a:spcAft>
+            </a:pPr>
+            <a:r>
+              <a:rPr sz="1750" b="1">
+                <a:solidFill>
+                  <a:srgbClr val="071C3F"/>
+                </a:solidFill>
+                <a:latin typeface="Arial"/>
+              </a:rPr>
+              <a:t>NASA OSDR query</a:t>
+            </a:r>
+          </a:p>
+          <a:p>
+            <a:pPr algn="ctr">
+              <a:spcBef>
+                <a:spcPts val="0"/>
+              </a:spcBef>
+              <a:spcAft>
+                <a:spcPts val="0"/>
+              </a:spcAft>
+            </a:pPr>
+            <a:r>
+              <a:rPr sz="1400">
+                <a:solidFill>
+                  <a:srgbClr val="697889"/>
+                </a:solidFill>
+                <a:latin typeface="Arial"/>
+              </a:rPr>
+              <a:t>FLT and GC counts + accession</a:t>
+            </a:r>
+          </a:p>
+        </p:txBody>
+      </p:sp>
+      <p:sp>
+        <p:nvSpPr>
+          <p:cNvPr id="98" name="Right Arrow 97"/>
+          <p:cNvSpPr/>
+          <p:nvPr/>
+        </p:nvSpPr>
+        <p:spPr>
+          <a:xfrm>
+            <a:off x="18041112" y="10277856"/>
+            <a:ext cx="411480" cy="329184"/>
+          </a:xfrm>
+          <a:prstGeom prst="rightArrow">
+            <a:avLst/>
+          </a:prstGeom>
+          <a:solidFill>
+            <a:srgbClr val="D97800"/>
+          </a:solidFill>
+          <a:ln>
+            <a:noFill/>
+          </a:ln>
+        </p:spPr>
+        <p:style>
+          <a:lnRef idx="1">
+            <a:schemeClr val="accent1"/>
+          </a:lnRef>
+          <a:fillRef idx="3">
+            <a:schemeClr val="accent1"/>
+          </a:fillRef>
+          <a:effectRef idx="2">
+            <a:schemeClr val="accent1"/>
+          </a:effectRef>
+          <a:fontRef idx="minor">
+            <a:schemeClr val="lt1"/>
+          </a:fontRef>
+        </p:style>
+        <p:txBody>
+          <a:bodyPr rtlCol="0" anchor="ctr"/>
+          <a:lstStyle/>
+          <a:p>
+            <a:pPr algn="ctr"/>
+          </a:p>
+        </p:txBody>
+      </p:sp>
+      <p:sp>
+        <p:nvSpPr>
+          <p:cNvPr id="99" name="Rounded Rectangle 98"/>
+          <p:cNvSpPr/>
+          <p:nvPr/>
+        </p:nvSpPr>
+        <p:spPr>
+          <a:xfrm>
+            <a:off x="18562320" y="9966960"/>
+            <a:ext cx="2834640" cy="987552"/>
+          </a:xfrm>
+          <a:prstGeom prst="roundRect">
+            <a:avLst>
+              <a:gd name="adj" fmla="val 6000"/>
+            </a:avLst>
+          </a:prstGeom>
+          <a:solidFill>
+            <a:srgbClr val="FFFFFF"/>
+          </a:solidFill>
+          <a:ln w="17780">
+            <a:solidFill>
+              <a:srgbClr val="D97800"/>
+            </a:solidFill>
+          </a:ln>
+        </p:spPr>
+        <p:style>
+          <a:lnRef idx="1">
+            <a:schemeClr val="accent1"/>
+          </a:lnRef>
+          <a:fillRef idx="3">
+            <a:schemeClr val="accent1"/>
+          </a:fillRef>
+          <a:effectRef idx="2">
+            <a:schemeClr val="accent1"/>
+          </a:effectRef>
+          <a:fontRef idx="minor">
+            <a:schemeClr val="lt1"/>
+          </a:fontRef>
+        </p:style>
+        <p:txBody>
+          <a:bodyPr rtlCol="0" anchor="ctr" wrap="square" bIns="36576"/>
+          <a:lstStyle/>
+          <a:p>
+            <a:pPr algn="ctr">
+              <a:spcAft>
+                <a:spcPts val="200"/>
+              </a:spcAft>
+            </a:pPr>
+            <a:r>
+              <a:rPr sz="1700" b="1">
+                <a:solidFill>
+                  <a:srgbClr val="071C3F"/>
+                </a:solidFill>
+                <a:latin typeface="Arial"/>
+              </a:rPr>
+              <a:t>Reference-query map</a:t>
+            </a:r>
+          </a:p>
+          <a:p>
+            <a:pPr algn="ctr">
+              <a:spcBef>
+                <a:spcPts val="0"/>
+              </a:spcBef>
+              <a:spcAft>
+                <a:spcPts val="0"/>
+              </a:spcAft>
+            </a:pPr>
+            <a:r>
+              <a:rPr sz="1400">
+                <a:solidFill>
+                  <a:srgbClr val="697889"/>
+                </a:solidFill>
+                <a:latin typeface="Arial"/>
+              </a:rPr>
+              <a:t>scArches adaptation</a:t>
+            </a:r>
+          </a:p>
+        </p:txBody>
+      </p:sp>
+      <p:sp>
+        <p:nvSpPr>
+          <p:cNvPr id="100" name="Right Arrow 99"/>
+          <p:cNvSpPr/>
+          <p:nvPr/>
+        </p:nvSpPr>
+        <p:spPr>
+          <a:xfrm>
+            <a:off x="21515832" y="10277856"/>
+            <a:ext cx="411480" cy="329184"/>
           </a:xfrm>
           <a:prstGeom prst="rightArrow">
             <a:avLst/>
@@ -7712,14 +8049,14 @@
       </p:sp>
       <p:sp>
         <p:nvSpPr>
-          <p:cNvPr id="94" name="Rounded Rectangle 93"/>
+          <p:cNvPr id="101" name="Rounded Rectangle 100"/>
           <p:cNvSpPr/>
           <p:nvPr/>
         </p:nvSpPr>
         <p:spPr>
           <a:xfrm>
-            <a:off x="24277320" y="8430768"/>
-            <a:ext cx="3429000" cy="932688"/>
+            <a:off x="22037040" y="9966960"/>
+            <a:ext cx="2697480" cy="987552"/>
           </a:xfrm>
           <a:prstGeom prst="roundRect">
             <a:avLst>
@@ -7759,7 +8096,7 @@
               </a:spcAft>
             </a:pPr>
             <a:r>
-              <a:rPr sz="1600" b="1">
+              <a:rPr sz="1700" b="1">
                 <a:solidFill>
                   <a:srgbClr val="071C3F"/>
                 </a:solidFill>
@@ -7778,29 +8115,29 @@
               </a:spcAft>
             </a:pPr>
             <a:r>
-              <a:rPr sz="1250">
+              <a:rPr sz="1400">
                 <a:solidFill>
                   <a:srgbClr val="697889"/>
                 </a:solidFill>
                 <a:latin typeface="Arial"/>
               </a:rPr>
-              <a:t>posterior mean by sample</a:t>
-            </a:r>
-          </a:p>
-        </p:txBody>
-      </p:sp>
-      <p:sp>
-        <p:nvSpPr>
-          <p:cNvPr id="95" name="Down Arrow 94"/>
+              <a:t>posterior mean per sample</a:t>
+            </a:r>
+          </a:p>
+        </p:txBody>
+      </p:sp>
+      <p:sp>
+        <p:nvSpPr>
+          <p:cNvPr id="102" name="Right Arrow 101"/>
           <p:cNvSpPr/>
           <p:nvPr/>
         </p:nvSpPr>
         <p:spPr>
           <a:xfrm>
-            <a:off x="25831800" y="9436608"/>
-            <a:ext cx="329184" cy="310896"/>
-          </a:xfrm>
-          <a:prstGeom prst="downArrow">
+            <a:off x="24853392" y="10277856"/>
+            <a:ext cx="365760" cy="329184"/>
+          </a:xfrm>
+          <a:prstGeom prst="rightArrow">
             <a:avLst/>
           </a:prstGeom>
           <a:solidFill>
@@ -7834,14 +8171,14 @@
       </p:sp>
       <p:sp>
         <p:nvSpPr>
-          <p:cNvPr id="96" name="Rounded Rectangle 95"/>
+          <p:cNvPr id="103" name="Rounded Rectangle 102"/>
           <p:cNvSpPr/>
           <p:nvPr/>
         </p:nvSpPr>
         <p:spPr>
           <a:xfrm>
-            <a:off x="24277320" y="9774936"/>
-            <a:ext cx="3429000" cy="932688"/>
+            <a:off x="25328880" y="9966960"/>
+            <a:ext cx="3017520" cy="987552"/>
           </a:xfrm>
           <a:prstGeom prst="roundRect">
             <a:avLst>
@@ -7881,7 +8218,7 @@
               </a:spcAft>
             </a:pPr>
             <a:r>
-              <a:rPr sz="1600" b="1">
+              <a:rPr sz="1650" b="1">
                 <a:solidFill>
                   <a:srgbClr val="071C3F"/>
                 </a:solidFill>
@@ -7900,27 +8237,27 @@
               </a:spcAft>
             </a:pPr>
             <a:r>
-              <a:rPr sz="1250">
+              <a:rPr sz="1400">
                 <a:solidFill>
                   <a:srgbClr val="697889"/>
                 </a:solidFill>
                 <a:latin typeface="Arial"/>
               </a:rPr>
-              <a:t>mean FLT minus GC score</a:t>
-            </a:r>
-          </a:p>
-        </p:txBody>
-      </p:sp>
-      <p:sp>
-        <p:nvSpPr>
-          <p:cNvPr id="97" name="TextBox 96"/>
+              <a:t>equal-weight mean FLT minus GC</a:t>
+            </a:r>
+          </a:p>
+        </p:txBody>
+      </p:sp>
+      <p:sp>
+        <p:nvSpPr>
+          <p:cNvPr id="104" name="TextBox 103"/>
           <p:cNvSpPr txBox="1"/>
           <p:nvPr/>
         </p:nvSpPr>
         <p:spPr>
           <a:xfrm>
-            <a:off x="15087600" y="11475720"/>
-            <a:ext cx="13213080" cy="347472"/>
+            <a:off x="15087600" y="11439144"/>
+            <a:ext cx="13213080" cy="384048"/>
           </a:xfrm>
           <a:prstGeom prst="rect">
             <a:avLst/>
@@ -7945,7 +8282,7 @@
               </a:spcAft>
             </a:pPr>
             <a:r>
-              <a:rPr sz="1250" b="0" i="0">
+              <a:rPr sz="1400" b="0" i="0">
                 <a:solidFill>
                   <a:srgbClr val="697889"/>
                 </a:solidFill>
@@ -7958,7 +8295,7 @@
       </p:sp>
       <p:sp>
         <p:nvSpPr>
-          <p:cNvPr id="98" name="Rectangle 97"/>
+          <p:cNvPr id="105" name="Rectangle 104"/>
           <p:cNvSpPr/>
           <p:nvPr/>
         </p:nvSpPr>
@@ -8001,7 +8338,7 @@
       </p:sp>
       <p:sp>
         <p:nvSpPr>
-          <p:cNvPr id="99" name="Rectangle 98"/>
+          <p:cNvPr id="106" name="Rectangle 105"/>
           <p:cNvSpPr/>
           <p:nvPr/>
         </p:nvSpPr>
@@ -8046,7 +8383,7 @@
       </p:sp>
       <p:sp>
         <p:nvSpPr>
-          <p:cNvPr id="100" name="TextBox 99"/>
+          <p:cNvPr id="107" name="TextBox 106"/>
           <p:cNvSpPr txBox="1"/>
           <p:nvPr/>
         </p:nvSpPr>
@@ -8078,20 +8415,20 @@
               </a:spcAft>
             </a:pPr>
             <a:r>
-              <a:rPr sz="2000" b="1" i="0">
+              <a:rPr sz="2400" b="1" i="0">
                 <a:solidFill>
                   <a:srgbClr val="111111"/>
                 </a:solidFill>
                 <a:latin typeface="Arial"/>
               </a:rPr>
-              <a:t>RESULTS: CROSS-MISSION PATHWAY SHIFTS</a:t>
+              <a:t>RESULTS: ALL 13 PRIMARY RETAINED PATHWAY SHIFTS</a:t>
             </a:r>
           </a:p>
         </p:txBody>
       </p:sp>
       <p:pic>
         <p:nvPicPr>
-          <p:cNvPr id="101" name="Retained pathway shifts" descr="Project-balanced expiMap pathway shifts for thymus, skin, liver, and spleen, with project effects and three-training ranges."/>
+          <p:cNvPr id="108" name="Retained pathway shifts" descr="Project-balanced expiMap pathway shifts for thymus, skin, liver, and spleen, with project effects and three-training ranges."/>
           <p:cNvPicPr>
             <a:picLocks noChangeAspect="1"/>
           </p:cNvPicPr>
@@ -8105,8 +8442,8 @@
         </p:blipFill>
         <p:spPr>
           <a:xfrm>
-            <a:off x="17048695" y="13560552"/>
-            <a:ext cx="9290889" cy="8065008"/>
+            <a:off x="14813280" y="13770356"/>
+            <a:ext cx="13761720" cy="7645400"/>
           </a:xfrm>
           <a:prstGeom prst="rect">
             <a:avLst/>
@@ -8115,14 +8452,14 @@
       </p:pic>
       <p:sp>
         <p:nvSpPr>
-          <p:cNvPr id="102" name="TextBox 101"/>
+          <p:cNvPr id="109" name="TextBox 108"/>
           <p:cNvSpPr txBox="1"/>
           <p:nvPr/>
         </p:nvSpPr>
         <p:spPr>
           <a:xfrm>
-            <a:off x="15041880" y="21744432"/>
-            <a:ext cx="13304520" cy="502920"/>
+            <a:off x="15041880" y="21598128"/>
+            <a:ext cx="13304520" cy="713232"/>
           </a:xfrm>
           <a:prstGeom prst="rect">
             <a:avLst/>
@@ -8147,20 +8484,20 @@
               </a:spcAft>
             </a:pPr>
             <a:r>
-              <a:rPr sz="1350" b="0" i="1">
+              <a:rPr sz="1500" b="0" i="1">
                 <a:solidFill>
                   <a:srgbClr val="697889"/>
                 </a:solidFill>
                 <a:latin typeface="Arial"/>
               </a:rPr>
-              <a:t>Open circles are OSDR projects; colored ranges span three complete reference-query trainings. All displayed shifts are lower in flight; axes are tissue specific.</a:t>
-            </a:r>
-          </a:p>
-        </p:txBody>
-      </p:sp>
-      <p:sp>
-        <p:nvSpPr>
-          <p:cNvPr id="103" name="Rectangle 102"/>
+              <a:t>All 13 primary retained programs are shown; three exploratory kidney programs remain in the paper. Open circles are OSDR projects; colored ranges span three complete reference-query trainings. All displayed shifts are lower in flight; axes are tissue specific.</a:t>
+            </a:r>
+          </a:p>
+        </p:txBody>
+      </p:sp>
+      <p:sp>
+        <p:nvSpPr>
+          <p:cNvPr id="110" name="Rectangle 109"/>
           <p:cNvSpPr/>
           <p:nvPr/>
         </p:nvSpPr>
@@ -8203,7 +8540,7 @@
       </p:sp>
       <p:sp>
         <p:nvSpPr>
-          <p:cNvPr id="104" name="Rectangle 103"/>
+          <p:cNvPr id="111" name="Rectangle 110"/>
           <p:cNvSpPr/>
           <p:nvPr/>
         </p:nvSpPr>
@@ -8248,7 +8585,7 @@
       </p:sp>
       <p:sp>
         <p:nvSpPr>
-          <p:cNvPr id="105" name="TextBox 104"/>
+          <p:cNvPr id="112" name="TextBox 111"/>
           <p:cNvSpPr txBox="1"/>
           <p:nvPr/>
         </p:nvSpPr>
@@ -8280,7 +8617,7 @@
               </a:spcAft>
             </a:pPr>
             <a:r>
-              <a:rPr sz="2000" b="1" i="0">
+              <a:rPr sz="2400" b="1" i="0">
                 <a:solidFill>
                   <a:srgbClr val="111111"/>
                 </a:solidFill>
@@ -8293,7 +8630,7 @@
       </p:sp>
       <p:sp>
         <p:nvSpPr>
-          <p:cNvPr id="106" name="TextBox 105"/>
+          <p:cNvPr id="113" name="TextBox 112"/>
           <p:cNvSpPr txBox="1"/>
           <p:nvPr/>
         </p:nvSpPr>
@@ -8325,7 +8662,7 @@
               </a:spcAft>
             </a:pPr>
             <a:r>
-              <a:rPr sz="1700" b="1" i="0">
+              <a:rPr sz="1900" b="1" i="0">
                 <a:solidFill>
                   <a:srgbClr val="236DA2"/>
                 </a:solidFill>
@@ -8338,7 +8675,7 @@
       </p:sp>
       <p:pic>
         <p:nvPicPr>
-          <p:cNvPr id="107" name="Tissue-state hypotheses" descr="Observed lower expiMap program scores and qualified tissue-state hypotheses for thymus, skin, liver, and spleen."/>
+          <p:cNvPr id="114" name="Tissue-state hypotheses" descr="Observed lower expiMap program scores and qualified tissue-state hypotheses for thymus, skin, liver, and spleen."/>
           <p:cNvPicPr>
             <a:picLocks noChangeAspect="1"/>
           </p:cNvPicPr>
@@ -8362,7 +8699,7 @@
       </p:pic>
       <p:sp>
         <p:nvSpPr>
-          <p:cNvPr id="108" name="Rectangle 107"/>
+          <p:cNvPr id="115" name="Rectangle 114"/>
           <p:cNvSpPr/>
           <p:nvPr/>
         </p:nvSpPr>
@@ -8405,7 +8742,7 @@
       </p:sp>
       <p:sp>
         <p:nvSpPr>
-          <p:cNvPr id="109" name="Rectangle 108"/>
+          <p:cNvPr id="116" name="Rectangle 115"/>
           <p:cNvSpPr/>
           <p:nvPr/>
         </p:nvSpPr>
@@ -8450,7 +8787,7 @@
       </p:sp>
       <p:sp>
         <p:nvSpPr>
-          <p:cNvPr id="110" name="TextBox 109"/>
+          <p:cNvPr id="117" name="TextBox 116"/>
           <p:cNvSpPr txBox="1"/>
           <p:nvPr/>
         </p:nvSpPr>
@@ -8482,7 +8819,7 @@
               </a:spcAft>
             </a:pPr>
             <a:r>
-              <a:rPr sz="2200" b="1" i="0">
+              <a:rPr sz="2600" b="1" i="0">
                 <a:solidFill>
                   <a:srgbClr val="111111"/>
                 </a:solidFill>
@@ -8495,7 +8832,7 @@
       </p:sp>
       <p:sp>
         <p:nvSpPr>
-          <p:cNvPr id="111" name="TextBox 110"/>
+          <p:cNvPr id="118" name="TextBox 117"/>
           <p:cNvSpPr txBox="1"/>
           <p:nvPr/>
         </p:nvSpPr>
@@ -8527,7 +8864,7 @@
               </a:spcAft>
             </a:pPr>
             <a:r>
-              <a:rPr sz="1550">
+              <a:rPr sz="1800">
                 <a:solidFill>
                   <a:srgbClr val="33445D"/>
                 </a:solidFill>
@@ -8549,7 +8886,7 @@
               </a:spcAft>
             </a:pPr>
             <a:r>
-              <a:rPr sz="1550">
+              <a:rPr sz="1800">
                 <a:solidFill>
                   <a:srgbClr val="33445D"/>
                 </a:solidFill>
@@ -8571,7 +8908,7 @@
               </a:spcAft>
             </a:pPr>
             <a:r>
-              <a:rPr sz="1550">
+              <a:rPr sz="1800">
                 <a:solidFill>
                   <a:srgbClr val="33445D"/>
                 </a:solidFill>
@@ -8584,7 +8921,7 @@
       </p:sp>
       <p:sp>
         <p:nvSpPr>
-          <p:cNvPr id="112" name="Rectangle 111"/>
+          <p:cNvPr id="119" name="Rectangle 118"/>
           <p:cNvSpPr/>
           <p:nvPr/>
         </p:nvSpPr>
@@ -8627,7 +8964,7 @@
       </p:sp>
       <p:sp>
         <p:nvSpPr>
-          <p:cNvPr id="113" name="Rectangle 112"/>
+          <p:cNvPr id="120" name="Rectangle 119"/>
           <p:cNvSpPr/>
           <p:nvPr/>
         </p:nvSpPr>
@@ -8672,7 +9009,7 @@
       </p:sp>
       <p:sp>
         <p:nvSpPr>
-          <p:cNvPr id="114" name="TextBox 113"/>
+          <p:cNvPr id="121" name="TextBox 120"/>
           <p:cNvSpPr txBox="1"/>
           <p:nvPr/>
         </p:nvSpPr>
@@ -8704,7 +9041,7 @@
               </a:spcAft>
             </a:pPr>
             <a:r>
-              <a:rPr sz="1800" b="1" i="0">
+              <a:rPr sz="2200" b="1" i="0">
                 <a:solidFill>
                   <a:srgbClr val="111111"/>
                 </a:solidFill>
@@ -8717,7 +9054,7 @@
       </p:sp>
       <p:sp>
         <p:nvSpPr>
-          <p:cNvPr id="115" name="TextBox 114"/>
+          <p:cNvPr id="122" name="TextBox 121"/>
           <p:cNvSpPr txBox="1"/>
           <p:nvPr/>
         </p:nvSpPr>
@@ -8749,7 +9086,7 @@
               </a:spcAft>
             </a:pPr>
             <a:r>
-              <a:rPr sz="1350" b="0" i="0">
+              <a:rPr sz="1450" b="0" i="0">
                 <a:solidFill>
                   <a:srgbClr val="33445D"/>
                 </a:solidFill>
@@ -8762,7 +9099,7 @@
       </p:sp>
       <p:sp>
         <p:nvSpPr>
-          <p:cNvPr id="116" name="Rectangle 115"/>
+          <p:cNvPr id="123" name="Rectangle 122"/>
           <p:cNvSpPr/>
           <p:nvPr/>
         </p:nvSpPr>
@@ -8805,7 +9142,7 @@
       </p:sp>
       <p:sp>
         <p:nvSpPr>
-          <p:cNvPr id="117" name="TextBox 116"/>
+          <p:cNvPr id="124" name="TextBox 123"/>
           <p:cNvSpPr txBox="1"/>
           <p:nvPr/>
         </p:nvSpPr>
@@ -8837,7 +9174,7 @@
               </a:spcAft>
             </a:pPr>
             <a:r>
-              <a:rPr sz="2000" b="1" i="0">
+              <a:rPr sz="2200" b="1" i="0">
                 <a:solidFill>
                   <a:srgbClr val="697889"/>
                 </a:solidFill>
@@ -8850,7 +9187,7 @@
       </p:sp>
       <p:sp>
         <p:nvSpPr>
-          <p:cNvPr id="118" name="TextBox 117"/>
+          <p:cNvPr id="125" name="TextBox 124"/>
           <p:cNvSpPr txBox="1"/>
           <p:nvPr/>
         </p:nvSpPr>
@@ -8882,7 +9219,7 @@
               </a:spcAft>
             </a:pPr>
             <a:r>
-              <a:rPr sz="1450" b="0" i="0">
+              <a:rPr sz="1600" b="0" i="0">
                 <a:solidFill>
                   <a:srgbClr val="33445D"/>
                 </a:solidFill>
@@ -8895,7 +9232,7 @@
       </p:sp>
       <p:sp>
         <p:nvSpPr>
-          <p:cNvPr id="119" name="TextBox 118"/>
+          <p:cNvPr id="126" name="TextBox 125"/>
           <p:cNvSpPr txBox="1"/>
           <p:nvPr/>
         </p:nvSpPr>
@@ -8927,7 +9264,7 @@
               </a:spcAft>
             </a:pPr>
             <a:r>
-              <a:rPr sz="1450" b="1" i="0">
+              <a:rPr sz="1600" b="1" i="0">
                 <a:solidFill>
                   <a:srgbClr val="082552"/>
                 </a:solidFill>
@@ -8941,7 +9278,7 @@
       </p:sp>
       <p:sp>
         <p:nvSpPr>
-          <p:cNvPr id="120" name="TextBox 119"/>
+          <p:cNvPr id="127" name="TextBox 126"/>
           <p:cNvSpPr txBox="1"/>
           <p:nvPr/>
         </p:nvSpPr>
@@ -8973,7 +9310,7 @@
               </a:spcAft>
             </a:pPr>
             <a:r>
-              <a:rPr sz="1400" b="0" i="0">
+              <a:rPr sz="1500" b="0" i="0">
                 <a:solidFill>
                   <a:srgbClr val="697889"/>
                 </a:solidFill>

</xml_diff>

<commit_message>
refine poster typography and post-score annotation
</commit_message>
<xml_diff>
--- a/paper/asgsr_expimap_hvg/poster/asgsr_expimap_poster.pptx
+++ b/paper/asgsr_expimap_hvg/poster/asgsr_expimap_poster.pptx
@@ -3192,8 +3192,8 @@
         </p:nvSpPr>
         <p:spPr>
           <a:xfrm>
-            <a:off x="731520" y="841248"/>
-            <a:ext cx="38770560" cy="2194560"/>
+            <a:off x="548640" y="914400"/>
+            <a:ext cx="39136320" cy="749808"/>
           </a:xfrm>
           <a:prstGeom prst="rect">
             <a:avLst/>
@@ -3201,7 +3201,7 @@
           <a:noFill/>
         </p:spPr>
         <p:txBody>
-          <a:bodyPr wrap="square" lIns="0" rIns="0" tIns="0" bIns="0" anchor="ctr">
+          <a:bodyPr wrap="none" lIns="0" rIns="0" tIns="0" bIns="0" anchor="ctr">
             <a:spAutoFit/>
           </a:bodyPr>
           <a:lstStyle/>
@@ -3218,14 +3218,13 @@
               </a:spcAft>
             </a:pPr>
             <a:r>
-              <a:rPr sz="5400" b="1" i="0">
+              <a:rPr sz="5000" b="1" i="0">
                 <a:solidFill>
                   <a:srgbClr val="111111"/>
                 </a:solidFill>
                 <a:latin typeface="Arial"/>
               </a:rPr>
-              <a:t>Cross-mission expiMap analysis recovers established tissue responses
-and identifies complementary pathway shifts in mouse spaceflight transcriptomes</a:t>
+              <a:t>Cross-mission expiMap analysis recovers established tissue responses</a:t>
             </a:r>
           </a:p>
         </p:txBody>
@@ -3238,6 +3237,51 @@
         </p:nvSpPr>
         <p:spPr>
           <a:xfrm>
+            <a:off x="548640" y="1755648"/>
+            <a:ext cx="39136320" cy="749808"/>
+          </a:xfrm>
+          <a:prstGeom prst="rect">
+            <a:avLst/>
+          </a:prstGeom>
+          <a:noFill/>
+        </p:spPr>
+        <p:txBody>
+          <a:bodyPr wrap="none" lIns="0" rIns="0" tIns="0" bIns="0" anchor="ctr">
+            <a:spAutoFit/>
+          </a:bodyPr>
+          <a:lstStyle/>
+          <a:p>
+            <a:pPr algn="ctr">
+              <a:lnSpc>
+                <a:spcPct val="100000"/>
+              </a:lnSpc>
+              <a:spcBef>
+                <a:spcPts val="0"/>
+              </a:spcBef>
+              <a:spcAft>
+                <a:spcPts val="0"/>
+              </a:spcAft>
+            </a:pPr>
+            <a:r>
+              <a:rPr sz="5000" b="1" i="0">
+                <a:solidFill>
+                  <a:srgbClr val="111111"/>
+                </a:solidFill>
+                <a:latin typeface="Arial"/>
+              </a:rPr>
+              <a:t>and identifies complementary pathway shifts in mouse spaceflight transcriptomes</a:t>
+            </a:r>
+          </a:p>
+        </p:txBody>
+      </p:sp>
+      <p:sp>
+        <p:nvSpPr>
+          <p:cNvPr id="6" name="TextBox 5"/>
+          <p:cNvSpPr txBox="1"/>
+          <p:nvPr/>
+        </p:nvSpPr>
+        <p:spPr>
+          <a:xfrm>
             <a:off x="1371600" y="3383280"/>
             <a:ext cx="37490400" cy="658368"/>
           </a:xfrm>
@@ -3247,7 +3291,7 @@
           <a:noFill/>
         </p:spPr>
         <p:txBody>
-          <a:bodyPr wrap="square" lIns="0" rIns="0" tIns="0" bIns="0" anchor="ctr">
+          <a:bodyPr wrap="none" lIns="0" rIns="0" tIns="0" bIns="0" anchor="ctr">
             <a:spAutoFit/>
           </a:bodyPr>
           <a:lstStyle/>
@@ -3277,7 +3321,7 @@
       </p:sp>
       <p:pic>
         <p:nvPicPr>
-          <p:cNvPr id="6" name="Picture 5" descr="image.png"/>
+          <p:cNvPr id="7" name="Picture 6" descr="image.png"/>
           <p:cNvPicPr>
             <a:picLocks noChangeAspect="1"/>
           </p:cNvPicPr>
@@ -3301,7 +3345,7 @@
       </p:pic>
       <p:sp>
         <p:nvSpPr>
-          <p:cNvPr id="7" name="Rectangle 6"/>
+          <p:cNvPr id="8" name="Rectangle 7"/>
           <p:cNvSpPr/>
           <p:nvPr/>
         </p:nvSpPr>
@@ -3344,7 +3388,7 @@
       </p:sp>
       <p:sp>
         <p:nvSpPr>
-          <p:cNvPr id="8" name="Rectangle 7"/>
+          <p:cNvPr id="9" name="Rectangle 8"/>
           <p:cNvSpPr/>
           <p:nvPr/>
         </p:nvSpPr>
@@ -3389,7 +3433,7 @@
       </p:sp>
       <p:sp>
         <p:nvSpPr>
-          <p:cNvPr id="9" name="TextBox 8"/>
+          <p:cNvPr id="10" name="TextBox 9"/>
           <p:cNvSpPr txBox="1"/>
           <p:nvPr/>
         </p:nvSpPr>
@@ -3404,7 +3448,7 @@
           <a:noFill/>
         </p:spPr>
         <p:txBody>
-          <a:bodyPr wrap="square" lIns="0" rIns="0" tIns="0" bIns="0" anchor="ctr">
+          <a:bodyPr wrap="none" lIns="0" rIns="0" tIns="0" bIns="0" anchor="ctr">
             <a:spAutoFit/>
           </a:bodyPr>
           <a:lstStyle/>
@@ -3434,7 +3478,7 @@
       </p:sp>
       <p:sp>
         <p:nvSpPr>
-          <p:cNvPr id="10" name="TextBox 9"/>
+          <p:cNvPr id="11" name="TextBox 10"/>
           <p:cNvSpPr txBox="1"/>
           <p:nvPr/>
         </p:nvSpPr>
@@ -3479,7 +3523,7 @@
       </p:sp>
       <p:sp>
         <p:nvSpPr>
-          <p:cNvPr id="11" name="Rectangle 10"/>
+          <p:cNvPr id="12" name="Rectangle 11"/>
           <p:cNvSpPr/>
           <p:nvPr/>
         </p:nvSpPr>
@@ -3522,7 +3566,7 @@
       </p:sp>
       <p:sp>
         <p:nvSpPr>
-          <p:cNvPr id="12" name="Rectangle 11"/>
+          <p:cNvPr id="13" name="Rectangle 12"/>
           <p:cNvSpPr/>
           <p:nvPr/>
         </p:nvSpPr>
@@ -3567,7 +3611,7 @@
       </p:sp>
       <p:sp>
         <p:nvSpPr>
-          <p:cNvPr id="13" name="TextBox 12"/>
+          <p:cNvPr id="14" name="TextBox 13"/>
           <p:cNvSpPr txBox="1"/>
           <p:nvPr/>
         </p:nvSpPr>
@@ -3582,7 +3626,7 @@
           <a:noFill/>
         </p:spPr>
         <p:txBody>
-          <a:bodyPr wrap="square" lIns="0" rIns="0" tIns="0" bIns="0" anchor="ctr">
+          <a:bodyPr wrap="none" lIns="0" rIns="0" tIns="0" bIns="0" anchor="ctr">
             <a:spAutoFit/>
           </a:bodyPr>
           <a:lstStyle/>
@@ -3612,7 +3656,7 @@
       </p:sp>
       <p:sp>
         <p:nvSpPr>
-          <p:cNvPr id="14" name="TextBox 13"/>
+          <p:cNvPr id="15" name="TextBox 14"/>
           <p:cNvSpPr txBox="1"/>
           <p:nvPr/>
         </p:nvSpPr>
@@ -3657,7 +3701,7 @@
       </p:sp>
       <p:sp>
         <p:nvSpPr>
-          <p:cNvPr id="15" name="TextBox 14"/>
+          <p:cNvPr id="16" name="TextBox 15"/>
           <p:cNvSpPr txBox="1"/>
           <p:nvPr/>
         </p:nvSpPr>
@@ -3672,7 +3716,7 @@
           <a:noFill/>
         </p:spPr>
         <p:txBody>
-          <a:bodyPr wrap="square" lIns="0" rIns="0" tIns="0" bIns="0" anchor="t">
+          <a:bodyPr wrap="none" lIns="0" rIns="0" tIns="0" bIns="0" anchor="t">
             <a:spAutoFit/>
           </a:bodyPr>
           <a:lstStyle/>
@@ -3689,20 +3733,20 @@
               </a:spcAft>
             </a:pPr>
             <a:r>
-              <a:rPr sz="2600" b="1" i="0">
+              <a:rPr sz="2500" b="1" i="0">
                 <a:solidFill>
                   <a:srgbClr val="071C3F"/>
                 </a:solidFill>
                 <a:latin typeface="Arial"/>
               </a:rPr>
-              <a:t>Identify gene programs that respond consistently to spaceflight across missions.</a:t>
-            </a:r>
-          </a:p>
-        </p:txBody>
-      </p:sp>
-      <p:sp>
-        <p:nvSpPr>
-          <p:cNvPr id="16" name="TextBox 15"/>
+              <a:t>Identify gene programs that shift consistently across spaceflight missions.</a:t>
+            </a:r>
+          </a:p>
+        </p:txBody>
+      </p:sp>
+      <p:sp>
+        <p:nvSpPr>
+          <p:cNvPr id="17" name="TextBox 16"/>
           <p:cNvSpPr txBox="1"/>
           <p:nvPr/>
         </p:nvSpPr>
@@ -3747,7 +3791,7 @@
       </p:sp>
       <p:sp>
         <p:nvSpPr>
-          <p:cNvPr id="17" name="TextBox 16"/>
+          <p:cNvPr id="18" name="TextBox 17"/>
           <p:cNvSpPr txBox="1"/>
           <p:nvPr/>
         </p:nvSpPr>
@@ -3762,7 +3806,7 @@
           <a:noFill/>
         </p:spPr>
         <p:txBody>
-          <a:bodyPr wrap="square" lIns="0" rIns="0" tIns="0" bIns="0" anchor="ctr">
+          <a:bodyPr wrap="none" lIns="0" rIns="0" tIns="0" bIns="0" anchor="ctr">
             <a:spAutoFit/>
           </a:bodyPr>
           <a:lstStyle/>
@@ -3779,7 +3823,7 @@
               </a:spcAft>
             </a:pPr>
             <a:r>
-              <a:rPr sz="1800" b="1" i="0">
+              <a:rPr sz="1700" b="1" i="0">
                 <a:solidFill>
                   <a:srgbClr val="071C3F"/>
                 </a:solidFill>
@@ -3792,7 +3836,7 @@
       </p:sp>
       <p:sp>
         <p:nvSpPr>
-          <p:cNvPr id="18" name="Rounded Rectangle 17"/>
+          <p:cNvPr id="19" name="Rounded Rectangle 18"/>
           <p:cNvSpPr/>
           <p:nvPr/>
         </p:nvSpPr>
@@ -3835,7 +3879,7 @@
       </p:sp>
       <p:sp>
         <p:nvSpPr>
-          <p:cNvPr id="19" name="TextBox 18"/>
+          <p:cNvPr id="20" name="TextBox 19"/>
           <p:cNvSpPr txBox="1"/>
           <p:nvPr/>
         </p:nvSpPr>
@@ -3850,7 +3894,7 @@
           <a:noFill/>
         </p:spPr>
         <p:txBody>
-          <a:bodyPr wrap="square" lIns="0" rIns="0" tIns="0" bIns="0" anchor="ctr">
+          <a:bodyPr wrap="none" lIns="0" rIns="0" tIns="0" bIns="0" anchor="ctr">
             <a:spAutoFit/>
           </a:bodyPr>
           <a:lstStyle/>
@@ -3880,7 +3924,7 @@
       </p:sp>
       <p:sp>
         <p:nvSpPr>
-          <p:cNvPr id="20" name="TextBox 19"/>
+          <p:cNvPr id="21" name="TextBox 20"/>
           <p:cNvSpPr txBox="1"/>
           <p:nvPr/>
         </p:nvSpPr>
@@ -3895,7 +3939,7 @@
           <a:noFill/>
         </p:spPr>
         <p:txBody>
-          <a:bodyPr wrap="square" lIns="0" rIns="0" tIns="0" bIns="0" anchor="ctr">
+          <a:bodyPr wrap="none" lIns="0" rIns="0" tIns="0" bIns="0" anchor="ctr">
             <a:spAutoFit/>
           </a:bodyPr>
           <a:lstStyle/>
@@ -3925,7 +3969,7 @@
       </p:sp>
       <p:sp>
         <p:nvSpPr>
-          <p:cNvPr id="21" name="Rounded Rectangle 20"/>
+          <p:cNvPr id="22" name="Rounded Rectangle 21"/>
           <p:cNvSpPr/>
           <p:nvPr/>
         </p:nvSpPr>
@@ -3968,7 +4012,7 @@
       </p:sp>
       <p:sp>
         <p:nvSpPr>
-          <p:cNvPr id="22" name="TextBox 21"/>
+          <p:cNvPr id="23" name="TextBox 22"/>
           <p:cNvSpPr txBox="1"/>
           <p:nvPr/>
         </p:nvSpPr>
@@ -3983,7 +4027,7 @@
           <a:noFill/>
         </p:spPr>
         <p:txBody>
-          <a:bodyPr wrap="square" lIns="0" rIns="0" tIns="0" bIns="0" anchor="ctr">
+          <a:bodyPr wrap="none" lIns="0" rIns="0" tIns="0" bIns="0" anchor="ctr">
             <a:spAutoFit/>
           </a:bodyPr>
           <a:lstStyle/>
@@ -4013,7 +4057,7 @@
       </p:sp>
       <p:sp>
         <p:nvSpPr>
-          <p:cNvPr id="23" name="TextBox 22"/>
+          <p:cNvPr id="24" name="TextBox 23"/>
           <p:cNvSpPr txBox="1"/>
           <p:nvPr/>
         </p:nvSpPr>
@@ -4028,7 +4072,7 @@
           <a:noFill/>
         </p:spPr>
         <p:txBody>
-          <a:bodyPr wrap="square" lIns="0" rIns="0" tIns="0" bIns="0" anchor="ctr">
+          <a:bodyPr wrap="none" lIns="0" rIns="0" tIns="0" bIns="0" anchor="ctr">
             <a:spAutoFit/>
           </a:bodyPr>
           <a:lstStyle/>
@@ -4058,7 +4102,7 @@
       </p:sp>
       <p:sp>
         <p:nvSpPr>
-          <p:cNvPr id="24" name="Rounded Rectangle 23"/>
+          <p:cNvPr id="25" name="Rounded Rectangle 24"/>
           <p:cNvSpPr/>
           <p:nvPr/>
         </p:nvSpPr>
@@ -4101,7 +4145,7 @@
       </p:sp>
       <p:sp>
         <p:nvSpPr>
-          <p:cNvPr id="25" name="TextBox 24"/>
+          <p:cNvPr id="26" name="TextBox 25"/>
           <p:cNvSpPr txBox="1"/>
           <p:nvPr/>
         </p:nvSpPr>
@@ -4116,7 +4160,7 @@
           <a:noFill/>
         </p:spPr>
         <p:txBody>
-          <a:bodyPr wrap="square" lIns="0" rIns="0" tIns="0" bIns="0" anchor="ctr">
+          <a:bodyPr wrap="none" lIns="0" rIns="0" tIns="0" bIns="0" anchor="ctr">
             <a:spAutoFit/>
           </a:bodyPr>
           <a:lstStyle/>
@@ -4146,7 +4190,7 @@
       </p:sp>
       <p:sp>
         <p:nvSpPr>
-          <p:cNvPr id="26" name="TextBox 25"/>
+          <p:cNvPr id="27" name="TextBox 26"/>
           <p:cNvSpPr txBox="1"/>
           <p:nvPr/>
         </p:nvSpPr>
@@ -4161,7 +4205,7 @@
           <a:noFill/>
         </p:spPr>
         <p:txBody>
-          <a:bodyPr wrap="square" lIns="0" rIns="0" tIns="0" bIns="0" anchor="ctr">
+          <a:bodyPr wrap="none" lIns="0" rIns="0" tIns="0" bIns="0" anchor="ctr">
             <a:spAutoFit/>
           </a:bodyPr>
           <a:lstStyle/>
@@ -4191,7 +4235,7 @@
       </p:sp>
       <p:sp>
         <p:nvSpPr>
-          <p:cNvPr id="27" name="Rounded Rectangle 26"/>
+          <p:cNvPr id="28" name="Rounded Rectangle 27"/>
           <p:cNvSpPr/>
           <p:nvPr/>
         </p:nvSpPr>
@@ -4234,7 +4278,7 @@
       </p:sp>
       <p:sp>
         <p:nvSpPr>
-          <p:cNvPr id="28" name="TextBox 27"/>
+          <p:cNvPr id="29" name="TextBox 28"/>
           <p:cNvSpPr txBox="1"/>
           <p:nvPr/>
         </p:nvSpPr>
@@ -4249,7 +4293,7 @@
           <a:noFill/>
         </p:spPr>
         <p:txBody>
-          <a:bodyPr wrap="square" lIns="0" rIns="0" tIns="0" bIns="0" anchor="ctr">
+          <a:bodyPr wrap="none" lIns="0" rIns="0" tIns="0" bIns="0" anchor="ctr">
             <a:spAutoFit/>
           </a:bodyPr>
           <a:lstStyle/>
@@ -4279,7 +4323,7 @@
       </p:sp>
       <p:sp>
         <p:nvSpPr>
-          <p:cNvPr id="29" name="TextBox 28"/>
+          <p:cNvPr id="30" name="TextBox 29"/>
           <p:cNvSpPr txBox="1"/>
           <p:nvPr/>
         </p:nvSpPr>
@@ -4324,7 +4368,7 @@
       </p:sp>
       <p:sp>
         <p:nvSpPr>
-          <p:cNvPr id="30" name="TextBox 29"/>
+          <p:cNvPr id="31" name="TextBox 30"/>
           <p:cNvSpPr txBox="1"/>
           <p:nvPr/>
         </p:nvSpPr>
@@ -4369,7 +4413,7 @@
       </p:sp>
       <p:graphicFrame>
         <p:nvGraphicFramePr>
-          <p:cNvPr id="31" name="Table 30"/>
+          <p:cNvPr id="32" name="Table 31"/>
           <p:cNvGraphicFramePr>
             <a:graphicFrameLocks noGrp="1"/>
           </p:cNvGraphicFramePr>
@@ -4395,7 +4439,7 @@
               <a:tr h="740664">
                 <a:tc>
                   <a:txBody>
-                    <a:bodyPr anchor="ctr"/>
+                    <a:bodyPr wrap="none" anchor="ctr"/>
                     <a:lstStyle/>
                     <a:p>
                       <a:pPr algn="l"/>
@@ -4418,7 +4462,7 @@
                 </a:tc>
                 <a:tc>
                   <a:txBody>
-                    <a:bodyPr anchor="ctr"/>
+                    <a:bodyPr wrap="none" anchor="ctr"/>
                     <a:lstStyle/>
                     <a:p>
                       <a:pPr algn="ctr"/>
@@ -4441,7 +4485,7 @@
                 </a:tc>
                 <a:tc>
                   <a:txBody>
-                    <a:bodyPr anchor="ctr"/>
+                    <a:bodyPr wrap="none" anchor="ctr"/>
                     <a:lstStyle/>
                     <a:p>
                       <a:pPr algn="ctr"/>
@@ -4464,7 +4508,7 @@
                 </a:tc>
                 <a:tc>
                   <a:txBody>
-                    <a:bodyPr anchor="ctr"/>
+                    <a:bodyPr wrap="none" anchor="ctr"/>
                     <a:lstStyle/>
                     <a:p>
                       <a:pPr algn="ctr"/>
@@ -4487,7 +4531,7 @@
                 </a:tc>
                 <a:tc>
                   <a:txBody>
-                    <a:bodyPr anchor="ctr"/>
+                    <a:bodyPr wrap="none" anchor="ctr"/>
                     <a:lstStyle/>
                     <a:p>
                       <a:pPr algn="ctr"/>
@@ -4512,7 +4556,7 @@
               <a:tr h="740664">
                 <a:tc>
                   <a:txBody>
-                    <a:bodyPr anchor="ctr"/>
+                    <a:bodyPr wrap="none" anchor="ctr"/>
                     <a:lstStyle/>
                     <a:p>
                       <a:pPr algn="l"/>
@@ -4535,7 +4579,7 @@
                 </a:tc>
                 <a:tc>
                   <a:txBody>
-                    <a:bodyPr anchor="ctr"/>
+                    <a:bodyPr wrap="none" anchor="ctr"/>
                     <a:lstStyle/>
                     <a:p>
                       <a:pPr algn="ctr"/>
@@ -4558,7 +4602,7 @@
                 </a:tc>
                 <a:tc>
                   <a:txBody>
-                    <a:bodyPr anchor="ctr"/>
+                    <a:bodyPr wrap="none" anchor="ctr"/>
                     <a:lstStyle/>
                     <a:p>
                       <a:pPr algn="ctr"/>
@@ -4581,7 +4625,7 @@
                 </a:tc>
                 <a:tc>
                   <a:txBody>
-                    <a:bodyPr anchor="ctr"/>
+                    <a:bodyPr wrap="none" anchor="ctr"/>
                     <a:lstStyle/>
                     <a:p>
                       <a:pPr algn="ctr"/>
@@ -4604,7 +4648,7 @@
                 </a:tc>
                 <a:tc>
                   <a:txBody>
-                    <a:bodyPr anchor="ctr"/>
+                    <a:bodyPr wrap="none" anchor="ctr"/>
                     <a:lstStyle/>
                     <a:p>
                       <a:pPr algn="ctr"/>
@@ -4629,7 +4673,7 @@
               <a:tr h="740664">
                 <a:tc>
                   <a:txBody>
-                    <a:bodyPr anchor="ctr"/>
+                    <a:bodyPr wrap="none" anchor="ctr"/>
                     <a:lstStyle/>
                     <a:p>
                       <a:pPr algn="l"/>
@@ -4652,7 +4696,7 @@
                 </a:tc>
                 <a:tc>
                   <a:txBody>
-                    <a:bodyPr anchor="ctr"/>
+                    <a:bodyPr wrap="none" anchor="ctr"/>
                     <a:lstStyle/>
                     <a:p>
                       <a:pPr algn="ctr"/>
@@ -4675,7 +4719,7 @@
                 </a:tc>
                 <a:tc>
                   <a:txBody>
-                    <a:bodyPr anchor="ctr"/>
+                    <a:bodyPr wrap="none" anchor="ctr"/>
                     <a:lstStyle/>
                     <a:p>
                       <a:pPr algn="ctr"/>
@@ -4698,7 +4742,7 @@
                 </a:tc>
                 <a:tc>
                   <a:txBody>
-                    <a:bodyPr anchor="ctr"/>
+                    <a:bodyPr wrap="none" anchor="ctr"/>
                     <a:lstStyle/>
                     <a:p>
                       <a:pPr algn="ctr"/>
@@ -4721,7 +4765,7 @@
                 </a:tc>
                 <a:tc>
                   <a:txBody>
-                    <a:bodyPr anchor="ctr"/>
+                    <a:bodyPr wrap="none" anchor="ctr"/>
                     <a:lstStyle/>
                     <a:p>
                       <a:pPr algn="ctr"/>
@@ -4746,7 +4790,7 @@
               <a:tr h="740664">
                 <a:tc>
                   <a:txBody>
-                    <a:bodyPr anchor="ctr"/>
+                    <a:bodyPr wrap="none" anchor="ctr"/>
                     <a:lstStyle/>
                     <a:p>
                       <a:pPr algn="l"/>
@@ -4769,7 +4813,7 @@
                 </a:tc>
                 <a:tc>
                   <a:txBody>
-                    <a:bodyPr anchor="ctr"/>
+                    <a:bodyPr wrap="none" anchor="ctr"/>
                     <a:lstStyle/>
                     <a:p>
                       <a:pPr algn="ctr"/>
@@ -4792,7 +4836,7 @@
                 </a:tc>
                 <a:tc>
                   <a:txBody>
-                    <a:bodyPr anchor="ctr"/>
+                    <a:bodyPr wrap="none" anchor="ctr"/>
                     <a:lstStyle/>
                     <a:p>
                       <a:pPr algn="ctr"/>
@@ -4815,7 +4859,7 @@
                 </a:tc>
                 <a:tc>
                   <a:txBody>
-                    <a:bodyPr anchor="ctr"/>
+                    <a:bodyPr wrap="none" anchor="ctr"/>
                     <a:lstStyle/>
                     <a:p>
                       <a:pPr algn="ctr"/>
@@ -4838,7 +4882,7 @@
                 </a:tc>
                 <a:tc>
                   <a:txBody>
-                    <a:bodyPr anchor="ctr"/>
+                    <a:bodyPr wrap="none" anchor="ctr"/>
                     <a:lstStyle/>
                     <a:p>
                       <a:pPr algn="ctr"/>
@@ -4863,7 +4907,7 @@
               <a:tr h="740664">
                 <a:tc>
                   <a:txBody>
-                    <a:bodyPr anchor="ctr"/>
+                    <a:bodyPr wrap="none" anchor="ctr"/>
                     <a:lstStyle/>
                     <a:p>
                       <a:pPr algn="l"/>
@@ -4886,7 +4930,7 @@
                 </a:tc>
                 <a:tc>
                   <a:txBody>
-                    <a:bodyPr anchor="ctr"/>
+                    <a:bodyPr wrap="none" anchor="ctr"/>
                     <a:lstStyle/>
                     <a:p>
                       <a:pPr algn="ctr"/>
@@ -4909,7 +4953,7 @@
                 </a:tc>
                 <a:tc>
                   <a:txBody>
-                    <a:bodyPr anchor="ctr"/>
+                    <a:bodyPr wrap="none" anchor="ctr"/>
                     <a:lstStyle/>
                     <a:p>
                       <a:pPr algn="ctr"/>
@@ -4932,7 +4976,7 @@
                 </a:tc>
                 <a:tc>
                   <a:txBody>
-                    <a:bodyPr anchor="ctr"/>
+                    <a:bodyPr wrap="none" anchor="ctr"/>
                     <a:lstStyle/>
                     <a:p>
                       <a:pPr algn="ctr"/>
@@ -4955,7 +4999,7 @@
                 </a:tc>
                 <a:tc>
                   <a:txBody>
-                    <a:bodyPr anchor="ctr"/>
+                    <a:bodyPr wrap="none" anchor="ctr"/>
                     <a:lstStyle/>
                     <a:p>
                       <a:pPr algn="ctr"/>
@@ -4983,7 +5027,7 @@
       </p:graphicFrame>
       <p:sp>
         <p:nvSpPr>
-          <p:cNvPr id="32" name="TextBox 31"/>
+          <p:cNvPr id="33" name="TextBox 32"/>
           <p:cNvSpPr txBox="1"/>
           <p:nvPr/>
         </p:nvSpPr>
@@ -5028,7 +5072,7 @@
       </p:sp>
       <p:sp>
         <p:nvSpPr>
-          <p:cNvPr id="33" name="TextBox 32"/>
+          <p:cNvPr id="34" name="TextBox 33"/>
           <p:cNvSpPr txBox="1"/>
           <p:nvPr/>
         </p:nvSpPr>
@@ -5073,7 +5117,7 @@
       </p:sp>
       <p:sp>
         <p:nvSpPr>
-          <p:cNvPr id="34" name="Rounded Rectangle 33"/>
+          <p:cNvPr id="35" name="Rounded Rectangle 34"/>
           <p:cNvSpPr/>
           <p:nvPr/>
         </p:nvSpPr>
@@ -5120,7 +5164,7 @@
       </p:sp>
       <p:sp>
         <p:nvSpPr>
-          <p:cNvPr id="35" name="TextBox 34"/>
+          <p:cNvPr id="36" name="TextBox 35"/>
           <p:cNvSpPr txBox="1"/>
           <p:nvPr/>
         </p:nvSpPr>
@@ -5135,7 +5179,7 @@
           <a:noFill/>
         </p:spPr>
         <p:txBody>
-          <a:bodyPr wrap="square" lIns="0" rIns="0" tIns="0" bIns="0" anchor="ctr">
+          <a:bodyPr wrap="none" lIns="0" rIns="0" tIns="0" bIns="0" anchor="ctr">
             <a:spAutoFit/>
           </a:bodyPr>
           <a:lstStyle/>
@@ -5165,7 +5209,7 @@
       </p:sp>
       <p:sp>
         <p:nvSpPr>
-          <p:cNvPr id="36" name="Rounded Rectangle 35"/>
+          <p:cNvPr id="37" name="Rounded Rectangle 36"/>
           <p:cNvSpPr/>
           <p:nvPr/>
         </p:nvSpPr>
@@ -5212,7 +5256,7 @@
       </p:sp>
       <p:sp>
         <p:nvSpPr>
-          <p:cNvPr id="37" name="TextBox 36"/>
+          <p:cNvPr id="38" name="TextBox 37"/>
           <p:cNvSpPr txBox="1"/>
           <p:nvPr/>
         </p:nvSpPr>
@@ -5227,7 +5271,7 @@
           <a:noFill/>
         </p:spPr>
         <p:txBody>
-          <a:bodyPr wrap="square" lIns="0" rIns="0" tIns="0" bIns="0" anchor="ctr">
+          <a:bodyPr wrap="none" lIns="0" rIns="0" tIns="0" bIns="0" anchor="ctr">
             <a:spAutoFit/>
           </a:bodyPr>
           <a:lstStyle/>
@@ -5257,7 +5301,7 @@
       </p:sp>
       <p:sp>
         <p:nvSpPr>
-          <p:cNvPr id="38" name="Rounded Rectangle 37"/>
+          <p:cNvPr id="39" name="Rounded Rectangle 38"/>
           <p:cNvSpPr/>
           <p:nvPr/>
         </p:nvSpPr>
@@ -5304,7 +5348,7 @@
       </p:sp>
       <p:sp>
         <p:nvSpPr>
-          <p:cNvPr id="39" name="TextBox 38"/>
+          <p:cNvPr id="40" name="TextBox 39"/>
           <p:cNvSpPr txBox="1"/>
           <p:nvPr/>
         </p:nvSpPr>
@@ -5319,7 +5363,7 @@
           <a:noFill/>
         </p:spPr>
         <p:txBody>
-          <a:bodyPr wrap="square" lIns="0" rIns="0" tIns="0" bIns="0" anchor="ctr">
+          <a:bodyPr wrap="none" lIns="0" rIns="0" tIns="0" bIns="0" anchor="ctr">
             <a:spAutoFit/>
           </a:bodyPr>
           <a:lstStyle/>
@@ -5349,7 +5393,7 @@
       </p:sp>
       <p:sp>
         <p:nvSpPr>
-          <p:cNvPr id="40" name="Rounded Rectangle 39"/>
+          <p:cNvPr id="41" name="Rounded Rectangle 40"/>
           <p:cNvSpPr/>
           <p:nvPr/>
         </p:nvSpPr>
@@ -5396,7 +5440,7 @@
       </p:sp>
       <p:sp>
         <p:nvSpPr>
-          <p:cNvPr id="41" name="TextBox 40"/>
+          <p:cNvPr id="42" name="TextBox 41"/>
           <p:cNvSpPr txBox="1"/>
           <p:nvPr/>
         </p:nvSpPr>
@@ -5411,7 +5455,7 @@
           <a:noFill/>
         </p:spPr>
         <p:txBody>
-          <a:bodyPr wrap="square" lIns="0" rIns="0" tIns="0" bIns="0" anchor="ctr">
+          <a:bodyPr wrap="none" lIns="0" rIns="0" tIns="0" bIns="0" anchor="ctr">
             <a:spAutoFit/>
           </a:bodyPr>
           <a:lstStyle/>
@@ -5441,7 +5485,7 @@
       </p:sp>
       <p:sp>
         <p:nvSpPr>
-          <p:cNvPr id="42" name="Rounded Rectangle 41"/>
+          <p:cNvPr id="43" name="Rounded Rectangle 42"/>
           <p:cNvSpPr/>
           <p:nvPr/>
         </p:nvSpPr>
@@ -5488,7 +5532,7 @@
       </p:sp>
       <p:sp>
         <p:nvSpPr>
-          <p:cNvPr id="43" name="TextBox 42"/>
+          <p:cNvPr id="44" name="TextBox 43"/>
           <p:cNvSpPr txBox="1"/>
           <p:nvPr/>
         </p:nvSpPr>
@@ -5503,7 +5547,7 @@
           <a:noFill/>
         </p:spPr>
         <p:txBody>
-          <a:bodyPr wrap="square" lIns="0" rIns="0" tIns="0" bIns="0" anchor="ctr">
+          <a:bodyPr wrap="none" lIns="0" rIns="0" tIns="0" bIns="0" anchor="ctr">
             <a:spAutoFit/>
           </a:bodyPr>
           <a:lstStyle/>
@@ -5533,7 +5577,7 @@
       </p:sp>
       <p:sp>
         <p:nvSpPr>
-          <p:cNvPr id="44" name="Rounded Rectangle 43"/>
+          <p:cNvPr id="45" name="Rounded Rectangle 44"/>
           <p:cNvSpPr/>
           <p:nvPr/>
         </p:nvSpPr>
@@ -5580,7 +5624,7 @@
       </p:sp>
       <p:sp>
         <p:nvSpPr>
-          <p:cNvPr id="45" name="TextBox 44"/>
+          <p:cNvPr id="46" name="TextBox 45"/>
           <p:cNvSpPr txBox="1"/>
           <p:nvPr/>
         </p:nvSpPr>
@@ -5595,7 +5639,7 @@
           <a:noFill/>
         </p:spPr>
         <p:txBody>
-          <a:bodyPr wrap="square" lIns="0" rIns="0" tIns="0" bIns="0" anchor="ctr">
+          <a:bodyPr wrap="none" lIns="0" rIns="0" tIns="0" bIns="0" anchor="ctr">
             <a:spAutoFit/>
           </a:bodyPr>
           <a:lstStyle/>
@@ -5625,7 +5669,7 @@
       </p:sp>
       <p:sp>
         <p:nvSpPr>
-          <p:cNvPr id="46" name="TextBox 45"/>
+          <p:cNvPr id="47" name="TextBox 46"/>
           <p:cNvSpPr txBox="1"/>
           <p:nvPr/>
         </p:nvSpPr>
@@ -5670,7 +5714,7 @@
       </p:sp>
       <p:sp>
         <p:nvSpPr>
-          <p:cNvPr id="47" name="Rectangle 46"/>
+          <p:cNvPr id="48" name="Rectangle 47"/>
           <p:cNvSpPr/>
           <p:nvPr/>
         </p:nvSpPr>
@@ -5713,7 +5757,7 @@
       </p:sp>
       <p:sp>
         <p:nvSpPr>
-          <p:cNvPr id="48" name="Rectangle 47"/>
+          <p:cNvPr id="49" name="Rectangle 48"/>
           <p:cNvSpPr/>
           <p:nvPr/>
         </p:nvSpPr>
@@ -5758,7 +5802,7 @@
       </p:sp>
       <p:sp>
         <p:nvSpPr>
-          <p:cNvPr id="49" name="TextBox 48"/>
+          <p:cNvPr id="50" name="TextBox 49"/>
           <p:cNvSpPr txBox="1"/>
           <p:nvPr/>
         </p:nvSpPr>
@@ -5773,7 +5817,7 @@
           <a:noFill/>
         </p:spPr>
         <p:txBody>
-          <a:bodyPr wrap="square" lIns="0" rIns="0" tIns="0" bIns="0" anchor="ctr">
+          <a:bodyPr wrap="none" lIns="0" rIns="0" tIns="0" bIns="0" anchor="ctr">
             <a:spAutoFit/>
           </a:bodyPr>
           <a:lstStyle/>
@@ -5803,7 +5847,7 @@
       </p:sp>
       <p:sp>
         <p:nvSpPr>
-          <p:cNvPr id="50" name="TextBox 49"/>
+          <p:cNvPr id="51" name="TextBox 50"/>
           <p:cNvSpPr txBox="1"/>
           <p:nvPr/>
         </p:nvSpPr>
@@ -5818,7 +5862,7 @@
           <a:noFill/>
         </p:spPr>
         <p:txBody>
-          <a:bodyPr wrap="square" lIns="0" rIns="0" tIns="0" bIns="0" anchor="t">
+          <a:bodyPr wrap="none" lIns="0" rIns="0" tIns="0" bIns="0" anchor="t">
             <a:spAutoFit/>
           </a:bodyPr>
           <a:lstStyle/>
@@ -5848,7 +5892,7 @@
       </p:sp>
       <p:sp>
         <p:nvSpPr>
-          <p:cNvPr id="51" name="TextBox 50"/>
+          <p:cNvPr id="52" name="TextBox 51"/>
           <p:cNvSpPr txBox="1"/>
           <p:nvPr/>
         </p:nvSpPr>
@@ -5863,7 +5907,7 @@
           <a:noFill/>
         </p:spPr>
         <p:txBody>
-          <a:bodyPr wrap="square" lIns="0" rIns="0" tIns="0" bIns="0" anchor="t">
+          <a:bodyPr wrap="none" lIns="0" rIns="0" tIns="0" bIns="0" anchor="t">
             <a:spAutoFit/>
           </a:bodyPr>
           <a:lstStyle/>
@@ -5893,7 +5937,7 @@
       </p:sp>
       <p:sp>
         <p:nvSpPr>
-          <p:cNvPr id="52" name="TextBox 51"/>
+          <p:cNvPr id="53" name="TextBox 52"/>
           <p:cNvSpPr txBox="1"/>
           <p:nvPr/>
         </p:nvSpPr>
@@ -5938,7 +5982,7 @@
       </p:sp>
       <p:sp>
         <p:nvSpPr>
-          <p:cNvPr id="53" name="Rounded Rectangle 52"/>
+          <p:cNvPr id="54" name="Rounded Rectangle 53"/>
           <p:cNvSpPr/>
           <p:nvPr/>
         </p:nvSpPr>
@@ -5976,7 +6020,7 @@
           </a:fontRef>
         </p:style>
         <p:txBody>
-          <a:bodyPr rtlCol="0" anchor="ctr" wrap="square" bIns="36576"/>
+          <a:bodyPr rtlCol="0" anchor="ctr" wrap="none" bIns="36576"/>
           <a:lstStyle/>
           <a:p>
             <a:pPr algn="ctr">
@@ -6010,14 +6054,14 @@
                 </a:solidFill>
                 <a:latin typeface="Arial"/>
               </a:rPr>
-              <a:t>tissue-matched non-spaceflight counts</a:t>
-            </a:r>
-          </a:p>
-        </p:txBody>
-      </p:sp>
-      <p:sp>
-        <p:nvSpPr>
-          <p:cNvPr id="54" name="Right Arrow 53"/>
+              <a:t>non-spaceflight tissue counts</a:t>
+            </a:r>
+          </a:p>
+        </p:txBody>
+      </p:sp>
+      <p:sp>
+        <p:nvSpPr>
+          <p:cNvPr id="55" name="Right Arrow 54"/>
           <p:cNvSpPr/>
           <p:nvPr/>
         </p:nvSpPr>
@@ -6060,7 +6104,7 @@
       </p:sp>
       <p:sp>
         <p:nvSpPr>
-          <p:cNvPr id="55" name="Rounded Rectangle 54"/>
+          <p:cNvPr id="56" name="Rounded Rectangle 55"/>
           <p:cNvSpPr/>
           <p:nvPr/>
         </p:nvSpPr>
@@ -6107,7 +6151,7 @@
       </p:sp>
       <p:sp>
         <p:nvSpPr>
-          <p:cNvPr id="56" name="TextBox 55"/>
+          <p:cNvPr id="57" name="TextBox 56"/>
           <p:cNvSpPr txBox="1"/>
           <p:nvPr/>
         </p:nvSpPr>
@@ -6152,7 +6196,7 @@
       </p:sp>
       <p:sp>
         <p:nvSpPr>
-          <p:cNvPr id="57" name="Oval 56"/>
+          <p:cNvPr id="58" name="Oval 57"/>
           <p:cNvSpPr/>
           <p:nvPr/>
         </p:nvSpPr>
@@ -6195,7 +6239,7 @@
       </p:sp>
       <p:sp>
         <p:nvSpPr>
-          <p:cNvPr id="58" name="Oval 57"/>
+          <p:cNvPr id="59" name="Oval 58"/>
           <p:cNvSpPr/>
           <p:nvPr/>
         </p:nvSpPr>
@@ -6238,7 +6282,7 @@
       </p:sp>
       <p:sp>
         <p:nvSpPr>
-          <p:cNvPr id="59" name="Oval 58"/>
+          <p:cNvPr id="60" name="Oval 59"/>
           <p:cNvSpPr/>
           <p:nvPr/>
         </p:nvSpPr>
@@ -6281,7 +6325,7 @@
       </p:sp>
       <p:sp>
         <p:nvSpPr>
-          <p:cNvPr id="60" name="Oval 59"/>
+          <p:cNvPr id="61" name="Oval 60"/>
           <p:cNvSpPr/>
           <p:nvPr/>
         </p:nvSpPr>
@@ -6324,14 +6368,14 @@
       </p:sp>
       <p:sp>
         <p:nvSpPr>
-          <p:cNvPr id="61" name="Trapezoid 60"/>
+          <p:cNvPr id="62" name="Trapezoid 61"/>
           <p:cNvSpPr/>
           <p:nvPr/>
         </p:nvSpPr>
         <p:spPr>
           <a:xfrm>
-            <a:off x="20089368" y="7626096"/>
-            <a:ext cx="1371600" cy="1298448"/>
+            <a:off x="19751040" y="7626096"/>
+            <a:ext cx="1920240" cy="1298448"/>
           </a:xfrm>
           <a:prstGeom prst="trapezoid">
             <a:avLst/>
@@ -6369,14 +6413,14 @@
       </p:sp>
       <p:sp>
         <p:nvSpPr>
-          <p:cNvPr id="62" name="TextBox 61"/>
+          <p:cNvPr id="63" name="TextBox 62"/>
           <p:cNvSpPr txBox="1"/>
           <p:nvPr/>
         </p:nvSpPr>
         <p:spPr>
           <a:xfrm>
-            <a:off x="20272248" y="7863840"/>
-            <a:ext cx="1005840" cy="731520"/>
+            <a:off x="19860768" y="8083296"/>
+            <a:ext cx="1700784" cy="347472"/>
           </a:xfrm>
           <a:prstGeom prst="rect">
             <a:avLst/>
@@ -6384,7 +6428,7 @@
           <a:noFill/>
         </p:spPr>
         <p:txBody>
-          <a:bodyPr wrap="square" lIns="0" rIns="0" tIns="0" bIns="0" anchor="ctr">
+          <a:bodyPr wrap="none" lIns="0" rIns="0" tIns="0" bIns="0" anchor="ctr">
             <a:spAutoFit/>
           </a:bodyPr>
           <a:lstStyle/>
@@ -6401,53 +6445,17 @@
               </a:spcAft>
             </a:pPr>
             <a:r>
-              <a:rPr sz="1600" b="1" i="0">
+              <a:rPr sz="1450" b="1" i="0">
                 <a:solidFill>
                   <a:srgbClr val="071C3F"/>
                 </a:solidFill>
                 <a:latin typeface="Arial"/>
               </a:rPr>
-              <a:t>dense
-encoder</a:t>
-            </a:r>
-          </a:p>
-        </p:txBody>
-      </p:sp>
-      <p:cxnSp>
-        <p:nvCxnSpPr>
-          <p:cNvPr id="63" name="Connector 62"/>
-          <p:cNvCxnSpPr/>
-          <p:nvPr/>
-        </p:nvCxnSpPr>
-        <p:spPr>
-          <a:xfrm>
-            <a:off x="19604735" y="7854695"/>
-            <a:ext cx="649225" cy="420625"/>
-          </a:xfrm>
-          <a:prstGeom prst="line">
-            <a:avLst/>
-          </a:prstGeom>
-          <a:ln w="10160">
-            <a:solidFill>
-              <a:srgbClr val="A9BBD0"/>
-            </a:solidFill>
-          </a:ln>
-        </p:spPr>
-        <p:style>
-          <a:lnRef idx="2">
-            <a:schemeClr val="accent1"/>
-          </a:lnRef>
-          <a:fillRef idx="0">
-            <a:schemeClr val="accent1"/>
-          </a:fillRef>
-          <a:effectRef idx="1">
-            <a:schemeClr val="accent1"/>
-          </a:effectRef>
-          <a:fontRef idx="minor">
-            <a:schemeClr val="tx1"/>
-          </a:fontRef>
-        </p:style>
-      </p:cxnSp>
+              <a:t>Dense encoder</a:t>
+            </a:r>
+          </a:p>
+        </p:txBody>
+      </p:sp>
       <p:cxnSp>
         <p:nvCxnSpPr>
           <p:cNvPr id="64" name="Connector 63"/>
@@ -6456,8 +6464,8 @@
         </p:nvCxnSpPr>
         <p:spPr>
           <a:xfrm>
-            <a:off x="19604735" y="8238743"/>
-            <a:ext cx="649225" cy="36577"/>
+            <a:off x="19604735" y="7854695"/>
+            <a:ext cx="310897" cy="420625"/>
           </a:xfrm>
           <a:prstGeom prst="line">
             <a:avLst/>
@@ -6490,9 +6498,9 @@
           <p:nvPr/>
         </p:nvCxnSpPr>
         <p:spPr>
-          <a:xfrm flipV="1">
-            <a:off x="19604735" y="8275320"/>
-            <a:ext cx="649225" cy="347471"/>
+          <a:xfrm>
+            <a:off x="19604735" y="8238743"/>
+            <a:ext cx="310897" cy="36577"/>
           </a:xfrm>
           <a:prstGeom prst="line">
             <a:avLst/>
@@ -6527,7 +6535,7 @@
         <p:spPr>
           <a:xfrm flipV="1">
             <a:off x="19604735" y="8275320"/>
-            <a:ext cx="649225" cy="731519"/>
+            <a:ext cx="310897" cy="347471"/>
           </a:xfrm>
           <a:prstGeom prst="line">
             <a:avLst/>
@@ -6561,13 +6569,13 @@
         </p:nvCxnSpPr>
         <p:spPr>
           <a:xfrm flipV="1">
-            <a:off x="21296376" y="7799831"/>
-            <a:ext cx="585216" cy="475489"/>
+            <a:off x="19604735" y="8275320"/>
+            <a:ext cx="310897" cy="731519"/>
           </a:xfrm>
           <a:prstGeom prst="line">
             <a:avLst/>
           </a:prstGeom>
-          <a:ln w="11430">
+          <a:ln w="10160">
             <a:solidFill>
               <a:srgbClr val="A9BBD0"/>
             </a:solidFill>
@@ -6588,9 +6596,44 @@
           </a:fontRef>
         </p:style>
       </p:cxnSp>
-      <p:sp>
-        <p:nvSpPr>
-          <p:cNvPr id="68" name="Oval 67"/>
+      <p:cxnSp>
+        <p:nvCxnSpPr>
+          <p:cNvPr id="68" name="Connector 67"/>
+          <p:cNvCxnSpPr/>
+          <p:nvPr/>
+        </p:nvCxnSpPr>
+        <p:spPr>
+          <a:xfrm flipV="1">
+            <a:off x="21506688" y="7799831"/>
+            <a:ext cx="374904" cy="475489"/>
+          </a:xfrm>
+          <a:prstGeom prst="line">
+            <a:avLst/>
+          </a:prstGeom>
+          <a:ln w="11430">
+            <a:solidFill>
+              <a:srgbClr val="A9BBD0"/>
+            </a:solidFill>
+          </a:ln>
+        </p:spPr>
+        <p:style>
+          <a:lnRef idx="2">
+            <a:schemeClr val="accent1"/>
+          </a:lnRef>
+          <a:fillRef idx="0">
+            <a:schemeClr val="accent1"/>
+          </a:fillRef>
+          <a:effectRef idx="1">
+            <a:schemeClr val="accent1"/>
+          </a:effectRef>
+          <a:fontRef idx="minor">
+            <a:schemeClr val="tx1"/>
+          </a:fontRef>
+        </p:style>
+      </p:cxnSp>
+      <p:sp>
+        <p:nvSpPr>
+          <p:cNvPr id="69" name="Oval 68"/>
           <p:cNvSpPr/>
           <p:nvPr/>
         </p:nvSpPr>
@@ -6633,7 +6676,7 @@
       </p:sp>
       <p:sp>
         <p:nvSpPr>
-          <p:cNvPr id="69" name="Rounded Rectangle 68"/>
+          <p:cNvPr id="70" name="Rounded Rectangle 69"/>
           <p:cNvSpPr/>
           <p:nvPr/>
         </p:nvSpPr>
@@ -6680,7 +6723,7 @@
       </p:sp>
       <p:sp>
         <p:nvSpPr>
-          <p:cNvPr id="70" name="TextBox 69"/>
+          <p:cNvPr id="71" name="TextBox 70"/>
           <p:cNvSpPr txBox="1"/>
           <p:nvPr/>
         </p:nvSpPr>
@@ -6695,7 +6738,7 @@
           <a:noFill/>
         </p:spPr>
         <p:txBody>
-          <a:bodyPr wrap="square" lIns="0" rIns="0" tIns="0" bIns="0" anchor="ctr">
+          <a:bodyPr wrap="none" lIns="0" rIns="0" tIns="0" bIns="0" anchor="ctr">
             <a:spAutoFit/>
           </a:bodyPr>
           <a:lstStyle/>
@@ -6725,14 +6768,14 @@
       </p:sp>
       <p:cxnSp>
         <p:nvCxnSpPr>
-          <p:cNvPr id="71" name="Connector 70"/>
+          <p:cNvPr id="72" name="Connector 71"/>
           <p:cNvCxnSpPr/>
           <p:nvPr/>
         </p:nvCxnSpPr>
         <p:spPr>
           <a:xfrm flipV="1">
-            <a:off x="21296376" y="8238744"/>
-            <a:ext cx="585216" cy="36576"/>
+            <a:off x="21506688" y="8238744"/>
+            <a:ext cx="374904" cy="36576"/>
           </a:xfrm>
           <a:prstGeom prst="line">
             <a:avLst/>
@@ -6760,7 +6803,7 @@
       </p:cxnSp>
       <p:sp>
         <p:nvSpPr>
-          <p:cNvPr id="72" name="Oval 71"/>
+          <p:cNvPr id="73" name="Oval 72"/>
           <p:cNvSpPr/>
           <p:nvPr/>
         </p:nvSpPr>
@@ -6803,7 +6846,7 @@
       </p:sp>
       <p:sp>
         <p:nvSpPr>
-          <p:cNvPr id="73" name="Rounded Rectangle 72"/>
+          <p:cNvPr id="74" name="Rounded Rectangle 73"/>
           <p:cNvSpPr/>
           <p:nvPr/>
         </p:nvSpPr>
@@ -6850,7 +6893,7 @@
       </p:sp>
       <p:sp>
         <p:nvSpPr>
-          <p:cNvPr id="74" name="TextBox 73"/>
+          <p:cNvPr id="75" name="TextBox 74"/>
           <p:cNvSpPr txBox="1"/>
           <p:nvPr/>
         </p:nvSpPr>
@@ -6865,7 +6908,7 @@
           <a:noFill/>
         </p:spPr>
         <p:txBody>
-          <a:bodyPr wrap="square" lIns="0" rIns="0" tIns="0" bIns="0" anchor="ctr">
+          <a:bodyPr wrap="none" lIns="0" rIns="0" tIns="0" bIns="0" anchor="ctr">
             <a:spAutoFit/>
           </a:bodyPr>
           <a:lstStyle/>
@@ -6895,14 +6938,14 @@
       </p:sp>
       <p:cxnSp>
         <p:nvCxnSpPr>
-          <p:cNvPr id="75" name="Connector 74"/>
+          <p:cNvPr id="76" name="Connector 75"/>
           <p:cNvCxnSpPr/>
           <p:nvPr/>
         </p:nvCxnSpPr>
         <p:spPr>
           <a:xfrm>
-            <a:off x="21296376" y="8275320"/>
-            <a:ext cx="585216" cy="402336"/>
+            <a:off x="21506688" y="8275320"/>
+            <a:ext cx="374904" cy="402336"/>
           </a:xfrm>
           <a:prstGeom prst="line">
             <a:avLst/>
@@ -6930,7 +6973,7 @@
       </p:cxnSp>
       <p:sp>
         <p:nvSpPr>
-          <p:cNvPr id="76" name="Oval 75"/>
+          <p:cNvPr id="77" name="Oval 76"/>
           <p:cNvSpPr/>
           <p:nvPr/>
         </p:nvSpPr>
@@ -6973,7 +7016,7 @@
       </p:sp>
       <p:sp>
         <p:nvSpPr>
-          <p:cNvPr id="77" name="Rounded Rectangle 76"/>
+          <p:cNvPr id="78" name="Rounded Rectangle 77"/>
           <p:cNvSpPr/>
           <p:nvPr/>
         </p:nvSpPr>
@@ -7020,7 +7063,7 @@
       </p:sp>
       <p:sp>
         <p:nvSpPr>
-          <p:cNvPr id="78" name="TextBox 77"/>
+          <p:cNvPr id="79" name="TextBox 78"/>
           <p:cNvSpPr txBox="1"/>
           <p:nvPr/>
         </p:nvSpPr>
@@ -7035,7 +7078,7 @@
           <a:noFill/>
         </p:spPr>
         <p:txBody>
-          <a:bodyPr wrap="square" lIns="0" rIns="0" tIns="0" bIns="0" anchor="ctr">
+          <a:bodyPr wrap="none" lIns="0" rIns="0" tIns="0" bIns="0" anchor="ctr">
             <a:spAutoFit/>
           </a:bodyPr>
           <a:lstStyle/>
@@ -7065,7 +7108,7 @@
       </p:sp>
       <p:sp>
         <p:nvSpPr>
-          <p:cNvPr id="79" name="Rounded Rectangle 78"/>
+          <p:cNvPr id="80" name="Rounded Rectangle 79"/>
           <p:cNvSpPr/>
           <p:nvPr/>
         </p:nvSpPr>
@@ -7110,7 +7153,7 @@
       </p:sp>
       <p:sp>
         <p:nvSpPr>
-          <p:cNvPr id="80" name="TextBox 79"/>
+          <p:cNvPr id="81" name="TextBox 80"/>
           <p:cNvSpPr txBox="1"/>
           <p:nvPr/>
         </p:nvSpPr>
@@ -7125,7 +7168,7 @@
           <a:noFill/>
         </p:spPr>
         <p:txBody>
-          <a:bodyPr wrap="square" lIns="0" rIns="0" tIns="0" bIns="0" anchor="ctr">
+          <a:bodyPr wrap="none" lIns="0" rIns="0" tIns="0" bIns="0" anchor="ctr">
             <a:spAutoFit/>
           </a:bodyPr>
           <a:lstStyle/>
@@ -7148,14 +7191,14 @@
                 </a:solidFill>
                 <a:latin typeface="Arial"/>
               </a:rPr>
-              <a:t>Reactome gene-program mask</a:t>
-            </a:r>
-          </a:p>
-        </p:txBody>
-      </p:sp>
-      <p:sp>
-        <p:nvSpPr>
-          <p:cNvPr id="81" name="Down Arrow 80"/>
+              <a:t>Reactome program mask</a:t>
+            </a:r>
+          </a:p>
+        </p:txBody>
+      </p:sp>
+      <p:sp>
+        <p:nvSpPr>
+          <p:cNvPr id="82" name="Down Arrow 81"/>
           <p:cNvSpPr/>
           <p:nvPr/>
         </p:nvSpPr>
@@ -7198,7 +7241,7 @@
       </p:sp>
       <p:sp>
         <p:nvSpPr>
-          <p:cNvPr id="82" name="Oval 81"/>
+          <p:cNvPr id="83" name="Oval 82"/>
           <p:cNvSpPr/>
           <p:nvPr/>
         </p:nvSpPr>
@@ -7241,7 +7284,7 @@
       </p:sp>
       <p:sp>
         <p:nvSpPr>
-          <p:cNvPr id="83" name="Oval 82"/>
+          <p:cNvPr id="84" name="Oval 83"/>
           <p:cNvSpPr/>
           <p:nvPr/>
         </p:nvSpPr>
@@ -7284,7 +7327,7 @@
       </p:sp>
       <p:sp>
         <p:nvSpPr>
-          <p:cNvPr id="84" name="Oval 83"/>
+          <p:cNvPr id="85" name="Oval 84"/>
           <p:cNvSpPr/>
           <p:nvPr/>
         </p:nvSpPr>
@@ -7327,7 +7370,7 @@
       </p:sp>
       <p:sp>
         <p:nvSpPr>
-          <p:cNvPr id="85" name="Oval 84"/>
+          <p:cNvPr id="86" name="Oval 85"/>
           <p:cNvSpPr/>
           <p:nvPr/>
         </p:nvSpPr>
@@ -7370,7 +7413,7 @@
       </p:sp>
       <p:cxnSp>
         <p:nvCxnSpPr>
-          <p:cNvPr id="86" name="Connector 85"/>
+          <p:cNvPr id="87" name="Connector 86"/>
           <p:cNvCxnSpPr/>
           <p:nvPr/>
         </p:nvCxnSpPr>
@@ -7378,41 +7421,6 @@
           <a:xfrm>
             <a:off x="24277320" y="7799831"/>
             <a:ext cx="2971800" cy="36576"/>
-          </a:xfrm>
-          <a:prstGeom prst="line">
-            <a:avLst/>
-          </a:prstGeom>
-          <a:ln w="15240">
-            <a:solidFill>
-              <a:srgbClr val="6A4C93"/>
-            </a:solidFill>
-          </a:ln>
-        </p:spPr>
-        <p:style>
-          <a:lnRef idx="2">
-            <a:schemeClr val="accent1"/>
-          </a:lnRef>
-          <a:fillRef idx="0">
-            <a:schemeClr val="accent1"/>
-          </a:fillRef>
-          <a:effectRef idx="1">
-            <a:schemeClr val="accent1"/>
-          </a:effectRef>
-          <a:fontRef idx="minor">
-            <a:schemeClr val="tx1"/>
-          </a:fontRef>
-        </p:style>
-      </p:cxnSp>
-      <p:cxnSp>
-        <p:nvCxnSpPr>
-          <p:cNvPr id="87" name="Connector 86"/>
-          <p:cNvCxnSpPr/>
-          <p:nvPr/>
-        </p:nvCxnSpPr>
-        <p:spPr>
-          <a:xfrm>
-            <a:off x="24277320" y="7799831"/>
-            <a:ext cx="2971800" cy="731520"/>
           </a:xfrm>
           <a:prstGeom prst="line">
             <a:avLst/>
@@ -7445,16 +7453,16 @@
           <p:nvPr/>
         </p:nvCxnSpPr>
         <p:spPr>
-          <a:xfrm flipV="1">
-            <a:off x="24277320" y="8183879"/>
-            <a:ext cx="2971800" cy="54865"/>
+          <a:xfrm>
+            <a:off x="24277320" y="7799831"/>
+            <a:ext cx="2971800" cy="731520"/>
           </a:xfrm>
           <a:prstGeom prst="line">
             <a:avLst/>
           </a:prstGeom>
           <a:ln w="15240">
             <a:solidFill>
-              <a:srgbClr val="A64D67"/>
+              <a:srgbClr val="6A4C93"/>
             </a:solidFill>
           </a:ln>
         </p:spPr>
@@ -7480,9 +7488,9 @@
           <p:nvPr/>
         </p:nvCxnSpPr>
         <p:spPr>
-          <a:xfrm>
-            <a:off x="24277320" y="8238744"/>
-            <a:ext cx="2971800" cy="640080"/>
+          <a:xfrm flipV="1">
+            <a:off x="24277320" y="8183879"/>
+            <a:ext cx="2971800" cy="54865"/>
           </a:xfrm>
           <a:prstGeom prst="line">
             <a:avLst/>
@@ -7515,16 +7523,16 @@
           <p:nvPr/>
         </p:nvCxnSpPr>
         <p:spPr>
-          <a:xfrm flipV="1">
-            <a:off x="24277320" y="8531351"/>
-            <a:ext cx="2971800" cy="146305"/>
+          <a:xfrm>
+            <a:off x="24277320" y="8238744"/>
+            <a:ext cx="2971800" cy="640080"/>
           </a:xfrm>
           <a:prstGeom prst="line">
             <a:avLst/>
           </a:prstGeom>
           <a:ln w="15240">
             <a:solidFill>
-              <a:srgbClr val="C65D37"/>
+              <a:srgbClr val="A64D67"/>
             </a:solidFill>
           </a:ln>
         </p:spPr>
@@ -7550,9 +7558,9 @@
           <p:nvPr/>
         </p:nvCxnSpPr>
         <p:spPr>
-          <a:xfrm>
-            <a:off x="24277320" y="8677656"/>
-            <a:ext cx="2971800" cy="201168"/>
+          <a:xfrm flipV="1">
+            <a:off x="24277320" y="8531351"/>
+            <a:ext cx="2971800" cy="146305"/>
           </a:xfrm>
           <a:prstGeom prst="line">
             <a:avLst/>
@@ -7578,9 +7586,44 @@
           </a:fontRef>
         </p:style>
       </p:cxnSp>
-      <p:sp>
-        <p:nvSpPr>
-          <p:cNvPr id="92" name="TextBox 91"/>
+      <p:cxnSp>
+        <p:nvCxnSpPr>
+          <p:cNvPr id="92" name="Connector 91"/>
+          <p:cNvCxnSpPr/>
+          <p:nvPr/>
+        </p:nvCxnSpPr>
+        <p:spPr>
+          <a:xfrm>
+            <a:off x="24277320" y="8677656"/>
+            <a:ext cx="2971800" cy="201168"/>
+          </a:xfrm>
+          <a:prstGeom prst="line">
+            <a:avLst/>
+          </a:prstGeom>
+          <a:ln w="15240">
+            <a:solidFill>
+              <a:srgbClr val="C65D37"/>
+            </a:solidFill>
+          </a:ln>
+        </p:spPr>
+        <p:style>
+          <a:lnRef idx="2">
+            <a:schemeClr val="accent1"/>
+          </a:lnRef>
+          <a:fillRef idx="0">
+            <a:schemeClr val="accent1"/>
+          </a:fillRef>
+          <a:effectRef idx="1">
+            <a:schemeClr val="accent1"/>
+          </a:effectRef>
+          <a:fontRef idx="minor">
+            <a:schemeClr val="tx1"/>
+          </a:fontRef>
+        </p:style>
+      </p:cxnSp>
+      <p:sp>
+        <p:nvSpPr>
+          <p:cNvPr id="93" name="TextBox 92"/>
           <p:cNvSpPr txBox="1"/>
           <p:nvPr/>
         </p:nvSpPr>
@@ -7595,7 +7638,7 @@
           <a:noFill/>
         </p:spPr>
         <p:txBody>
-          <a:bodyPr wrap="square" lIns="0" rIns="0" tIns="0" bIns="0" anchor="t">
+          <a:bodyPr wrap="none" lIns="0" rIns="0" tIns="0" bIns="0" anchor="t">
             <a:spAutoFit/>
           </a:bodyPr>
           <a:lstStyle/>
@@ -7625,7 +7668,7 @@
       </p:sp>
       <p:sp>
         <p:nvSpPr>
-          <p:cNvPr id="93" name="TextBox 92"/>
+          <p:cNvPr id="94" name="TextBox 93"/>
           <p:cNvSpPr txBox="1"/>
           <p:nvPr/>
         </p:nvSpPr>
@@ -7640,7 +7683,7 @@
           <a:noFill/>
         </p:spPr>
         <p:txBody>
-          <a:bodyPr wrap="square" lIns="0" rIns="0" tIns="0" bIns="0" anchor="t">
+          <a:bodyPr wrap="none" lIns="0" rIns="0" tIns="0" bIns="0" anchor="t">
             <a:spAutoFit/>
           </a:bodyPr>
           <a:lstStyle/>
@@ -7663,14 +7706,14 @@
                 </a:solidFill>
                 <a:latin typeface="Arial"/>
               </a:rPr>
-              <a:t>annotated latent program scores</a:t>
-            </a:r>
-          </a:p>
-        </p:txBody>
-      </p:sp>
-      <p:sp>
-        <p:nvSpPr>
-          <p:cNvPr id="94" name="TextBox 93"/>
+              <a:t>annotated program scores</a:t>
+            </a:r>
+          </a:p>
+        </p:txBody>
+      </p:sp>
+      <p:sp>
+        <p:nvSpPr>
+          <p:cNvPr id="95" name="TextBox 94"/>
           <p:cNvSpPr txBox="1"/>
           <p:nvPr/>
         </p:nvSpPr>
@@ -7685,7 +7728,7 @@
           <a:noFill/>
         </p:spPr>
         <p:txBody>
-          <a:bodyPr wrap="square" lIns="0" rIns="0" tIns="0" bIns="0" anchor="t">
+          <a:bodyPr wrap="none" lIns="0" rIns="0" tIns="0" bIns="0" anchor="t">
             <a:spAutoFit/>
           </a:bodyPr>
           <a:lstStyle/>
@@ -7715,7 +7758,7 @@
       </p:sp>
       <p:sp>
         <p:nvSpPr>
-          <p:cNvPr id="95" name="TextBox 94"/>
+          <p:cNvPr id="96" name="TextBox 95"/>
           <p:cNvSpPr txBox="1"/>
           <p:nvPr/>
         </p:nvSpPr>
@@ -7730,7 +7773,7 @@
           <a:noFill/>
         </p:spPr>
         <p:txBody>
-          <a:bodyPr wrap="square" lIns="0" rIns="0" tIns="0" bIns="0" anchor="t">
+          <a:bodyPr wrap="none" lIns="0" rIns="0" tIns="0" bIns="0" anchor="t">
             <a:spAutoFit/>
           </a:bodyPr>
           <a:lstStyle/>
@@ -7753,14 +7796,14 @@
                 </a:solidFill>
                 <a:latin typeface="Arial"/>
               </a:rPr>
-              <a:t>reconstructed genes</a:t>
-            </a:r>
-          </a:p>
-        </p:txBody>
-      </p:sp>
-      <p:sp>
-        <p:nvSpPr>
-          <p:cNvPr id="96" name="TextBox 95"/>
+              <a:t>output genes</a:t>
+            </a:r>
+          </a:p>
+        </p:txBody>
+      </p:sp>
+      <p:sp>
+        <p:nvSpPr>
+          <p:cNvPr id="97" name="TextBox 96"/>
           <p:cNvSpPr txBox="1"/>
           <p:nvPr/>
         </p:nvSpPr>
@@ -7805,7 +7848,7 @@
       </p:sp>
       <p:sp>
         <p:nvSpPr>
-          <p:cNvPr id="97" name="Rounded Rectangle 96"/>
+          <p:cNvPr id="98" name="Rounded Rectangle 97"/>
           <p:cNvSpPr/>
           <p:nvPr/>
         </p:nvSpPr>
@@ -7843,7 +7886,7 @@
           </a:fontRef>
         </p:style>
         <p:txBody>
-          <a:bodyPr rtlCol="0" anchor="ctr" wrap="square" bIns="36576"/>
+          <a:bodyPr rtlCol="0" anchor="ctr" wrap="none" bIns="36576"/>
           <a:lstStyle/>
           <a:p>
             <a:pPr algn="ctr">
@@ -7877,14 +7920,14 @@
                 </a:solidFill>
                 <a:latin typeface="Arial"/>
               </a:rPr>
-              <a:t>FLT and GC counts + accession</a:t>
-            </a:r>
-          </a:p>
-        </p:txBody>
-      </p:sp>
-      <p:sp>
-        <p:nvSpPr>
-          <p:cNvPr id="98" name="Right Arrow 97"/>
+              <a:t>FLT, GC, and accession</a:t>
+            </a:r>
+          </a:p>
+        </p:txBody>
+      </p:sp>
+      <p:sp>
+        <p:nvSpPr>
+          <p:cNvPr id="99" name="Right Arrow 98"/>
           <p:cNvSpPr/>
           <p:nvPr/>
         </p:nvSpPr>
@@ -7927,7 +7970,7 @@
       </p:sp>
       <p:sp>
         <p:nvSpPr>
-          <p:cNvPr id="99" name="Rounded Rectangle 98"/>
+          <p:cNvPr id="100" name="Rounded Rectangle 99"/>
           <p:cNvSpPr/>
           <p:nvPr/>
         </p:nvSpPr>
@@ -7965,7 +8008,7 @@
           </a:fontRef>
         </p:style>
         <p:txBody>
-          <a:bodyPr rtlCol="0" anchor="ctr" wrap="square" bIns="36576"/>
+          <a:bodyPr rtlCol="0" anchor="ctr" wrap="none" bIns="36576"/>
           <a:lstStyle/>
           <a:p>
             <a:pPr algn="ctr">
@@ -8006,7 +8049,7 @@
       </p:sp>
       <p:sp>
         <p:nvSpPr>
-          <p:cNvPr id="100" name="Right Arrow 99"/>
+          <p:cNvPr id="101" name="Right Arrow 100"/>
           <p:cNvSpPr/>
           <p:nvPr/>
         </p:nvSpPr>
@@ -8049,7 +8092,7 @@
       </p:sp>
       <p:sp>
         <p:nvSpPr>
-          <p:cNvPr id="101" name="Rounded Rectangle 100"/>
+          <p:cNvPr id="102" name="Rounded Rectangle 101"/>
           <p:cNvSpPr/>
           <p:nvPr/>
         </p:nvSpPr>
@@ -8087,7 +8130,7 @@
           </a:fontRef>
         </p:style>
         <p:txBody>
-          <a:bodyPr rtlCol="0" anchor="ctr" wrap="square" bIns="36576"/>
+          <a:bodyPr rtlCol="0" anchor="ctr" wrap="none" bIns="36576"/>
           <a:lstStyle/>
           <a:p>
             <a:pPr algn="ctr">
@@ -8128,7 +8171,7 @@
       </p:sp>
       <p:sp>
         <p:nvSpPr>
-          <p:cNvPr id="102" name="Right Arrow 101"/>
+          <p:cNvPr id="103" name="Right Arrow 102"/>
           <p:cNvSpPr/>
           <p:nvPr/>
         </p:nvSpPr>
@@ -8171,7 +8214,7 @@
       </p:sp>
       <p:sp>
         <p:nvSpPr>
-          <p:cNvPr id="103" name="Rounded Rectangle 102"/>
+          <p:cNvPr id="104" name="Rounded Rectangle 103"/>
           <p:cNvSpPr/>
           <p:nvPr/>
         </p:nvSpPr>
@@ -8209,7 +8252,7 @@
           </a:fontRef>
         </p:style>
         <p:txBody>
-          <a:bodyPr rtlCol="0" anchor="ctr" wrap="square" bIns="36576"/>
+          <a:bodyPr rtlCol="0" anchor="ctr" wrap="none" bIns="36576"/>
           <a:lstStyle/>
           <a:p>
             <a:pPr algn="ctr">
@@ -8243,21 +8286,143 @@
                 </a:solidFill>
                 <a:latin typeface="Arial"/>
               </a:rPr>
-              <a:t>equal-weight mean FLT minus GC</a:t>
-            </a:r>
-          </a:p>
-        </p:txBody>
-      </p:sp>
-      <p:sp>
-        <p:nvSpPr>
-          <p:cNvPr id="104" name="TextBox 103"/>
+              <a:t>equal-weight FLT - GC mean</a:t>
+            </a:r>
+          </a:p>
+        </p:txBody>
+      </p:sp>
+      <p:sp>
+        <p:nvSpPr>
+          <p:cNvPr id="105" name="Down Arrow 104"/>
+          <p:cNvSpPr/>
+          <p:nvPr/>
+        </p:nvSpPr>
+        <p:spPr>
+          <a:xfrm>
+            <a:off x="26673048" y="10991088"/>
+            <a:ext cx="329184" cy="310896"/>
+          </a:xfrm>
+          <a:prstGeom prst="downArrow">
+            <a:avLst/>
+          </a:prstGeom>
+          <a:solidFill>
+            <a:srgbClr val="178C6A"/>
+          </a:solidFill>
+          <a:ln>
+            <a:noFill/>
+          </a:ln>
+        </p:spPr>
+        <p:style>
+          <a:lnRef idx="1">
+            <a:schemeClr val="accent1"/>
+          </a:lnRef>
+          <a:fillRef idx="3">
+            <a:schemeClr val="accent1"/>
+          </a:fillRef>
+          <a:effectRef idx="2">
+            <a:schemeClr val="accent1"/>
+          </a:effectRef>
+          <a:fontRef idx="minor">
+            <a:schemeClr val="lt1"/>
+          </a:fontRef>
+        </p:style>
+        <p:txBody>
+          <a:bodyPr rtlCol="0" anchor="ctr"/>
+          <a:lstStyle/>
+          <a:p>
+            <a:pPr algn="ctr"/>
+          </a:p>
+        </p:txBody>
+      </p:sp>
+      <p:sp>
+        <p:nvSpPr>
+          <p:cNvPr id="106" name="Rounded Rectangle 105"/>
+          <p:cNvSpPr/>
+          <p:nvPr/>
+        </p:nvSpPr>
+        <p:spPr>
+          <a:xfrm>
+            <a:off x="23180040" y="11301984"/>
+            <a:ext cx="5166360" cy="566928"/>
+          </a:xfrm>
+          <a:prstGeom prst="roundRect">
+            <a:avLst>
+              <a:gd name="adj" fmla="val 6000"/>
+            </a:avLst>
+          </a:prstGeom>
+          <a:solidFill>
+            <a:srgbClr val="EBF5EF"/>
+          </a:solidFill>
+          <a:ln w="17780">
+            <a:solidFill>
+              <a:srgbClr val="178C6A"/>
+            </a:solidFill>
+          </a:ln>
+        </p:spPr>
+        <p:style>
+          <a:lnRef idx="1">
+            <a:schemeClr val="accent1"/>
+          </a:lnRef>
+          <a:fillRef idx="3">
+            <a:schemeClr val="accent1"/>
+          </a:fillRef>
+          <a:effectRef idx="2">
+            <a:schemeClr val="accent1"/>
+          </a:effectRef>
+          <a:fontRef idx="minor">
+            <a:schemeClr val="lt1"/>
+          </a:fontRef>
+        </p:style>
+        <p:txBody>
+          <a:bodyPr rtlCol="0" anchor="ctr" wrap="none" bIns="36576"/>
+          <a:lstStyle/>
+          <a:p>
+            <a:pPr algn="ctr">
+              <a:spcAft>
+                <a:spcPts val="200"/>
+              </a:spcAft>
+            </a:pPr>
+            <a:r>
+              <a:rPr sz="1550" b="1">
+                <a:solidFill>
+                  <a:srgbClr val="071C3F"/>
+                </a:solidFill>
+                <a:latin typeface="Arial"/>
+              </a:rPr>
+              <a:t>Post-score annotation</a:t>
+            </a:r>
+          </a:p>
+          <a:p>
+            <a:pPr algn="ctr">
+              <a:spcBef>
+                <a:spcPts val="0"/>
+              </a:spcBef>
+              <a:spcAft>
+                <a:spcPts val="0"/>
+              </a:spcAft>
+            </a:pPr>
+            <a:r>
+              <a:rPr sz="1350">
+                <a:solidFill>
+                  <a:srgbClr val="697889"/>
+                </a:solidFill>
+                <a:latin typeface="Arial"/>
+              </a:rPr>
+              <a:t>literature and mission-context role</a:t>
+            </a:r>
+          </a:p>
+        </p:txBody>
+      </p:sp>
+      <p:sp>
+        <p:nvSpPr>
+          <p:cNvPr id="107" name="TextBox 106"/>
           <p:cNvSpPr txBox="1"/>
           <p:nvPr/>
         </p:nvSpPr>
         <p:spPr>
           <a:xfrm>
-            <a:off x="15087600" y="11439144"/>
-            <a:ext cx="13213080" cy="384048"/>
+            <a:off x="15041880" y="11430000"/>
+            <a:ext cx="7818120" cy="310896"/>
           </a:xfrm>
           <a:prstGeom prst="rect">
             <a:avLst/>
@@ -8265,7 +8430,7 @@
           <a:noFill/>
         </p:spPr>
         <p:txBody>
-          <a:bodyPr wrap="square" lIns="0" rIns="0" tIns="0" bIns="0" anchor="t">
+          <a:bodyPr wrap="none" lIns="0" rIns="0" tIns="0" bIns="0" anchor="t">
             <a:spAutoFit/>
           </a:bodyPr>
           <a:lstStyle/>
@@ -8288,14 +8453,14 @@
                 </a:solidFill>
                 <a:latin typeface="Arial"/>
               </a:rPr>
-              <a:t>approximately 2,000 HVGs | 319-387 retained Reactome programs | negative-binomial reference | 250-epoch query map</a:t>
-            </a:r>
-          </a:p>
-        </p:txBody>
-      </p:sp>
-      <p:sp>
-        <p:nvSpPr>
-          <p:cNvPr id="105" name="Rectangle 104"/>
+              <a:t>~2,000 HVGs | 319-387 Reactome programs | 250-epoch query mapping</a:t>
+            </a:r>
+          </a:p>
+        </p:txBody>
+      </p:sp>
+      <p:sp>
+        <p:nvSpPr>
+          <p:cNvPr id="108" name="Rectangle 107"/>
           <p:cNvSpPr/>
           <p:nvPr/>
         </p:nvSpPr>
@@ -8338,7 +8503,7 @@
       </p:sp>
       <p:sp>
         <p:nvSpPr>
-          <p:cNvPr id="106" name="Rectangle 105"/>
+          <p:cNvPr id="109" name="Rectangle 108"/>
           <p:cNvSpPr/>
           <p:nvPr/>
         </p:nvSpPr>
@@ -8383,7 +8548,7 @@
       </p:sp>
       <p:sp>
         <p:nvSpPr>
-          <p:cNvPr id="107" name="TextBox 106"/>
+          <p:cNvPr id="110" name="TextBox 109"/>
           <p:cNvSpPr txBox="1"/>
           <p:nvPr/>
         </p:nvSpPr>
@@ -8398,7 +8563,7 @@
           <a:noFill/>
         </p:spPr>
         <p:txBody>
-          <a:bodyPr wrap="square" lIns="0" rIns="0" tIns="0" bIns="0" anchor="ctr">
+          <a:bodyPr wrap="none" lIns="0" rIns="0" tIns="0" bIns="0" anchor="ctr">
             <a:spAutoFit/>
           </a:bodyPr>
           <a:lstStyle/>
@@ -8428,7 +8593,7 @@
       </p:sp>
       <p:pic>
         <p:nvPicPr>
-          <p:cNvPr id="108" name="Retained pathway shifts" descr="Project-balanced expiMap pathway shifts for thymus, skin, liver, and spleen, with project effects and three-training ranges."/>
+          <p:cNvPr id="111" name="Retained pathway shifts" descr="Project-balanced expiMap pathway shifts for thymus, skin, liver, and spleen, with project effects and three-training ranges."/>
           <p:cNvPicPr>
             <a:picLocks noChangeAspect="1"/>
           </p:cNvPicPr>
@@ -8452,7 +8617,7 @@
       </p:pic>
       <p:sp>
         <p:nvSpPr>
-          <p:cNvPr id="109" name="TextBox 108"/>
+          <p:cNvPr id="112" name="TextBox 111"/>
           <p:cNvSpPr txBox="1"/>
           <p:nvPr/>
         </p:nvSpPr>
@@ -8497,7 +8662,7 @@
       </p:sp>
       <p:sp>
         <p:nvSpPr>
-          <p:cNvPr id="110" name="Rectangle 109"/>
+          <p:cNvPr id="113" name="Rectangle 112"/>
           <p:cNvSpPr/>
           <p:nvPr/>
         </p:nvSpPr>
@@ -8540,7 +8705,7 @@
       </p:sp>
       <p:sp>
         <p:nvSpPr>
-          <p:cNvPr id="111" name="Rectangle 110"/>
+          <p:cNvPr id="114" name="Rectangle 113"/>
           <p:cNvSpPr/>
           <p:nvPr/>
         </p:nvSpPr>
@@ -8585,7 +8750,7 @@
       </p:sp>
       <p:sp>
         <p:nvSpPr>
-          <p:cNvPr id="112" name="TextBox 111"/>
+          <p:cNvPr id="115" name="TextBox 114"/>
           <p:cNvSpPr txBox="1"/>
           <p:nvPr/>
         </p:nvSpPr>
@@ -8600,7 +8765,7 @@
           <a:noFill/>
         </p:spPr>
         <p:txBody>
-          <a:bodyPr wrap="square" lIns="0" rIns="0" tIns="0" bIns="0" anchor="ctr">
+          <a:bodyPr wrap="none" lIns="0" rIns="0" tIns="0" bIns="0" anchor="ctr">
             <a:spAutoFit/>
           </a:bodyPr>
           <a:lstStyle/>
@@ -8630,7 +8795,7 @@
       </p:sp>
       <p:sp>
         <p:nvSpPr>
-          <p:cNvPr id="113" name="TextBox 112"/>
+          <p:cNvPr id="116" name="TextBox 115"/>
           <p:cNvSpPr txBox="1"/>
           <p:nvPr/>
         </p:nvSpPr>
@@ -8645,7 +8810,7 @@
           <a:noFill/>
         </p:spPr>
         <p:txBody>
-          <a:bodyPr wrap="square" lIns="0" rIns="0" tIns="0" bIns="0" anchor="t">
+          <a:bodyPr wrap="none" lIns="0" rIns="0" tIns="0" bIns="0" anchor="t">
             <a:spAutoFit/>
           </a:bodyPr>
           <a:lstStyle/>
@@ -8675,7 +8840,7 @@
       </p:sp>
       <p:pic>
         <p:nvPicPr>
-          <p:cNvPr id="114" name="Tissue-state hypotheses" descr="Observed lower expiMap program scores and qualified tissue-state hypotheses for thymus, skin, liver, and spleen."/>
+          <p:cNvPr id="117" name="Tissue-state hypotheses" descr="Observed lower expiMap program scores and qualified tissue-state hypotheses for thymus, skin, liver, and spleen."/>
           <p:cNvPicPr>
             <a:picLocks noChangeAspect="1"/>
           </p:cNvPicPr>
@@ -8699,7 +8864,7 @@
       </p:pic>
       <p:sp>
         <p:nvSpPr>
-          <p:cNvPr id="115" name="Rectangle 114"/>
+          <p:cNvPr id="118" name="Rectangle 117"/>
           <p:cNvSpPr/>
           <p:nvPr/>
         </p:nvSpPr>
@@ -8742,7 +8907,7 @@
       </p:sp>
       <p:sp>
         <p:nvSpPr>
-          <p:cNvPr id="116" name="Rectangle 115"/>
+          <p:cNvPr id="119" name="Rectangle 118"/>
           <p:cNvSpPr/>
           <p:nvPr/>
         </p:nvSpPr>
@@ -8787,7 +8952,7 @@
       </p:sp>
       <p:sp>
         <p:nvSpPr>
-          <p:cNvPr id="117" name="TextBox 116"/>
+          <p:cNvPr id="120" name="TextBox 119"/>
           <p:cNvSpPr txBox="1"/>
           <p:nvPr/>
         </p:nvSpPr>
@@ -8802,7 +8967,7 @@
           <a:noFill/>
         </p:spPr>
         <p:txBody>
-          <a:bodyPr wrap="square" lIns="0" rIns="0" tIns="0" bIns="0" anchor="ctr">
+          <a:bodyPr wrap="none" lIns="0" rIns="0" tIns="0" bIns="0" anchor="ctr">
             <a:spAutoFit/>
           </a:bodyPr>
           <a:lstStyle/>
@@ -8832,7 +8997,7 @@
       </p:sp>
       <p:sp>
         <p:nvSpPr>
-          <p:cNvPr id="118" name="TextBox 117"/>
+          <p:cNvPr id="121" name="TextBox 120"/>
           <p:cNvSpPr txBox="1"/>
           <p:nvPr/>
         </p:nvSpPr>
@@ -8921,7 +9086,7 @@
       </p:sp>
       <p:sp>
         <p:nvSpPr>
-          <p:cNvPr id="119" name="Rectangle 118"/>
+          <p:cNvPr id="122" name="Rectangle 121"/>
           <p:cNvSpPr/>
           <p:nvPr/>
         </p:nvSpPr>
@@ -8964,7 +9129,7 @@
       </p:sp>
       <p:sp>
         <p:nvSpPr>
-          <p:cNvPr id="120" name="Rectangle 119"/>
+          <p:cNvPr id="123" name="Rectangle 122"/>
           <p:cNvSpPr/>
           <p:nvPr/>
         </p:nvSpPr>
@@ -9009,7 +9174,7 @@
       </p:sp>
       <p:sp>
         <p:nvSpPr>
-          <p:cNvPr id="121" name="TextBox 120"/>
+          <p:cNvPr id="124" name="TextBox 123"/>
           <p:cNvSpPr txBox="1"/>
           <p:nvPr/>
         </p:nvSpPr>
@@ -9024,7 +9189,7 @@
           <a:noFill/>
         </p:spPr>
         <p:txBody>
-          <a:bodyPr wrap="square" lIns="0" rIns="0" tIns="0" bIns="0" anchor="ctr">
+          <a:bodyPr wrap="none" lIns="0" rIns="0" tIns="0" bIns="0" anchor="ctr">
             <a:spAutoFit/>
           </a:bodyPr>
           <a:lstStyle/>
@@ -9054,7 +9219,7 @@
       </p:sp>
       <p:sp>
         <p:nvSpPr>
-          <p:cNvPr id="122" name="TextBox 121"/>
+          <p:cNvPr id="125" name="TextBox 124"/>
           <p:cNvSpPr txBox="1"/>
           <p:nvPr/>
         </p:nvSpPr>
@@ -9099,7 +9264,7 @@
       </p:sp>
       <p:sp>
         <p:nvSpPr>
-          <p:cNvPr id="123" name="Rectangle 122"/>
+          <p:cNvPr id="126" name="Rectangle 125"/>
           <p:cNvSpPr/>
           <p:nvPr/>
         </p:nvSpPr>
@@ -9142,7 +9307,7 @@
       </p:sp>
       <p:sp>
         <p:nvSpPr>
-          <p:cNvPr id="124" name="TextBox 123"/>
+          <p:cNvPr id="127" name="TextBox 126"/>
           <p:cNvSpPr txBox="1"/>
           <p:nvPr/>
         </p:nvSpPr>
@@ -9187,7 +9352,7 @@
       </p:sp>
       <p:sp>
         <p:nvSpPr>
-          <p:cNvPr id="125" name="TextBox 124"/>
+          <p:cNvPr id="128" name="TextBox 127"/>
           <p:cNvSpPr txBox="1"/>
           <p:nvPr/>
         </p:nvSpPr>
@@ -9232,7 +9397,7 @@
       </p:sp>
       <p:sp>
         <p:nvSpPr>
-          <p:cNvPr id="126" name="TextBox 125"/>
+          <p:cNvPr id="129" name="TextBox 128"/>
           <p:cNvSpPr txBox="1"/>
           <p:nvPr/>
         </p:nvSpPr>
@@ -9247,7 +9412,7 @@
           <a:noFill/>
         </p:spPr>
         <p:txBody>
-          <a:bodyPr wrap="square" lIns="0" rIns="0" tIns="0" bIns="0" anchor="t">
+          <a:bodyPr wrap="none" lIns="0" rIns="0" tIns="0" bIns="0" anchor="t">
             <a:spAutoFit/>
           </a:bodyPr>
           <a:lstStyle/>
@@ -9278,7 +9443,7 @@
       </p:sp>
       <p:sp>
         <p:nvSpPr>
-          <p:cNvPr id="127" name="TextBox 126"/>
+          <p:cNvPr id="130" name="TextBox 129"/>
           <p:cNvSpPr txBox="1"/>
           <p:nvPr/>
         </p:nvSpPr>

</xml_diff>

<commit_message>
fix poster abstract overflow and paragraph flow
</commit_message>
<xml_diff>
--- a/paper/asgsr_expimap_hvg/poster/asgsr_expimap_poster.pptx
+++ b/paper/asgsr_expimap_hvg/poster/asgsr_expimap_poster.pptx
@@ -3485,7 +3485,7 @@
         <p:spPr>
           <a:xfrm>
             <a:off x="777240" y="5925312"/>
-            <a:ext cx="12938760" cy="2212848"/>
+            <a:ext cx="12938760" cy="2286000"/>
           </a:xfrm>
           <a:prstGeom prst="rect">
             <a:avLst/>
@@ -3516,7 +3516,7 @@
                 </a:solidFill>
                 <a:latin typeface="Arial"/>
               </a:rPr>
-              <a:t>Spaceflight affects multiple organs, but differences among missions can obscure responses that recur across studies. We asked whether pathway-constrained expiMap models could identify reproducible programs in NASA OSDR mouse bulk RNA-seq. Samples were mapped into tissue-matched ARCHS4 references using approximately 2,000 highly variable genes linked to current mouse Reactome pathways. Project-balanced flight-ground shifts were evaluated with enrichment, held-out projects, three complete trainings, composition proxies, and member-gene review. Retained patterns included lower repair and cytoskeletal programs in thymus, lower maintenance and barrier programs in skin, lower adaptive-immune programs in liver, and coordinated lower adaptive and innate immune programs in spleen, the strongest multi-pathway result.</a:t>
+              <a:t>Mission differences can obscure spaceflight responses shared across studies. We mapped NASA OSDR mouse bulk RNA sequencing samples to ARCHS4 references matched by tissue and analyzed about 2,000 highly variable genes with expiMap models constrained by Reactome. Flight versus ground shifts were balanced across projects and assessed with enrichment tests, project holdouts, three training runs, composition proxies, review of member genes, and post-score literature annotation. Retained programs were lower for thymic repair and cytoskeletal processes, skin maintenance and barrier processes, liver adaptive immunity, and spleen adaptive and innate immunity. Spleen showed the strongest result across multiple pathways.</a:t>
             </a:r>
           </a:p>
         </p:txBody>

</xml_diff>

<commit_message>
expand poster evidence and refine expiMap architecture
</commit_message>
<xml_diff>
--- a/paper/asgsr_expimap_hvg/poster/asgsr_expimap_poster.pptx
+++ b/paper/asgsr_expimap_hvg/poster/asgsr_expimap_poster.pptx
@@ -3516,7 +3516,7 @@
                 </a:solidFill>
                 <a:latin typeface="Arial"/>
               </a:rPr>
-              <a:t>Mission differences can obscure spaceflight responses shared across studies. We mapped NASA OSDR mouse bulk RNA sequencing samples to ARCHS4 references matched by tissue and analyzed about 2,000 highly variable genes with expiMap models constrained by Reactome. Flight versus ground shifts were balanced across projects and assessed with enrichment tests, project holdouts, three training runs, composition proxies, review of member genes, and post-score literature annotation. Retained programs were lower for thymic repair and cytoskeletal processes, skin maintenance and barrier processes, liver adaptive immunity, and spleen adaptive and innate immunity. Spleen showed the strongest result across multiple pathways.</a:t>
+              <a:t>Mission differences can obscure spaceflight responses shared across studies. We mapped NASA OSDR mouse bulk RNA sequencing samples to ARCHS4 references matched by tissue. We used expiMap models constrained by Reactome to analyze about 2,000 highly variable genes. Flight versus ground shifts were balanced across projects and assessed with enrichment tests, project holdouts, three training runs, composition proxies, review of member genes, and literature annotation after scoring. Retained programs were lower for thymic repair and cytoskeletal processes, skin maintenance and barrier processes, liver adaptive immunity, and spleen adaptive and innate immunity. Spleen showed the strongest result across multiple pathways.</a:t>
             </a:r>
           </a:p>
         </p:txBody>
@@ -6166,7 +6166,7 @@
           <a:noFill/>
         </p:spPr>
         <p:txBody>
-          <a:bodyPr wrap="square" lIns="0" rIns="0" tIns="0" bIns="0" anchor="t">
+          <a:bodyPr wrap="none" lIns="0" rIns="0" tIns="0" bIns="0" anchor="t">
             <a:spAutoFit/>
           </a:bodyPr>
           <a:lstStyle/>
@@ -6189,7 +6189,7 @@
                 </a:solidFill>
                 <a:latin typeface="Arial"/>
               </a:rPr>
-              <a:t>Tissue expiMap reference</a:t>
+              <a:t>expiMap tissue model</a:t>
             </a:r>
           </a:p>
         </p:txBody>
@@ -6373,9 +6373,9 @@
           <p:nvPr/>
         </p:nvSpPr>
         <p:spPr>
-          <a:xfrm>
-            <a:off x="19751040" y="7626096"/>
-            <a:ext cx="1920240" cy="1298448"/>
+          <a:xfrm rot="5400000">
+            <a:off x="19869912" y="7626096"/>
+            <a:ext cx="1353312" cy="1298448"/>
           </a:xfrm>
           <a:prstGeom prst="trapezoid">
             <a:avLst/>
@@ -6419,8 +6419,8 @@
         </p:nvSpPr>
         <p:spPr>
           <a:xfrm>
-            <a:off x="19860768" y="8083296"/>
-            <a:ext cx="1700784" cy="347472"/>
+            <a:off x="19824192" y="8083296"/>
+            <a:ext cx="1444752" cy="347472"/>
           </a:xfrm>
           <a:prstGeom prst="rect">
             <a:avLst/>
@@ -6445,13 +6445,13 @@
               </a:spcAft>
             </a:pPr>
             <a:r>
-              <a:rPr sz="1450" b="1" i="0">
+              <a:rPr sz="1400" b="1" i="0">
                 <a:solidFill>
                   <a:srgbClr val="071C3F"/>
                 </a:solidFill>
                 <a:latin typeface="Arial"/>
               </a:rPr>
-              <a:t>Dense encoder</a:t>
+              <a:t>Encoder</a:t>
             </a:r>
           </a:p>
         </p:txBody>
@@ -6465,7 +6465,7 @@
         <p:spPr>
           <a:xfrm>
             <a:off x="19604735" y="7854695"/>
-            <a:ext cx="310897" cy="420625"/>
+            <a:ext cx="301753" cy="420625"/>
           </a:xfrm>
           <a:prstGeom prst="line">
             <a:avLst/>
@@ -6500,7 +6500,7 @@
         <p:spPr>
           <a:xfrm>
             <a:off x="19604735" y="8238743"/>
-            <a:ext cx="310897" cy="36577"/>
+            <a:ext cx="301753" cy="36577"/>
           </a:xfrm>
           <a:prstGeom prst="line">
             <a:avLst/>
@@ -6535,7 +6535,7 @@
         <p:spPr>
           <a:xfrm flipV="1">
             <a:off x="19604735" y="8275320"/>
-            <a:ext cx="310897" cy="347471"/>
+            <a:ext cx="301753" cy="347471"/>
           </a:xfrm>
           <a:prstGeom prst="line">
             <a:avLst/>
@@ -6570,7 +6570,7 @@
         <p:spPr>
           <a:xfrm flipV="1">
             <a:off x="19604735" y="8275320"/>
-            <a:ext cx="310897" cy="731519"/>
+            <a:ext cx="301753" cy="731519"/>
           </a:xfrm>
           <a:prstGeom prst="line">
             <a:avLst/>
@@ -6604,8 +6604,8 @@
         </p:nvCxnSpPr>
         <p:spPr>
           <a:xfrm flipV="1">
-            <a:off x="21506688" y="7799831"/>
-            <a:ext cx="374904" cy="475489"/>
+            <a:off x="21186648" y="7799831"/>
+            <a:ext cx="457200" cy="475489"/>
           </a:xfrm>
           <a:prstGeom prst="line">
             <a:avLst/>
@@ -6639,7 +6639,7 @@
         </p:nvSpPr>
         <p:spPr>
           <a:xfrm>
-            <a:off x="21881592" y="7653527"/>
+            <a:off x="21643848" y="7653527"/>
             <a:ext cx="292608" cy="292608"/>
           </a:xfrm>
           <a:prstGeom prst="ellipse">
@@ -6682,7 +6682,7 @@
         </p:nvSpPr>
         <p:spPr>
           <a:xfrm>
-            <a:off x="22247352" y="7635240"/>
+            <a:off x="22009608" y="7635240"/>
             <a:ext cx="2029968" cy="329184"/>
           </a:xfrm>
           <a:prstGeom prst="roundRect">
@@ -6729,7 +6729,7 @@
         </p:nvSpPr>
         <p:spPr>
           <a:xfrm>
-            <a:off x="22338792" y="7635240"/>
+            <a:off x="22101048" y="7635240"/>
             <a:ext cx="1847088" cy="329184"/>
           </a:xfrm>
           <a:prstGeom prst="rect">
@@ -6774,8 +6774,8 @@
         </p:nvCxnSpPr>
         <p:spPr>
           <a:xfrm flipV="1">
-            <a:off x="21506688" y="8238744"/>
-            <a:ext cx="374904" cy="36576"/>
+            <a:off x="21186648" y="8238744"/>
+            <a:ext cx="457200" cy="36576"/>
           </a:xfrm>
           <a:prstGeom prst="line">
             <a:avLst/>
@@ -6809,7 +6809,7 @@
         </p:nvSpPr>
         <p:spPr>
           <a:xfrm>
-            <a:off x="21881592" y="8092440"/>
+            <a:off x="21643848" y="8092440"/>
             <a:ext cx="292608" cy="292608"/>
           </a:xfrm>
           <a:prstGeom prst="ellipse">
@@ -6852,7 +6852,7 @@
         </p:nvSpPr>
         <p:spPr>
           <a:xfrm>
-            <a:off x="22247352" y="8074152"/>
+            <a:off x="22009608" y="8074152"/>
             <a:ext cx="2029968" cy="329184"/>
           </a:xfrm>
           <a:prstGeom prst="roundRect">
@@ -6899,7 +6899,7 @@
         </p:nvSpPr>
         <p:spPr>
           <a:xfrm>
-            <a:off x="22338792" y="8074152"/>
+            <a:off x="22101048" y="8074152"/>
             <a:ext cx="1847088" cy="329184"/>
           </a:xfrm>
           <a:prstGeom prst="rect">
@@ -6944,8 +6944,8 @@
         </p:nvCxnSpPr>
         <p:spPr>
           <a:xfrm>
-            <a:off x="21506688" y="8275320"/>
-            <a:ext cx="374904" cy="402336"/>
+            <a:off x="21186648" y="8275320"/>
+            <a:ext cx="457200" cy="402336"/>
           </a:xfrm>
           <a:prstGeom prst="line">
             <a:avLst/>
@@ -6979,7 +6979,7 @@
         </p:nvSpPr>
         <p:spPr>
           <a:xfrm>
-            <a:off x="21881592" y="8531352"/>
+            <a:off x="21643848" y="8531352"/>
             <a:ext cx="292608" cy="292608"/>
           </a:xfrm>
           <a:prstGeom prst="ellipse">
@@ -7022,7 +7022,7 @@
         </p:nvSpPr>
         <p:spPr>
           <a:xfrm>
-            <a:off x="22247352" y="8513064"/>
+            <a:off x="22009608" y="8513064"/>
             <a:ext cx="2029968" cy="329184"/>
           </a:xfrm>
           <a:prstGeom prst="roundRect">
@@ -7069,7 +7069,7 @@
         </p:nvSpPr>
         <p:spPr>
           <a:xfrm>
-            <a:off x="22338792" y="8513064"/>
+            <a:off x="22101048" y="8513064"/>
             <a:ext cx="1847088" cy="329184"/>
           </a:xfrm>
           <a:prstGeom prst="rect">
@@ -7106,16 +7106,488 @@
           </a:p>
         </p:txBody>
       </p:sp>
-      <p:sp>
-        <p:nvSpPr>
-          <p:cNvPr id="80" name="Rounded Rectangle 79"/>
+      <p:cxnSp>
+        <p:nvCxnSpPr>
+          <p:cNvPr id="80" name="Connector 79"/>
+          <p:cNvCxnSpPr/>
+          <p:nvPr/>
+        </p:nvCxnSpPr>
+        <p:spPr>
+          <a:xfrm>
+            <a:off x="24039576" y="7799831"/>
+            <a:ext cx="3209544" cy="36576"/>
+          </a:xfrm>
+          <a:prstGeom prst="line">
+            <a:avLst/>
+          </a:prstGeom>
+          <a:ln w="15240">
+            <a:solidFill>
+              <a:srgbClr val="6A4C93"/>
+            </a:solidFill>
+          </a:ln>
+        </p:spPr>
+        <p:style>
+          <a:lnRef idx="2">
+            <a:schemeClr val="accent1"/>
+          </a:lnRef>
+          <a:fillRef idx="0">
+            <a:schemeClr val="accent1"/>
+          </a:fillRef>
+          <a:effectRef idx="1">
+            <a:schemeClr val="accent1"/>
+          </a:effectRef>
+          <a:fontRef idx="minor">
+            <a:schemeClr val="tx1"/>
+          </a:fontRef>
+        </p:style>
+      </p:cxnSp>
+      <p:cxnSp>
+        <p:nvCxnSpPr>
+          <p:cNvPr id="81" name="Connector 80"/>
+          <p:cNvCxnSpPr/>
+          <p:nvPr/>
+        </p:nvCxnSpPr>
+        <p:spPr>
+          <a:xfrm>
+            <a:off x="24039576" y="7799831"/>
+            <a:ext cx="3209544" cy="731520"/>
+          </a:xfrm>
+          <a:prstGeom prst="line">
+            <a:avLst/>
+          </a:prstGeom>
+          <a:ln w="15240">
+            <a:solidFill>
+              <a:srgbClr val="6A4C93"/>
+            </a:solidFill>
+          </a:ln>
+        </p:spPr>
+        <p:style>
+          <a:lnRef idx="2">
+            <a:schemeClr val="accent1"/>
+          </a:lnRef>
+          <a:fillRef idx="0">
+            <a:schemeClr val="accent1"/>
+          </a:fillRef>
+          <a:effectRef idx="1">
+            <a:schemeClr val="accent1"/>
+          </a:effectRef>
+          <a:fontRef idx="minor">
+            <a:schemeClr val="tx1"/>
+          </a:fontRef>
+        </p:style>
+      </p:cxnSp>
+      <p:cxnSp>
+        <p:nvCxnSpPr>
+          <p:cNvPr id="82" name="Connector 81"/>
+          <p:cNvCxnSpPr/>
+          <p:nvPr/>
+        </p:nvCxnSpPr>
+        <p:spPr>
+          <a:xfrm flipV="1">
+            <a:off x="24039576" y="8183879"/>
+            <a:ext cx="3209544" cy="54865"/>
+          </a:xfrm>
+          <a:prstGeom prst="line">
+            <a:avLst/>
+          </a:prstGeom>
+          <a:ln w="15240">
+            <a:solidFill>
+              <a:srgbClr val="A64D67"/>
+            </a:solidFill>
+          </a:ln>
+        </p:spPr>
+        <p:style>
+          <a:lnRef idx="2">
+            <a:schemeClr val="accent1"/>
+          </a:lnRef>
+          <a:fillRef idx="0">
+            <a:schemeClr val="accent1"/>
+          </a:fillRef>
+          <a:effectRef idx="1">
+            <a:schemeClr val="accent1"/>
+          </a:effectRef>
+          <a:fontRef idx="minor">
+            <a:schemeClr val="tx1"/>
+          </a:fontRef>
+        </p:style>
+      </p:cxnSp>
+      <p:cxnSp>
+        <p:nvCxnSpPr>
+          <p:cNvPr id="83" name="Connector 82"/>
+          <p:cNvCxnSpPr/>
+          <p:nvPr/>
+        </p:nvCxnSpPr>
+        <p:spPr>
+          <a:xfrm>
+            <a:off x="24039576" y="8238744"/>
+            <a:ext cx="3209544" cy="640080"/>
+          </a:xfrm>
+          <a:prstGeom prst="line">
+            <a:avLst/>
+          </a:prstGeom>
+          <a:ln w="15240">
+            <a:solidFill>
+              <a:srgbClr val="A64D67"/>
+            </a:solidFill>
+          </a:ln>
+        </p:spPr>
+        <p:style>
+          <a:lnRef idx="2">
+            <a:schemeClr val="accent1"/>
+          </a:lnRef>
+          <a:fillRef idx="0">
+            <a:schemeClr val="accent1"/>
+          </a:fillRef>
+          <a:effectRef idx="1">
+            <a:schemeClr val="accent1"/>
+          </a:effectRef>
+          <a:fontRef idx="minor">
+            <a:schemeClr val="tx1"/>
+          </a:fontRef>
+        </p:style>
+      </p:cxnSp>
+      <p:cxnSp>
+        <p:nvCxnSpPr>
+          <p:cNvPr id="84" name="Connector 83"/>
+          <p:cNvCxnSpPr/>
+          <p:nvPr/>
+        </p:nvCxnSpPr>
+        <p:spPr>
+          <a:xfrm flipV="1">
+            <a:off x="24039576" y="8531351"/>
+            <a:ext cx="3209544" cy="146305"/>
+          </a:xfrm>
+          <a:prstGeom prst="line">
+            <a:avLst/>
+          </a:prstGeom>
+          <a:ln w="15240">
+            <a:solidFill>
+              <a:srgbClr val="C65D37"/>
+            </a:solidFill>
+          </a:ln>
+        </p:spPr>
+        <p:style>
+          <a:lnRef idx="2">
+            <a:schemeClr val="accent1"/>
+          </a:lnRef>
+          <a:fillRef idx="0">
+            <a:schemeClr val="accent1"/>
+          </a:fillRef>
+          <a:effectRef idx="1">
+            <a:schemeClr val="accent1"/>
+          </a:effectRef>
+          <a:fontRef idx="minor">
+            <a:schemeClr val="tx1"/>
+          </a:fontRef>
+        </p:style>
+      </p:cxnSp>
+      <p:cxnSp>
+        <p:nvCxnSpPr>
+          <p:cNvPr id="85" name="Connector 84"/>
+          <p:cNvCxnSpPr/>
+          <p:nvPr/>
+        </p:nvCxnSpPr>
+        <p:spPr>
+          <a:xfrm>
+            <a:off x="24039576" y="8677656"/>
+            <a:ext cx="3209544" cy="201168"/>
+          </a:xfrm>
+          <a:prstGeom prst="line">
+            <a:avLst/>
+          </a:prstGeom>
+          <a:ln w="15240">
+            <a:solidFill>
+              <a:srgbClr val="C65D37"/>
+            </a:solidFill>
+          </a:ln>
+        </p:spPr>
+        <p:style>
+          <a:lnRef idx="2">
+            <a:schemeClr val="accent1"/>
+          </a:lnRef>
+          <a:fillRef idx="0">
+            <a:schemeClr val="accent1"/>
+          </a:fillRef>
+          <a:effectRef idx="1">
+            <a:schemeClr val="accent1"/>
+          </a:effectRef>
+          <a:fontRef idx="minor">
+            <a:schemeClr val="tx1"/>
+          </a:fontRef>
+        </p:style>
+      </p:cxnSp>
+      <p:sp>
+        <p:nvSpPr>
+          <p:cNvPr id="86" name="Trapezoid 85"/>
           <p:cNvSpPr/>
           <p:nvPr/>
         </p:nvSpPr>
         <p:spPr>
-          <a:xfrm>
-            <a:off x="24505920" y="7168896"/>
-            <a:ext cx="3246120" cy="530352"/>
+          <a:xfrm rot="16200000">
+            <a:off x="24533352" y="7626096"/>
+            <a:ext cx="1353312" cy="1298448"/>
+          </a:xfrm>
+          <a:prstGeom prst="trapezoid">
+            <a:avLst/>
+          </a:prstGeom>
+          <a:solidFill>
+            <a:srgbClr val="E5F1EC"/>
+          </a:solidFill>
+          <a:ln w="17780">
+            <a:solidFill>
+              <a:srgbClr val="178C6A"/>
+            </a:solidFill>
+          </a:ln>
+        </p:spPr>
+        <p:style>
+          <a:lnRef idx="1">
+            <a:schemeClr val="accent1"/>
+          </a:lnRef>
+          <a:fillRef idx="3">
+            <a:schemeClr val="accent1"/>
+          </a:fillRef>
+          <a:effectRef idx="2">
+            <a:schemeClr val="accent1"/>
+          </a:effectRef>
+          <a:fontRef idx="minor">
+            <a:schemeClr val="lt1"/>
+          </a:fontRef>
+        </p:style>
+        <p:txBody>
+          <a:bodyPr rtlCol="0" anchor="ctr"/>
+          <a:lstStyle/>
+          <a:p>
+            <a:pPr algn="ctr"/>
+          </a:p>
+        </p:txBody>
+      </p:sp>
+      <p:sp>
+        <p:nvSpPr>
+          <p:cNvPr id="87" name="TextBox 86"/>
+          <p:cNvSpPr txBox="1"/>
+          <p:nvPr/>
+        </p:nvSpPr>
+        <p:spPr>
+          <a:xfrm>
+            <a:off x="24423623" y="8083296"/>
+            <a:ext cx="1572768" cy="347472"/>
+          </a:xfrm>
+          <a:prstGeom prst="rect">
+            <a:avLst/>
+          </a:prstGeom>
+          <a:noFill/>
+        </p:spPr>
+        <p:txBody>
+          <a:bodyPr wrap="none" lIns="0" rIns="0" tIns="0" bIns="0" anchor="ctr">
+            <a:spAutoFit/>
+          </a:bodyPr>
+          <a:lstStyle/>
+          <a:p>
+            <a:pPr algn="ctr">
+              <a:lnSpc>
+                <a:spcPct val="100000"/>
+              </a:lnSpc>
+              <a:spcBef>
+                <a:spcPts val="0"/>
+              </a:spcBef>
+              <a:spcAft>
+                <a:spcPts val="0"/>
+              </a:spcAft>
+            </a:pPr>
+            <a:r>
+              <a:rPr sz="1350" b="1" i="0">
+                <a:solidFill>
+                  <a:srgbClr val="071C3F"/>
+                </a:solidFill>
+                <a:latin typeface="Arial"/>
+              </a:rPr>
+              <a:t>Decoder</a:t>
+            </a:r>
+          </a:p>
+        </p:txBody>
+      </p:sp>
+      <p:sp>
+        <p:nvSpPr>
+          <p:cNvPr id="88" name="Oval 87"/>
+          <p:cNvSpPr/>
+          <p:nvPr/>
+        </p:nvSpPr>
+        <p:spPr>
+          <a:xfrm>
+            <a:off x="27249120" y="7726679"/>
+            <a:ext cx="219456" cy="219456"/>
+          </a:xfrm>
+          <a:prstGeom prst="ellipse">
+            <a:avLst/>
+          </a:prstGeom>
+          <a:solidFill>
+            <a:srgbClr val="A9BBD0"/>
+          </a:solidFill>
+          <a:ln>
+            <a:noFill/>
+          </a:ln>
+        </p:spPr>
+        <p:style>
+          <a:lnRef idx="1">
+            <a:schemeClr val="accent1"/>
+          </a:lnRef>
+          <a:fillRef idx="3">
+            <a:schemeClr val="accent1"/>
+          </a:fillRef>
+          <a:effectRef idx="2">
+            <a:schemeClr val="accent1"/>
+          </a:effectRef>
+          <a:fontRef idx="minor">
+            <a:schemeClr val="lt1"/>
+          </a:fontRef>
+        </p:style>
+        <p:txBody>
+          <a:bodyPr rtlCol="0" anchor="ctr"/>
+          <a:lstStyle/>
+          <a:p>
+            <a:pPr algn="ctr"/>
+          </a:p>
+        </p:txBody>
+      </p:sp>
+      <p:sp>
+        <p:nvSpPr>
+          <p:cNvPr id="89" name="Oval 88"/>
+          <p:cNvSpPr/>
+          <p:nvPr/>
+        </p:nvSpPr>
+        <p:spPr>
+          <a:xfrm>
+            <a:off x="27249120" y="8074152"/>
+            <a:ext cx="219456" cy="219456"/>
+          </a:xfrm>
+          <a:prstGeom prst="ellipse">
+            <a:avLst/>
+          </a:prstGeom>
+          <a:solidFill>
+            <a:srgbClr val="A9BBD0"/>
+          </a:solidFill>
+          <a:ln>
+            <a:noFill/>
+          </a:ln>
+        </p:spPr>
+        <p:style>
+          <a:lnRef idx="1">
+            <a:schemeClr val="accent1"/>
+          </a:lnRef>
+          <a:fillRef idx="3">
+            <a:schemeClr val="accent1"/>
+          </a:fillRef>
+          <a:effectRef idx="2">
+            <a:schemeClr val="accent1"/>
+          </a:effectRef>
+          <a:fontRef idx="minor">
+            <a:schemeClr val="lt1"/>
+          </a:fontRef>
+        </p:style>
+        <p:txBody>
+          <a:bodyPr rtlCol="0" anchor="ctr"/>
+          <a:lstStyle/>
+          <a:p>
+            <a:pPr algn="ctr"/>
+          </a:p>
+        </p:txBody>
+      </p:sp>
+      <p:sp>
+        <p:nvSpPr>
+          <p:cNvPr id="90" name="Oval 89"/>
+          <p:cNvSpPr/>
+          <p:nvPr/>
+        </p:nvSpPr>
+        <p:spPr>
+          <a:xfrm>
+            <a:off x="27249120" y="8421624"/>
+            <a:ext cx="219456" cy="219456"/>
+          </a:xfrm>
+          <a:prstGeom prst="ellipse">
+            <a:avLst/>
+          </a:prstGeom>
+          <a:solidFill>
+            <a:srgbClr val="A9BBD0"/>
+          </a:solidFill>
+          <a:ln>
+            <a:noFill/>
+          </a:ln>
+        </p:spPr>
+        <p:style>
+          <a:lnRef idx="1">
+            <a:schemeClr val="accent1"/>
+          </a:lnRef>
+          <a:fillRef idx="3">
+            <a:schemeClr val="accent1"/>
+          </a:fillRef>
+          <a:effectRef idx="2">
+            <a:schemeClr val="accent1"/>
+          </a:effectRef>
+          <a:fontRef idx="minor">
+            <a:schemeClr val="lt1"/>
+          </a:fontRef>
+        </p:style>
+        <p:txBody>
+          <a:bodyPr rtlCol="0" anchor="ctr"/>
+          <a:lstStyle/>
+          <a:p>
+            <a:pPr algn="ctr"/>
+          </a:p>
+        </p:txBody>
+      </p:sp>
+      <p:sp>
+        <p:nvSpPr>
+          <p:cNvPr id="91" name="Oval 90"/>
+          <p:cNvSpPr/>
+          <p:nvPr/>
+        </p:nvSpPr>
+        <p:spPr>
+          <a:xfrm>
+            <a:off x="27249120" y="8769096"/>
+            <a:ext cx="219456" cy="219456"/>
+          </a:xfrm>
+          <a:prstGeom prst="ellipse">
+            <a:avLst/>
+          </a:prstGeom>
+          <a:solidFill>
+            <a:srgbClr val="A9BBD0"/>
+          </a:solidFill>
+          <a:ln>
+            <a:noFill/>
+          </a:ln>
+        </p:spPr>
+        <p:style>
+          <a:lnRef idx="1">
+            <a:schemeClr val="accent1"/>
+          </a:lnRef>
+          <a:fillRef idx="3">
+            <a:schemeClr val="accent1"/>
+          </a:fillRef>
+          <a:effectRef idx="2">
+            <a:schemeClr val="accent1"/>
+          </a:effectRef>
+          <a:fontRef idx="minor">
+            <a:schemeClr val="lt1"/>
+          </a:fontRef>
+        </p:style>
+        <p:txBody>
+          <a:bodyPr rtlCol="0" anchor="ctr"/>
+          <a:lstStyle/>
+          <a:p>
+            <a:pPr algn="ctr"/>
+          </a:p>
+        </p:txBody>
+      </p:sp>
+      <p:sp>
+        <p:nvSpPr>
+          <p:cNvPr id="92" name="Rounded Rectangle 91"/>
+          <p:cNvSpPr/>
+          <p:nvPr/>
+        </p:nvSpPr>
+        <p:spPr>
+          <a:xfrm>
+            <a:off x="24112727" y="7168896"/>
+            <a:ext cx="3456432" cy="530352"/>
           </a:xfrm>
           <a:prstGeom prst="roundRect">
             <a:avLst/>
@@ -7153,14 +7625,14 @@
       </p:sp>
       <p:sp>
         <p:nvSpPr>
-          <p:cNvPr id="81" name="TextBox 80"/>
+          <p:cNvPr id="93" name="TextBox 92"/>
           <p:cNvSpPr txBox="1"/>
           <p:nvPr/>
         </p:nvSpPr>
         <p:spPr>
           <a:xfrm>
-            <a:off x="24624792" y="7223760"/>
-            <a:ext cx="3008376" cy="402336"/>
+            <a:off x="24231600" y="7223760"/>
+            <a:ext cx="3218688" cy="402336"/>
           </a:xfrm>
           <a:prstGeom prst="rect">
             <a:avLst/>
@@ -7185,26 +7657,26 @@
               </a:spcAft>
             </a:pPr>
             <a:r>
-              <a:rPr sz="1450" b="1" i="0">
+              <a:rPr sz="1320" b="1" i="0">
                 <a:solidFill>
                   <a:srgbClr val="178C6A"/>
                 </a:solidFill>
                 <a:latin typeface="Arial"/>
               </a:rPr>
-              <a:t>Reactome program mask</a:t>
-            </a:r>
-          </a:p>
-        </p:txBody>
-      </p:sp>
-      <p:sp>
-        <p:nvSpPr>
-          <p:cNvPr id="82" name="Down Arrow 81"/>
+              <a:t>Reactome mask selects pathway-gene edges</a:t>
+            </a:r>
+          </a:p>
+        </p:txBody>
+      </p:sp>
+      <p:sp>
+        <p:nvSpPr>
+          <p:cNvPr id="94" name="Down Arrow 93"/>
           <p:cNvSpPr/>
           <p:nvPr/>
         </p:nvSpPr>
         <p:spPr>
           <a:xfrm>
-            <a:off x="25667208" y="7726679"/>
+            <a:off x="25045415" y="7726679"/>
             <a:ext cx="329184" cy="310896"/>
           </a:xfrm>
           <a:prstGeom prst="downArrow">
@@ -7241,389 +7713,7 @@
       </p:sp>
       <p:sp>
         <p:nvSpPr>
-          <p:cNvPr id="83" name="Oval 82"/>
-          <p:cNvSpPr/>
-          <p:nvPr/>
-        </p:nvSpPr>
-        <p:spPr>
-          <a:xfrm>
-            <a:off x="27249120" y="7726679"/>
-            <a:ext cx="219456" cy="219456"/>
-          </a:xfrm>
-          <a:prstGeom prst="ellipse">
-            <a:avLst/>
-          </a:prstGeom>
-          <a:solidFill>
-            <a:srgbClr val="A9BBD0"/>
-          </a:solidFill>
-          <a:ln>
-            <a:noFill/>
-          </a:ln>
-        </p:spPr>
-        <p:style>
-          <a:lnRef idx="1">
-            <a:schemeClr val="accent1"/>
-          </a:lnRef>
-          <a:fillRef idx="3">
-            <a:schemeClr val="accent1"/>
-          </a:fillRef>
-          <a:effectRef idx="2">
-            <a:schemeClr val="accent1"/>
-          </a:effectRef>
-          <a:fontRef idx="minor">
-            <a:schemeClr val="lt1"/>
-          </a:fontRef>
-        </p:style>
-        <p:txBody>
-          <a:bodyPr rtlCol="0" anchor="ctr"/>
-          <a:lstStyle/>
-          <a:p>
-            <a:pPr algn="ctr"/>
-          </a:p>
-        </p:txBody>
-      </p:sp>
-      <p:sp>
-        <p:nvSpPr>
-          <p:cNvPr id="84" name="Oval 83"/>
-          <p:cNvSpPr/>
-          <p:nvPr/>
-        </p:nvSpPr>
-        <p:spPr>
-          <a:xfrm>
-            <a:off x="27249120" y="8074152"/>
-            <a:ext cx="219456" cy="219456"/>
-          </a:xfrm>
-          <a:prstGeom prst="ellipse">
-            <a:avLst/>
-          </a:prstGeom>
-          <a:solidFill>
-            <a:srgbClr val="A9BBD0"/>
-          </a:solidFill>
-          <a:ln>
-            <a:noFill/>
-          </a:ln>
-        </p:spPr>
-        <p:style>
-          <a:lnRef idx="1">
-            <a:schemeClr val="accent1"/>
-          </a:lnRef>
-          <a:fillRef idx="3">
-            <a:schemeClr val="accent1"/>
-          </a:fillRef>
-          <a:effectRef idx="2">
-            <a:schemeClr val="accent1"/>
-          </a:effectRef>
-          <a:fontRef idx="minor">
-            <a:schemeClr val="lt1"/>
-          </a:fontRef>
-        </p:style>
-        <p:txBody>
-          <a:bodyPr rtlCol="0" anchor="ctr"/>
-          <a:lstStyle/>
-          <a:p>
-            <a:pPr algn="ctr"/>
-          </a:p>
-        </p:txBody>
-      </p:sp>
-      <p:sp>
-        <p:nvSpPr>
-          <p:cNvPr id="85" name="Oval 84"/>
-          <p:cNvSpPr/>
-          <p:nvPr/>
-        </p:nvSpPr>
-        <p:spPr>
-          <a:xfrm>
-            <a:off x="27249120" y="8421624"/>
-            <a:ext cx="219456" cy="219456"/>
-          </a:xfrm>
-          <a:prstGeom prst="ellipse">
-            <a:avLst/>
-          </a:prstGeom>
-          <a:solidFill>
-            <a:srgbClr val="A9BBD0"/>
-          </a:solidFill>
-          <a:ln>
-            <a:noFill/>
-          </a:ln>
-        </p:spPr>
-        <p:style>
-          <a:lnRef idx="1">
-            <a:schemeClr val="accent1"/>
-          </a:lnRef>
-          <a:fillRef idx="3">
-            <a:schemeClr val="accent1"/>
-          </a:fillRef>
-          <a:effectRef idx="2">
-            <a:schemeClr val="accent1"/>
-          </a:effectRef>
-          <a:fontRef idx="minor">
-            <a:schemeClr val="lt1"/>
-          </a:fontRef>
-        </p:style>
-        <p:txBody>
-          <a:bodyPr rtlCol="0" anchor="ctr"/>
-          <a:lstStyle/>
-          <a:p>
-            <a:pPr algn="ctr"/>
-          </a:p>
-        </p:txBody>
-      </p:sp>
-      <p:sp>
-        <p:nvSpPr>
-          <p:cNvPr id="86" name="Oval 85"/>
-          <p:cNvSpPr/>
-          <p:nvPr/>
-        </p:nvSpPr>
-        <p:spPr>
-          <a:xfrm>
-            <a:off x="27249120" y="8769096"/>
-            <a:ext cx="219456" cy="219456"/>
-          </a:xfrm>
-          <a:prstGeom prst="ellipse">
-            <a:avLst/>
-          </a:prstGeom>
-          <a:solidFill>
-            <a:srgbClr val="A9BBD0"/>
-          </a:solidFill>
-          <a:ln>
-            <a:noFill/>
-          </a:ln>
-        </p:spPr>
-        <p:style>
-          <a:lnRef idx="1">
-            <a:schemeClr val="accent1"/>
-          </a:lnRef>
-          <a:fillRef idx="3">
-            <a:schemeClr val="accent1"/>
-          </a:fillRef>
-          <a:effectRef idx="2">
-            <a:schemeClr val="accent1"/>
-          </a:effectRef>
-          <a:fontRef idx="minor">
-            <a:schemeClr val="lt1"/>
-          </a:fontRef>
-        </p:style>
-        <p:txBody>
-          <a:bodyPr rtlCol="0" anchor="ctr"/>
-          <a:lstStyle/>
-          <a:p>
-            <a:pPr algn="ctr"/>
-          </a:p>
-        </p:txBody>
-      </p:sp>
-      <p:cxnSp>
-        <p:nvCxnSpPr>
-          <p:cNvPr id="87" name="Connector 86"/>
-          <p:cNvCxnSpPr/>
-          <p:nvPr/>
-        </p:nvCxnSpPr>
-        <p:spPr>
-          <a:xfrm>
-            <a:off x="24277320" y="7799831"/>
-            <a:ext cx="2971800" cy="36576"/>
-          </a:xfrm>
-          <a:prstGeom prst="line">
-            <a:avLst/>
-          </a:prstGeom>
-          <a:ln w="15240">
-            <a:solidFill>
-              <a:srgbClr val="6A4C93"/>
-            </a:solidFill>
-          </a:ln>
-        </p:spPr>
-        <p:style>
-          <a:lnRef idx="2">
-            <a:schemeClr val="accent1"/>
-          </a:lnRef>
-          <a:fillRef idx="0">
-            <a:schemeClr val="accent1"/>
-          </a:fillRef>
-          <a:effectRef idx="1">
-            <a:schemeClr val="accent1"/>
-          </a:effectRef>
-          <a:fontRef idx="minor">
-            <a:schemeClr val="tx1"/>
-          </a:fontRef>
-        </p:style>
-      </p:cxnSp>
-      <p:cxnSp>
-        <p:nvCxnSpPr>
-          <p:cNvPr id="88" name="Connector 87"/>
-          <p:cNvCxnSpPr/>
-          <p:nvPr/>
-        </p:nvCxnSpPr>
-        <p:spPr>
-          <a:xfrm>
-            <a:off x="24277320" y="7799831"/>
-            <a:ext cx="2971800" cy="731520"/>
-          </a:xfrm>
-          <a:prstGeom prst="line">
-            <a:avLst/>
-          </a:prstGeom>
-          <a:ln w="15240">
-            <a:solidFill>
-              <a:srgbClr val="6A4C93"/>
-            </a:solidFill>
-          </a:ln>
-        </p:spPr>
-        <p:style>
-          <a:lnRef idx="2">
-            <a:schemeClr val="accent1"/>
-          </a:lnRef>
-          <a:fillRef idx="0">
-            <a:schemeClr val="accent1"/>
-          </a:fillRef>
-          <a:effectRef idx="1">
-            <a:schemeClr val="accent1"/>
-          </a:effectRef>
-          <a:fontRef idx="minor">
-            <a:schemeClr val="tx1"/>
-          </a:fontRef>
-        </p:style>
-      </p:cxnSp>
-      <p:cxnSp>
-        <p:nvCxnSpPr>
-          <p:cNvPr id="89" name="Connector 88"/>
-          <p:cNvCxnSpPr/>
-          <p:nvPr/>
-        </p:nvCxnSpPr>
-        <p:spPr>
-          <a:xfrm flipV="1">
-            <a:off x="24277320" y="8183879"/>
-            <a:ext cx="2971800" cy="54865"/>
-          </a:xfrm>
-          <a:prstGeom prst="line">
-            <a:avLst/>
-          </a:prstGeom>
-          <a:ln w="15240">
-            <a:solidFill>
-              <a:srgbClr val="A64D67"/>
-            </a:solidFill>
-          </a:ln>
-        </p:spPr>
-        <p:style>
-          <a:lnRef idx="2">
-            <a:schemeClr val="accent1"/>
-          </a:lnRef>
-          <a:fillRef idx="0">
-            <a:schemeClr val="accent1"/>
-          </a:fillRef>
-          <a:effectRef idx="1">
-            <a:schemeClr val="accent1"/>
-          </a:effectRef>
-          <a:fontRef idx="minor">
-            <a:schemeClr val="tx1"/>
-          </a:fontRef>
-        </p:style>
-      </p:cxnSp>
-      <p:cxnSp>
-        <p:nvCxnSpPr>
-          <p:cNvPr id="90" name="Connector 89"/>
-          <p:cNvCxnSpPr/>
-          <p:nvPr/>
-        </p:nvCxnSpPr>
-        <p:spPr>
-          <a:xfrm>
-            <a:off x="24277320" y="8238744"/>
-            <a:ext cx="2971800" cy="640080"/>
-          </a:xfrm>
-          <a:prstGeom prst="line">
-            <a:avLst/>
-          </a:prstGeom>
-          <a:ln w="15240">
-            <a:solidFill>
-              <a:srgbClr val="A64D67"/>
-            </a:solidFill>
-          </a:ln>
-        </p:spPr>
-        <p:style>
-          <a:lnRef idx="2">
-            <a:schemeClr val="accent1"/>
-          </a:lnRef>
-          <a:fillRef idx="0">
-            <a:schemeClr val="accent1"/>
-          </a:fillRef>
-          <a:effectRef idx="1">
-            <a:schemeClr val="accent1"/>
-          </a:effectRef>
-          <a:fontRef idx="minor">
-            <a:schemeClr val="tx1"/>
-          </a:fontRef>
-        </p:style>
-      </p:cxnSp>
-      <p:cxnSp>
-        <p:nvCxnSpPr>
-          <p:cNvPr id="91" name="Connector 90"/>
-          <p:cNvCxnSpPr/>
-          <p:nvPr/>
-        </p:nvCxnSpPr>
-        <p:spPr>
-          <a:xfrm flipV="1">
-            <a:off x="24277320" y="8531351"/>
-            <a:ext cx="2971800" cy="146305"/>
-          </a:xfrm>
-          <a:prstGeom prst="line">
-            <a:avLst/>
-          </a:prstGeom>
-          <a:ln w="15240">
-            <a:solidFill>
-              <a:srgbClr val="C65D37"/>
-            </a:solidFill>
-          </a:ln>
-        </p:spPr>
-        <p:style>
-          <a:lnRef idx="2">
-            <a:schemeClr val="accent1"/>
-          </a:lnRef>
-          <a:fillRef idx="0">
-            <a:schemeClr val="accent1"/>
-          </a:fillRef>
-          <a:effectRef idx="1">
-            <a:schemeClr val="accent1"/>
-          </a:effectRef>
-          <a:fontRef idx="minor">
-            <a:schemeClr val="tx1"/>
-          </a:fontRef>
-        </p:style>
-      </p:cxnSp>
-      <p:cxnSp>
-        <p:nvCxnSpPr>
-          <p:cNvPr id="92" name="Connector 91"/>
-          <p:cNvCxnSpPr/>
-          <p:nvPr/>
-        </p:nvCxnSpPr>
-        <p:spPr>
-          <a:xfrm>
-            <a:off x="24277320" y="8677656"/>
-            <a:ext cx="2971800" cy="201168"/>
-          </a:xfrm>
-          <a:prstGeom prst="line">
-            <a:avLst/>
-          </a:prstGeom>
-          <a:ln w="15240">
-            <a:solidFill>
-              <a:srgbClr val="C65D37"/>
-            </a:solidFill>
-          </a:ln>
-        </p:spPr>
-        <p:style>
-          <a:lnRef idx="2">
-            <a:schemeClr val="accent1"/>
-          </a:lnRef>
-          <a:fillRef idx="0">
-            <a:schemeClr val="accent1"/>
-          </a:fillRef>
-          <a:effectRef idx="1">
-            <a:schemeClr val="accent1"/>
-          </a:effectRef>
-          <a:fontRef idx="minor">
-            <a:schemeClr val="tx1"/>
-          </a:fontRef>
-        </p:style>
-      </p:cxnSp>
-      <p:sp>
-        <p:nvSpPr>
-          <p:cNvPr id="93" name="TextBox 92"/>
+          <p:cNvPr id="95" name="TextBox 94"/>
           <p:cNvSpPr txBox="1"/>
           <p:nvPr/>
         </p:nvSpPr>
@@ -7668,14 +7758,14 @@
       </p:sp>
       <p:sp>
         <p:nvSpPr>
-          <p:cNvPr id="94" name="TextBox 93"/>
+          <p:cNvPr id="96" name="TextBox 95"/>
           <p:cNvSpPr txBox="1"/>
           <p:nvPr/>
         </p:nvSpPr>
         <p:spPr>
           <a:xfrm>
-            <a:off x="21607272" y="9052560"/>
-            <a:ext cx="2834640" cy="320040"/>
+            <a:off x="21598128" y="9052560"/>
+            <a:ext cx="2423160" cy="320040"/>
           </a:xfrm>
           <a:prstGeom prst="rect">
             <a:avLst/>
@@ -7706,21 +7796,21 @@
                 </a:solidFill>
                 <a:latin typeface="Arial"/>
               </a:rPr>
-              <a:t>annotated program scores</a:t>
-            </a:r>
-          </a:p>
-        </p:txBody>
-      </p:sp>
-      <p:sp>
-        <p:nvSpPr>
-          <p:cNvPr id="95" name="TextBox 94"/>
+              <a:t>program scores</a:t>
+            </a:r>
+          </a:p>
+        </p:txBody>
+      </p:sp>
+      <p:sp>
+        <p:nvSpPr>
+          <p:cNvPr id="97" name="TextBox 96"/>
           <p:cNvSpPr txBox="1"/>
           <p:nvPr/>
         </p:nvSpPr>
         <p:spPr>
           <a:xfrm>
-            <a:off x="24597360" y="9052560"/>
-            <a:ext cx="2240280" cy="320040"/>
+            <a:off x="24368760" y="9052560"/>
+            <a:ext cx="1682495" cy="320040"/>
           </a:xfrm>
           <a:prstGeom prst="rect">
             <a:avLst/>
@@ -7758,14 +7848,14 @@
       </p:sp>
       <p:sp>
         <p:nvSpPr>
-          <p:cNvPr id="96" name="TextBox 95"/>
+          <p:cNvPr id="98" name="TextBox 97"/>
           <p:cNvSpPr txBox="1"/>
           <p:nvPr/>
         </p:nvSpPr>
         <p:spPr>
           <a:xfrm>
-            <a:off x="26471880" y="9052560"/>
-            <a:ext cx="1691640" cy="320040"/>
+            <a:off x="26609040" y="9052560"/>
+            <a:ext cx="1508760" cy="320040"/>
           </a:xfrm>
           <a:prstGeom prst="rect">
             <a:avLst/>
@@ -7803,7 +7893,7 @@
       </p:sp>
       <p:sp>
         <p:nvSpPr>
-          <p:cNvPr id="97" name="TextBox 96"/>
+          <p:cNvPr id="99" name="TextBox 98"/>
           <p:cNvSpPr txBox="1"/>
           <p:nvPr/>
         </p:nvSpPr>
@@ -7848,7 +7938,7 @@
       </p:sp>
       <p:sp>
         <p:nvSpPr>
-          <p:cNvPr id="98" name="Rounded Rectangle 97"/>
+          <p:cNvPr id="100" name="Rounded Rectangle 99"/>
           <p:cNvSpPr/>
           <p:nvPr/>
         </p:nvSpPr>
@@ -7927,7 +8017,7 @@
       </p:sp>
       <p:sp>
         <p:nvSpPr>
-          <p:cNvPr id="99" name="Right Arrow 98"/>
+          <p:cNvPr id="101" name="Right Arrow 100"/>
           <p:cNvSpPr/>
           <p:nvPr/>
         </p:nvSpPr>
@@ -7970,7 +8060,7 @@
       </p:sp>
       <p:sp>
         <p:nvSpPr>
-          <p:cNvPr id="100" name="Rounded Rectangle 99"/>
+          <p:cNvPr id="102" name="Rounded Rectangle 101"/>
           <p:cNvSpPr/>
           <p:nvPr/>
         </p:nvSpPr>
@@ -8049,7 +8139,7 @@
       </p:sp>
       <p:sp>
         <p:nvSpPr>
-          <p:cNvPr id="101" name="Right Arrow 100"/>
+          <p:cNvPr id="103" name="Right Arrow 102"/>
           <p:cNvSpPr/>
           <p:nvPr/>
         </p:nvSpPr>
@@ -8092,7 +8182,7 @@
       </p:sp>
       <p:sp>
         <p:nvSpPr>
-          <p:cNvPr id="102" name="Rounded Rectangle 101"/>
+          <p:cNvPr id="104" name="Rounded Rectangle 103"/>
           <p:cNvSpPr/>
           <p:nvPr/>
         </p:nvSpPr>
@@ -8171,7 +8261,7 @@
       </p:sp>
       <p:sp>
         <p:nvSpPr>
-          <p:cNvPr id="103" name="Right Arrow 102"/>
+          <p:cNvPr id="105" name="Right Arrow 104"/>
           <p:cNvSpPr/>
           <p:nvPr/>
         </p:nvSpPr>
@@ -8214,7 +8304,7 @@
       </p:sp>
       <p:sp>
         <p:nvSpPr>
-          <p:cNvPr id="104" name="Rounded Rectangle 103"/>
+          <p:cNvPr id="106" name="Rounded Rectangle 105"/>
           <p:cNvSpPr/>
           <p:nvPr/>
         </p:nvSpPr>
@@ -8293,7 +8383,7 @@
       </p:sp>
       <p:sp>
         <p:nvSpPr>
-          <p:cNvPr id="105" name="Down Arrow 104"/>
+          <p:cNvPr id="107" name="Down Arrow 106"/>
           <p:cNvSpPr/>
           <p:nvPr/>
         </p:nvSpPr>
@@ -8336,7 +8426,7 @@
       </p:sp>
       <p:sp>
         <p:nvSpPr>
-          <p:cNvPr id="106" name="Rounded Rectangle 105"/>
+          <p:cNvPr id="108" name="Rounded Rectangle 107"/>
           <p:cNvSpPr/>
           <p:nvPr/>
         </p:nvSpPr>
@@ -8415,7 +8505,7 @@
       </p:sp>
       <p:sp>
         <p:nvSpPr>
-          <p:cNvPr id="107" name="TextBox 106"/>
+          <p:cNvPr id="109" name="TextBox 108"/>
           <p:cNvSpPr txBox="1"/>
           <p:nvPr/>
         </p:nvSpPr>
@@ -8460,7 +8550,7 @@
       </p:sp>
       <p:sp>
         <p:nvSpPr>
-          <p:cNvPr id="108" name="Rectangle 107"/>
+          <p:cNvPr id="110" name="Rectangle 109"/>
           <p:cNvSpPr/>
           <p:nvPr/>
         </p:nvSpPr>
@@ -8503,7 +8593,7 @@
       </p:sp>
       <p:sp>
         <p:nvSpPr>
-          <p:cNvPr id="109" name="Rectangle 108"/>
+          <p:cNvPr id="111" name="Rectangle 110"/>
           <p:cNvSpPr/>
           <p:nvPr/>
         </p:nvSpPr>
@@ -8548,7 +8638,7 @@
       </p:sp>
       <p:sp>
         <p:nvSpPr>
-          <p:cNvPr id="110" name="TextBox 109"/>
+          <p:cNvPr id="112" name="TextBox 111"/>
           <p:cNvSpPr txBox="1"/>
           <p:nvPr/>
         </p:nvSpPr>
@@ -8586,14 +8676,14 @@
                 </a:solidFill>
                 <a:latin typeface="Arial"/>
               </a:rPr>
-              <a:t>RESULTS: ALL 13 PRIMARY RETAINED PATHWAY SHIFTS</a:t>
+              <a:t>RESULTS: ALIGNED ANCHORS AND RETAINED PROGRAM SHIFTS</a:t>
             </a:r>
           </a:p>
         </p:txBody>
       </p:sp>
       <p:pic>
         <p:nvPicPr>
-          <p:cNvPr id="111" name="Retained pathway shifts" descr="Project-balanced expiMap pathway shifts for thymus, skin, liver, and spleen, with project effects and three-training ranges."/>
+          <p:cNvPr id="113" name="Retained pathway shifts" descr="Literature-aligned anchors and retained expiMap pathway shifts for thymus, skin, liver, and spleen, with project effects and three-training ranges."/>
           <p:cNvPicPr>
             <a:picLocks noChangeAspect="1"/>
           </p:cNvPicPr>
@@ -8617,7 +8707,7 @@
       </p:pic>
       <p:sp>
         <p:nvSpPr>
-          <p:cNvPr id="112" name="TextBox 111"/>
+          <p:cNvPr id="114" name="TextBox 113"/>
           <p:cNvSpPr txBox="1"/>
           <p:nvPr/>
         </p:nvSpPr>
@@ -8655,14 +8745,14 @@
                 </a:solidFill>
                 <a:latin typeface="Arial"/>
               </a:rPr>
-              <a:t>All 13 primary retained programs are shown; three exploratory kidney programs remain in the paper. Open circles are OSDR projects; colored ranges span three complete reference-query trainings. All displayed shifts are lower in flight; axes are tissue specific.</a:t>
-            </a:r>
-          </a:p>
-        </p:txBody>
-      </p:sp>
-      <p:sp>
-        <p:nvSpPr>
-          <p:cNvPr id="113" name="Rectangle 112"/>
+              <a:t>Filled markers show the 13 primary retained programs. Four open green diamonds show literature-aligned anchors that failed at least one robustness gate and provide context rather than additional claims. Colored ranges span three complete trainings; axes are tissue specific.</a:t>
+            </a:r>
+          </a:p>
+        </p:txBody>
+      </p:sp>
+      <p:sp>
+        <p:nvSpPr>
+          <p:cNvPr id="115" name="Rectangle 114"/>
           <p:cNvSpPr/>
           <p:nvPr/>
         </p:nvSpPr>
@@ -8705,7 +8795,7 @@
       </p:sp>
       <p:sp>
         <p:nvSpPr>
-          <p:cNvPr id="114" name="Rectangle 113"/>
+          <p:cNvPr id="116" name="Rectangle 115"/>
           <p:cNvSpPr/>
           <p:nvPr/>
         </p:nvSpPr>
@@ -8750,7 +8840,7 @@
       </p:sp>
       <p:sp>
         <p:nvSpPr>
-          <p:cNvPr id="115" name="TextBox 114"/>
+          <p:cNvPr id="117" name="TextBox 116"/>
           <p:cNvSpPr txBox="1"/>
           <p:nvPr/>
         </p:nvSpPr>
@@ -8795,7 +8885,7 @@
       </p:sp>
       <p:sp>
         <p:nvSpPr>
-          <p:cNvPr id="116" name="TextBox 115"/>
+          <p:cNvPr id="118" name="TextBox 117"/>
           <p:cNvSpPr txBox="1"/>
           <p:nvPr/>
         </p:nvSpPr>
@@ -8840,7 +8930,7 @@
       </p:sp>
       <p:pic>
         <p:nvPicPr>
-          <p:cNvPr id="117" name="Tissue-state hypotheses" descr="Observed lower expiMap program scores and qualified tissue-state hypotheses for thymus, skin, liver, and spleen."/>
+          <p:cNvPr id="119" name="Tissue-state hypotheses" descr="Observed lower expiMap program scores and qualified tissue-state hypotheses for thymus, skin, liver, and spleen."/>
           <p:cNvPicPr>
             <a:picLocks noChangeAspect="1"/>
           </p:cNvPicPr>
@@ -8864,7 +8954,7 @@
       </p:pic>
       <p:sp>
         <p:nvSpPr>
-          <p:cNvPr id="118" name="Rectangle 117"/>
+          <p:cNvPr id="120" name="Rectangle 119"/>
           <p:cNvSpPr/>
           <p:nvPr/>
         </p:nvSpPr>
@@ -8907,7 +8997,7 @@
       </p:sp>
       <p:sp>
         <p:nvSpPr>
-          <p:cNvPr id="119" name="Rectangle 118"/>
+          <p:cNvPr id="121" name="Rectangle 120"/>
           <p:cNvSpPr/>
           <p:nvPr/>
         </p:nvSpPr>
@@ -8952,7 +9042,7 @@
       </p:sp>
       <p:sp>
         <p:nvSpPr>
-          <p:cNvPr id="120" name="TextBox 119"/>
+          <p:cNvPr id="122" name="TextBox 121"/>
           <p:cNvSpPr txBox="1"/>
           <p:nvPr/>
         </p:nvSpPr>
@@ -8997,7 +9087,7 @@
       </p:sp>
       <p:sp>
         <p:nvSpPr>
-          <p:cNvPr id="121" name="TextBox 120"/>
+          <p:cNvPr id="123" name="TextBox 122"/>
           <p:cNvSpPr txBox="1"/>
           <p:nvPr/>
         </p:nvSpPr>
@@ -9035,7 +9125,7 @@
                 </a:solidFill>
                 <a:latin typeface="Arial"/>
               </a:rPr>
-              <a:t>• Spleen was strongest: T-cell receptor, neutrophil degranulation, and C-type lectin receptor programs were lower across five projects and three trainings; all had GSEA FDR &lt;0.05.</a:t>
+              <a:t>• Spleen was strongest: T cell receptor, neutrophil degranulation, and C‑type lectin receptor programs were lower across five projects and three trainings; all had GSEA FDR &lt;0.05.</a:t>
             </a:r>
           </a:p>
           <a:p>
@@ -9057,7 +9147,7 @@
                 </a:solidFill>
                 <a:latin typeface="Arial"/>
               </a:rPr>
-              <a:t>• Skin and thymus emphasized lower tissue-maintenance programs; liver added a lower adaptive-immune axis to heterogeneous metabolism.</a:t>
+              <a:t>• Skin and thymus emphasized lower tissue maintenance programs; liver showed lower adaptive immune signaling amid heterogeneous metabolism.</a:t>
             </a:r>
           </a:p>
           <a:p>
@@ -9079,14 +9169,14 @@
                 </a:solidFill>
                 <a:latin typeface="Arial"/>
               </a:rPr>
-              <a:t>• Bulk latent scores are testable hypotheses, not causal or cell-type-resolved pathway activity.</a:t>
-            </a:r>
-          </a:p>
-        </p:txBody>
-      </p:sp>
-      <p:sp>
-        <p:nvSpPr>
-          <p:cNvPr id="122" name="Rectangle 121"/>
+              <a:t>• Bulk latent scores are testable hypotheses, not causal or cell resolved measures of pathway activity.</a:t>
+            </a:r>
+          </a:p>
+        </p:txBody>
+      </p:sp>
+      <p:sp>
+        <p:nvSpPr>
+          <p:cNvPr id="124" name="Rectangle 123"/>
           <p:cNvSpPr/>
           <p:nvPr/>
         </p:nvSpPr>
@@ -9129,7 +9219,7 @@
       </p:sp>
       <p:sp>
         <p:nvSpPr>
-          <p:cNvPr id="123" name="Rectangle 122"/>
+          <p:cNvPr id="125" name="Rectangle 124"/>
           <p:cNvSpPr/>
           <p:nvPr/>
         </p:nvSpPr>
@@ -9174,7 +9264,7 @@
       </p:sp>
       <p:sp>
         <p:nvSpPr>
-          <p:cNvPr id="124" name="TextBox 123"/>
+          <p:cNvPr id="126" name="TextBox 125"/>
           <p:cNvSpPr txBox="1"/>
           <p:nvPr/>
         </p:nvSpPr>
@@ -9219,7 +9309,7 @@
       </p:sp>
       <p:sp>
         <p:nvSpPr>
-          <p:cNvPr id="125" name="TextBox 124"/>
+          <p:cNvPr id="127" name="TextBox 126"/>
           <p:cNvSpPr txBox="1"/>
           <p:nvPr/>
         </p:nvSpPr>
@@ -9264,7 +9354,7 @@
       </p:sp>
       <p:sp>
         <p:nvSpPr>
-          <p:cNvPr id="126" name="Rectangle 125"/>
+          <p:cNvPr id="128" name="Rectangle 127"/>
           <p:cNvSpPr/>
           <p:nvPr/>
         </p:nvSpPr>
@@ -9307,7 +9397,7 @@
       </p:sp>
       <p:sp>
         <p:nvSpPr>
-          <p:cNvPr id="127" name="TextBox 126"/>
+          <p:cNvPr id="129" name="TextBox 128"/>
           <p:cNvSpPr txBox="1"/>
           <p:nvPr/>
         </p:nvSpPr>
@@ -9352,7 +9442,7 @@
       </p:sp>
       <p:sp>
         <p:nvSpPr>
-          <p:cNvPr id="128" name="TextBox 127"/>
+          <p:cNvPr id="130" name="TextBox 129"/>
           <p:cNvSpPr txBox="1"/>
           <p:nvPr/>
         </p:nvSpPr>
@@ -9397,7 +9487,7 @@
       </p:sp>
       <p:sp>
         <p:nvSpPr>
-          <p:cNvPr id="129" name="TextBox 128"/>
+          <p:cNvPr id="131" name="TextBox 130"/>
           <p:cNvSpPr txBox="1"/>
           <p:nvPr/>
         </p:nvSpPr>
@@ -9443,7 +9533,7 @@
       </p:sp>
       <p:sp>
         <p:nvSpPr>
-          <p:cNvPr id="130" name="TextBox 129"/>
+          <p:cNvPr id="132" name="TextBox 131"/>
           <p:cNvSpPr txBox="1"/>
           <p:nvPr/>
         </p:nvSpPr>

</xml_diff>

<commit_message>
clarify tissue-state evidence and hypotheses
</commit_message>
<xml_diff>
--- a/paper/asgsr_expimap_hvg/poster/asgsr_expimap_poster.pptx
+++ b/paper/asgsr_expimap_hvg/poster/asgsr_expimap_poster.pptx
@@ -8923,14 +8923,14 @@
                 </a:solidFill>
                 <a:latin typeface="Arial"/>
               </a:rPr>
-              <a:t>Final robustness-filtered tissue stories</a:t>
+              <a:t>Prior evidence, observed shifts, and hypotheses to test</a:t>
             </a:r>
           </a:p>
         </p:txBody>
       </p:sp>
       <p:pic>
         <p:nvPicPr>
-          <p:cNvPr id="119" name="Tissue-state hypotheses" descr="Observed lower expiMap program scores and qualified tissue-state hypotheses for thymus, skin, liver, and spleen."/>
+          <p:cNvPr id="119" name="Tissue-state hypotheses" descr="Prior-literature phenotypes, observed lower expiMap program scores, and complementary hypotheses for thymus, skin, liver, and spleen."/>
           <p:cNvPicPr>
             <a:picLocks noChangeAspect="1"/>
           </p:cNvPicPr>

</xml_diff>

<commit_message>
fix poster text wrapping and decoder visibility
</commit_message>
<xml_diff>
--- a/paper/asgsr_expimap_hvg/poster/asgsr_expimap_poster.pptx
+++ b/paper/asgsr_expimap_hvg/poster/asgsr_expimap_poster.pptx
@@ -3493,8 +3493,8 @@
           <a:noFill/>
         </p:spPr>
         <p:txBody>
-          <a:bodyPr wrap="square" lIns="0" rIns="0" tIns="0" bIns="0" anchor="t">
-            <a:spAutoFit/>
+          <a:bodyPr wrap="none" lIns="0" rIns="0" tIns="0" bIns="0" anchor="t">
+            <a:noAutofit/>
           </a:bodyPr>
           <a:lstStyle/>
           <a:p>
@@ -3510,13 +3510,20 @@
               </a:spcAft>
             </a:pPr>
             <a:r>
-              <a:rPr sz="2000" b="0" i="0">
+              <a:rPr sz="1850" b="0" i="0">
                 <a:solidFill>
                   <a:srgbClr val="33445D"/>
                 </a:solidFill>
                 <a:latin typeface="Arial"/>
               </a:rPr>
-              <a:t>Mission differences can obscure spaceflight responses shared across studies. We mapped NASA OSDR mouse bulk RNA sequencing samples to ARCHS4 references matched by tissue. We used expiMap models constrained by Reactome to analyze about 2,000 highly variable genes. Flight versus ground shifts were balanced across projects and assessed with enrichment tests, project holdouts, three training runs, composition proxies, review of member genes, and literature annotation after scoring. Retained programs were lower for thymic repair and cytoskeletal processes, skin maintenance and barrier processes, liver adaptive immunity, and spleen adaptive and innate immunity. Spleen showed the strongest result across multiple pathways.</a:t>
+              <a:t>Mission differences can obscure spaceflight responses shared across studies.
+We mapped NASA OSDR mouse bulk RNA sequencing samples to tissue-matched ARCHS4
+references and analyzed about 2,000 highly variable genes with Reactome-constrained expiMap.
+Flight-ground shifts were balanced across projects and evaluated with gene-set enrichment,
+project holdouts, three complete training runs, composition proxies, member-gene review,
+and literature annotation after scoring. Retained programs were lower for thymic repair,
+skin maintenance, liver adaptive immunity, and splenic adaptive and innate immunity.
+Spleen showed the strongest result across multiple pathways.</a:t>
             </a:r>
           </a:p>
         </p:txBody>
@@ -4338,8 +4345,8 @@
           <a:noFill/>
         </p:spPr>
         <p:txBody>
-          <a:bodyPr wrap="square" lIns="0" rIns="0" tIns="0" bIns="0" anchor="t">
-            <a:spAutoFit/>
+          <a:bodyPr wrap="none" lIns="0" rIns="0" tIns="0" bIns="0" anchor="t">
+            <a:noAutofit/>
           </a:bodyPr>
           <a:lstStyle/>
           <a:p>
@@ -4361,7 +4368,9 @@
                 </a:solidFill>
                 <a:latin typeface="Arial"/>
               </a:rPr>
-              <a:t>Study identity and protocol can dominate an unconstrained expression representation. Tissue-matched reference mapping, accession conditioning, and equal project weighting reduce this bias without claiming to remove all mission confounding.</a:t>
+              <a:t>Study identity and protocol can dominate an unconstrained expression representation.
+Tissue-matched reference mapping, accession conditioning, and equal project weighting
+reduce this bias without claiming to remove all mission confounding.</a:t>
             </a:r>
           </a:p>
         </p:txBody>
@@ -4454,7 +4463,7 @@
                       </a:r>
                     </a:p>
                   </a:txBody>
-                  <a:tcPr marL="64008" marR="54864" marT="27432" marB="27432">
+                  <a:tcPr marL="182880" marR="54864" marT="27432" marB="27432">
                     <a:solidFill>
                       <a:srgbClr val="082552"/>
                     </a:solidFill>
@@ -4571,7 +4580,7 @@
                       </a:r>
                     </a:p>
                   </a:txBody>
-                  <a:tcPr marL="64008" marR="54864" marT="27432" marB="27432">
+                  <a:tcPr marL="182880" marR="54864" marT="27432" marB="27432">
                     <a:solidFill>
                       <a:srgbClr val="FFFFFF"/>
                     </a:solidFill>
@@ -4688,7 +4697,7 @@
                       </a:r>
                     </a:p>
                   </a:txBody>
-                  <a:tcPr marL="64008" marR="54864" marT="27432" marB="27432">
+                  <a:tcPr marL="182880" marR="54864" marT="27432" marB="27432">
                     <a:solidFill>
                       <a:srgbClr val="EEF4F8"/>
                     </a:solidFill>
@@ -4805,7 +4814,7 @@
                       </a:r>
                     </a:p>
                   </a:txBody>
-                  <a:tcPr marL="64008" marR="54864" marT="27432" marB="27432">
+                  <a:tcPr marL="182880" marR="54864" marT="27432" marB="27432">
                     <a:solidFill>
                       <a:srgbClr val="FFFFFF"/>
                     </a:solidFill>
@@ -4922,7 +4931,7 @@
                       </a:r>
                     </a:p>
                   </a:txBody>
-                  <a:tcPr marL="64008" marR="54864" marT="27432" marB="27432">
+                  <a:tcPr marL="182880" marR="54864" marT="27432" marB="27432">
                     <a:solidFill>
                       <a:srgbClr val="EEF4F8"/>
                     </a:solidFill>
@@ -5042,8 +5051,8 @@
           <a:noFill/>
         </p:spPr>
         <p:txBody>
-          <a:bodyPr wrap="square" lIns="0" rIns="0" tIns="0" bIns="0" anchor="t">
-            <a:spAutoFit/>
+          <a:bodyPr wrap="none" lIns="0" rIns="0" tIns="0" bIns="0" anchor="t">
+            <a:noAutofit/>
           </a:bodyPr>
           <a:lstStyle/>
           <a:p>
@@ -5684,8 +5693,8 @@
           <a:noFill/>
         </p:spPr>
         <p:txBody>
-          <a:bodyPr wrap="square" lIns="0" rIns="0" tIns="0" bIns="0" anchor="t">
-            <a:spAutoFit/>
+          <a:bodyPr wrap="none" lIns="0" rIns="0" tIns="0" bIns="0" anchor="t">
+            <a:noAutofit/>
           </a:bodyPr>
           <a:lstStyle/>
           <a:p>
@@ -5707,7 +5716,8 @@
                 </a:solidFill>
                 <a:latin typeface="Arial"/>
               </a:rPr>
-              <a:t>Complementary means an annotated Reactome program that adds a plausible perspective beyond the dominant phenotype in prior literature. De novo nodes were not retained in the final models.</a:t>
+              <a:t>Complementary programs add a plausible perspective beyond the dominant phenotype
+in prior literature. De novo nodes were not retained in the final models.</a:t>
             </a:r>
           </a:p>
         </p:txBody>
@@ -7330,9 +7340,7 @@
           <a:prstGeom prst="trapezoid">
             <a:avLst/>
           </a:prstGeom>
-          <a:solidFill>
-            <a:srgbClr val="E5F1EC"/>
-          </a:solidFill>
+          <a:noFill/>
           <a:ln w="17780">
             <a:solidFill>
               <a:srgbClr val="178C6A"/>
@@ -7363,14 +7371,57 @@
       </p:sp>
       <p:sp>
         <p:nvSpPr>
-          <p:cNvPr id="87" name="TextBox 86"/>
+          <p:cNvPr id="87" name="Rectangle 86"/>
+          <p:cNvSpPr/>
+          <p:nvPr/>
+        </p:nvSpPr>
+        <p:spPr>
+          <a:xfrm>
+            <a:off x="24780239" y="8092440"/>
+            <a:ext cx="859536" cy="310896"/>
+          </a:xfrm>
+          <a:prstGeom prst="rect">
+            <a:avLst/>
+          </a:prstGeom>
+          <a:solidFill>
+            <a:srgbClr val="FFFFFF"/>
+          </a:solidFill>
+          <a:ln>
+            <a:noFill/>
+          </a:ln>
+        </p:spPr>
+        <p:style>
+          <a:lnRef idx="1">
+            <a:schemeClr val="accent1"/>
+          </a:lnRef>
+          <a:fillRef idx="3">
+            <a:schemeClr val="accent1"/>
+          </a:fillRef>
+          <a:effectRef idx="2">
+            <a:schemeClr val="accent1"/>
+          </a:effectRef>
+          <a:fontRef idx="minor">
+            <a:schemeClr val="lt1"/>
+          </a:fontRef>
+        </p:style>
+        <p:txBody>
+          <a:bodyPr rtlCol="0" anchor="ctr"/>
+          <a:lstStyle/>
+          <a:p>
+            <a:pPr algn="ctr"/>
+          </a:p>
+        </p:txBody>
+      </p:sp>
+      <p:sp>
+        <p:nvSpPr>
+          <p:cNvPr id="88" name="TextBox 87"/>
           <p:cNvSpPr txBox="1"/>
           <p:nvPr/>
         </p:nvSpPr>
         <p:spPr>
           <a:xfrm>
-            <a:off x="24423623" y="8083296"/>
-            <a:ext cx="1572768" cy="347472"/>
+            <a:off x="24734519" y="8083296"/>
+            <a:ext cx="950976" cy="347472"/>
           </a:xfrm>
           <a:prstGeom prst="rect">
             <a:avLst/>
@@ -7408,7 +7459,7 @@
       </p:sp>
       <p:sp>
         <p:nvSpPr>
-          <p:cNvPr id="88" name="Oval 87"/>
+          <p:cNvPr id="89" name="Oval 88"/>
           <p:cNvSpPr/>
           <p:nvPr/>
         </p:nvSpPr>
@@ -7451,7 +7502,7 @@
       </p:sp>
       <p:sp>
         <p:nvSpPr>
-          <p:cNvPr id="89" name="Oval 88"/>
+          <p:cNvPr id="90" name="Oval 89"/>
           <p:cNvSpPr/>
           <p:nvPr/>
         </p:nvSpPr>
@@ -7494,7 +7545,7 @@
       </p:sp>
       <p:sp>
         <p:nvSpPr>
-          <p:cNvPr id="90" name="Oval 89"/>
+          <p:cNvPr id="91" name="Oval 90"/>
           <p:cNvSpPr/>
           <p:nvPr/>
         </p:nvSpPr>
@@ -7537,7 +7588,7 @@
       </p:sp>
       <p:sp>
         <p:nvSpPr>
-          <p:cNvPr id="91" name="Oval 90"/>
+          <p:cNvPr id="92" name="Oval 91"/>
           <p:cNvSpPr/>
           <p:nvPr/>
         </p:nvSpPr>
@@ -7580,7 +7631,7 @@
       </p:sp>
       <p:sp>
         <p:nvSpPr>
-          <p:cNvPr id="92" name="Rounded Rectangle 91"/>
+          <p:cNvPr id="93" name="Rounded Rectangle 92"/>
           <p:cNvSpPr/>
           <p:nvPr/>
         </p:nvSpPr>
@@ -7625,7 +7676,7 @@
       </p:sp>
       <p:sp>
         <p:nvSpPr>
-          <p:cNvPr id="93" name="TextBox 92"/>
+          <p:cNvPr id="94" name="TextBox 93"/>
           <p:cNvSpPr txBox="1"/>
           <p:nvPr/>
         </p:nvSpPr>
@@ -7670,7 +7721,7 @@
       </p:sp>
       <p:sp>
         <p:nvSpPr>
-          <p:cNvPr id="94" name="Down Arrow 93"/>
+          <p:cNvPr id="95" name="Down Arrow 94"/>
           <p:cNvSpPr/>
           <p:nvPr/>
         </p:nvSpPr>
@@ -7713,7 +7764,7 @@
       </p:sp>
       <p:sp>
         <p:nvSpPr>
-          <p:cNvPr id="95" name="TextBox 94"/>
+          <p:cNvPr id="96" name="TextBox 95"/>
           <p:cNvSpPr txBox="1"/>
           <p:nvPr/>
         </p:nvSpPr>
@@ -7758,7 +7809,7 @@
       </p:sp>
       <p:sp>
         <p:nvSpPr>
-          <p:cNvPr id="96" name="TextBox 95"/>
+          <p:cNvPr id="97" name="TextBox 96"/>
           <p:cNvSpPr txBox="1"/>
           <p:nvPr/>
         </p:nvSpPr>
@@ -7803,7 +7854,7 @@
       </p:sp>
       <p:sp>
         <p:nvSpPr>
-          <p:cNvPr id="97" name="TextBox 96"/>
+          <p:cNvPr id="98" name="TextBox 97"/>
           <p:cNvSpPr txBox="1"/>
           <p:nvPr/>
         </p:nvSpPr>
@@ -7848,7 +7899,7 @@
       </p:sp>
       <p:sp>
         <p:nvSpPr>
-          <p:cNvPr id="98" name="TextBox 97"/>
+          <p:cNvPr id="99" name="TextBox 98"/>
           <p:cNvSpPr txBox="1"/>
           <p:nvPr/>
         </p:nvSpPr>
@@ -7893,7 +7944,7 @@
       </p:sp>
       <p:sp>
         <p:nvSpPr>
-          <p:cNvPr id="99" name="TextBox 98"/>
+          <p:cNvPr id="100" name="TextBox 99"/>
           <p:cNvSpPr txBox="1"/>
           <p:nvPr/>
         </p:nvSpPr>
@@ -7938,7 +7989,7 @@
       </p:sp>
       <p:sp>
         <p:nvSpPr>
-          <p:cNvPr id="100" name="Rounded Rectangle 99"/>
+          <p:cNvPr id="101" name="Rounded Rectangle 100"/>
           <p:cNvSpPr/>
           <p:nvPr/>
         </p:nvSpPr>
@@ -8017,7 +8068,7 @@
       </p:sp>
       <p:sp>
         <p:nvSpPr>
-          <p:cNvPr id="101" name="Right Arrow 100"/>
+          <p:cNvPr id="102" name="Right Arrow 101"/>
           <p:cNvSpPr/>
           <p:nvPr/>
         </p:nvSpPr>
@@ -8060,7 +8111,7 @@
       </p:sp>
       <p:sp>
         <p:nvSpPr>
-          <p:cNvPr id="102" name="Rounded Rectangle 101"/>
+          <p:cNvPr id="103" name="Rounded Rectangle 102"/>
           <p:cNvSpPr/>
           <p:nvPr/>
         </p:nvSpPr>
@@ -8139,7 +8190,7 @@
       </p:sp>
       <p:sp>
         <p:nvSpPr>
-          <p:cNvPr id="103" name="Right Arrow 102"/>
+          <p:cNvPr id="104" name="Right Arrow 103"/>
           <p:cNvSpPr/>
           <p:nvPr/>
         </p:nvSpPr>
@@ -8182,7 +8233,7 @@
       </p:sp>
       <p:sp>
         <p:nvSpPr>
-          <p:cNvPr id="104" name="Rounded Rectangle 103"/>
+          <p:cNvPr id="105" name="Rounded Rectangle 104"/>
           <p:cNvSpPr/>
           <p:nvPr/>
         </p:nvSpPr>
@@ -8261,7 +8312,7 @@
       </p:sp>
       <p:sp>
         <p:nvSpPr>
-          <p:cNvPr id="105" name="Right Arrow 104"/>
+          <p:cNvPr id="106" name="Right Arrow 105"/>
           <p:cNvSpPr/>
           <p:nvPr/>
         </p:nvSpPr>
@@ -8304,7 +8355,7 @@
       </p:sp>
       <p:sp>
         <p:nvSpPr>
-          <p:cNvPr id="106" name="Rounded Rectangle 105"/>
+          <p:cNvPr id="107" name="Rounded Rectangle 106"/>
           <p:cNvSpPr/>
           <p:nvPr/>
         </p:nvSpPr>
@@ -8383,7 +8434,7 @@
       </p:sp>
       <p:sp>
         <p:nvSpPr>
-          <p:cNvPr id="107" name="Down Arrow 106"/>
+          <p:cNvPr id="108" name="Down Arrow 107"/>
           <p:cNvSpPr/>
           <p:nvPr/>
         </p:nvSpPr>
@@ -8426,7 +8477,7 @@
       </p:sp>
       <p:sp>
         <p:nvSpPr>
-          <p:cNvPr id="108" name="Rounded Rectangle 107"/>
+          <p:cNvPr id="109" name="Rounded Rectangle 108"/>
           <p:cNvSpPr/>
           <p:nvPr/>
         </p:nvSpPr>
@@ -8505,7 +8556,7 @@
       </p:sp>
       <p:sp>
         <p:nvSpPr>
-          <p:cNvPr id="109" name="TextBox 108"/>
+          <p:cNvPr id="110" name="TextBox 109"/>
           <p:cNvSpPr txBox="1"/>
           <p:nvPr/>
         </p:nvSpPr>
@@ -8550,7 +8601,7 @@
       </p:sp>
       <p:sp>
         <p:nvSpPr>
-          <p:cNvPr id="110" name="Rectangle 109"/>
+          <p:cNvPr id="111" name="Rectangle 110"/>
           <p:cNvSpPr/>
           <p:nvPr/>
         </p:nvSpPr>
@@ -8593,7 +8644,7 @@
       </p:sp>
       <p:sp>
         <p:nvSpPr>
-          <p:cNvPr id="111" name="Rectangle 110"/>
+          <p:cNvPr id="112" name="Rectangle 111"/>
           <p:cNvSpPr/>
           <p:nvPr/>
         </p:nvSpPr>
@@ -8638,7 +8689,7 @@
       </p:sp>
       <p:sp>
         <p:nvSpPr>
-          <p:cNvPr id="112" name="TextBox 111"/>
+          <p:cNvPr id="113" name="TextBox 112"/>
           <p:cNvSpPr txBox="1"/>
           <p:nvPr/>
         </p:nvSpPr>
@@ -8683,7 +8734,7 @@
       </p:sp>
       <p:pic>
         <p:nvPicPr>
-          <p:cNvPr id="113" name="Retained pathway shifts" descr="Literature-aligned anchors and retained expiMap pathway shifts for thymus, skin, liver, and spleen, with project effects and three-training ranges."/>
+          <p:cNvPr id="114" name="Retained pathway shifts" descr="Literature-aligned anchors and retained expiMap pathway shifts for thymus, skin, liver, and spleen, with project effects and three-training ranges."/>
           <p:cNvPicPr>
             <a:picLocks noChangeAspect="1"/>
           </p:cNvPicPr>
@@ -8707,7 +8758,7 @@
       </p:pic>
       <p:sp>
         <p:nvSpPr>
-          <p:cNvPr id="114" name="TextBox 113"/>
+          <p:cNvPr id="115" name="TextBox 114"/>
           <p:cNvSpPr txBox="1"/>
           <p:nvPr/>
         </p:nvSpPr>
@@ -8722,8 +8773,8 @@
           <a:noFill/>
         </p:spPr>
         <p:txBody>
-          <a:bodyPr wrap="square" lIns="0" rIns="0" tIns="0" bIns="0" anchor="t">
-            <a:spAutoFit/>
+          <a:bodyPr wrap="none" lIns="0" rIns="0" tIns="0" bIns="0" anchor="t">
+            <a:noAutofit/>
           </a:bodyPr>
           <a:lstStyle/>
           <a:p>
@@ -8739,20 +8790,22 @@
               </a:spcAft>
             </a:pPr>
             <a:r>
-              <a:rPr sz="1500" b="0" i="1">
+              <a:rPr sz="1450" b="0" i="1">
                 <a:solidFill>
                   <a:srgbClr val="697889"/>
                 </a:solidFill>
                 <a:latin typeface="Arial"/>
               </a:rPr>
-              <a:t>Filled markers show the 13 primary retained programs. Four open green diamonds show literature-aligned anchors that failed at least one robustness gate and provide context rather than additional claims. Colored ranges span three complete trainings; axes are tissue specific.</a:t>
-            </a:r>
-          </a:p>
-        </p:txBody>
-      </p:sp>
-      <p:sp>
-        <p:nvSpPr>
-          <p:cNvPr id="115" name="Rectangle 114"/>
+              <a:t>Filled markers show 13 retained programs. Open diamonds are literature-aligned context only,
+not retained findings; keratinization reversed in one of three trainings. Colored ranges span
+three complete trainings; axes are tissue specific.</a:t>
+            </a:r>
+          </a:p>
+        </p:txBody>
+      </p:sp>
+      <p:sp>
+        <p:nvSpPr>
+          <p:cNvPr id="116" name="Rectangle 115"/>
           <p:cNvSpPr/>
           <p:nvPr/>
         </p:nvSpPr>
@@ -8795,7 +8848,7 @@
       </p:sp>
       <p:sp>
         <p:nvSpPr>
-          <p:cNvPr id="116" name="Rectangle 115"/>
+          <p:cNvPr id="117" name="Rectangle 116"/>
           <p:cNvSpPr/>
           <p:nvPr/>
         </p:nvSpPr>
@@ -8840,7 +8893,7 @@
       </p:sp>
       <p:sp>
         <p:nvSpPr>
-          <p:cNvPr id="117" name="TextBox 116"/>
+          <p:cNvPr id="118" name="TextBox 117"/>
           <p:cNvSpPr txBox="1"/>
           <p:nvPr/>
         </p:nvSpPr>
@@ -8885,7 +8938,7 @@
       </p:sp>
       <p:sp>
         <p:nvSpPr>
-          <p:cNvPr id="118" name="TextBox 117"/>
+          <p:cNvPr id="119" name="TextBox 118"/>
           <p:cNvSpPr txBox="1"/>
           <p:nvPr/>
         </p:nvSpPr>
@@ -8930,7 +8983,7 @@
       </p:sp>
       <p:pic>
         <p:nvPicPr>
-          <p:cNvPr id="119" name="Tissue-state hypotheses" descr="Prior-literature phenotypes, observed lower expiMap program scores, and complementary hypotheses for thymus, skin, liver, and spleen."/>
+          <p:cNvPr id="120" name="Tissue-state hypotheses" descr="Prior-literature phenotypes, observed lower expiMap program scores, and complementary hypotheses for thymus, skin, liver, and spleen."/>
           <p:cNvPicPr>
             <a:picLocks noChangeAspect="1"/>
           </p:cNvPicPr>
@@ -8954,7 +9007,7 @@
       </p:pic>
       <p:sp>
         <p:nvSpPr>
-          <p:cNvPr id="120" name="Rectangle 119"/>
+          <p:cNvPr id="121" name="Rectangle 120"/>
           <p:cNvSpPr/>
           <p:nvPr/>
         </p:nvSpPr>
@@ -8997,7 +9050,7 @@
       </p:sp>
       <p:sp>
         <p:nvSpPr>
-          <p:cNvPr id="121" name="Rectangle 120"/>
+          <p:cNvPr id="122" name="Rectangle 121"/>
           <p:cNvSpPr/>
           <p:nvPr/>
         </p:nvSpPr>
@@ -9042,7 +9095,7 @@
       </p:sp>
       <p:sp>
         <p:nvSpPr>
-          <p:cNvPr id="122" name="TextBox 121"/>
+          <p:cNvPr id="123" name="TextBox 122"/>
           <p:cNvSpPr txBox="1"/>
           <p:nvPr/>
         </p:nvSpPr>
@@ -9087,14 +9140,14 @@
       </p:sp>
       <p:sp>
         <p:nvSpPr>
-          <p:cNvPr id="123" name="TextBox 122"/>
+          <p:cNvPr id="124" name="TextBox 123"/>
           <p:cNvSpPr txBox="1"/>
           <p:nvPr/>
         </p:nvSpPr>
         <p:spPr>
           <a:xfrm>
-            <a:off x="29718000" y="18333720"/>
-            <a:ext cx="13350240" cy="2057400"/>
+            <a:off x="29718000" y="18306288"/>
+            <a:ext cx="13350240" cy="621792"/>
           </a:xfrm>
           <a:prstGeom prst="rect">
             <a:avLst/>
@@ -9102,12 +9155,12 @@
           <a:noFill/>
         </p:spPr>
         <p:txBody>
-          <a:bodyPr wrap="square" lIns="0" rIns="0" tIns="0" bIns="0">
-            <a:spAutoFit/>
+          <a:bodyPr wrap="none" lIns="0" rIns="0" tIns="0" bIns="0" anchor="t">
+            <a:noAutofit/>
           </a:bodyPr>
           <a:lstStyle/>
           <a:p>
-            <a:pPr>
+            <a:pPr algn="l">
               <a:lnSpc>
                 <a:spcPct val="100000"/>
               </a:lnSpc>
@@ -9115,21 +9168,45 @@
                 <a:spcPts val="0"/>
               </a:spcBef>
               <a:spcAft>
-                <a:spcPts val="400"/>
+                <a:spcPts val="0"/>
               </a:spcAft>
             </a:pPr>
             <a:r>
-              <a:rPr sz="1800">
+              <a:rPr sz="1750" b="0" i="0">
                 <a:solidFill>
                   <a:srgbClr val="33445D"/>
                 </a:solidFill>
                 <a:latin typeface="Arial"/>
               </a:rPr>
-              <a:t>• Spleen was strongest: T cell receptor, neutrophil degranulation, and C‑type lectin receptor programs were lower across five projects and three trainings; all had GSEA FDR &lt;0.05.</a:t>
-            </a:r>
-          </a:p>
-          <a:p>
-            <a:pPr>
+              <a:t>• Spleen was strongest: T cell receptor, neutrophil degranulation, and C‑type lectin
+  receptor programs were lower across five projects and three trainings; all had GSEA FDR &lt;0.05.</a:t>
+            </a:r>
+          </a:p>
+        </p:txBody>
+      </p:sp>
+      <p:sp>
+        <p:nvSpPr>
+          <p:cNvPr id="125" name="TextBox 124"/>
+          <p:cNvSpPr txBox="1"/>
+          <p:nvPr/>
+        </p:nvSpPr>
+        <p:spPr>
+          <a:xfrm>
+            <a:off x="29718000" y="19019520"/>
+            <a:ext cx="13350240" cy="621792"/>
+          </a:xfrm>
+          <a:prstGeom prst="rect">
+            <a:avLst/>
+          </a:prstGeom>
+          <a:noFill/>
+        </p:spPr>
+        <p:txBody>
+          <a:bodyPr wrap="none" lIns="0" rIns="0" tIns="0" bIns="0" anchor="t">
+            <a:noAutofit/>
+          </a:bodyPr>
+          <a:lstStyle/>
+          <a:p>
+            <a:pPr algn="l">
               <a:lnSpc>
                 <a:spcPct val="100000"/>
               </a:lnSpc>
@@ -9137,21 +9214,45 @@
                 <a:spcPts val="0"/>
               </a:spcBef>
               <a:spcAft>
-                <a:spcPts val="400"/>
+                <a:spcPts val="0"/>
               </a:spcAft>
             </a:pPr>
             <a:r>
-              <a:rPr sz="1800">
+              <a:rPr sz="1750" b="0" i="0">
                 <a:solidFill>
                   <a:srgbClr val="33445D"/>
                 </a:solidFill>
                 <a:latin typeface="Arial"/>
               </a:rPr>
-              <a:t>• Skin and thymus emphasized lower tissue maintenance programs; liver showed lower adaptive immune signaling amid heterogeneous metabolism.</a:t>
-            </a:r>
-          </a:p>
-          <a:p>
-            <a:pPr>
+              <a:t>• Skin and thymus emphasized lower tissue maintenance programs; liver showed lower
+  adaptive immune signaling amid heterogeneous metabolism.</a:t>
+            </a:r>
+          </a:p>
+        </p:txBody>
+      </p:sp>
+      <p:sp>
+        <p:nvSpPr>
+          <p:cNvPr id="126" name="TextBox 125"/>
+          <p:cNvSpPr txBox="1"/>
+          <p:nvPr/>
+        </p:nvSpPr>
+        <p:spPr>
+          <a:xfrm>
+            <a:off x="29718000" y="19732752"/>
+            <a:ext cx="13350240" cy="329184"/>
+          </a:xfrm>
+          <a:prstGeom prst="rect">
+            <a:avLst/>
+          </a:prstGeom>
+          <a:noFill/>
+        </p:spPr>
+        <p:txBody>
+          <a:bodyPr wrap="none" lIns="0" rIns="0" tIns="0" bIns="0" anchor="t">
+            <a:noAutofit/>
+          </a:bodyPr>
+          <a:lstStyle/>
+          <a:p>
+            <a:pPr algn="l">
               <a:lnSpc>
                 <a:spcPct val="100000"/>
               </a:lnSpc>
@@ -9159,24 +9260,24 @@
                 <a:spcPts val="0"/>
               </a:spcBef>
               <a:spcAft>
-                <a:spcPts val="400"/>
+                <a:spcPts val="0"/>
               </a:spcAft>
             </a:pPr>
             <a:r>
-              <a:rPr sz="1800">
+              <a:rPr sz="1750" b="0" i="0">
                 <a:solidFill>
                   <a:srgbClr val="33445D"/>
                 </a:solidFill>
                 <a:latin typeface="Arial"/>
               </a:rPr>
-              <a:t>• Bulk latent scores are testable hypotheses, not causal or cell resolved measures of pathway activity.</a:t>
-            </a:r>
-          </a:p>
-        </p:txBody>
-      </p:sp>
-      <p:sp>
-        <p:nvSpPr>
-          <p:cNvPr id="124" name="Rectangle 123"/>
+              <a:t>• Bulk latent scores are testable hypotheses, not causal or cell-resolved measures of pathway activity.</a:t>
+            </a:r>
+          </a:p>
+        </p:txBody>
+      </p:sp>
+      <p:sp>
+        <p:nvSpPr>
+          <p:cNvPr id="127" name="Rectangle 126"/>
           <p:cNvSpPr/>
           <p:nvPr/>
         </p:nvSpPr>
@@ -9219,7 +9320,7 @@
       </p:sp>
       <p:sp>
         <p:nvSpPr>
-          <p:cNvPr id="125" name="Rectangle 124"/>
+          <p:cNvPr id="128" name="Rectangle 127"/>
           <p:cNvSpPr/>
           <p:nvPr/>
         </p:nvSpPr>
@@ -9264,7 +9365,7 @@
       </p:sp>
       <p:sp>
         <p:nvSpPr>
-          <p:cNvPr id="126" name="TextBox 125"/>
+          <p:cNvPr id="129" name="TextBox 128"/>
           <p:cNvSpPr txBox="1"/>
           <p:nvPr/>
         </p:nvSpPr>
@@ -9309,7 +9410,7 @@
       </p:sp>
       <p:sp>
         <p:nvSpPr>
-          <p:cNvPr id="127" name="TextBox 126"/>
+          <p:cNvPr id="130" name="TextBox 129"/>
           <p:cNvSpPr txBox="1"/>
           <p:nvPr/>
         </p:nvSpPr>
@@ -9324,8 +9425,8 @@
           <a:noFill/>
         </p:spPr>
         <p:txBody>
-          <a:bodyPr wrap="square" lIns="0" rIns="0" tIns="0" bIns="0" anchor="t">
-            <a:spAutoFit/>
+          <a:bodyPr wrap="none" lIns="0" rIns="0" tIns="0" bIns="0" anchor="t">
+            <a:noAutofit/>
           </a:bodyPr>
           <a:lstStyle/>
           <a:p>
@@ -9341,20 +9442,22 @@
               </a:spcAft>
             </a:pPr>
             <a:r>
-              <a:rPr sz="1450" b="0" i="0">
+              <a:rPr sz="1350" b="0" i="0">
                 <a:solidFill>
                   <a:srgbClr val="33445D"/>
                 </a:solidFill>
                 <a:latin typeface="Arial"/>
               </a:rPr>
-              <a:t>1 Gebre et al., NAR 2025 (OSDR). 2 Lotfollahi et al., Nat Cell Biol 2023 (expiMap). 3 Lachmann et al., Nat Commun 2018 (ARCHS4). 4 Milacic et al., NAR 2024 (Reactome). 5 Horie et al., Sci Rep 2019. 6 Cope et al., Commun Med 2024. 7 Beheshti et al., Sci Rep 2019. 8 Gridley et al., J Appl Physiol 2009.</a:t>
-            </a:r>
-          </a:p>
-        </p:txBody>
-      </p:sp>
-      <p:sp>
-        <p:nvSpPr>
-          <p:cNvPr id="128" name="Rectangle 127"/>
+              <a:t>1 Gebre et al., NAR 2025 (OSDR). 2 Lotfollahi et al., Nat Cell Biol 2023 (expiMap).
+3 Lachmann et al., Nat Commun 2018 (ARCHS4). 4 Milacic et al., NAR 2024 (Reactome).
+5 Horie et al., Sci Rep 2019. 6 Cope et al., Commun Med 2024. 7 Beheshti et al., Sci Rep 2019. 8 Gridley et al., J Appl Physiol 2009.</a:t>
+            </a:r>
+          </a:p>
+        </p:txBody>
+      </p:sp>
+      <p:sp>
+        <p:nvSpPr>
+          <p:cNvPr id="131" name="Rectangle 130"/>
           <p:cNvSpPr/>
           <p:nvPr/>
         </p:nvSpPr>
@@ -9397,7 +9500,7 @@
       </p:sp>
       <p:sp>
         <p:nvSpPr>
-          <p:cNvPr id="129" name="TextBox 128"/>
+          <p:cNvPr id="132" name="TextBox 131"/>
           <p:cNvSpPr txBox="1"/>
           <p:nvPr/>
         </p:nvSpPr>
@@ -9442,7 +9545,7 @@
       </p:sp>
       <p:sp>
         <p:nvSpPr>
-          <p:cNvPr id="130" name="TextBox 129"/>
+          <p:cNvPr id="133" name="TextBox 132"/>
           <p:cNvSpPr txBox="1"/>
           <p:nvPr/>
         </p:nvSpPr>
@@ -9457,8 +9560,8 @@
           <a:noFill/>
         </p:spPr>
         <p:txBody>
-          <a:bodyPr wrap="square" lIns="0" rIns="0" tIns="0" bIns="0" anchor="t">
-            <a:spAutoFit/>
+          <a:bodyPr wrap="none" lIns="0" rIns="0" tIns="0" bIns="0" anchor="t">
+            <a:noAutofit/>
           </a:bodyPr>
           <a:lstStyle/>
           <a:p>
@@ -9480,14 +9583,15 @@
                 </a:solidFill>
                 <a:latin typeface="Arial"/>
               </a:rPr>
-              <a:t>Mentor: James Casaletto | NASA Space Life Sciences Training Program | NASA OSDR, ARCHS4, and Reactome investigators and curation teams</a:t>
-            </a:r>
-          </a:p>
-        </p:txBody>
-      </p:sp>
-      <p:sp>
-        <p:nvSpPr>
-          <p:cNvPr id="131" name="TextBox 130"/>
+              <a:t>Mentor: James Casaletto | NASA Space Life Sciences Training Program
+NASA OSDR, ARCHS4, and Reactome investigators and curation teams</a:t>
+            </a:r>
+          </a:p>
+        </p:txBody>
+      </p:sp>
+      <p:sp>
+        <p:nvSpPr>
+          <p:cNvPr id="134" name="TextBox 133"/>
           <p:cNvSpPr txBox="1"/>
           <p:nvPr/>
         </p:nvSpPr>
@@ -9533,7 +9637,7 @@
       </p:sp>
       <p:sp>
         <p:nvSpPr>
-          <p:cNvPr id="132" name="TextBox 131"/>
+          <p:cNvPr id="135" name="TextBox 134"/>
           <p:cNvSpPr txBox="1"/>
           <p:nvPr/>
         </p:nvSpPr>

</xml_diff>

<commit_message>
enforce whole-word wrapping in poster
</commit_message>
<xml_diff>
--- a/paper/asgsr_expimap_hvg/poster/asgsr_expimap_poster.pptx
+++ b/paper/asgsr_expimap_hvg/poster/asgsr_expimap_poster.pptx
@@ -3161,7 +3161,7 @@
           </a:bodyPr>
           <a:lstStyle/>
           <a:p>
-            <a:pPr algn="l">
+            <a:pPr algn="l" latinLnBrk="0" eaLnBrk="0" hangingPunct="0">
               <a:lnSpc>
                 <a:spcPct val="100000"/>
               </a:lnSpc>
@@ -3206,7 +3206,7 @@
           </a:bodyPr>
           <a:lstStyle/>
           <a:p>
-            <a:pPr algn="ctr">
+            <a:pPr algn="ctr" latinLnBrk="0" eaLnBrk="0" hangingPunct="0">
               <a:lnSpc>
                 <a:spcPct val="100000"/>
               </a:lnSpc>
@@ -3251,7 +3251,7 @@
           </a:bodyPr>
           <a:lstStyle/>
           <a:p>
-            <a:pPr algn="ctr">
+            <a:pPr algn="ctr" latinLnBrk="0" eaLnBrk="0" hangingPunct="0">
               <a:lnSpc>
                 <a:spcPct val="100000"/>
               </a:lnSpc>
@@ -3296,7 +3296,7 @@
           </a:bodyPr>
           <a:lstStyle/>
           <a:p>
-            <a:pPr algn="ctr">
+            <a:pPr algn="ctr" latinLnBrk="0" eaLnBrk="0" hangingPunct="0">
               <a:lnSpc>
                 <a:spcPct val="100000"/>
               </a:lnSpc>
@@ -3453,7 +3453,7 @@
           </a:bodyPr>
           <a:lstStyle/>
           <a:p>
-            <a:pPr algn="ctr">
+            <a:pPr algn="ctr" latinLnBrk="0" eaLnBrk="0" hangingPunct="0">
               <a:lnSpc>
                 <a:spcPct val="100000"/>
               </a:lnSpc>
@@ -3493,12 +3493,12 @@
           <a:noFill/>
         </p:spPr>
         <p:txBody>
-          <a:bodyPr wrap="none" lIns="0" rIns="0" tIns="0" bIns="0" anchor="t">
+          <a:bodyPr wrap="square" lIns="0" rIns="0" tIns="0" bIns="0" anchor="t">
             <a:noAutofit/>
           </a:bodyPr>
           <a:lstStyle/>
           <a:p>
-            <a:pPr algn="l">
+            <a:pPr algn="l" latinLnBrk="0" eaLnBrk="0" hangingPunct="0">
               <a:lnSpc>
                 <a:spcPct val="100000"/>
               </a:lnSpc>
@@ -3516,14 +3516,7 @@
                 </a:solidFill>
                 <a:latin typeface="Arial"/>
               </a:rPr>
-              <a:t>Mission differences can obscure spaceflight responses shared across studies.
-We mapped NASA OSDR mouse bulk RNA sequencing samples to tissue-matched ARCHS4
-references and analyzed about 2,000 highly variable genes with Reactome-constrained expiMap.
-Flight-ground shifts were balanced across projects and evaluated with gene-set enrichment,
-project holdouts, three complete training runs, composition proxies, member-gene review,
-and literature annotation after scoring. Retained programs were lower for thymic repair,
-skin maintenance, liver adaptive immunity, and splenic adaptive and innate immunity.
-Spleen showed the strongest result across multiple pathways.</a:t>
+              <a:t>Mission differences can obscure spaceflight responses shared across studies. We mapped NASA OSDR mouse bulk RNA sequencing samples to tissue-matched ARCHS4 references and analyzed about 2,000 highly variable genes with Reactome-constrained expiMap. Flight-ground shifts were balanced across projects and evaluated with gene-set enrichment, project holdouts, three complete training runs, composition proxies, member-gene review, and literature annotation after scoring. Retained programs were lower for thymic repair, skin maintenance, liver adaptive immunity, and splenic adaptive and innate immunity. Spleen showed the strongest result across multiple pathways.</a:t>
             </a:r>
           </a:p>
         </p:txBody>
@@ -3638,7 +3631,7 @@
           </a:bodyPr>
           <a:lstStyle/>
           <a:p>
-            <a:pPr algn="ctr">
+            <a:pPr algn="ctr" latinLnBrk="0" eaLnBrk="0" hangingPunct="0">
               <a:lnSpc>
                 <a:spcPct val="100000"/>
               </a:lnSpc>
@@ -3683,7 +3676,7 @@
           </a:bodyPr>
           <a:lstStyle/>
           <a:p>
-            <a:pPr algn="l">
+            <a:pPr algn="l" latinLnBrk="0" eaLnBrk="0" hangingPunct="0">
               <a:lnSpc>
                 <a:spcPct val="100000"/>
               </a:lnSpc>
@@ -3728,7 +3721,7 @@
           </a:bodyPr>
           <a:lstStyle/>
           <a:p>
-            <a:pPr algn="l">
+            <a:pPr algn="l" latinLnBrk="0" eaLnBrk="0" hangingPunct="0">
               <a:lnSpc>
                 <a:spcPct val="100000"/>
               </a:lnSpc>
@@ -3773,7 +3766,7 @@
           </a:bodyPr>
           <a:lstStyle/>
           <a:p>
-            <a:pPr algn="l">
+            <a:pPr algn="l" latinLnBrk="0" eaLnBrk="0" hangingPunct="0">
               <a:lnSpc>
                 <a:spcPct val="100000"/>
               </a:lnSpc>
@@ -3818,7 +3811,7 @@
           </a:bodyPr>
           <a:lstStyle/>
           <a:p>
-            <a:pPr algn="l">
+            <a:pPr algn="l" latinLnBrk="0" eaLnBrk="0" hangingPunct="0">
               <a:lnSpc>
                 <a:spcPct val="100000"/>
               </a:lnSpc>
@@ -3906,7 +3899,7 @@
           </a:bodyPr>
           <a:lstStyle/>
           <a:p>
-            <a:pPr algn="ctr">
+            <a:pPr algn="ctr" latinLnBrk="0" eaLnBrk="0" hangingPunct="0">
               <a:lnSpc>
                 <a:spcPct val="100000"/>
               </a:lnSpc>
@@ -3951,7 +3944,7 @@
           </a:bodyPr>
           <a:lstStyle/>
           <a:p>
-            <a:pPr algn="ctr">
+            <a:pPr algn="ctr" latinLnBrk="0" eaLnBrk="0" hangingPunct="0">
               <a:lnSpc>
                 <a:spcPct val="100000"/>
               </a:lnSpc>
@@ -4039,7 +4032,7 @@
           </a:bodyPr>
           <a:lstStyle/>
           <a:p>
-            <a:pPr algn="ctr">
+            <a:pPr algn="ctr" latinLnBrk="0" eaLnBrk="0" hangingPunct="0">
               <a:lnSpc>
                 <a:spcPct val="100000"/>
               </a:lnSpc>
@@ -4084,7 +4077,7 @@
           </a:bodyPr>
           <a:lstStyle/>
           <a:p>
-            <a:pPr algn="ctr">
+            <a:pPr algn="ctr" latinLnBrk="0" eaLnBrk="0" hangingPunct="0">
               <a:lnSpc>
                 <a:spcPct val="100000"/>
               </a:lnSpc>
@@ -4172,7 +4165,7 @@
           </a:bodyPr>
           <a:lstStyle/>
           <a:p>
-            <a:pPr algn="ctr">
+            <a:pPr algn="ctr" latinLnBrk="0" eaLnBrk="0" hangingPunct="0">
               <a:lnSpc>
                 <a:spcPct val="100000"/>
               </a:lnSpc>
@@ -4217,7 +4210,7 @@
           </a:bodyPr>
           <a:lstStyle/>
           <a:p>
-            <a:pPr algn="ctr">
+            <a:pPr algn="ctr" latinLnBrk="0" eaLnBrk="0" hangingPunct="0">
               <a:lnSpc>
                 <a:spcPct val="100000"/>
               </a:lnSpc>
@@ -4305,7 +4298,7 @@
           </a:bodyPr>
           <a:lstStyle/>
           <a:p>
-            <a:pPr algn="ctr">
+            <a:pPr algn="ctr" latinLnBrk="0" eaLnBrk="0" hangingPunct="0">
               <a:lnSpc>
                 <a:spcPct val="100000"/>
               </a:lnSpc>
@@ -4345,12 +4338,12 @@
           <a:noFill/>
         </p:spPr>
         <p:txBody>
-          <a:bodyPr wrap="none" lIns="0" rIns="0" tIns="0" bIns="0" anchor="t">
+          <a:bodyPr wrap="square" lIns="0" rIns="0" tIns="0" bIns="0" anchor="t">
             <a:noAutofit/>
           </a:bodyPr>
           <a:lstStyle/>
           <a:p>
-            <a:pPr algn="l">
+            <a:pPr algn="l" latinLnBrk="0" eaLnBrk="0" hangingPunct="0">
               <a:lnSpc>
                 <a:spcPct val="100000"/>
               </a:lnSpc>
@@ -4368,9 +4361,7 @@
                 </a:solidFill>
                 <a:latin typeface="Arial"/>
               </a:rPr>
-              <a:t>Study identity and protocol can dominate an unconstrained expression representation.
-Tissue-matched reference mapping, accession conditioning, and equal project weighting
-reduce this bias without claiming to remove all mission confounding.</a:t>
+              <a:t>Study identity and protocol can dominate an unconstrained expression representation. Tissue-matched reference mapping, accession conditioning, and equal project weighting reduce this bias without claiming to remove all mission confounding.</a:t>
             </a:r>
           </a:p>
         </p:txBody>
@@ -4397,7 +4388,7 @@
           </a:bodyPr>
           <a:lstStyle/>
           <a:p>
-            <a:pPr algn="l">
+            <a:pPr algn="l" latinLnBrk="0" eaLnBrk="0" hangingPunct="0">
               <a:lnSpc>
                 <a:spcPct val="100000"/>
               </a:lnSpc>
@@ -4451,7 +4442,7 @@
                     <a:bodyPr wrap="none" anchor="ctr"/>
                     <a:lstStyle/>
                     <a:p>
-                      <a:pPr algn="l"/>
+                      <a:pPr algn="l" latinLnBrk="0" eaLnBrk="0" hangingPunct="0"/>
                       <a:r>
                         <a:rPr sz="1600" b="1">
                           <a:solidFill>
@@ -4474,7 +4465,7 @@
                     <a:bodyPr wrap="none" anchor="ctr"/>
                     <a:lstStyle/>
                     <a:p>
-                      <a:pPr algn="ctr"/>
+                      <a:pPr algn="ctr" latinLnBrk="0" eaLnBrk="0" hangingPunct="0"/>
                       <a:r>
                         <a:rPr sz="1600" b="1">
                           <a:solidFill>
@@ -4497,7 +4488,7 @@
                     <a:bodyPr wrap="none" anchor="ctr"/>
                     <a:lstStyle/>
                     <a:p>
-                      <a:pPr algn="ctr"/>
+                      <a:pPr algn="ctr" latinLnBrk="0" eaLnBrk="0" hangingPunct="0"/>
                       <a:r>
                         <a:rPr sz="1600" b="1">
                           <a:solidFill>
@@ -4520,7 +4511,7 @@
                     <a:bodyPr wrap="none" anchor="ctr"/>
                     <a:lstStyle/>
                     <a:p>
-                      <a:pPr algn="ctr"/>
+                      <a:pPr algn="ctr" latinLnBrk="0" eaLnBrk="0" hangingPunct="0"/>
                       <a:r>
                         <a:rPr sz="1600" b="1">
                           <a:solidFill>
@@ -4543,7 +4534,7 @@
                     <a:bodyPr wrap="none" anchor="ctr"/>
                     <a:lstStyle/>
                     <a:p>
-                      <a:pPr algn="ctr"/>
+                      <a:pPr algn="ctr" latinLnBrk="0" eaLnBrk="0" hangingPunct="0"/>
                       <a:r>
                         <a:rPr sz="1600" b="1">
                           <a:solidFill>
@@ -4568,7 +4559,7 @@
                     <a:bodyPr wrap="none" anchor="ctr"/>
                     <a:lstStyle/>
                     <a:p>
-                      <a:pPr algn="l"/>
+                      <a:pPr algn="l" latinLnBrk="0" eaLnBrk="0" hangingPunct="0"/>
                       <a:r>
                         <a:rPr sz="1650" b="1">
                           <a:solidFill>
@@ -4591,7 +4582,7 @@
                     <a:bodyPr wrap="none" anchor="ctr"/>
                     <a:lstStyle/>
                     <a:p>
-                      <a:pPr algn="ctr"/>
+                      <a:pPr algn="ctr" latinLnBrk="0" eaLnBrk="0" hangingPunct="0"/>
                       <a:r>
                         <a:rPr sz="1650" b="0">
                           <a:solidFill>
@@ -4614,7 +4605,7 @@
                     <a:bodyPr wrap="none" anchor="ctr"/>
                     <a:lstStyle/>
                     <a:p>
-                      <a:pPr algn="ctr"/>
+                      <a:pPr algn="ctr" latinLnBrk="0" eaLnBrk="0" hangingPunct="0"/>
                       <a:r>
                         <a:rPr sz="1650" b="0">
                           <a:solidFill>
@@ -4637,7 +4628,7 @@
                     <a:bodyPr wrap="none" anchor="ctr"/>
                     <a:lstStyle/>
                     <a:p>
-                      <a:pPr algn="ctr"/>
+                      <a:pPr algn="ctr" latinLnBrk="0" eaLnBrk="0" hangingPunct="0"/>
                       <a:r>
                         <a:rPr sz="1650" b="0">
                           <a:solidFill>
@@ -4660,7 +4651,7 @@
                     <a:bodyPr wrap="none" anchor="ctr"/>
                     <a:lstStyle/>
                     <a:p>
-                      <a:pPr algn="ctr"/>
+                      <a:pPr algn="ctr" latinLnBrk="0" eaLnBrk="0" hangingPunct="0"/>
                       <a:r>
                         <a:rPr sz="1650" b="0">
                           <a:solidFill>
@@ -4685,7 +4676,7 @@
                     <a:bodyPr wrap="none" anchor="ctr"/>
                     <a:lstStyle/>
                     <a:p>
-                      <a:pPr algn="l"/>
+                      <a:pPr algn="l" latinLnBrk="0" eaLnBrk="0" hangingPunct="0"/>
                       <a:r>
                         <a:rPr sz="1650" b="1">
                           <a:solidFill>
@@ -4708,7 +4699,7 @@
                     <a:bodyPr wrap="none" anchor="ctr"/>
                     <a:lstStyle/>
                     <a:p>
-                      <a:pPr algn="ctr"/>
+                      <a:pPr algn="ctr" latinLnBrk="0" eaLnBrk="0" hangingPunct="0"/>
                       <a:r>
                         <a:rPr sz="1650" b="0">
                           <a:solidFill>
@@ -4731,7 +4722,7 @@
                     <a:bodyPr wrap="none" anchor="ctr"/>
                     <a:lstStyle/>
                     <a:p>
-                      <a:pPr algn="ctr"/>
+                      <a:pPr algn="ctr" latinLnBrk="0" eaLnBrk="0" hangingPunct="0"/>
                       <a:r>
                         <a:rPr sz="1650" b="0">
                           <a:solidFill>
@@ -4754,7 +4745,7 @@
                     <a:bodyPr wrap="none" anchor="ctr"/>
                     <a:lstStyle/>
                     <a:p>
-                      <a:pPr algn="ctr"/>
+                      <a:pPr algn="ctr" latinLnBrk="0" eaLnBrk="0" hangingPunct="0"/>
                       <a:r>
                         <a:rPr sz="1650" b="0">
                           <a:solidFill>
@@ -4777,7 +4768,7 @@
                     <a:bodyPr wrap="none" anchor="ctr"/>
                     <a:lstStyle/>
                     <a:p>
-                      <a:pPr algn="ctr"/>
+                      <a:pPr algn="ctr" latinLnBrk="0" eaLnBrk="0" hangingPunct="0"/>
                       <a:r>
                         <a:rPr sz="1650" b="0">
                           <a:solidFill>
@@ -4802,7 +4793,7 @@
                     <a:bodyPr wrap="none" anchor="ctr"/>
                     <a:lstStyle/>
                     <a:p>
-                      <a:pPr algn="l"/>
+                      <a:pPr algn="l" latinLnBrk="0" eaLnBrk="0" hangingPunct="0"/>
                       <a:r>
                         <a:rPr sz="1650" b="1">
                           <a:solidFill>
@@ -4825,7 +4816,7 @@
                     <a:bodyPr wrap="none" anchor="ctr"/>
                     <a:lstStyle/>
                     <a:p>
-                      <a:pPr algn="ctr"/>
+                      <a:pPr algn="ctr" latinLnBrk="0" eaLnBrk="0" hangingPunct="0"/>
                       <a:r>
                         <a:rPr sz="1650" b="0">
                           <a:solidFill>
@@ -4848,7 +4839,7 @@
                     <a:bodyPr wrap="none" anchor="ctr"/>
                     <a:lstStyle/>
                     <a:p>
-                      <a:pPr algn="ctr"/>
+                      <a:pPr algn="ctr" latinLnBrk="0" eaLnBrk="0" hangingPunct="0"/>
                       <a:r>
                         <a:rPr sz="1650" b="0">
                           <a:solidFill>
@@ -4871,7 +4862,7 @@
                     <a:bodyPr wrap="none" anchor="ctr"/>
                     <a:lstStyle/>
                     <a:p>
-                      <a:pPr algn="ctr"/>
+                      <a:pPr algn="ctr" latinLnBrk="0" eaLnBrk="0" hangingPunct="0"/>
                       <a:r>
                         <a:rPr sz="1650" b="0">
                           <a:solidFill>
@@ -4894,7 +4885,7 @@
                     <a:bodyPr wrap="none" anchor="ctr"/>
                     <a:lstStyle/>
                     <a:p>
-                      <a:pPr algn="ctr"/>
+                      <a:pPr algn="ctr" latinLnBrk="0" eaLnBrk="0" hangingPunct="0"/>
                       <a:r>
                         <a:rPr sz="1650" b="0">
                           <a:solidFill>
@@ -4919,7 +4910,7 @@
                     <a:bodyPr wrap="none" anchor="ctr"/>
                     <a:lstStyle/>
                     <a:p>
-                      <a:pPr algn="l"/>
+                      <a:pPr algn="l" latinLnBrk="0" eaLnBrk="0" hangingPunct="0"/>
                       <a:r>
                         <a:rPr sz="1650" b="1">
                           <a:solidFill>
@@ -4942,7 +4933,7 @@
                     <a:bodyPr wrap="none" anchor="ctr"/>
                     <a:lstStyle/>
                     <a:p>
-                      <a:pPr algn="ctr"/>
+                      <a:pPr algn="ctr" latinLnBrk="0" eaLnBrk="0" hangingPunct="0"/>
                       <a:r>
                         <a:rPr sz="1650" b="0">
                           <a:solidFill>
@@ -4965,7 +4956,7 @@
                     <a:bodyPr wrap="none" anchor="ctr"/>
                     <a:lstStyle/>
                     <a:p>
-                      <a:pPr algn="ctr"/>
+                      <a:pPr algn="ctr" latinLnBrk="0" eaLnBrk="0" hangingPunct="0"/>
                       <a:r>
                         <a:rPr sz="1650" b="0">
                           <a:solidFill>
@@ -4988,7 +4979,7 @@
                     <a:bodyPr wrap="none" anchor="ctr"/>
                     <a:lstStyle/>
                     <a:p>
-                      <a:pPr algn="ctr"/>
+                      <a:pPr algn="ctr" latinLnBrk="0" eaLnBrk="0" hangingPunct="0"/>
                       <a:r>
                         <a:rPr sz="1650" b="0">
                           <a:solidFill>
@@ -5011,7 +5002,7 @@
                     <a:bodyPr wrap="none" anchor="ctr"/>
                     <a:lstStyle/>
                     <a:p>
-                      <a:pPr algn="ctr"/>
+                      <a:pPr algn="ctr" latinLnBrk="0" eaLnBrk="0" hangingPunct="0"/>
                       <a:r>
                         <a:rPr sz="1650" b="0">
                           <a:solidFill>
@@ -5051,12 +5042,12 @@
           <a:noFill/>
         </p:spPr>
         <p:txBody>
-          <a:bodyPr wrap="none" lIns="0" rIns="0" tIns="0" bIns="0" anchor="t">
+          <a:bodyPr wrap="square" lIns="0" rIns="0" tIns="0" bIns="0" anchor="t">
             <a:noAutofit/>
           </a:bodyPr>
           <a:lstStyle/>
           <a:p>
-            <a:pPr algn="l">
+            <a:pPr algn="l" latinLnBrk="0" eaLnBrk="0" hangingPunct="0">
               <a:lnSpc>
                 <a:spcPct val="100000"/>
               </a:lnSpc>
@@ -5101,7 +5092,7 @@
           </a:bodyPr>
           <a:lstStyle/>
           <a:p>
-            <a:pPr algn="l">
+            <a:pPr algn="l" latinLnBrk="0" eaLnBrk="0" hangingPunct="0">
               <a:lnSpc>
                 <a:spcPct val="100000"/>
               </a:lnSpc>
@@ -5193,7 +5184,7 @@
           </a:bodyPr>
           <a:lstStyle/>
           <a:p>
-            <a:pPr algn="ctr">
+            <a:pPr algn="ctr" latinLnBrk="0" eaLnBrk="0" hangingPunct="0">
               <a:lnSpc>
                 <a:spcPct val="100000"/>
               </a:lnSpc>
@@ -5285,7 +5276,7 @@
           </a:bodyPr>
           <a:lstStyle/>
           <a:p>
-            <a:pPr algn="ctr">
+            <a:pPr algn="ctr" latinLnBrk="0" eaLnBrk="0" hangingPunct="0">
               <a:lnSpc>
                 <a:spcPct val="100000"/>
               </a:lnSpc>
@@ -5377,7 +5368,7 @@
           </a:bodyPr>
           <a:lstStyle/>
           <a:p>
-            <a:pPr algn="ctr">
+            <a:pPr algn="ctr" latinLnBrk="0" eaLnBrk="0" hangingPunct="0">
               <a:lnSpc>
                 <a:spcPct val="100000"/>
               </a:lnSpc>
@@ -5469,7 +5460,7 @@
           </a:bodyPr>
           <a:lstStyle/>
           <a:p>
-            <a:pPr algn="ctr">
+            <a:pPr algn="ctr" latinLnBrk="0" eaLnBrk="0" hangingPunct="0">
               <a:lnSpc>
                 <a:spcPct val="100000"/>
               </a:lnSpc>
@@ -5561,7 +5552,7 @@
           </a:bodyPr>
           <a:lstStyle/>
           <a:p>
-            <a:pPr algn="ctr">
+            <a:pPr algn="ctr" latinLnBrk="0" eaLnBrk="0" hangingPunct="0">
               <a:lnSpc>
                 <a:spcPct val="100000"/>
               </a:lnSpc>
@@ -5653,7 +5644,7 @@
           </a:bodyPr>
           <a:lstStyle/>
           <a:p>
-            <a:pPr algn="ctr">
+            <a:pPr algn="ctr" latinLnBrk="0" eaLnBrk="0" hangingPunct="0">
               <a:lnSpc>
                 <a:spcPct val="100000"/>
               </a:lnSpc>
@@ -5693,12 +5684,12 @@
           <a:noFill/>
         </p:spPr>
         <p:txBody>
-          <a:bodyPr wrap="none" lIns="0" rIns="0" tIns="0" bIns="0" anchor="t">
+          <a:bodyPr wrap="square" lIns="0" rIns="0" tIns="0" bIns="0" anchor="t">
             <a:noAutofit/>
           </a:bodyPr>
           <a:lstStyle/>
           <a:p>
-            <a:pPr algn="l">
+            <a:pPr algn="l" latinLnBrk="0" eaLnBrk="0" hangingPunct="0">
               <a:lnSpc>
                 <a:spcPct val="100000"/>
               </a:lnSpc>
@@ -5716,8 +5707,7 @@
                 </a:solidFill>
                 <a:latin typeface="Arial"/>
               </a:rPr>
-              <a:t>Complementary programs add a plausible perspective beyond the dominant phenotype
-in prior literature. De novo nodes were not retained in the final models.</a:t>
+              <a:t>Complementary programs add a plausible perspective beyond the dominant phenotype in prior literature. De novo nodes were not retained in the final models.</a:t>
             </a:r>
           </a:p>
         </p:txBody>
@@ -5832,7 +5822,7 @@
           </a:bodyPr>
           <a:lstStyle/>
           <a:p>
-            <a:pPr algn="ctr">
+            <a:pPr algn="ctr" latinLnBrk="0" eaLnBrk="0" hangingPunct="0">
               <a:lnSpc>
                 <a:spcPct val="100000"/>
               </a:lnSpc>
@@ -5877,7 +5867,7 @@
           </a:bodyPr>
           <a:lstStyle/>
           <a:p>
-            <a:pPr algn="ctr">
+            <a:pPr algn="ctr" latinLnBrk="0" eaLnBrk="0" hangingPunct="0">
               <a:lnSpc>
                 <a:spcPct val="100000"/>
               </a:lnSpc>
@@ -5922,7 +5912,7 @@
           </a:bodyPr>
           <a:lstStyle/>
           <a:p>
-            <a:pPr algn="ctr">
+            <a:pPr algn="ctr" latinLnBrk="0" eaLnBrk="0" hangingPunct="0">
               <a:lnSpc>
                 <a:spcPct val="100000"/>
               </a:lnSpc>
@@ -5967,7 +5957,7 @@
           </a:bodyPr>
           <a:lstStyle/>
           <a:p>
-            <a:pPr algn="l">
+            <a:pPr algn="l" latinLnBrk="0" eaLnBrk="0" hangingPunct="0">
               <a:lnSpc>
                 <a:spcPct val="100000"/>
               </a:lnSpc>
@@ -6033,7 +6023,7 @@
           <a:bodyPr rtlCol="0" anchor="ctr" wrap="none" bIns="36576"/>
           <a:lstStyle/>
           <a:p>
-            <a:pPr algn="ctr">
+            <a:pPr algn="ctr" latinLnBrk="0" eaLnBrk="0" hangingPunct="0">
               <a:spcAft>
                 <a:spcPts val="200"/>
               </a:spcAft>
@@ -6049,7 +6039,7 @@
             </a:r>
           </a:p>
           <a:p>
-            <a:pPr algn="ctr">
+            <a:pPr algn="ctr" latinLnBrk="0" eaLnBrk="0" hangingPunct="0">
               <a:spcBef>
                 <a:spcPts val="0"/>
               </a:spcBef>
@@ -6181,7 +6171,7 @@
           </a:bodyPr>
           <a:lstStyle/>
           <a:p>
-            <a:pPr algn="l">
+            <a:pPr algn="l" latinLnBrk="0" eaLnBrk="0" hangingPunct="0">
               <a:lnSpc>
                 <a:spcPct val="100000"/>
               </a:lnSpc>
@@ -6443,7 +6433,7 @@
           </a:bodyPr>
           <a:lstStyle/>
           <a:p>
-            <a:pPr algn="ctr">
+            <a:pPr algn="ctr" latinLnBrk="0" eaLnBrk="0" hangingPunct="0">
               <a:lnSpc>
                 <a:spcPct val="100000"/>
               </a:lnSpc>
@@ -6753,7 +6743,7 @@
           </a:bodyPr>
           <a:lstStyle/>
           <a:p>
-            <a:pPr algn="ctr">
+            <a:pPr algn="ctr" latinLnBrk="0" eaLnBrk="0" hangingPunct="0">
               <a:lnSpc>
                 <a:spcPct val="100000"/>
               </a:lnSpc>
@@ -6923,7 +6913,7 @@
           </a:bodyPr>
           <a:lstStyle/>
           <a:p>
-            <a:pPr algn="ctr">
+            <a:pPr algn="ctr" latinLnBrk="0" eaLnBrk="0" hangingPunct="0">
               <a:lnSpc>
                 <a:spcPct val="100000"/>
               </a:lnSpc>
@@ -7093,7 +7083,7 @@
           </a:bodyPr>
           <a:lstStyle/>
           <a:p>
-            <a:pPr algn="ctr">
+            <a:pPr algn="ctr" latinLnBrk="0" eaLnBrk="0" hangingPunct="0">
               <a:lnSpc>
                 <a:spcPct val="100000"/>
               </a:lnSpc>
@@ -7434,7 +7424,7 @@
           </a:bodyPr>
           <a:lstStyle/>
           <a:p>
-            <a:pPr algn="ctr">
+            <a:pPr algn="ctr" latinLnBrk="0" eaLnBrk="0" hangingPunct="0">
               <a:lnSpc>
                 <a:spcPct val="100000"/>
               </a:lnSpc>
@@ -7696,7 +7686,7 @@
           </a:bodyPr>
           <a:lstStyle/>
           <a:p>
-            <a:pPr algn="ctr">
+            <a:pPr algn="ctr" latinLnBrk="0" eaLnBrk="0" hangingPunct="0">
               <a:lnSpc>
                 <a:spcPct val="100000"/>
               </a:lnSpc>
@@ -7784,7 +7774,7 @@
           </a:bodyPr>
           <a:lstStyle/>
           <a:p>
-            <a:pPr algn="ctr">
+            <a:pPr algn="ctr" latinLnBrk="0" eaLnBrk="0" hangingPunct="0">
               <a:lnSpc>
                 <a:spcPct val="100000"/>
               </a:lnSpc>
@@ -7829,7 +7819,7 @@
           </a:bodyPr>
           <a:lstStyle/>
           <a:p>
-            <a:pPr algn="ctr">
+            <a:pPr algn="ctr" latinLnBrk="0" eaLnBrk="0" hangingPunct="0">
               <a:lnSpc>
                 <a:spcPct val="100000"/>
               </a:lnSpc>
@@ -7874,7 +7864,7 @@
           </a:bodyPr>
           <a:lstStyle/>
           <a:p>
-            <a:pPr algn="ctr">
+            <a:pPr algn="ctr" latinLnBrk="0" eaLnBrk="0" hangingPunct="0">
               <a:lnSpc>
                 <a:spcPct val="100000"/>
               </a:lnSpc>
@@ -7919,7 +7909,7 @@
           </a:bodyPr>
           <a:lstStyle/>
           <a:p>
-            <a:pPr algn="ctr">
+            <a:pPr algn="ctr" latinLnBrk="0" eaLnBrk="0" hangingPunct="0">
               <a:lnSpc>
                 <a:spcPct val="100000"/>
               </a:lnSpc>
@@ -7964,7 +7954,7 @@
           </a:bodyPr>
           <a:lstStyle/>
           <a:p>
-            <a:pPr algn="l">
+            <a:pPr algn="l" latinLnBrk="0" eaLnBrk="0" hangingPunct="0">
               <a:lnSpc>
                 <a:spcPct val="100000"/>
               </a:lnSpc>
@@ -8030,7 +8020,7 @@
           <a:bodyPr rtlCol="0" anchor="ctr" wrap="none" bIns="36576"/>
           <a:lstStyle/>
           <a:p>
-            <a:pPr algn="ctr">
+            <a:pPr algn="ctr" latinLnBrk="0" eaLnBrk="0" hangingPunct="0">
               <a:spcAft>
                 <a:spcPts val="200"/>
               </a:spcAft>
@@ -8046,7 +8036,7 @@
             </a:r>
           </a:p>
           <a:p>
-            <a:pPr algn="ctr">
+            <a:pPr algn="ctr" latinLnBrk="0" eaLnBrk="0" hangingPunct="0">
               <a:spcBef>
                 <a:spcPts val="0"/>
               </a:spcBef>
@@ -8152,7 +8142,7 @@
           <a:bodyPr rtlCol="0" anchor="ctr" wrap="none" bIns="36576"/>
           <a:lstStyle/>
           <a:p>
-            <a:pPr algn="ctr">
+            <a:pPr algn="ctr" latinLnBrk="0" eaLnBrk="0" hangingPunct="0">
               <a:spcAft>
                 <a:spcPts val="200"/>
               </a:spcAft>
@@ -8168,7 +8158,7 @@
             </a:r>
           </a:p>
           <a:p>
-            <a:pPr algn="ctr">
+            <a:pPr algn="ctr" latinLnBrk="0" eaLnBrk="0" hangingPunct="0">
               <a:spcBef>
                 <a:spcPts val="0"/>
               </a:spcBef>
@@ -8274,7 +8264,7 @@
           <a:bodyPr rtlCol="0" anchor="ctr" wrap="none" bIns="36576"/>
           <a:lstStyle/>
           <a:p>
-            <a:pPr algn="ctr">
+            <a:pPr algn="ctr" latinLnBrk="0" eaLnBrk="0" hangingPunct="0">
               <a:spcAft>
                 <a:spcPts val="200"/>
               </a:spcAft>
@@ -8290,7 +8280,7 @@
             </a:r>
           </a:p>
           <a:p>
-            <a:pPr algn="ctr">
+            <a:pPr algn="ctr" latinLnBrk="0" eaLnBrk="0" hangingPunct="0">
               <a:spcBef>
                 <a:spcPts val="0"/>
               </a:spcBef>
@@ -8396,7 +8386,7 @@
           <a:bodyPr rtlCol="0" anchor="ctr" wrap="none" bIns="36576"/>
           <a:lstStyle/>
           <a:p>
-            <a:pPr algn="ctr">
+            <a:pPr algn="ctr" latinLnBrk="0" eaLnBrk="0" hangingPunct="0">
               <a:spcAft>
                 <a:spcPts val="200"/>
               </a:spcAft>
@@ -8412,7 +8402,7 @@
             </a:r>
           </a:p>
           <a:p>
-            <a:pPr algn="ctr">
+            <a:pPr algn="ctr" latinLnBrk="0" eaLnBrk="0" hangingPunct="0">
               <a:spcBef>
                 <a:spcPts val="0"/>
               </a:spcBef>
@@ -8518,7 +8508,7 @@
           <a:bodyPr rtlCol="0" anchor="ctr" wrap="none" bIns="36576"/>
           <a:lstStyle/>
           <a:p>
-            <a:pPr algn="ctr">
+            <a:pPr algn="ctr" latinLnBrk="0" eaLnBrk="0" hangingPunct="0">
               <a:spcAft>
                 <a:spcPts val="200"/>
               </a:spcAft>
@@ -8534,7 +8524,7 @@
             </a:r>
           </a:p>
           <a:p>
-            <a:pPr algn="ctr">
+            <a:pPr algn="ctr" latinLnBrk="0" eaLnBrk="0" hangingPunct="0">
               <a:spcBef>
                 <a:spcPts val="0"/>
               </a:spcBef>
@@ -8576,7 +8566,7 @@
           </a:bodyPr>
           <a:lstStyle/>
           <a:p>
-            <a:pPr algn="ctr">
+            <a:pPr algn="ctr" latinLnBrk="0" eaLnBrk="0" hangingPunct="0">
               <a:lnSpc>
                 <a:spcPct val="100000"/>
               </a:lnSpc>
@@ -8709,7 +8699,7 @@
           </a:bodyPr>
           <a:lstStyle/>
           <a:p>
-            <a:pPr algn="ctr">
+            <a:pPr algn="ctr" latinLnBrk="0" eaLnBrk="0" hangingPunct="0">
               <a:lnSpc>
                 <a:spcPct val="100000"/>
               </a:lnSpc>
@@ -8773,12 +8763,12 @@
           <a:noFill/>
         </p:spPr>
         <p:txBody>
-          <a:bodyPr wrap="none" lIns="0" rIns="0" tIns="0" bIns="0" anchor="t">
+          <a:bodyPr wrap="square" lIns="0" rIns="0" tIns="0" bIns="0" anchor="t">
             <a:noAutofit/>
           </a:bodyPr>
           <a:lstStyle/>
           <a:p>
-            <a:pPr algn="ctr">
+            <a:pPr algn="ctr" latinLnBrk="0" eaLnBrk="0" hangingPunct="0">
               <a:lnSpc>
                 <a:spcPct val="100000"/>
               </a:lnSpc>
@@ -8796,9 +8786,7 @@
                 </a:solidFill>
                 <a:latin typeface="Arial"/>
               </a:rPr>
-              <a:t>Filled markers show 13 retained programs. Open diamonds are literature-aligned context only,
-not retained findings; keratinization reversed in one of three trainings. Colored ranges span
-three complete trainings; axes are tissue specific.</a:t>
+              <a:t>Filled markers show 13 retained programs. Open diamonds are literature-aligned context only, not retained findings; keratinization reversed in one of three trainings. Colored ranges span three complete trainings; axes are tissue specific.</a:t>
             </a:r>
           </a:p>
         </p:txBody>
@@ -8913,7 +8901,7 @@
           </a:bodyPr>
           <a:lstStyle/>
           <a:p>
-            <a:pPr algn="ctr">
+            <a:pPr algn="ctr" latinLnBrk="0" eaLnBrk="0" hangingPunct="0">
               <a:lnSpc>
                 <a:spcPct val="100000"/>
               </a:lnSpc>
@@ -8958,7 +8946,7 @@
           </a:bodyPr>
           <a:lstStyle/>
           <a:p>
-            <a:pPr algn="ctr">
+            <a:pPr algn="ctr" latinLnBrk="0" eaLnBrk="0" hangingPunct="0">
               <a:lnSpc>
                 <a:spcPct val="100000"/>
               </a:lnSpc>
@@ -9115,7 +9103,7 @@
           </a:bodyPr>
           <a:lstStyle/>
           <a:p>
-            <a:pPr algn="ctr">
+            <a:pPr algn="ctr" latinLnBrk="0" eaLnBrk="0" hangingPunct="0">
               <a:lnSpc>
                 <a:spcPct val="100000"/>
               </a:lnSpc>
@@ -9155,12 +9143,12 @@
           <a:noFill/>
         </p:spPr>
         <p:txBody>
-          <a:bodyPr wrap="none" lIns="0" rIns="0" tIns="0" bIns="0" anchor="t">
+          <a:bodyPr wrap="square" lIns="0" rIns="0" tIns="0" bIns="0" anchor="t">
             <a:noAutofit/>
           </a:bodyPr>
           <a:lstStyle/>
           <a:p>
-            <a:pPr algn="l">
+            <a:pPr algn="l" latinLnBrk="0" eaLnBrk="0" hangingPunct="0">
               <a:lnSpc>
                 <a:spcPct val="100000"/>
               </a:lnSpc>
@@ -9178,8 +9166,7 @@
                 </a:solidFill>
                 <a:latin typeface="Arial"/>
               </a:rPr>
-              <a:t>• Spleen was strongest: T cell receptor, neutrophil degranulation, and C‑type lectin
-  receptor programs were lower across five projects and three trainings; all had GSEA FDR &lt;0.05.</a:t>
+              <a:t>• Spleen was strongest: T cell receptor, neutrophil degranulation, and C‑type lectin receptor programs were lower across five projects and three trainings; all had GSEA FDR &lt;0.05.</a:t>
             </a:r>
           </a:p>
         </p:txBody>
@@ -9201,12 +9188,12 @@
           <a:noFill/>
         </p:spPr>
         <p:txBody>
-          <a:bodyPr wrap="none" lIns="0" rIns="0" tIns="0" bIns="0" anchor="t">
+          <a:bodyPr wrap="square" lIns="0" rIns="0" tIns="0" bIns="0" anchor="t">
             <a:noAutofit/>
           </a:bodyPr>
           <a:lstStyle/>
           <a:p>
-            <a:pPr algn="l">
+            <a:pPr algn="l" latinLnBrk="0" eaLnBrk="0" hangingPunct="0">
               <a:lnSpc>
                 <a:spcPct val="100000"/>
               </a:lnSpc>
@@ -9224,8 +9211,7 @@
                 </a:solidFill>
                 <a:latin typeface="Arial"/>
               </a:rPr>
-              <a:t>• Skin and thymus emphasized lower tissue maintenance programs; liver showed lower
-  adaptive immune signaling amid heterogeneous metabolism.</a:t>
+              <a:t>• Skin and thymus emphasized lower tissue maintenance programs; liver showed lower adaptive immune signaling amid heterogeneous metabolism.</a:t>
             </a:r>
           </a:p>
         </p:txBody>
@@ -9247,12 +9233,12 @@
           <a:noFill/>
         </p:spPr>
         <p:txBody>
-          <a:bodyPr wrap="none" lIns="0" rIns="0" tIns="0" bIns="0" anchor="t">
+          <a:bodyPr wrap="square" lIns="0" rIns="0" tIns="0" bIns="0" anchor="t">
             <a:noAutofit/>
           </a:bodyPr>
           <a:lstStyle/>
           <a:p>
-            <a:pPr algn="l">
+            <a:pPr algn="l" latinLnBrk="0" eaLnBrk="0" hangingPunct="0">
               <a:lnSpc>
                 <a:spcPct val="100000"/>
               </a:lnSpc>
@@ -9385,7 +9371,7 @@
           </a:bodyPr>
           <a:lstStyle/>
           <a:p>
-            <a:pPr algn="ctr">
+            <a:pPr algn="ctr" latinLnBrk="0" eaLnBrk="0" hangingPunct="0">
               <a:lnSpc>
                 <a:spcPct val="100000"/>
               </a:lnSpc>
@@ -9425,12 +9411,12 @@
           <a:noFill/>
         </p:spPr>
         <p:txBody>
-          <a:bodyPr wrap="none" lIns="0" rIns="0" tIns="0" bIns="0" anchor="t">
+          <a:bodyPr wrap="square" lIns="0" rIns="0" tIns="0" bIns="0" anchor="t">
             <a:noAutofit/>
           </a:bodyPr>
           <a:lstStyle/>
           <a:p>
-            <a:pPr algn="l">
+            <a:pPr algn="l" latinLnBrk="0" eaLnBrk="0" hangingPunct="0">
               <a:lnSpc>
                 <a:spcPct val="100000"/>
               </a:lnSpc>
@@ -9448,9 +9434,7 @@
                 </a:solidFill>
                 <a:latin typeface="Arial"/>
               </a:rPr>
-              <a:t>1 Gebre et al., NAR 2025 (OSDR). 2 Lotfollahi et al., Nat Cell Biol 2023 (expiMap).
-3 Lachmann et al., Nat Commun 2018 (ARCHS4). 4 Milacic et al., NAR 2024 (Reactome).
-5 Horie et al., Sci Rep 2019. 6 Cope et al., Commun Med 2024. 7 Beheshti et al., Sci Rep 2019. 8 Gridley et al., J Appl Physiol 2009.</a:t>
+              <a:t>1 Gebre et al., NAR 2025 (OSDR). 2 Lotfollahi et al., Nat Cell Biol 2023 (expiMap). 3 Lachmann et al., Nat Commun 2018 (ARCHS4). 4 Milacic et al., NAR 2024 (Reactome). 5 Horie et al., Sci Rep 2019. 6 Cope et al., Commun Med 2024. 7 Beheshti et al., Sci Rep 2019. 8 Gridley et al., J Appl Physiol 2009.</a:t>
             </a:r>
           </a:p>
         </p:txBody>
@@ -9520,7 +9504,7 @@
           </a:bodyPr>
           <a:lstStyle/>
           <a:p>
-            <a:pPr algn="l">
+            <a:pPr algn="l" latinLnBrk="0" eaLnBrk="0" hangingPunct="0">
               <a:lnSpc>
                 <a:spcPct val="100000"/>
               </a:lnSpc>
@@ -9560,12 +9544,12 @@
           <a:noFill/>
         </p:spPr>
         <p:txBody>
-          <a:bodyPr wrap="none" lIns="0" rIns="0" tIns="0" bIns="0" anchor="t">
+          <a:bodyPr wrap="square" lIns="0" rIns="0" tIns="0" bIns="0" anchor="t">
             <a:noAutofit/>
           </a:bodyPr>
           <a:lstStyle/>
           <a:p>
-            <a:pPr algn="l">
+            <a:pPr algn="l" latinLnBrk="0" eaLnBrk="0" hangingPunct="0">
               <a:lnSpc>
                 <a:spcPct val="100000"/>
               </a:lnSpc>
@@ -9583,8 +9567,7 @@
                 </a:solidFill>
                 <a:latin typeface="Arial"/>
               </a:rPr>
-              <a:t>Mentor: James Casaletto | NASA Space Life Sciences Training Program
-NASA OSDR, ARCHS4, and Reactome investigators and curation teams</a:t>
+              <a:t>Mentor: James Casaletto | NASA Space Life Sciences Training Program | NASA OSDR, ARCHS4, and Reactome investigators and curation teams</a:t>
             </a:r>
           </a:p>
         </p:txBody>
@@ -9611,7 +9594,7 @@
           </a:bodyPr>
           <a:lstStyle/>
           <a:p>
-            <a:pPr algn="r">
+            <a:pPr algn="r" latinLnBrk="0" eaLnBrk="0" hangingPunct="0">
               <a:lnSpc>
                 <a:spcPct val="100000"/>
               </a:lnSpc>
@@ -9657,7 +9640,7 @@
           </a:bodyPr>
           <a:lstStyle/>
           <a:p>
-            <a:pPr algn="l">
+            <a:pPr algn="l" latinLnBrk="0" eaLnBrk="0" hangingPunct="0">
               <a:lnSpc>
                 <a:spcPct val="100000"/>
               </a:lnSpc>

</xml_diff>

<commit_message>
replace poster prose with fixed line objects
</commit_message>
<xml_diff>
--- a/paper/asgsr_expimap_hvg/poster/asgsr_expimap_poster.pptx
+++ b/paper/asgsr_expimap_hvg/poster/asgsr_expimap_poster.pptx
@@ -3485,7 +3485,7 @@
         <p:spPr>
           <a:xfrm>
             <a:off x="777240" y="5925312"/>
-            <a:ext cx="12938760" cy="2286000"/>
+            <a:ext cx="12938760" cy="285750"/>
           </a:xfrm>
           <a:prstGeom prst="rect">
             <a:avLst/>
@@ -3493,7 +3493,7 @@
           <a:noFill/>
         </p:spPr>
         <p:txBody>
-          <a:bodyPr wrap="square" lIns="0" rIns="0" tIns="0" bIns="0" anchor="t">
+          <a:bodyPr wrap="none" lIns="0" rIns="0" tIns="0" bIns="0" anchor="ctr">
             <a:noAutofit/>
           </a:bodyPr>
           <a:lstStyle/>
@@ -3516,14 +3516,329 @@
                 </a:solidFill>
                 <a:latin typeface="Arial"/>
               </a:rPr>
-              <a:t>Mission differences can obscure spaceflight responses shared across studies. We mapped NASA OSDR mouse bulk RNA sequencing samples to tissue-matched ARCHS4 references and analyzed about 2,000 highly variable genes with Reactome-constrained expiMap. Flight-ground shifts were balanced across projects and evaluated with gene-set enrichment, project holdouts, three complete training runs, composition proxies, member-gene review, and literature annotation after scoring. Retained programs were lower for thymic repair, skin maintenance, liver adaptive immunity, and splenic adaptive and innate immunity. Spleen showed the strongest result across multiple pathways.</a:t>
-            </a:r>
-          </a:p>
-        </p:txBody>
-      </p:sp>
-      <p:sp>
-        <p:nvSpPr>
-          <p:cNvPr id="12" name="Rectangle 11"/>
+              <a:t>Mission differences can obscure spaceflight responses shared across studies.</a:t>
+            </a:r>
+          </a:p>
+        </p:txBody>
+      </p:sp>
+      <p:sp>
+        <p:nvSpPr>
+          <p:cNvPr id="12" name="TextBox 11"/>
+          <p:cNvSpPr txBox="1"/>
+          <p:nvPr/>
+        </p:nvSpPr>
+        <p:spPr>
+          <a:xfrm>
+            <a:off x="777240" y="6211062"/>
+            <a:ext cx="12938760" cy="285750"/>
+          </a:xfrm>
+          <a:prstGeom prst="rect">
+            <a:avLst/>
+          </a:prstGeom>
+          <a:noFill/>
+        </p:spPr>
+        <p:txBody>
+          <a:bodyPr wrap="none" lIns="0" rIns="0" tIns="0" bIns="0" anchor="ctr">
+            <a:noAutofit/>
+          </a:bodyPr>
+          <a:lstStyle/>
+          <a:p>
+            <a:pPr algn="l" latinLnBrk="0" eaLnBrk="0" hangingPunct="0">
+              <a:lnSpc>
+                <a:spcPct val="100000"/>
+              </a:lnSpc>
+              <a:spcBef>
+                <a:spcPts val="0"/>
+              </a:spcBef>
+              <a:spcAft>
+                <a:spcPts val="0"/>
+              </a:spcAft>
+            </a:pPr>
+            <a:r>
+              <a:rPr sz="1850" b="0" i="0">
+                <a:solidFill>
+                  <a:srgbClr val="33445D"/>
+                </a:solidFill>
+                <a:latin typeface="Arial"/>
+              </a:rPr>
+              <a:t>We mapped NASA OSDR mouse bulk RNA sequencing samples to tissue-matched ARCHS4 references.</a:t>
+            </a:r>
+          </a:p>
+        </p:txBody>
+      </p:sp>
+      <p:sp>
+        <p:nvSpPr>
+          <p:cNvPr id="13" name="TextBox 12"/>
+          <p:cNvSpPr txBox="1"/>
+          <p:nvPr/>
+        </p:nvSpPr>
+        <p:spPr>
+          <a:xfrm>
+            <a:off x="777240" y="6496812"/>
+            <a:ext cx="12938760" cy="285750"/>
+          </a:xfrm>
+          <a:prstGeom prst="rect">
+            <a:avLst/>
+          </a:prstGeom>
+          <a:noFill/>
+        </p:spPr>
+        <p:txBody>
+          <a:bodyPr wrap="none" lIns="0" rIns="0" tIns="0" bIns="0" anchor="ctr">
+            <a:noAutofit/>
+          </a:bodyPr>
+          <a:lstStyle/>
+          <a:p>
+            <a:pPr algn="l" latinLnBrk="0" eaLnBrk="0" hangingPunct="0">
+              <a:lnSpc>
+                <a:spcPct val="100000"/>
+              </a:lnSpc>
+              <a:spcBef>
+                <a:spcPts val="0"/>
+              </a:spcBef>
+              <a:spcAft>
+                <a:spcPts val="0"/>
+              </a:spcAft>
+            </a:pPr>
+            <a:r>
+              <a:rPr sz="1850" b="0" i="0">
+                <a:solidFill>
+                  <a:srgbClr val="33445D"/>
+                </a:solidFill>
+                <a:latin typeface="Arial"/>
+              </a:rPr>
+              <a:t>Reactome-constrained expiMap models analyzed about 2,000 highly variable genes.</a:t>
+            </a:r>
+          </a:p>
+        </p:txBody>
+      </p:sp>
+      <p:sp>
+        <p:nvSpPr>
+          <p:cNvPr id="14" name="TextBox 13"/>
+          <p:cNvSpPr txBox="1"/>
+          <p:nvPr/>
+        </p:nvSpPr>
+        <p:spPr>
+          <a:xfrm>
+            <a:off x="777240" y="6782562"/>
+            <a:ext cx="12938760" cy="285750"/>
+          </a:xfrm>
+          <a:prstGeom prst="rect">
+            <a:avLst/>
+          </a:prstGeom>
+          <a:noFill/>
+        </p:spPr>
+        <p:txBody>
+          <a:bodyPr wrap="none" lIns="0" rIns="0" tIns="0" bIns="0" anchor="ctr">
+            <a:noAutofit/>
+          </a:bodyPr>
+          <a:lstStyle/>
+          <a:p>
+            <a:pPr algn="l" latinLnBrk="0" eaLnBrk="0" hangingPunct="0">
+              <a:lnSpc>
+                <a:spcPct val="100000"/>
+              </a:lnSpc>
+              <a:spcBef>
+                <a:spcPts val="0"/>
+              </a:spcBef>
+              <a:spcAft>
+                <a:spcPts val="0"/>
+              </a:spcAft>
+            </a:pPr>
+            <a:r>
+              <a:rPr sz="1850" b="0" i="0">
+                <a:solidFill>
+                  <a:srgbClr val="33445D"/>
+                </a:solidFill>
+                <a:latin typeface="Arial"/>
+              </a:rPr>
+              <a:t>Flight-ground shifts were balanced across projects and evaluated with gene-set enrichment,</a:t>
+            </a:r>
+          </a:p>
+        </p:txBody>
+      </p:sp>
+      <p:sp>
+        <p:nvSpPr>
+          <p:cNvPr id="15" name="TextBox 14"/>
+          <p:cNvSpPr txBox="1"/>
+          <p:nvPr/>
+        </p:nvSpPr>
+        <p:spPr>
+          <a:xfrm>
+            <a:off x="777240" y="7068312"/>
+            <a:ext cx="12938760" cy="285750"/>
+          </a:xfrm>
+          <a:prstGeom prst="rect">
+            <a:avLst/>
+          </a:prstGeom>
+          <a:noFill/>
+        </p:spPr>
+        <p:txBody>
+          <a:bodyPr wrap="none" lIns="0" rIns="0" tIns="0" bIns="0" anchor="ctr">
+            <a:noAutofit/>
+          </a:bodyPr>
+          <a:lstStyle/>
+          <a:p>
+            <a:pPr algn="l" latinLnBrk="0" eaLnBrk="0" hangingPunct="0">
+              <a:lnSpc>
+                <a:spcPct val="100000"/>
+              </a:lnSpc>
+              <a:spcBef>
+                <a:spcPts val="0"/>
+              </a:spcBef>
+              <a:spcAft>
+                <a:spcPts val="0"/>
+              </a:spcAft>
+            </a:pPr>
+            <a:r>
+              <a:rPr sz="1850" b="0" i="0">
+                <a:solidFill>
+                  <a:srgbClr val="33445D"/>
+                </a:solidFill>
+                <a:latin typeface="Arial"/>
+              </a:rPr>
+              <a:t>project holdouts, three complete training runs, composition proxies, and member-gene review.</a:t>
+            </a:r>
+          </a:p>
+        </p:txBody>
+      </p:sp>
+      <p:sp>
+        <p:nvSpPr>
+          <p:cNvPr id="16" name="TextBox 15"/>
+          <p:cNvSpPr txBox="1"/>
+          <p:nvPr/>
+        </p:nvSpPr>
+        <p:spPr>
+          <a:xfrm>
+            <a:off x="777240" y="7354062"/>
+            <a:ext cx="12938760" cy="285750"/>
+          </a:xfrm>
+          <a:prstGeom prst="rect">
+            <a:avLst/>
+          </a:prstGeom>
+          <a:noFill/>
+        </p:spPr>
+        <p:txBody>
+          <a:bodyPr wrap="none" lIns="0" rIns="0" tIns="0" bIns="0" anchor="ctr">
+            <a:noAutofit/>
+          </a:bodyPr>
+          <a:lstStyle/>
+          <a:p>
+            <a:pPr algn="l" latinLnBrk="0" eaLnBrk="0" hangingPunct="0">
+              <a:lnSpc>
+                <a:spcPct val="100000"/>
+              </a:lnSpc>
+              <a:spcBef>
+                <a:spcPts val="0"/>
+              </a:spcBef>
+              <a:spcAft>
+                <a:spcPts val="0"/>
+              </a:spcAft>
+            </a:pPr>
+            <a:r>
+              <a:rPr sz="1850" b="0" i="0">
+                <a:solidFill>
+                  <a:srgbClr val="33445D"/>
+                </a:solidFill>
+                <a:latin typeface="Arial"/>
+              </a:rPr>
+              <a:t>Literature review was performed after scoring. Retained programs were lower for thymic repair,</a:t>
+            </a:r>
+          </a:p>
+        </p:txBody>
+      </p:sp>
+      <p:sp>
+        <p:nvSpPr>
+          <p:cNvPr id="17" name="TextBox 16"/>
+          <p:cNvSpPr txBox="1"/>
+          <p:nvPr/>
+        </p:nvSpPr>
+        <p:spPr>
+          <a:xfrm>
+            <a:off x="777240" y="7639812"/>
+            <a:ext cx="12938760" cy="285750"/>
+          </a:xfrm>
+          <a:prstGeom prst="rect">
+            <a:avLst/>
+          </a:prstGeom>
+          <a:noFill/>
+        </p:spPr>
+        <p:txBody>
+          <a:bodyPr wrap="none" lIns="0" rIns="0" tIns="0" bIns="0" anchor="ctr">
+            <a:noAutofit/>
+          </a:bodyPr>
+          <a:lstStyle/>
+          <a:p>
+            <a:pPr algn="l" latinLnBrk="0" eaLnBrk="0" hangingPunct="0">
+              <a:lnSpc>
+                <a:spcPct val="100000"/>
+              </a:lnSpc>
+              <a:spcBef>
+                <a:spcPts val="0"/>
+              </a:spcBef>
+              <a:spcAft>
+                <a:spcPts val="0"/>
+              </a:spcAft>
+            </a:pPr>
+            <a:r>
+              <a:rPr sz="1850" b="0" i="0">
+                <a:solidFill>
+                  <a:srgbClr val="33445D"/>
+                </a:solidFill>
+                <a:latin typeface="Arial"/>
+              </a:rPr>
+              <a:t>skin maintenance, liver adaptive immunity, and splenic adaptive and innate immunity.</a:t>
+            </a:r>
+          </a:p>
+        </p:txBody>
+      </p:sp>
+      <p:sp>
+        <p:nvSpPr>
+          <p:cNvPr id="18" name="TextBox 17"/>
+          <p:cNvSpPr txBox="1"/>
+          <p:nvPr/>
+        </p:nvSpPr>
+        <p:spPr>
+          <a:xfrm>
+            <a:off x="777240" y="7925562"/>
+            <a:ext cx="12938760" cy="285750"/>
+          </a:xfrm>
+          <a:prstGeom prst="rect">
+            <a:avLst/>
+          </a:prstGeom>
+          <a:noFill/>
+        </p:spPr>
+        <p:txBody>
+          <a:bodyPr wrap="none" lIns="0" rIns="0" tIns="0" bIns="0" anchor="ctr">
+            <a:noAutofit/>
+          </a:bodyPr>
+          <a:lstStyle/>
+          <a:p>
+            <a:pPr algn="l" latinLnBrk="0" eaLnBrk="0" hangingPunct="0">
+              <a:lnSpc>
+                <a:spcPct val="100000"/>
+              </a:lnSpc>
+              <a:spcBef>
+                <a:spcPts val="0"/>
+              </a:spcBef>
+              <a:spcAft>
+                <a:spcPts val="0"/>
+              </a:spcAft>
+            </a:pPr>
+            <a:r>
+              <a:rPr sz="1850" b="0" i="0">
+                <a:solidFill>
+                  <a:srgbClr val="33445D"/>
+                </a:solidFill>
+                <a:latin typeface="Arial"/>
+              </a:rPr>
+              <a:t>Spleen showed the strongest result across multiple pathways.</a:t>
+            </a:r>
+          </a:p>
+        </p:txBody>
+      </p:sp>
+      <p:sp>
+        <p:nvSpPr>
+          <p:cNvPr id="19" name="Rectangle 18"/>
           <p:cNvSpPr/>
           <p:nvPr/>
         </p:nvSpPr>
@@ -3566,7 +3881,7 @@
       </p:sp>
       <p:sp>
         <p:nvSpPr>
-          <p:cNvPr id="13" name="Rectangle 12"/>
+          <p:cNvPr id="20" name="Rectangle 19"/>
           <p:cNvSpPr/>
           <p:nvPr/>
         </p:nvSpPr>
@@ -3611,7 +3926,7 @@
       </p:sp>
       <p:sp>
         <p:nvSpPr>
-          <p:cNvPr id="14" name="TextBox 13"/>
+          <p:cNvPr id="21" name="TextBox 20"/>
           <p:cNvSpPr txBox="1"/>
           <p:nvPr/>
         </p:nvSpPr>
@@ -3656,7 +3971,7 @@
       </p:sp>
       <p:sp>
         <p:nvSpPr>
-          <p:cNvPr id="15" name="TextBox 14"/>
+          <p:cNvPr id="22" name="TextBox 21"/>
           <p:cNvSpPr txBox="1"/>
           <p:nvPr/>
         </p:nvSpPr>
@@ -3701,7 +4016,7 @@
       </p:sp>
       <p:sp>
         <p:nvSpPr>
-          <p:cNvPr id="16" name="TextBox 15"/>
+          <p:cNvPr id="23" name="TextBox 22"/>
           <p:cNvSpPr txBox="1"/>
           <p:nvPr/>
         </p:nvSpPr>
@@ -3746,7 +4061,7 @@
       </p:sp>
       <p:sp>
         <p:nvSpPr>
-          <p:cNvPr id="17" name="TextBox 16"/>
+          <p:cNvPr id="24" name="TextBox 23"/>
           <p:cNvSpPr txBox="1"/>
           <p:nvPr/>
         </p:nvSpPr>
@@ -3791,7 +4106,7 @@
       </p:sp>
       <p:sp>
         <p:nvSpPr>
-          <p:cNvPr id="18" name="TextBox 17"/>
+          <p:cNvPr id="25" name="TextBox 24"/>
           <p:cNvSpPr txBox="1"/>
           <p:nvPr/>
         </p:nvSpPr>
@@ -3836,7 +4151,7 @@
       </p:sp>
       <p:sp>
         <p:nvSpPr>
-          <p:cNvPr id="19" name="Rounded Rectangle 18"/>
+          <p:cNvPr id="26" name="Rounded Rectangle 25"/>
           <p:cNvSpPr/>
           <p:nvPr/>
         </p:nvSpPr>
@@ -3879,7 +4194,7 @@
       </p:sp>
       <p:sp>
         <p:nvSpPr>
-          <p:cNvPr id="20" name="TextBox 19"/>
+          <p:cNvPr id="27" name="TextBox 26"/>
           <p:cNvSpPr txBox="1"/>
           <p:nvPr/>
         </p:nvSpPr>
@@ -3924,7 +4239,7 @@
       </p:sp>
       <p:sp>
         <p:nvSpPr>
-          <p:cNvPr id="21" name="TextBox 20"/>
+          <p:cNvPr id="28" name="TextBox 27"/>
           <p:cNvSpPr txBox="1"/>
           <p:nvPr/>
         </p:nvSpPr>
@@ -3969,7 +4284,7 @@
       </p:sp>
       <p:sp>
         <p:nvSpPr>
-          <p:cNvPr id="22" name="Rounded Rectangle 21"/>
+          <p:cNvPr id="29" name="Rounded Rectangle 28"/>
           <p:cNvSpPr/>
           <p:nvPr/>
         </p:nvSpPr>
@@ -4012,7 +4327,7 @@
       </p:sp>
       <p:sp>
         <p:nvSpPr>
-          <p:cNvPr id="23" name="TextBox 22"/>
+          <p:cNvPr id="30" name="TextBox 29"/>
           <p:cNvSpPr txBox="1"/>
           <p:nvPr/>
         </p:nvSpPr>
@@ -4057,7 +4372,7 @@
       </p:sp>
       <p:sp>
         <p:nvSpPr>
-          <p:cNvPr id="24" name="TextBox 23"/>
+          <p:cNvPr id="31" name="TextBox 30"/>
           <p:cNvSpPr txBox="1"/>
           <p:nvPr/>
         </p:nvSpPr>
@@ -4102,7 +4417,7 @@
       </p:sp>
       <p:sp>
         <p:nvSpPr>
-          <p:cNvPr id="25" name="Rounded Rectangle 24"/>
+          <p:cNvPr id="32" name="Rounded Rectangle 31"/>
           <p:cNvSpPr/>
           <p:nvPr/>
         </p:nvSpPr>
@@ -4145,7 +4460,7 @@
       </p:sp>
       <p:sp>
         <p:nvSpPr>
-          <p:cNvPr id="26" name="TextBox 25"/>
+          <p:cNvPr id="33" name="TextBox 32"/>
           <p:cNvSpPr txBox="1"/>
           <p:nvPr/>
         </p:nvSpPr>
@@ -4190,7 +4505,7 @@
       </p:sp>
       <p:sp>
         <p:nvSpPr>
-          <p:cNvPr id="27" name="TextBox 26"/>
+          <p:cNvPr id="34" name="TextBox 33"/>
           <p:cNvSpPr txBox="1"/>
           <p:nvPr/>
         </p:nvSpPr>
@@ -4235,7 +4550,7 @@
       </p:sp>
       <p:sp>
         <p:nvSpPr>
-          <p:cNvPr id="28" name="Rounded Rectangle 27"/>
+          <p:cNvPr id="35" name="Rounded Rectangle 34"/>
           <p:cNvSpPr/>
           <p:nvPr/>
         </p:nvSpPr>
@@ -4278,7 +4593,7 @@
       </p:sp>
       <p:sp>
         <p:nvSpPr>
-          <p:cNvPr id="29" name="TextBox 28"/>
+          <p:cNvPr id="36" name="TextBox 35"/>
           <p:cNvSpPr txBox="1"/>
           <p:nvPr/>
         </p:nvSpPr>
@@ -4323,14 +4638,14 @@
       </p:sp>
       <p:sp>
         <p:nvSpPr>
-          <p:cNvPr id="30" name="TextBox 29"/>
+          <p:cNvPr id="37" name="TextBox 36"/>
           <p:cNvSpPr txBox="1"/>
           <p:nvPr/>
         </p:nvSpPr>
         <p:spPr>
           <a:xfrm>
             <a:off x="822960" y="12454128"/>
-            <a:ext cx="12847320" cy="1417320"/>
+            <a:ext cx="12847320" cy="292608"/>
           </a:xfrm>
           <a:prstGeom prst="rect">
             <a:avLst/>
@@ -4338,7 +4653,7 @@
           <a:noFill/>
         </p:spPr>
         <p:txBody>
-          <a:bodyPr wrap="square" lIns="0" rIns="0" tIns="0" bIns="0" anchor="t">
+          <a:bodyPr wrap="none" lIns="0" rIns="0" tIns="0" bIns="0" anchor="ctr">
             <a:noAutofit/>
           </a:bodyPr>
           <a:lstStyle/>
@@ -4361,21 +4676,21 @@
                 </a:solidFill>
                 <a:latin typeface="Arial"/>
               </a:rPr>
-              <a:t>Study identity and protocol can dominate an unconstrained expression representation. Tissue-matched reference mapping, accession conditioning, and equal project weighting reduce this bias without claiming to remove all mission confounding.</a:t>
-            </a:r>
-          </a:p>
-        </p:txBody>
-      </p:sp>
-      <p:sp>
-        <p:nvSpPr>
-          <p:cNvPr id="31" name="TextBox 30"/>
+              <a:t>Study identity and protocol can dominate an unconstrained expression representation.</a:t>
+            </a:r>
+          </a:p>
+        </p:txBody>
+      </p:sp>
+      <p:sp>
+        <p:nvSpPr>
+          <p:cNvPr id="38" name="TextBox 37"/>
           <p:cNvSpPr txBox="1"/>
           <p:nvPr/>
         </p:nvSpPr>
         <p:spPr>
           <a:xfrm>
-            <a:off x="822960" y="14008608"/>
-            <a:ext cx="12847320" cy="365760"/>
+            <a:off x="822960" y="12746736"/>
+            <a:ext cx="12847320" cy="292608"/>
           </a:xfrm>
           <a:prstGeom prst="rect">
             <a:avLst/>
@@ -4383,8 +4698,8 @@
           <a:noFill/>
         </p:spPr>
         <p:txBody>
-          <a:bodyPr wrap="square" lIns="0" rIns="0" tIns="0" bIns="0" anchor="t">
-            <a:spAutoFit/>
+          <a:bodyPr wrap="none" lIns="0" rIns="0" tIns="0" bIns="0" anchor="ctr">
+            <a:noAutofit/>
           </a:bodyPr>
           <a:lstStyle/>
           <a:p>
@@ -4400,6 +4715,96 @@
               </a:spcAft>
             </a:pPr>
             <a:r>
+              <a:rPr sz="1900" b="0" i="0">
+                <a:solidFill>
+                  <a:srgbClr val="33445D"/>
+                </a:solidFill>
+                <a:latin typeface="Arial"/>
+              </a:rPr>
+              <a:t>Tissue-matched reference mapping, accession conditioning, and equal project weighting</a:t>
+            </a:r>
+          </a:p>
+        </p:txBody>
+      </p:sp>
+      <p:sp>
+        <p:nvSpPr>
+          <p:cNvPr id="39" name="TextBox 38"/>
+          <p:cNvSpPr txBox="1"/>
+          <p:nvPr/>
+        </p:nvSpPr>
+        <p:spPr>
+          <a:xfrm>
+            <a:off x="822960" y="13039344"/>
+            <a:ext cx="12847320" cy="292608"/>
+          </a:xfrm>
+          <a:prstGeom prst="rect">
+            <a:avLst/>
+          </a:prstGeom>
+          <a:noFill/>
+        </p:spPr>
+        <p:txBody>
+          <a:bodyPr wrap="none" lIns="0" rIns="0" tIns="0" bIns="0" anchor="ctr">
+            <a:noAutofit/>
+          </a:bodyPr>
+          <a:lstStyle/>
+          <a:p>
+            <a:pPr algn="l" latinLnBrk="0" eaLnBrk="0" hangingPunct="0">
+              <a:lnSpc>
+                <a:spcPct val="100000"/>
+              </a:lnSpc>
+              <a:spcBef>
+                <a:spcPts val="0"/>
+              </a:spcBef>
+              <a:spcAft>
+                <a:spcPts val="0"/>
+              </a:spcAft>
+            </a:pPr>
+            <a:r>
+              <a:rPr sz="1900" b="0" i="0">
+                <a:solidFill>
+                  <a:srgbClr val="33445D"/>
+                </a:solidFill>
+                <a:latin typeface="Arial"/>
+              </a:rPr>
+              <a:t>reduce this bias without claiming to remove all mission confounding.</a:t>
+            </a:r>
+          </a:p>
+        </p:txBody>
+      </p:sp>
+      <p:sp>
+        <p:nvSpPr>
+          <p:cNvPr id="40" name="TextBox 39"/>
+          <p:cNvSpPr txBox="1"/>
+          <p:nvPr/>
+        </p:nvSpPr>
+        <p:spPr>
+          <a:xfrm>
+            <a:off x="822960" y="14008608"/>
+            <a:ext cx="12847320" cy="365760"/>
+          </a:xfrm>
+          <a:prstGeom prst="rect">
+            <a:avLst/>
+          </a:prstGeom>
+          <a:noFill/>
+        </p:spPr>
+        <p:txBody>
+          <a:bodyPr wrap="square" lIns="0" rIns="0" tIns="0" bIns="0" anchor="t">
+            <a:spAutoFit/>
+          </a:bodyPr>
+          <a:lstStyle/>
+          <a:p>
+            <a:pPr algn="l" latinLnBrk="0" eaLnBrk="0" hangingPunct="0">
+              <a:lnSpc>
+                <a:spcPct val="100000"/>
+              </a:lnSpc>
+              <a:spcBef>
+                <a:spcPts val="0"/>
+              </a:spcBef>
+              <a:spcAft>
+                <a:spcPts val="0"/>
+              </a:spcAft>
+            </a:pPr>
+            <a:r>
               <a:rPr sz="1900" b="1" i="0">
                 <a:solidFill>
                   <a:srgbClr val="9A6D1D"/>
@@ -4413,7 +4818,7 @@
       </p:sp>
       <p:graphicFrame>
         <p:nvGraphicFramePr>
-          <p:cNvPr id="32" name="Table 31"/>
+          <p:cNvPr id="41" name="Table 40"/>
           <p:cNvGraphicFramePr>
             <a:graphicFrameLocks noGrp="1"/>
           </p:cNvGraphicFramePr>
@@ -5027,14 +5432,14 @@
       </p:graphicFrame>
       <p:sp>
         <p:nvSpPr>
-          <p:cNvPr id="33" name="TextBox 32"/>
+          <p:cNvPr id="42" name="TextBox 41"/>
           <p:cNvSpPr txBox="1"/>
           <p:nvPr/>
         </p:nvSpPr>
         <p:spPr>
           <a:xfrm>
             <a:off x="822960" y="18260568"/>
-            <a:ext cx="12847320" cy="502920"/>
+            <a:ext cx="12847320" cy="251460"/>
           </a:xfrm>
           <a:prstGeom prst="rect">
             <a:avLst/>
@@ -5042,7 +5447,7 @@
           <a:noFill/>
         </p:spPr>
         <p:txBody>
-          <a:bodyPr wrap="square" lIns="0" rIns="0" tIns="0" bIns="0" anchor="t">
+          <a:bodyPr wrap="none" lIns="0" rIns="0" tIns="0" bIns="0" anchor="ctr">
             <a:noAutofit/>
           </a:bodyPr>
           <a:lstStyle/>
@@ -5065,21 +5470,21 @@
                 </a:solidFill>
                 <a:latin typeface="Arial"/>
               </a:rPr>
-              <a:t>OSDR counts are primary analysis samples. Spleen excludes one condition-strain-confounded project.</a:t>
-            </a:r>
-          </a:p>
-        </p:txBody>
-      </p:sp>
-      <p:sp>
-        <p:nvSpPr>
-          <p:cNvPr id="34" name="TextBox 33"/>
+              <a:t>OSDR counts are primary analysis samples.</a:t>
+            </a:r>
+          </a:p>
+        </p:txBody>
+      </p:sp>
+      <p:sp>
+        <p:nvSpPr>
+          <p:cNvPr id="43" name="TextBox 42"/>
           <p:cNvSpPr txBox="1"/>
           <p:nvPr/>
         </p:nvSpPr>
         <p:spPr>
           <a:xfrm>
-            <a:off x="822960" y="18882360"/>
-            <a:ext cx="12847320" cy="365760"/>
+            <a:off x="822960" y="18512027"/>
+            <a:ext cx="12847320" cy="251460"/>
           </a:xfrm>
           <a:prstGeom prst="rect">
             <a:avLst/>
@@ -5087,8 +5492,8 @@
           <a:noFill/>
         </p:spPr>
         <p:txBody>
-          <a:bodyPr wrap="square" lIns="0" rIns="0" tIns="0" bIns="0" anchor="t">
-            <a:spAutoFit/>
+          <a:bodyPr wrap="none" lIns="0" rIns="0" tIns="0" bIns="0" anchor="ctr">
+            <a:noAutofit/>
           </a:bodyPr>
           <a:lstStyle/>
           <a:p>
@@ -5104,6 +5509,51 @@
               </a:spcAft>
             </a:pPr>
             <a:r>
+              <a:rPr sz="1450" b="0" i="1">
+                <a:solidFill>
+                  <a:srgbClr val="697889"/>
+                </a:solidFill>
+                <a:latin typeface="Arial"/>
+              </a:rPr>
+              <a:t>Spleen excludes one condition-strain-confounded project.</a:t>
+            </a:r>
+          </a:p>
+        </p:txBody>
+      </p:sp>
+      <p:sp>
+        <p:nvSpPr>
+          <p:cNvPr id="44" name="TextBox 43"/>
+          <p:cNvSpPr txBox="1"/>
+          <p:nvPr/>
+        </p:nvSpPr>
+        <p:spPr>
+          <a:xfrm>
+            <a:off x="822960" y="18882360"/>
+            <a:ext cx="12847320" cy="365760"/>
+          </a:xfrm>
+          <a:prstGeom prst="rect">
+            <a:avLst/>
+          </a:prstGeom>
+          <a:noFill/>
+        </p:spPr>
+        <p:txBody>
+          <a:bodyPr wrap="square" lIns="0" rIns="0" tIns="0" bIns="0" anchor="t">
+            <a:spAutoFit/>
+          </a:bodyPr>
+          <a:lstStyle/>
+          <a:p>
+            <a:pPr algn="l" latinLnBrk="0" eaLnBrk="0" hangingPunct="0">
+              <a:lnSpc>
+                <a:spcPct val="100000"/>
+              </a:lnSpc>
+              <a:spcBef>
+                <a:spcPts val="0"/>
+              </a:spcBef>
+              <a:spcAft>
+                <a:spcPts val="0"/>
+              </a:spcAft>
+            </a:pPr>
+            <a:r>
               <a:rPr sz="1900" b="1" i="0">
                 <a:solidFill>
                   <a:srgbClr val="9A6D1D"/>
@@ -5117,7 +5567,7 @@
       </p:sp>
       <p:sp>
         <p:nvSpPr>
-          <p:cNvPr id="35" name="Rounded Rectangle 34"/>
+          <p:cNvPr id="45" name="Rounded Rectangle 44"/>
           <p:cNvSpPr/>
           <p:nvPr/>
         </p:nvSpPr>
@@ -5164,7 +5614,7 @@
       </p:sp>
       <p:sp>
         <p:nvSpPr>
-          <p:cNvPr id="36" name="TextBox 35"/>
+          <p:cNvPr id="46" name="TextBox 45"/>
           <p:cNvSpPr txBox="1"/>
           <p:nvPr/>
         </p:nvSpPr>
@@ -5209,7 +5659,7 @@
       </p:sp>
       <p:sp>
         <p:nvSpPr>
-          <p:cNvPr id="37" name="Rounded Rectangle 36"/>
+          <p:cNvPr id="47" name="Rounded Rectangle 46"/>
           <p:cNvSpPr/>
           <p:nvPr/>
         </p:nvSpPr>
@@ -5256,7 +5706,7 @@
       </p:sp>
       <p:sp>
         <p:nvSpPr>
-          <p:cNvPr id="38" name="TextBox 37"/>
+          <p:cNvPr id="48" name="TextBox 47"/>
           <p:cNvSpPr txBox="1"/>
           <p:nvPr/>
         </p:nvSpPr>
@@ -5301,7 +5751,7 @@
       </p:sp>
       <p:sp>
         <p:nvSpPr>
-          <p:cNvPr id="39" name="Rounded Rectangle 38"/>
+          <p:cNvPr id="49" name="Rounded Rectangle 48"/>
           <p:cNvSpPr/>
           <p:nvPr/>
         </p:nvSpPr>
@@ -5348,7 +5798,7 @@
       </p:sp>
       <p:sp>
         <p:nvSpPr>
-          <p:cNvPr id="40" name="TextBox 39"/>
+          <p:cNvPr id="50" name="TextBox 49"/>
           <p:cNvSpPr txBox="1"/>
           <p:nvPr/>
         </p:nvSpPr>
@@ -5393,7 +5843,7 @@
       </p:sp>
       <p:sp>
         <p:nvSpPr>
-          <p:cNvPr id="41" name="Rounded Rectangle 40"/>
+          <p:cNvPr id="51" name="Rounded Rectangle 50"/>
           <p:cNvSpPr/>
           <p:nvPr/>
         </p:nvSpPr>
@@ -5440,7 +5890,7 @@
       </p:sp>
       <p:sp>
         <p:nvSpPr>
-          <p:cNvPr id="42" name="TextBox 41"/>
+          <p:cNvPr id="52" name="TextBox 51"/>
           <p:cNvSpPr txBox="1"/>
           <p:nvPr/>
         </p:nvSpPr>
@@ -5485,7 +5935,7 @@
       </p:sp>
       <p:sp>
         <p:nvSpPr>
-          <p:cNvPr id="43" name="Rounded Rectangle 42"/>
+          <p:cNvPr id="53" name="Rounded Rectangle 52"/>
           <p:cNvSpPr/>
           <p:nvPr/>
         </p:nvSpPr>
@@ -5532,7 +5982,7 @@
       </p:sp>
       <p:sp>
         <p:nvSpPr>
-          <p:cNvPr id="44" name="TextBox 43"/>
+          <p:cNvPr id="54" name="TextBox 53"/>
           <p:cNvSpPr txBox="1"/>
           <p:nvPr/>
         </p:nvSpPr>
@@ -5577,7 +6027,7 @@
       </p:sp>
       <p:sp>
         <p:nvSpPr>
-          <p:cNvPr id="45" name="Rounded Rectangle 44"/>
+          <p:cNvPr id="55" name="Rounded Rectangle 54"/>
           <p:cNvSpPr/>
           <p:nvPr/>
         </p:nvSpPr>
@@ -5624,7 +6074,7 @@
       </p:sp>
       <p:sp>
         <p:nvSpPr>
-          <p:cNvPr id="46" name="TextBox 45"/>
+          <p:cNvPr id="56" name="TextBox 55"/>
           <p:cNvSpPr txBox="1"/>
           <p:nvPr/>
         </p:nvSpPr>
@@ -5669,14 +6119,14 @@
       </p:sp>
       <p:sp>
         <p:nvSpPr>
-          <p:cNvPr id="47" name="TextBox 46"/>
+          <p:cNvPr id="57" name="TextBox 56"/>
           <p:cNvSpPr txBox="1"/>
           <p:nvPr/>
         </p:nvSpPr>
         <p:spPr>
           <a:xfrm>
             <a:off x="822960" y="21104352"/>
-            <a:ext cx="12847320" cy="1051560"/>
+            <a:ext cx="12847320" cy="301752"/>
           </a:xfrm>
           <a:prstGeom prst="rect">
             <a:avLst/>
@@ -5684,7 +6134,7 @@
           <a:noFill/>
         </p:spPr>
         <p:txBody>
-          <a:bodyPr wrap="square" lIns="0" rIns="0" tIns="0" bIns="0" anchor="t">
+          <a:bodyPr wrap="none" lIns="0" rIns="0" tIns="0" bIns="0" anchor="ctr">
             <a:noAutofit/>
           </a:bodyPr>
           <a:lstStyle/>
@@ -5707,14 +6157,59 @@
                 </a:solidFill>
                 <a:latin typeface="Arial"/>
               </a:rPr>
-              <a:t>Complementary programs add a plausible perspective beyond the dominant phenotype in prior literature. De novo nodes were not retained in the final models.</a:t>
-            </a:r>
-          </a:p>
-        </p:txBody>
-      </p:sp>
-      <p:sp>
-        <p:nvSpPr>
-          <p:cNvPr id="48" name="Rectangle 47"/>
+              <a:t>Complementary programs add a plausible perspective beyond the dominant phenotype</a:t>
+            </a:r>
+          </a:p>
+        </p:txBody>
+      </p:sp>
+      <p:sp>
+        <p:nvSpPr>
+          <p:cNvPr id="58" name="TextBox 57"/>
+          <p:cNvSpPr txBox="1"/>
+          <p:nvPr/>
+        </p:nvSpPr>
+        <p:spPr>
+          <a:xfrm>
+            <a:off x="822960" y="21406103"/>
+            <a:ext cx="12847320" cy="301752"/>
+          </a:xfrm>
+          <a:prstGeom prst="rect">
+            <a:avLst/>
+          </a:prstGeom>
+          <a:noFill/>
+        </p:spPr>
+        <p:txBody>
+          <a:bodyPr wrap="none" lIns="0" rIns="0" tIns="0" bIns="0" anchor="ctr">
+            <a:noAutofit/>
+          </a:bodyPr>
+          <a:lstStyle/>
+          <a:p>
+            <a:pPr algn="l" latinLnBrk="0" eaLnBrk="0" hangingPunct="0">
+              <a:lnSpc>
+                <a:spcPct val="100000"/>
+              </a:lnSpc>
+              <a:spcBef>
+                <a:spcPts val="0"/>
+              </a:spcBef>
+              <a:spcAft>
+                <a:spcPts val="0"/>
+              </a:spcAft>
+            </a:pPr>
+            <a:r>
+              <a:rPr sz="1650" b="0" i="0">
+                <a:solidFill>
+                  <a:srgbClr val="33445D"/>
+                </a:solidFill>
+                <a:latin typeface="Arial"/>
+              </a:rPr>
+              <a:t>in prior literature. De novo nodes were not retained in the final models.</a:t>
+            </a:r>
+          </a:p>
+        </p:txBody>
+      </p:sp>
+      <p:sp>
+        <p:nvSpPr>
+          <p:cNvPr id="59" name="Rectangle 58"/>
           <p:cNvSpPr/>
           <p:nvPr/>
         </p:nvSpPr>
@@ -5757,7 +6252,7 @@
       </p:sp>
       <p:sp>
         <p:nvSpPr>
-          <p:cNvPr id="49" name="Rectangle 48"/>
+          <p:cNvPr id="60" name="Rectangle 59"/>
           <p:cNvSpPr/>
           <p:nvPr/>
         </p:nvSpPr>
@@ -5802,7 +6297,7 @@
       </p:sp>
       <p:sp>
         <p:nvSpPr>
-          <p:cNvPr id="50" name="TextBox 49"/>
+          <p:cNvPr id="61" name="TextBox 60"/>
           <p:cNvSpPr txBox="1"/>
           <p:nvPr/>
         </p:nvSpPr>
@@ -5847,7 +6342,7 @@
       </p:sp>
       <p:sp>
         <p:nvSpPr>
-          <p:cNvPr id="51" name="TextBox 50"/>
+          <p:cNvPr id="62" name="TextBox 61"/>
           <p:cNvSpPr txBox="1"/>
           <p:nvPr/>
         </p:nvSpPr>
@@ -5892,7 +6387,7 @@
       </p:sp>
       <p:sp>
         <p:nvSpPr>
-          <p:cNvPr id="52" name="TextBox 51"/>
+          <p:cNvPr id="63" name="TextBox 62"/>
           <p:cNvSpPr txBox="1"/>
           <p:nvPr/>
         </p:nvSpPr>
@@ -5937,7 +6432,7 @@
       </p:sp>
       <p:sp>
         <p:nvSpPr>
-          <p:cNvPr id="53" name="TextBox 52"/>
+          <p:cNvPr id="64" name="TextBox 63"/>
           <p:cNvSpPr txBox="1"/>
           <p:nvPr/>
         </p:nvSpPr>
@@ -5982,7 +6477,7 @@
       </p:sp>
       <p:sp>
         <p:nvSpPr>
-          <p:cNvPr id="54" name="Rounded Rectangle 53"/>
+          <p:cNvPr id="65" name="Rounded Rectangle 64"/>
           <p:cNvSpPr/>
           <p:nvPr/>
         </p:nvSpPr>
@@ -6061,7 +6556,7 @@
       </p:sp>
       <p:sp>
         <p:nvSpPr>
-          <p:cNvPr id="55" name="Right Arrow 54"/>
+          <p:cNvPr id="66" name="Right Arrow 65"/>
           <p:cNvSpPr/>
           <p:nvPr/>
         </p:nvSpPr>
@@ -6104,7 +6599,7 @@
       </p:sp>
       <p:sp>
         <p:nvSpPr>
-          <p:cNvPr id="56" name="Rounded Rectangle 55"/>
+          <p:cNvPr id="67" name="Rounded Rectangle 66"/>
           <p:cNvSpPr/>
           <p:nvPr/>
         </p:nvSpPr>
@@ -6151,7 +6646,7 @@
       </p:sp>
       <p:sp>
         <p:nvSpPr>
-          <p:cNvPr id="57" name="TextBox 56"/>
+          <p:cNvPr id="68" name="TextBox 67"/>
           <p:cNvSpPr txBox="1"/>
           <p:nvPr/>
         </p:nvSpPr>
@@ -6196,7 +6691,7 @@
       </p:sp>
       <p:sp>
         <p:nvSpPr>
-          <p:cNvPr id="58" name="Oval 57"/>
+          <p:cNvPr id="69" name="Oval 68"/>
           <p:cNvSpPr/>
           <p:nvPr/>
         </p:nvSpPr>
@@ -6239,7 +6734,7 @@
       </p:sp>
       <p:sp>
         <p:nvSpPr>
-          <p:cNvPr id="59" name="Oval 58"/>
+          <p:cNvPr id="70" name="Oval 69"/>
           <p:cNvSpPr/>
           <p:nvPr/>
         </p:nvSpPr>
@@ -6282,7 +6777,7 @@
       </p:sp>
       <p:sp>
         <p:nvSpPr>
-          <p:cNvPr id="60" name="Oval 59"/>
+          <p:cNvPr id="71" name="Oval 70"/>
           <p:cNvSpPr/>
           <p:nvPr/>
         </p:nvSpPr>
@@ -6325,7 +6820,7 @@
       </p:sp>
       <p:sp>
         <p:nvSpPr>
-          <p:cNvPr id="61" name="Oval 60"/>
+          <p:cNvPr id="72" name="Oval 71"/>
           <p:cNvSpPr/>
           <p:nvPr/>
         </p:nvSpPr>
@@ -6368,7 +6863,7 @@
       </p:sp>
       <p:sp>
         <p:nvSpPr>
-          <p:cNvPr id="62" name="Trapezoid 61"/>
+          <p:cNvPr id="73" name="Trapezoid 72"/>
           <p:cNvSpPr/>
           <p:nvPr/>
         </p:nvSpPr>
@@ -6413,7 +6908,7 @@
       </p:sp>
       <p:sp>
         <p:nvSpPr>
-          <p:cNvPr id="63" name="TextBox 62"/>
+          <p:cNvPr id="74" name="TextBox 73"/>
           <p:cNvSpPr txBox="1"/>
           <p:nvPr/>
         </p:nvSpPr>
@@ -6458,7 +6953,7 @@
       </p:sp>
       <p:cxnSp>
         <p:nvCxnSpPr>
-          <p:cNvPr id="64" name="Connector 63"/>
+          <p:cNvPr id="75" name="Connector 74"/>
           <p:cNvCxnSpPr/>
           <p:nvPr/>
         </p:nvCxnSpPr>
@@ -6493,7 +6988,7 @@
       </p:cxnSp>
       <p:cxnSp>
         <p:nvCxnSpPr>
-          <p:cNvPr id="65" name="Connector 64"/>
+          <p:cNvPr id="76" name="Connector 75"/>
           <p:cNvCxnSpPr/>
           <p:nvPr/>
         </p:nvCxnSpPr>
@@ -6528,7 +7023,7 @@
       </p:cxnSp>
       <p:cxnSp>
         <p:nvCxnSpPr>
-          <p:cNvPr id="66" name="Connector 65"/>
+          <p:cNvPr id="77" name="Connector 76"/>
           <p:cNvCxnSpPr/>
           <p:nvPr/>
         </p:nvCxnSpPr>
@@ -6563,7 +7058,7 @@
       </p:cxnSp>
       <p:cxnSp>
         <p:nvCxnSpPr>
-          <p:cNvPr id="67" name="Connector 66"/>
+          <p:cNvPr id="78" name="Connector 77"/>
           <p:cNvCxnSpPr/>
           <p:nvPr/>
         </p:nvCxnSpPr>
@@ -6598,7 +7093,7 @@
       </p:cxnSp>
       <p:cxnSp>
         <p:nvCxnSpPr>
-          <p:cNvPr id="68" name="Connector 67"/>
+          <p:cNvPr id="79" name="Connector 78"/>
           <p:cNvCxnSpPr/>
           <p:nvPr/>
         </p:nvCxnSpPr>
@@ -6633,7 +7128,7 @@
       </p:cxnSp>
       <p:sp>
         <p:nvSpPr>
-          <p:cNvPr id="69" name="Oval 68"/>
+          <p:cNvPr id="80" name="Oval 79"/>
           <p:cNvSpPr/>
           <p:nvPr/>
         </p:nvSpPr>
@@ -6676,7 +7171,7 @@
       </p:sp>
       <p:sp>
         <p:nvSpPr>
-          <p:cNvPr id="70" name="Rounded Rectangle 69"/>
+          <p:cNvPr id="81" name="Rounded Rectangle 80"/>
           <p:cNvSpPr/>
           <p:nvPr/>
         </p:nvSpPr>
@@ -6723,7 +7218,7 @@
       </p:sp>
       <p:sp>
         <p:nvSpPr>
-          <p:cNvPr id="71" name="TextBox 70"/>
+          <p:cNvPr id="82" name="TextBox 81"/>
           <p:cNvSpPr txBox="1"/>
           <p:nvPr/>
         </p:nvSpPr>
@@ -6768,7 +7263,7 @@
       </p:sp>
       <p:cxnSp>
         <p:nvCxnSpPr>
-          <p:cNvPr id="72" name="Connector 71"/>
+          <p:cNvPr id="83" name="Connector 82"/>
           <p:cNvCxnSpPr/>
           <p:nvPr/>
         </p:nvCxnSpPr>
@@ -6803,7 +7298,7 @@
       </p:cxnSp>
       <p:sp>
         <p:nvSpPr>
-          <p:cNvPr id="73" name="Oval 72"/>
+          <p:cNvPr id="84" name="Oval 83"/>
           <p:cNvSpPr/>
           <p:nvPr/>
         </p:nvSpPr>
@@ -6846,7 +7341,7 @@
       </p:sp>
       <p:sp>
         <p:nvSpPr>
-          <p:cNvPr id="74" name="Rounded Rectangle 73"/>
+          <p:cNvPr id="85" name="Rounded Rectangle 84"/>
           <p:cNvSpPr/>
           <p:nvPr/>
         </p:nvSpPr>
@@ -6893,7 +7388,7 @@
       </p:sp>
       <p:sp>
         <p:nvSpPr>
-          <p:cNvPr id="75" name="TextBox 74"/>
+          <p:cNvPr id="86" name="TextBox 85"/>
           <p:cNvSpPr txBox="1"/>
           <p:nvPr/>
         </p:nvSpPr>
@@ -6938,7 +7433,7 @@
       </p:sp>
       <p:cxnSp>
         <p:nvCxnSpPr>
-          <p:cNvPr id="76" name="Connector 75"/>
+          <p:cNvPr id="87" name="Connector 86"/>
           <p:cNvCxnSpPr/>
           <p:nvPr/>
         </p:nvCxnSpPr>
@@ -6973,7 +7468,7 @@
       </p:cxnSp>
       <p:sp>
         <p:nvSpPr>
-          <p:cNvPr id="77" name="Oval 76"/>
+          <p:cNvPr id="88" name="Oval 87"/>
           <p:cNvSpPr/>
           <p:nvPr/>
         </p:nvSpPr>
@@ -7016,7 +7511,7 @@
       </p:sp>
       <p:sp>
         <p:nvSpPr>
-          <p:cNvPr id="78" name="Rounded Rectangle 77"/>
+          <p:cNvPr id="89" name="Rounded Rectangle 88"/>
           <p:cNvSpPr/>
           <p:nvPr/>
         </p:nvSpPr>
@@ -7063,7 +7558,7 @@
       </p:sp>
       <p:sp>
         <p:nvSpPr>
-          <p:cNvPr id="79" name="TextBox 78"/>
+          <p:cNvPr id="90" name="TextBox 89"/>
           <p:cNvSpPr txBox="1"/>
           <p:nvPr/>
         </p:nvSpPr>
@@ -7108,7 +7603,7 @@
       </p:sp>
       <p:cxnSp>
         <p:nvCxnSpPr>
-          <p:cNvPr id="80" name="Connector 79"/>
+          <p:cNvPr id="91" name="Connector 90"/>
           <p:cNvCxnSpPr/>
           <p:nvPr/>
         </p:nvCxnSpPr>
@@ -7143,7 +7638,7 @@
       </p:cxnSp>
       <p:cxnSp>
         <p:nvCxnSpPr>
-          <p:cNvPr id="81" name="Connector 80"/>
+          <p:cNvPr id="92" name="Connector 91"/>
           <p:cNvCxnSpPr/>
           <p:nvPr/>
         </p:nvCxnSpPr>
@@ -7178,7 +7673,7 @@
       </p:cxnSp>
       <p:cxnSp>
         <p:nvCxnSpPr>
-          <p:cNvPr id="82" name="Connector 81"/>
+          <p:cNvPr id="93" name="Connector 92"/>
           <p:cNvCxnSpPr/>
           <p:nvPr/>
         </p:nvCxnSpPr>
@@ -7213,7 +7708,7 @@
       </p:cxnSp>
       <p:cxnSp>
         <p:nvCxnSpPr>
-          <p:cNvPr id="83" name="Connector 82"/>
+          <p:cNvPr id="94" name="Connector 93"/>
           <p:cNvCxnSpPr/>
           <p:nvPr/>
         </p:nvCxnSpPr>
@@ -7248,7 +7743,7 @@
       </p:cxnSp>
       <p:cxnSp>
         <p:nvCxnSpPr>
-          <p:cNvPr id="84" name="Connector 83"/>
+          <p:cNvPr id="95" name="Connector 94"/>
           <p:cNvCxnSpPr/>
           <p:nvPr/>
         </p:nvCxnSpPr>
@@ -7283,7 +7778,7 @@
       </p:cxnSp>
       <p:cxnSp>
         <p:nvCxnSpPr>
-          <p:cNvPr id="85" name="Connector 84"/>
+          <p:cNvPr id="96" name="Connector 95"/>
           <p:cNvCxnSpPr/>
           <p:nvPr/>
         </p:nvCxnSpPr>
@@ -7318,7 +7813,7 @@
       </p:cxnSp>
       <p:sp>
         <p:nvSpPr>
-          <p:cNvPr id="86" name="Trapezoid 85"/>
+          <p:cNvPr id="97" name="Trapezoid 96"/>
           <p:cNvSpPr/>
           <p:nvPr/>
         </p:nvSpPr>
@@ -7361,7 +7856,7 @@
       </p:sp>
       <p:sp>
         <p:nvSpPr>
-          <p:cNvPr id="87" name="Rectangle 86"/>
+          <p:cNvPr id="98" name="Rectangle 97"/>
           <p:cNvSpPr/>
           <p:nvPr/>
         </p:nvSpPr>
@@ -7404,7 +7899,7 @@
       </p:sp>
       <p:sp>
         <p:nvSpPr>
-          <p:cNvPr id="88" name="TextBox 87"/>
+          <p:cNvPr id="99" name="TextBox 98"/>
           <p:cNvSpPr txBox="1"/>
           <p:nvPr/>
         </p:nvSpPr>
@@ -7449,7 +7944,7 @@
       </p:sp>
       <p:sp>
         <p:nvSpPr>
-          <p:cNvPr id="89" name="Oval 88"/>
+          <p:cNvPr id="100" name="Oval 99"/>
           <p:cNvSpPr/>
           <p:nvPr/>
         </p:nvSpPr>
@@ -7492,7 +7987,7 @@
       </p:sp>
       <p:sp>
         <p:nvSpPr>
-          <p:cNvPr id="90" name="Oval 89"/>
+          <p:cNvPr id="101" name="Oval 100"/>
           <p:cNvSpPr/>
           <p:nvPr/>
         </p:nvSpPr>
@@ -7535,7 +8030,7 @@
       </p:sp>
       <p:sp>
         <p:nvSpPr>
-          <p:cNvPr id="91" name="Oval 90"/>
+          <p:cNvPr id="102" name="Oval 101"/>
           <p:cNvSpPr/>
           <p:nvPr/>
         </p:nvSpPr>
@@ -7578,7 +8073,7 @@
       </p:sp>
       <p:sp>
         <p:nvSpPr>
-          <p:cNvPr id="92" name="Oval 91"/>
+          <p:cNvPr id="103" name="Oval 102"/>
           <p:cNvSpPr/>
           <p:nvPr/>
         </p:nvSpPr>
@@ -7621,7 +8116,7 @@
       </p:sp>
       <p:sp>
         <p:nvSpPr>
-          <p:cNvPr id="93" name="Rounded Rectangle 92"/>
+          <p:cNvPr id="104" name="Rounded Rectangle 103"/>
           <p:cNvSpPr/>
           <p:nvPr/>
         </p:nvSpPr>
@@ -7666,7 +8161,7 @@
       </p:sp>
       <p:sp>
         <p:nvSpPr>
-          <p:cNvPr id="94" name="TextBox 93"/>
+          <p:cNvPr id="105" name="TextBox 104"/>
           <p:cNvSpPr txBox="1"/>
           <p:nvPr/>
         </p:nvSpPr>
@@ -7711,7 +8206,7 @@
       </p:sp>
       <p:sp>
         <p:nvSpPr>
-          <p:cNvPr id="95" name="Down Arrow 94"/>
+          <p:cNvPr id="106" name="Down Arrow 105"/>
           <p:cNvSpPr/>
           <p:nvPr/>
         </p:nvSpPr>
@@ -7754,7 +8249,7 @@
       </p:sp>
       <p:sp>
         <p:nvSpPr>
-          <p:cNvPr id="96" name="TextBox 95"/>
+          <p:cNvPr id="107" name="TextBox 106"/>
           <p:cNvSpPr txBox="1"/>
           <p:nvPr/>
         </p:nvSpPr>
@@ -7799,7 +8294,7 @@
       </p:sp>
       <p:sp>
         <p:nvSpPr>
-          <p:cNvPr id="97" name="TextBox 96"/>
+          <p:cNvPr id="108" name="TextBox 107"/>
           <p:cNvSpPr txBox="1"/>
           <p:nvPr/>
         </p:nvSpPr>
@@ -7844,7 +8339,7 @@
       </p:sp>
       <p:sp>
         <p:nvSpPr>
-          <p:cNvPr id="98" name="TextBox 97"/>
+          <p:cNvPr id="109" name="TextBox 108"/>
           <p:cNvSpPr txBox="1"/>
           <p:nvPr/>
         </p:nvSpPr>
@@ -7889,7 +8384,7 @@
       </p:sp>
       <p:sp>
         <p:nvSpPr>
-          <p:cNvPr id="99" name="TextBox 98"/>
+          <p:cNvPr id="110" name="TextBox 109"/>
           <p:cNvSpPr txBox="1"/>
           <p:nvPr/>
         </p:nvSpPr>
@@ -7934,7 +8429,7 @@
       </p:sp>
       <p:sp>
         <p:nvSpPr>
-          <p:cNvPr id="100" name="TextBox 99"/>
+          <p:cNvPr id="111" name="TextBox 110"/>
           <p:cNvSpPr txBox="1"/>
           <p:nvPr/>
         </p:nvSpPr>
@@ -7979,7 +8474,7 @@
       </p:sp>
       <p:sp>
         <p:nvSpPr>
-          <p:cNvPr id="101" name="Rounded Rectangle 100"/>
+          <p:cNvPr id="112" name="Rounded Rectangle 111"/>
           <p:cNvSpPr/>
           <p:nvPr/>
         </p:nvSpPr>
@@ -8058,7 +8553,7 @@
       </p:sp>
       <p:sp>
         <p:nvSpPr>
-          <p:cNvPr id="102" name="Right Arrow 101"/>
+          <p:cNvPr id="113" name="Right Arrow 112"/>
           <p:cNvSpPr/>
           <p:nvPr/>
         </p:nvSpPr>
@@ -8101,7 +8596,7 @@
       </p:sp>
       <p:sp>
         <p:nvSpPr>
-          <p:cNvPr id="103" name="Rounded Rectangle 102"/>
+          <p:cNvPr id="114" name="Rounded Rectangle 113"/>
           <p:cNvSpPr/>
           <p:nvPr/>
         </p:nvSpPr>
@@ -8180,7 +8675,7 @@
       </p:sp>
       <p:sp>
         <p:nvSpPr>
-          <p:cNvPr id="104" name="Right Arrow 103"/>
+          <p:cNvPr id="115" name="Right Arrow 114"/>
           <p:cNvSpPr/>
           <p:nvPr/>
         </p:nvSpPr>
@@ -8223,7 +8718,7 @@
       </p:sp>
       <p:sp>
         <p:nvSpPr>
-          <p:cNvPr id="105" name="Rounded Rectangle 104"/>
+          <p:cNvPr id="116" name="Rounded Rectangle 115"/>
           <p:cNvSpPr/>
           <p:nvPr/>
         </p:nvSpPr>
@@ -8302,7 +8797,7 @@
       </p:sp>
       <p:sp>
         <p:nvSpPr>
-          <p:cNvPr id="106" name="Right Arrow 105"/>
+          <p:cNvPr id="117" name="Right Arrow 116"/>
           <p:cNvSpPr/>
           <p:nvPr/>
         </p:nvSpPr>
@@ -8345,7 +8840,7 @@
       </p:sp>
       <p:sp>
         <p:nvSpPr>
-          <p:cNvPr id="107" name="Rounded Rectangle 106"/>
+          <p:cNvPr id="118" name="Rounded Rectangle 117"/>
           <p:cNvSpPr/>
           <p:nvPr/>
         </p:nvSpPr>
@@ -8424,7 +8919,7 @@
       </p:sp>
       <p:sp>
         <p:nvSpPr>
-          <p:cNvPr id="108" name="Down Arrow 107"/>
+          <p:cNvPr id="119" name="Down Arrow 118"/>
           <p:cNvSpPr/>
           <p:nvPr/>
         </p:nvSpPr>
@@ -8467,7 +8962,7 @@
       </p:sp>
       <p:sp>
         <p:nvSpPr>
-          <p:cNvPr id="109" name="Rounded Rectangle 108"/>
+          <p:cNvPr id="120" name="Rounded Rectangle 119"/>
           <p:cNvSpPr/>
           <p:nvPr/>
         </p:nvSpPr>
@@ -8546,7 +9041,7 @@
       </p:sp>
       <p:sp>
         <p:nvSpPr>
-          <p:cNvPr id="110" name="TextBox 109"/>
+          <p:cNvPr id="121" name="TextBox 120"/>
           <p:cNvSpPr txBox="1"/>
           <p:nvPr/>
         </p:nvSpPr>
@@ -8591,7 +9086,7 @@
       </p:sp>
       <p:sp>
         <p:nvSpPr>
-          <p:cNvPr id="111" name="Rectangle 110"/>
+          <p:cNvPr id="122" name="Rectangle 121"/>
           <p:cNvSpPr/>
           <p:nvPr/>
         </p:nvSpPr>
@@ -8634,7 +9129,7 @@
       </p:sp>
       <p:sp>
         <p:nvSpPr>
-          <p:cNvPr id="112" name="Rectangle 111"/>
+          <p:cNvPr id="123" name="Rectangle 122"/>
           <p:cNvSpPr/>
           <p:nvPr/>
         </p:nvSpPr>
@@ -8679,7 +9174,7 @@
       </p:sp>
       <p:sp>
         <p:nvSpPr>
-          <p:cNvPr id="113" name="TextBox 112"/>
+          <p:cNvPr id="124" name="TextBox 123"/>
           <p:cNvSpPr txBox="1"/>
           <p:nvPr/>
         </p:nvSpPr>
@@ -8724,7 +9219,7 @@
       </p:sp>
       <p:pic>
         <p:nvPicPr>
-          <p:cNvPr id="114" name="Retained pathway shifts" descr="Literature-aligned anchors and retained expiMap pathway shifts for thymus, skin, liver, and spleen, with project effects and three-training ranges."/>
+          <p:cNvPr id="125" name="Retained pathway shifts" descr="Literature-aligned anchors and retained expiMap pathway shifts for thymus, skin, liver, and spleen, with project effects and three-training ranges."/>
           <p:cNvPicPr>
             <a:picLocks noChangeAspect="1"/>
           </p:cNvPicPr>
@@ -8748,14 +9243,14 @@
       </p:pic>
       <p:sp>
         <p:nvSpPr>
-          <p:cNvPr id="115" name="TextBox 114"/>
+          <p:cNvPr id="126" name="TextBox 125"/>
           <p:cNvSpPr txBox="1"/>
           <p:nvPr/>
         </p:nvSpPr>
         <p:spPr>
           <a:xfrm>
             <a:off x="15041880" y="21598128"/>
-            <a:ext cx="13304520" cy="713232"/>
+            <a:ext cx="13304520" cy="237744"/>
           </a:xfrm>
           <a:prstGeom prst="rect">
             <a:avLst/>
@@ -8763,7 +9258,7 @@
           <a:noFill/>
         </p:spPr>
         <p:txBody>
-          <a:bodyPr wrap="square" lIns="0" rIns="0" tIns="0" bIns="0" anchor="t">
+          <a:bodyPr wrap="none" lIns="0" rIns="0" tIns="0" bIns="0" anchor="ctr">
             <a:noAutofit/>
           </a:bodyPr>
           <a:lstStyle/>
@@ -8786,14 +9281,104 @@
                 </a:solidFill>
                 <a:latin typeface="Arial"/>
               </a:rPr>
-              <a:t>Filled markers show 13 retained programs. Open diamonds are literature-aligned context only, not retained findings; keratinization reversed in one of three trainings. Colored ranges span three complete trainings; axes are tissue specific.</a:t>
-            </a:r>
-          </a:p>
-        </p:txBody>
-      </p:sp>
-      <p:sp>
-        <p:nvSpPr>
-          <p:cNvPr id="116" name="Rectangle 115"/>
+              <a:t>Filled markers show 13 retained programs. Open diamonds are literature-aligned context only,</a:t>
+            </a:r>
+          </a:p>
+        </p:txBody>
+      </p:sp>
+      <p:sp>
+        <p:nvSpPr>
+          <p:cNvPr id="127" name="TextBox 126"/>
+          <p:cNvSpPr txBox="1"/>
+          <p:nvPr/>
+        </p:nvSpPr>
+        <p:spPr>
+          <a:xfrm>
+            <a:off x="15041880" y="21835872"/>
+            <a:ext cx="13304520" cy="237744"/>
+          </a:xfrm>
+          <a:prstGeom prst="rect">
+            <a:avLst/>
+          </a:prstGeom>
+          <a:noFill/>
+        </p:spPr>
+        <p:txBody>
+          <a:bodyPr wrap="none" lIns="0" rIns="0" tIns="0" bIns="0" anchor="ctr">
+            <a:noAutofit/>
+          </a:bodyPr>
+          <a:lstStyle/>
+          <a:p>
+            <a:pPr algn="ctr" latinLnBrk="0" eaLnBrk="0" hangingPunct="0">
+              <a:lnSpc>
+                <a:spcPct val="100000"/>
+              </a:lnSpc>
+              <a:spcBef>
+                <a:spcPts val="0"/>
+              </a:spcBef>
+              <a:spcAft>
+                <a:spcPts val="0"/>
+              </a:spcAft>
+            </a:pPr>
+            <a:r>
+              <a:rPr sz="1450" b="0" i="1">
+                <a:solidFill>
+                  <a:srgbClr val="697889"/>
+                </a:solidFill>
+                <a:latin typeface="Arial"/>
+              </a:rPr>
+              <a:t>not retained findings; keratinization reversed in one of three trainings.</a:t>
+            </a:r>
+          </a:p>
+        </p:txBody>
+      </p:sp>
+      <p:sp>
+        <p:nvSpPr>
+          <p:cNvPr id="128" name="TextBox 127"/>
+          <p:cNvSpPr txBox="1"/>
+          <p:nvPr/>
+        </p:nvSpPr>
+        <p:spPr>
+          <a:xfrm>
+            <a:off x="15041880" y="22073616"/>
+            <a:ext cx="13304520" cy="237744"/>
+          </a:xfrm>
+          <a:prstGeom prst="rect">
+            <a:avLst/>
+          </a:prstGeom>
+          <a:noFill/>
+        </p:spPr>
+        <p:txBody>
+          <a:bodyPr wrap="none" lIns="0" rIns="0" tIns="0" bIns="0" anchor="ctr">
+            <a:noAutofit/>
+          </a:bodyPr>
+          <a:lstStyle/>
+          <a:p>
+            <a:pPr algn="ctr" latinLnBrk="0" eaLnBrk="0" hangingPunct="0">
+              <a:lnSpc>
+                <a:spcPct val="100000"/>
+              </a:lnSpc>
+              <a:spcBef>
+                <a:spcPts val="0"/>
+              </a:spcBef>
+              <a:spcAft>
+                <a:spcPts val="0"/>
+              </a:spcAft>
+            </a:pPr>
+            <a:r>
+              <a:rPr sz="1450" b="0" i="1">
+                <a:solidFill>
+                  <a:srgbClr val="697889"/>
+                </a:solidFill>
+                <a:latin typeface="Arial"/>
+              </a:rPr>
+              <a:t>Colored ranges span three complete trainings; axes are tissue specific.</a:t>
+            </a:r>
+          </a:p>
+        </p:txBody>
+      </p:sp>
+      <p:sp>
+        <p:nvSpPr>
+          <p:cNvPr id="129" name="Rectangle 128"/>
           <p:cNvSpPr/>
           <p:nvPr/>
         </p:nvSpPr>
@@ -8836,7 +9421,7 @@
       </p:sp>
       <p:sp>
         <p:nvSpPr>
-          <p:cNvPr id="117" name="Rectangle 116"/>
+          <p:cNvPr id="130" name="Rectangle 129"/>
           <p:cNvSpPr/>
           <p:nvPr/>
         </p:nvSpPr>
@@ -8881,7 +9466,7 @@
       </p:sp>
       <p:sp>
         <p:nvSpPr>
-          <p:cNvPr id="118" name="TextBox 117"/>
+          <p:cNvPr id="131" name="TextBox 130"/>
           <p:cNvSpPr txBox="1"/>
           <p:nvPr/>
         </p:nvSpPr>
@@ -8926,7 +9511,7 @@
       </p:sp>
       <p:sp>
         <p:nvSpPr>
-          <p:cNvPr id="119" name="TextBox 118"/>
+          <p:cNvPr id="132" name="TextBox 131"/>
           <p:cNvSpPr txBox="1"/>
           <p:nvPr/>
         </p:nvSpPr>
@@ -8971,7 +9556,7 @@
       </p:sp>
       <p:pic>
         <p:nvPicPr>
-          <p:cNvPr id="120" name="Tissue-state hypotheses" descr="Prior-literature phenotypes, observed lower expiMap program scores, and complementary hypotheses for thymus, skin, liver, and spleen."/>
+          <p:cNvPr id="133" name="Tissue-state hypotheses" descr="Prior-literature phenotypes, observed lower expiMap program scores, and complementary hypotheses for thymus, skin, liver, and spleen."/>
           <p:cNvPicPr>
             <a:picLocks noChangeAspect="1"/>
           </p:cNvPicPr>
@@ -8995,7 +9580,7 @@
       </p:pic>
       <p:sp>
         <p:nvSpPr>
-          <p:cNvPr id="121" name="Rectangle 120"/>
+          <p:cNvPr id="134" name="Rectangle 133"/>
           <p:cNvSpPr/>
           <p:nvPr/>
         </p:nvSpPr>
@@ -9038,7 +9623,7 @@
       </p:sp>
       <p:sp>
         <p:nvSpPr>
-          <p:cNvPr id="122" name="Rectangle 121"/>
+          <p:cNvPr id="135" name="Rectangle 134"/>
           <p:cNvSpPr/>
           <p:nvPr/>
         </p:nvSpPr>
@@ -9083,7 +9668,7 @@
       </p:sp>
       <p:sp>
         <p:nvSpPr>
-          <p:cNvPr id="123" name="TextBox 122"/>
+          <p:cNvPr id="136" name="TextBox 135"/>
           <p:cNvSpPr txBox="1"/>
           <p:nvPr/>
         </p:nvSpPr>
@@ -9128,14 +9713,14 @@
       </p:sp>
       <p:sp>
         <p:nvSpPr>
-          <p:cNvPr id="124" name="TextBox 123"/>
+          <p:cNvPr id="137" name="TextBox 136"/>
           <p:cNvSpPr txBox="1"/>
           <p:nvPr/>
         </p:nvSpPr>
         <p:spPr>
           <a:xfrm>
             <a:off x="29718000" y="18306288"/>
-            <a:ext cx="13350240" cy="621792"/>
+            <a:ext cx="13350240" cy="310896"/>
           </a:xfrm>
           <a:prstGeom prst="rect">
             <a:avLst/>
@@ -9143,7 +9728,7 @@
           <a:noFill/>
         </p:spPr>
         <p:txBody>
-          <a:bodyPr wrap="square" lIns="0" rIns="0" tIns="0" bIns="0" anchor="t">
+          <a:bodyPr wrap="none" lIns="0" rIns="0" tIns="0" bIns="0" anchor="ctr">
             <a:noAutofit/>
           </a:bodyPr>
           <a:lstStyle/>
@@ -9166,21 +9751,21 @@
                 </a:solidFill>
                 <a:latin typeface="Arial"/>
               </a:rPr>
-              <a:t>• Spleen was strongest: T cell receptor, neutrophil degranulation, and C‑type lectin receptor programs were lower across five projects and three trainings; all had GSEA FDR &lt;0.05.</a:t>
-            </a:r>
-          </a:p>
-        </p:txBody>
-      </p:sp>
-      <p:sp>
-        <p:nvSpPr>
-          <p:cNvPr id="125" name="TextBox 124"/>
+              <a:t>• Spleen was strongest: T cell receptor, neutrophil degranulation, and C‑type lectin</a:t>
+            </a:r>
+          </a:p>
+        </p:txBody>
+      </p:sp>
+      <p:sp>
+        <p:nvSpPr>
+          <p:cNvPr id="138" name="TextBox 137"/>
           <p:cNvSpPr txBox="1"/>
           <p:nvPr/>
         </p:nvSpPr>
         <p:spPr>
           <a:xfrm>
-            <a:off x="29718000" y="19019520"/>
-            <a:ext cx="13350240" cy="621792"/>
+            <a:off x="29718000" y="18617184"/>
+            <a:ext cx="13350240" cy="310896"/>
           </a:xfrm>
           <a:prstGeom prst="rect">
             <a:avLst/>
@@ -9188,7 +9773,7 @@
           <a:noFill/>
         </p:spPr>
         <p:txBody>
-          <a:bodyPr wrap="square" lIns="0" rIns="0" tIns="0" bIns="0" anchor="t">
+          <a:bodyPr wrap="none" lIns="0" rIns="0" tIns="0" bIns="0" anchor="ctr">
             <a:noAutofit/>
           </a:bodyPr>
           <a:lstStyle/>
@@ -9211,21 +9796,21 @@
                 </a:solidFill>
                 <a:latin typeface="Arial"/>
               </a:rPr>
-              <a:t>• Skin and thymus emphasized lower tissue maintenance programs; liver showed lower adaptive immune signaling amid heterogeneous metabolism.</a:t>
-            </a:r>
-          </a:p>
-        </p:txBody>
-      </p:sp>
-      <p:sp>
-        <p:nvSpPr>
-          <p:cNvPr id="126" name="TextBox 125"/>
+              <a:t>  receptor programs were lower across five projects and three trainings; all had GSEA FDR &lt;0.05.</a:t>
+            </a:r>
+          </a:p>
+        </p:txBody>
+      </p:sp>
+      <p:sp>
+        <p:nvSpPr>
+          <p:cNvPr id="139" name="TextBox 138"/>
           <p:cNvSpPr txBox="1"/>
           <p:nvPr/>
         </p:nvSpPr>
         <p:spPr>
           <a:xfrm>
-            <a:off x="29718000" y="19732752"/>
-            <a:ext cx="13350240" cy="329184"/>
+            <a:off x="29718000" y="19019520"/>
+            <a:ext cx="13350240" cy="310896"/>
           </a:xfrm>
           <a:prstGeom prst="rect">
             <a:avLst/>
@@ -9233,7 +9818,7 @@
           <a:noFill/>
         </p:spPr>
         <p:txBody>
-          <a:bodyPr wrap="square" lIns="0" rIns="0" tIns="0" bIns="0" anchor="t">
+          <a:bodyPr wrap="none" lIns="0" rIns="0" tIns="0" bIns="0" anchor="ctr">
             <a:noAutofit/>
           </a:bodyPr>
           <a:lstStyle/>
@@ -9256,14 +9841,149 @@
                 </a:solidFill>
                 <a:latin typeface="Arial"/>
               </a:rPr>
-              <a:t>• Bulk latent scores are testable hypotheses, not causal or cell-resolved measures of pathway activity.</a:t>
-            </a:r>
-          </a:p>
-        </p:txBody>
-      </p:sp>
-      <p:sp>
-        <p:nvSpPr>
-          <p:cNvPr id="127" name="Rectangle 126"/>
+              <a:t>• Skin and thymus emphasized lower tissue maintenance programs; liver showed lower</a:t>
+            </a:r>
+          </a:p>
+        </p:txBody>
+      </p:sp>
+      <p:sp>
+        <p:nvSpPr>
+          <p:cNvPr id="140" name="TextBox 139"/>
+          <p:cNvSpPr txBox="1"/>
+          <p:nvPr/>
+        </p:nvSpPr>
+        <p:spPr>
+          <a:xfrm>
+            <a:off x="29718000" y="19330416"/>
+            <a:ext cx="13350240" cy="310896"/>
+          </a:xfrm>
+          <a:prstGeom prst="rect">
+            <a:avLst/>
+          </a:prstGeom>
+          <a:noFill/>
+        </p:spPr>
+        <p:txBody>
+          <a:bodyPr wrap="none" lIns="0" rIns="0" tIns="0" bIns="0" anchor="ctr">
+            <a:noAutofit/>
+          </a:bodyPr>
+          <a:lstStyle/>
+          <a:p>
+            <a:pPr algn="l" latinLnBrk="0" eaLnBrk="0" hangingPunct="0">
+              <a:lnSpc>
+                <a:spcPct val="100000"/>
+              </a:lnSpc>
+              <a:spcBef>
+                <a:spcPts val="0"/>
+              </a:spcBef>
+              <a:spcAft>
+                <a:spcPts val="0"/>
+              </a:spcAft>
+            </a:pPr>
+            <a:r>
+              <a:rPr sz="1750" b="0" i="0">
+                <a:solidFill>
+                  <a:srgbClr val="33445D"/>
+                </a:solidFill>
+                <a:latin typeface="Arial"/>
+              </a:rPr>
+              <a:t>  adaptive immune signaling amid heterogeneous metabolism.</a:t>
+            </a:r>
+          </a:p>
+        </p:txBody>
+      </p:sp>
+      <p:sp>
+        <p:nvSpPr>
+          <p:cNvPr id="141" name="TextBox 140"/>
+          <p:cNvSpPr txBox="1"/>
+          <p:nvPr/>
+        </p:nvSpPr>
+        <p:spPr>
+          <a:xfrm>
+            <a:off x="29718000" y="19659600"/>
+            <a:ext cx="13350240" cy="265176"/>
+          </a:xfrm>
+          <a:prstGeom prst="rect">
+            <a:avLst/>
+          </a:prstGeom>
+          <a:noFill/>
+        </p:spPr>
+        <p:txBody>
+          <a:bodyPr wrap="none" lIns="0" rIns="0" tIns="0" bIns="0" anchor="ctr">
+            <a:noAutofit/>
+          </a:bodyPr>
+          <a:lstStyle/>
+          <a:p>
+            <a:pPr algn="l" latinLnBrk="0" eaLnBrk="0" hangingPunct="0">
+              <a:lnSpc>
+                <a:spcPct val="100000"/>
+              </a:lnSpc>
+              <a:spcBef>
+                <a:spcPts val="0"/>
+              </a:spcBef>
+              <a:spcAft>
+                <a:spcPts val="0"/>
+              </a:spcAft>
+            </a:pPr>
+            <a:r>
+              <a:rPr sz="1750" b="0" i="0">
+                <a:solidFill>
+                  <a:srgbClr val="33445D"/>
+                </a:solidFill>
+                <a:latin typeface="Arial"/>
+              </a:rPr>
+              <a:t>• Bulk latent scores are testable hypotheses, not causal or cell-resolved measures</a:t>
+            </a:r>
+          </a:p>
+        </p:txBody>
+      </p:sp>
+      <p:sp>
+        <p:nvSpPr>
+          <p:cNvPr id="142" name="TextBox 141"/>
+          <p:cNvSpPr txBox="1"/>
+          <p:nvPr/>
+        </p:nvSpPr>
+        <p:spPr>
+          <a:xfrm>
+            <a:off x="29718000" y="19924776"/>
+            <a:ext cx="13350240" cy="265176"/>
+          </a:xfrm>
+          <a:prstGeom prst="rect">
+            <a:avLst/>
+          </a:prstGeom>
+          <a:noFill/>
+        </p:spPr>
+        <p:txBody>
+          <a:bodyPr wrap="none" lIns="0" rIns="0" tIns="0" bIns="0" anchor="ctr">
+            <a:noAutofit/>
+          </a:bodyPr>
+          <a:lstStyle/>
+          <a:p>
+            <a:pPr algn="l" latinLnBrk="0" eaLnBrk="0" hangingPunct="0">
+              <a:lnSpc>
+                <a:spcPct val="100000"/>
+              </a:lnSpc>
+              <a:spcBef>
+                <a:spcPts val="0"/>
+              </a:spcBef>
+              <a:spcAft>
+                <a:spcPts val="0"/>
+              </a:spcAft>
+            </a:pPr>
+            <a:r>
+              <a:rPr sz="1750" b="0" i="0">
+                <a:solidFill>
+                  <a:srgbClr val="33445D"/>
+                </a:solidFill>
+                <a:latin typeface="Arial"/>
+              </a:rPr>
+              <a:t>  of pathway activity.</a:t>
+            </a:r>
+          </a:p>
+        </p:txBody>
+      </p:sp>
+      <p:sp>
+        <p:nvSpPr>
+          <p:cNvPr id="143" name="Rectangle 142"/>
           <p:cNvSpPr/>
           <p:nvPr/>
         </p:nvSpPr>
@@ -9306,7 +10026,7 @@
       </p:sp>
       <p:sp>
         <p:nvSpPr>
-          <p:cNvPr id="128" name="Rectangle 127"/>
+          <p:cNvPr id="144" name="Rectangle 143"/>
           <p:cNvSpPr/>
           <p:nvPr/>
         </p:nvSpPr>
@@ -9351,7 +10071,7 @@
       </p:sp>
       <p:sp>
         <p:nvSpPr>
-          <p:cNvPr id="129" name="TextBox 128"/>
+          <p:cNvPr id="145" name="TextBox 144"/>
           <p:cNvSpPr txBox="1"/>
           <p:nvPr/>
         </p:nvSpPr>
@@ -9396,14 +10116,14 @@
       </p:sp>
       <p:sp>
         <p:nvSpPr>
-          <p:cNvPr id="130" name="TextBox 129"/>
+          <p:cNvPr id="146" name="TextBox 145"/>
           <p:cNvSpPr txBox="1"/>
           <p:nvPr/>
         </p:nvSpPr>
         <p:spPr>
           <a:xfrm>
             <a:off x="29690568" y="21744432"/>
-            <a:ext cx="13405104" cy="713232"/>
+            <a:ext cx="13405104" cy="178308"/>
           </a:xfrm>
           <a:prstGeom prst="rect">
             <a:avLst/>
@@ -9411,7 +10131,7 @@
           <a:noFill/>
         </p:spPr>
         <p:txBody>
-          <a:bodyPr wrap="square" lIns="0" rIns="0" tIns="0" bIns="0" anchor="t">
+          <a:bodyPr wrap="none" lIns="0" rIns="0" tIns="0" bIns="0" anchor="ctr">
             <a:noAutofit/>
           </a:bodyPr>
           <a:lstStyle/>
@@ -9428,20 +10148,155 @@
               </a:spcAft>
             </a:pPr>
             <a:r>
-              <a:rPr sz="1350" b="0" i="0">
+              <a:rPr sz="1250" b="0" i="0">
                 <a:solidFill>
                   <a:srgbClr val="33445D"/>
                 </a:solidFill>
                 <a:latin typeface="Arial"/>
               </a:rPr>
-              <a:t>1 Gebre et al., NAR 2025 (OSDR). 2 Lotfollahi et al., Nat Cell Biol 2023 (expiMap). 3 Lachmann et al., Nat Commun 2018 (ARCHS4). 4 Milacic et al., NAR 2024 (Reactome). 5 Horie et al., Sci Rep 2019. 6 Cope et al., Commun Med 2024. 7 Beheshti et al., Sci Rep 2019. 8 Gridley et al., J Appl Physiol 2009.</a:t>
-            </a:r>
-          </a:p>
-        </p:txBody>
-      </p:sp>
-      <p:sp>
-        <p:nvSpPr>
-          <p:cNvPr id="131" name="Rectangle 130"/>
+              <a:t>1 Gebre et al., NAR 2025 (OSDR). 2 Lotfollahi et al., Nat Cell Biol 2023 (expiMap).</a:t>
+            </a:r>
+          </a:p>
+        </p:txBody>
+      </p:sp>
+      <p:sp>
+        <p:nvSpPr>
+          <p:cNvPr id="147" name="TextBox 146"/>
+          <p:cNvSpPr txBox="1"/>
+          <p:nvPr/>
+        </p:nvSpPr>
+        <p:spPr>
+          <a:xfrm>
+            <a:off x="29690568" y="21922740"/>
+            <a:ext cx="13405104" cy="178308"/>
+          </a:xfrm>
+          <a:prstGeom prst="rect">
+            <a:avLst/>
+          </a:prstGeom>
+          <a:noFill/>
+        </p:spPr>
+        <p:txBody>
+          <a:bodyPr wrap="none" lIns="0" rIns="0" tIns="0" bIns="0" anchor="ctr">
+            <a:noAutofit/>
+          </a:bodyPr>
+          <a:lstStyle/>
+          <a:p>
+            <a:pPr algn="l" latinLnBrk="0" eaLnBrk="0" hangingPunct="0">
+              <a:lnSpc>
+                <a:spcPct val="100000"/>
+              </a:lnSpc>
+              <a:spcBef>
+                <a:spcPts val="0"/>
+              </a:spcBef>
+              <a:spcAft>
+                <a:spcPts val="0"/>
+              </a:spcAft>
+            </a:pPr>
+            <a:r>
+              <a:rPr sz="1250" b="0" i="0">
+                <a:solidFill>
+                  <a:srgbClr val="33445D"/>
+                </a:solidFill>
+                <a:latin typeface="Arial"/>
+              </a:rPr>
+              <a:t>3 Lachmann et al., Nat Commun 2018 (ARCHS4). 4 Milacic et al., NAR 2024 (Reactome).</a:t>
+            </a:r>
+          </a:p>
+        </p:txBody>
+      </p:sp>
+      <p:sp>
+        <p:nvSpPr>
+          <p:cNvPr id="148" name="TextBox 147"/>
+          <p:cNvSpPr txBox="1"/>
+          <p:nvPr/>
+        </p:nvSpPr>
+        <p:spPr>
+          <a:xfrm>
+            <a:off x="29690568" y="22101048"/>
+            <a:ext cx="13405104" cy="178308"/>
+          </a:xfrm>
+          <a:prstGeom prst="rect">
+            <a:avLst/>
+          </a:prstGeom>
+          <a:noFill/>
+        </p:spPr>
+        <p:txBody>
+          <a:bodyPr wrap="none" lIns="0" rIns="0" tIns="0" bIns="0" anchor="ctr">
+            <a:noAutofit/>
+          </a:bodyPr>
+          <a:lstStyle/>
+          <a:p>
+            <a:pPr algn="l" latinLnBrk="0" eaLnBrk="0" hangingPunct="0">
+              <a:lnSpc>
+                <a:spcPct val="100000"/>
+              </a:lnSpc>
+              <a:spcBef>
+                <a:spcPts val="0"/>
+              </a:spcBef>
+              <a:spcAft>
+                <a:spcPts val="0"/>
+              </a:spcAft>
+            </a:pPr>
+            <a:r>
+              <a:rPr sz="1250" b="0" i="0">
+                <a:solidFill>
+                  <a:srgbClr val="33445D"/>
+                </a:solidFill>
+                <a:latin typeface="Arial"/>
+              </a:rPr>
+              <a:t>5 Horie et al., Sci Rep 2019. 6 Cope et al., Commun Med 2024.</a:t>
+            </a:r>
+          </a:p>
+        </p:txBody>
+      </p:sp>
+      <p:sp>
+        <p:nvSpPr>
+          <p:cNvPr id="149" name="TextBox 148"/>
+          <p:cNvSpPr txBox="1"/>
+          <p:nvPr/>
+        </p:nvSpPr>
+        <p:spPr>
+          <a:xfrm>
+            <a:off x="29690568" y="22279356"/>
+            <a:ext cx="13405104" cy="178308"/>
+          </a:xfrm>
+          <a:prstGeom prst="rect">
+            <a:avLst/>
+          </a:prstGeom>
+          <a:noFill/>
+        </p:spPr>
+        <p:txBody>
+          <a:bodyPr wrap="none" lIns="0" rIns="0" tIns="0" bIns="0" anchor="ctr">
+            <a:noAutofit/>
+          </a:bodyPr>
+          <a:lstStyle/>
+          <a:p>
+            <a:pPr algn="l" latinLnBrk="0" eaLnBrk="0" hangingPunct="0">
+              <a:lnSpc>
+                <a:spcPct val="100000"/>
+              </a:lnSpc>
+              <a:spcBef>
+                <a:spcPts val="0"/>
+              </a:spcBef>
+              <a:spcAft>
+                <a:spcPts val="0"/>
+              </a:spcAft>
+            </a:pPr>
+            <a:r>
+              <a:rPr sz="1250" b="0" i="0">
+                <a:solidFill>
+                  <a:srgbClr val="33445D"/>
+                </a:solidFill>
+                <a:latin typeface="Arial"/>
+              </a:rPr>
+              <a:t>7 Beheshti et al., Sci Rep 2019. 8 Gridley et al., J Appl Physiol 2009.</a:t>
+            </a:r>
+          </a:p>
+        </p:txBody>
+      </p:sp>
+      <p:sp>
+        <p:nvSpPr>
+          <p:cNvPr id="150" name="Rectangle 149"/>
           <p:cNvSpPr/>
           <p:nvPr/>
         </p:nvSpPr>
@@ -9484,7 +10339,7 @@
       </p:sp>
       <p:sp>
         <p:nvSpPr>
-          <p:cNvPr id="132" name="TextBox 131"/>
+          <p:cNvPr id="151" name="TextBox 150"/>
           <p:cNvSpPr txBox="1"/>
           <p:nvPr/>
         </p:nvSpPr>
@@ -9529,14 +10384,14 @@
       </p:sp>
       <p:sp>
         <p:nvSpPr>
-          <p:cNvPr id="133" name="TextBox 132"/>
+          <p:cNvPr id="152" name="TextBox 151"/>
           <p:cNvSpPr txBox="1"/>
           <p:nvPr/>
         </p:nvSpPr>
         <p:spPr>
           <a:xfrm>
             <a:off x="14813280" y="23335488"/>
-            <a:ext cx="18836640" cy="804672"/>
+            <a:ext cx="18836640" cy="301752"/>
           </a:xfrm>
           <a:prstGeom prst="rect">
             <a:avLst/>
@@ -9544,7 +10399,7 @@
           <a:noFill/>
         </p:spPr>
         <p:txBody>
-          <a:bodyPr wrap="square" lIns="0" rIns="0" tIns="0" bIns="0" anchor="t">
+          <a:bodyPr wrap="none" lIns="0" rIns="0" tIns="0" bIns="0" anchor="ctr">
             <a:noAutofit/>
           </a:bodyPr>
           <a:lstStyle/>
@@ -9567,14 +10422,59 @@
                 </a:solidFill>
                 <a:latin typeface="Arial"/>
               </a:rPr>
-              <a:t>Mentor: James Casaletto | NASA Space Life Sciences Training Program | NASA OSDR, ARCHS4, and Reactome investigators and curation teams</a:t>
-            </a:r>
-          </a:p>
-        </p:txBody>
-      </p:sp>
-      <p:sp>
-        <p:nvSpPr>
-          <p:cNvPr id="134" name="TextBox 133"/>
+              <a:t>Mentor: James Casaletto | NASA Space Life Sciences Training Program</a:t>
+            </a:r>
+          </a:p>
+        </p:txBody>
+      </p:sp>
+      <p:sp>
+        <p:nvSpPr>
+          <p:cNvPr id="153" name="TextBox 152"/>
+          <p:cNvSpPr txBox="1"/>
+          <p:nvPr/>
+        </p:nvSpPr>
+        <p:spPr>
+          <a:xfrm>
+            <a:off x="14813280" y="23637239"/>
+            <a:ext cx="18836640" cy="301752"/>
+          </a:xfrm>
+          <a:prstGeom prst="rect">
+            <a:avLst/>
+          </a:prstGeom>
+          <a:noFill/>
+        </p:spPr>
+        <p:txBody>
+          <a:bodyPr wrap="none" lIns="0" rIns="0" tIns="0" bIns="0" anchor="ctr">
+            <a:noAutofit/>
+          </a:bodyPr>
+          <a:lstStyle/>
+          <a:p>
+            <a:pPr algn="l" latinLnBrk="0" eaLnBrk="0" hangingPunct="0">
+              <a:lnSpc>
+                <a:spcPct val="100000"/>
+              </a:lnSpc>
+              <a:spcBef>
+                <a:spcPts val="0"/>
+              </a:spcBef>
+              <a:spcAft>
+                <a:spcPts val="0"/>
+              </a:spcAft>
+            </a:pPr>
+            <a:r>
+              <a:rPr sz="1600" b="0" i="0">
+                <a:solidFill>
+                  <a:srgbClr val="33445D"/>
+                </a:solidFill>
+                <a:latin typeface="Arial"/>
+              </a:rPr>
+              <a:t>NASA OSDR, ARCHS4, and Reactome investigators and curation teams</a:t>
+            </a:r>
+          </a:p>
+        </p:txBody>
+      </p:sp>
+      <p:sp>
+        <p:nvSpPr>
+          <p:cNvPr id="154" name="TextBox 153"/>
           <p:cNvSpPr txBox="1"/>
           <p:nvPr/>
         </p:nvSpPr>
@@ -9620,7 +10520,7 @@
       </p:sp>
       <p:sp>
         <p:nvSpPr>
-          <p:cNvPr id="135" name="TextBox 134"/>
+          <p:cNvPr id="155" name="TextBox 154"/>
           <p:cNvSpPr txBox="1"/>
           <p:nvPr/>
         </p:nvSpPr>

</xml_diff>

<commit_message>
format fixed poster lines as paragraphs
</commit_message>
<xml_diff>
--- a/paper/asgsr_expimap_hvg/poster/asgsr_expimap_poster.pptx
+++ b/paper/asgsr_expimap_hvg/poster/asgsr_expimap_poster.pptx
@@ -3485,7 +3485,7 @@
         <p:spPr>
           <a:xfrm>
             <a:off x="777240" y="5925312"/>
-            <a:ext cx="12938760" cy="285750"/>
+            <a:ext cx="12938760" cy="283464"/>
           </a:xfrm>
           <a:prstGeom prst="rect">
             <a:avLst/>
@@ -3516,7 +3516,7 @@
                 </a:solidFill>
                 <a:latin typeface="Arial"/>
               </a:rPr>
-              <a:t>Mission differences can obscure spaceflight responses shared across studies.</a:t>
+              <a:t>Mission differences can obscure spaceflight responses shared across studies. We mapped NASA OSDR mouse bulk RNA</a:t>
             </a:r>
           </a:p>
         </p:txBody>
@@ -3529,8 +3529,8 @@
         </p:nvSpPr>
         <p:spPr>
           <a:xfrm>
-            <a:off x="777240" y="6211062"/>
-            <a:ext cx="12938760" cy="285750"/>
+            <a:off x="777240" y="6208776"/>
+            <a:ext cx="12938760" cy="283464"/>
           </a:xfrm>
           <a:prstGeom prst="rect">
             <a:avLst/>
@@ -3561,7 +3561,7 @@
                 </a:solidFill>
                 <a:latin typeface="Arial"/>
               </a:rPr>
-              <a:t>We mapped NASA OSDR mouse bulk RNA sequencing samples to tissue-matched ARCHS4 references.</a:t>
+              <a:t>sequencing samples to tissue-matched ARCHS4 references. Reactome-constrained expiMap models analyzed about</a:t>
             </a:r>
           </a:p>
         </p:txBody>
@@ -3574,8 +3574,8 @@
         </p:nvSpPr>
         <p:spPr>
           <a:xfrm>
-            <a:off x="777240" y="6496812"/>
-            <a:ext cx="12938760" cy="285750"/>
+            <a:off x="777240" y="6492240"/>
+            <a:ext cx="12938760" cy="283464"/>
           </a:xfrm>
           <a:prstGeom prst="rect">
             <a:avLst/>
@@ -3606,7 +3606,7 @@
                 </a:solidFill>
                 <a:latin typeface="Arial"/>
               </a:rPr>
-              <a:t>Reactome-constrained expiMap models analyzed about 2,000 highly variable genes.</a:t>
+              <a:t>2,000 highly variable genes. Flight-ground shifts were balanced across projects and evaluated with gene-set</a:t>
             </a:r>
           </a:p>
         </p:txBody>
@@ -3619,8 +3619,8 @@
         </p:nvSpPr>
         <p:spPr>
           <a:xfrm>
-            <a:off x="777240" y="6782562"/>
-            <a:ext cx="12938760" cy="285750"/>
+            <a:off x="777240" y="6775704"/>
+            <a:ext cx="12938760" cy="283464"/>
           </a:xfrm>
           <a:prstGeom prst="rect">
             <a:avLst/>
@@ -3651,7 +3651,7 @@
                 </a:solidFill>
                 <a:latin typeface="Arial"/>
               </a:rPr>
-              <a:t>Flight-ground shifts were balanced across projects and evaluated with gene-set enrichment,</a:t>
+              <a:t>enrichment, project holdouts, three complete training runs, composition proxies, and member-gene review.</a:t>
             </a:r>
           </a:p>
         </p:txBody>
@@ -3664,8 +3664,8 @@
         </p:nvSpPr>
         <p:spPr>
           <a:xfrm>
-            <a:off x="777240" y="7068312"/>
-            <a:ext cx="12938760" cy="285750"/>
+            <a:off x="777240" y="7059168"/>
+            <a:ext cx="12938760" cy="283464"/>
           </a:xfrm>
           <a:prstGeom prst="rect">
             <a:avLst/>
@@ -3696,7 +3696,7 @@
                 </a:solidFill>
                 <a:latin typeface="Arial"/>
               </a:rPr>
-              <a:t>project holdouts, three complete training runs, composition proxies, and member-gene review.</a:t>
+              <a:t>Literature review followed scoring. Retained programs were lower for thymic repair, skin maintenance, liver</a:t>
             </a:r>
           </a:p>
         </p:txBody>
@@ -3709,8 +3709,8 @@
         </p:nvSpPr>
         <p:spPr>
           <a:xfrm>
-            <a:off x="777240" y="7354062"/>
-            <a:ext cx="12938760" cy="285750"/>
+            <a:off x="777240" y="7342632"/>
+            <a:ext cx="12938760" cy="283464"/>
           </a:xfrm>
           <a:prstGeom prst="rect">
             <a:avLst/>
@@ -3741,104 +3741,14 @@
                 </a:solidFill>
                 <a:latin typeface="Arial"/>
               </a:rPr>
-              <a:t>Literature review was performed after scoring. Retained programs were lower for thymic repair,</a:t>
-            </a:r>
-          </a:p>
-        </p:txBody>
-      </p:sp>
-      <p:sp>
-        <p:nvSpPr>
-          <p:cNvPr id="17" name="TextBox 16"/>
-          <p:cNvSpPr txBox="1"/>
-          <p:nvPr/>
-        </p:nvSpPr>
-        <p:spPr>
-          <a:xfrm>
-            <a:off x="777240" y="7639812"/>
-            <a:ext cx="12938760" cy="285750"/>
-          </a:xfrm>
-          <a:prstGeom prst="rect">
-            <a:avLst/>
-          </a:prstGeom>
-          <a:noFill/>
-        </p:spPr>
-        <p:txBody>
-          <a:bodyPr wrap="none" lIns="0" rIns="0" tIns="0" bIns="0" anchor="ctr">
-            <a:noAutofit/>
-          </a:bodyPr>
-          <a:lstStyle/>
-          <a:p>
-            <a:pPr algn="l" latinLnBrk="0" eaLnBrk="0" hangingPunct="0">
-              <a:lnSpc>
-                <a:spcPct val="100000"/>
-              </a:lnSpc>
-              <a:spcBef>
-                <a:spcPts val="0"/>
-              </a:spcBef>
-              <a:spcAft>
-                <a:spcPts val="0"/>
-              </a:spcAft>
-            </a:pPr>
-            <a:r>
-              <a:rPr sz="1850" b="0" i="0">
-                <a:solidFill>
-                  <a:srgbClr val="33445D"/>
-                </a:solidFill>
-                <a:latin typeface="Arial"/>
-              </a:rPr>
-              <a:t>skin maintenance, liver adaptive immunity, and splenic adaptive and innate immunity.</a:t>
-            </a:r>
-          </a:p>
-        </p:txBody>
-      </p:sp>
-      <p:sp>
-        <p:nvSpPr>
-          <p:cNvPr id="18" name="TextBox 17"/>
-          <p:cNvSpPr txBox="1"/>
-          <p:nvPr/>
-        </p:nvSpPr>
-        <p:spPr>
-          <a:xfrm>
-            <a:off x="777240" y="7925562"/>
-            <a:ext cx="12938760" cy="285750"/>
-          </a:xfrm>
-          <a:prstGeom prst="rect">
-            <a:avLst/>
-          </a:prstGeom>
-          <a:noFill/>
-        </p:spPr>
-        <p:txBody>
-          <a:bodyPr wrap="none" lIns="0" rIns="0" tIns="0" bIns="0" anchor="ctr">
-            <a:noAutofit/>
-          </a:bodyPr>
-          <a:lstStyle/>
-          <a:p>
-            <a:pPr algn="l" latinLnBrk="0" eaLnBrk="0" hangingPunct="0">
-              <a:lnSpc>
-                <a:spcPct val="100000"/>
-              </a:lnSpc>
-              <a:spcBef>
-                <a:spcPts val="0"/>
-              </a:spcBef>
-              <a:spcAft>
-                <a:spcPts val="0"/>
-              </a:spcAft>
-            </a:pPr>
-            <a:r>
-              <a:rPr sz="1850" b="0" i="0">
-                <a:solidFill>
-                  <a:srgbClr val="33445D"/>
-                </a:solidFill>
-                <a:latin typeface="Arial"/>
-              </a:rPr>
-              <a:t>Spleen showed the strongest result across multiple pathways.</a:t>
-            </a:r>
-          </a:p>
-        </p:txBody>
-      </p:sp>
-      <p:sp>
-        <p:nvSpPr>
-          <p:cNvPr id="19" name="Rectangle 18"/>
+              <a:t>adaptive immunity, and splenic adaptive and innate immunity. Spleen showed the strongest multi-pathway result.</a:t>
+            </a:r>
+          </a:p>
+        </p:txBody>
+      </p:sp>
+      <p:sp>
+        <p:nvSpPr>
+          <p:cNvPr id="17" name="Rectangle 16"/>
           <p:cNvSpPr/>
           <p:nvPr/>
         </p:nvSpPr>
@@ -3881,7 +3791,7 @@
       </p:sp>
       <p:sp>
         <p:nvSpPr>
-          <p:cNvPr id="20" name="Rectangle 19"/>
+          <p:cNvPr id="18" name="Rectangle 17"/>
           <p:cNvSpPr/>
           <p:nvPr/>
         </p:nvSpPr>
@@ -3926,7 +3836,7 @@
       </p:sp>
       <p:sp>
         <p:nvSpPr>
-          <p:cNvPr id="21" name="TextBox 20"/>
+          <p:cNvPr id="19" name="TextBox 18"/>
           <p:cNvSpPr txBox="1"/>
           <p:nvPr/>
         </p:nvSpPr>
@@ -3971,7 +3881,7 @@
       </p:sp>
       <p:sp>
         <p:nvSpPr>
-          <p:cNvPr id="22" name="TextBox 21"/>
+          <p:cNvPr id="20" name="TextBox 19"/>
           <p:cNvSpPr txBox="1"/>
           <p:nvPr/>
         </p:nvSpPr>
@@ -4016,7 +3926,7 @@
       </p:sp>
       <p:sp>
         <p:nvSpPr>
-          <p:cNvPr id="23" name="TextBox 22"/>
+          <p:cNvPr id="21" name="TextBox 20"/>
           <p:cNvSpPr txBox="1"/>
           <p:nvPr/>
         </p:nvSpPr>
@@ -4061,7 +3971,7 @@
       </p:sp>
       <p:sp>
         <p:nvSpPr>
-          <p:cNvPr id="24" name="TextBox 23"/>
+          <p:cNvPr id="22" name="TextBox 21"/>
           <p:cNvSpPr txBox="1"/>
           <p:nvPr/>
         </p:nvSpPr>
@@ -4106,7 +4016,7 @@
       </p:sp>
       <p:sp>
         <p:nvSpPr>
-          <p:cNvPr id="25" name="TextBox 24"/>
+          <p:cNvPr id="23" name="TextBox 22"/>
           <p:cNvSpPr txBox="1"/>
           <p:nvPr/>
         </p:nvSpPr>
@@ -4151,7 +4061,7 @@
       </p:sp>
       <p:sp>
         <p:nvSpPr>
-          <p:cNvPr id="26" name="Rounded Rectangle 25"/>
+          <p:cNvPr id="24" name="Rounded Rectangle 23"/>
           <p:cNvSpPr/>
           <p:nvPr/>
         </p:nvSpPr>
@@ -4194,7 +4104,7 @@
       </p:sp>
       <p:sp>
         <p:nvSpPr>
-          <p:cNvPr id="27" name="TextBox 26"/>
+          <p:cNvPr id="25" name="TextBox 24"/>
           <p:cNvSpPr txBox="1"/>
           <p:nvPr/>
         </p:nvSpPr>
@@ -4239,7 +4149,7 @@
       </p:sp>
       <p:sp>
         <p:nvSpPr>
-          <p:cNvPr id="28" name="TextBox 27"/>
+          <p:cNvPr id="26" name="TextBox 25"/>
           <p:cNvSpPr txBox="1"/>
           <p:nvPr/>
         </p:nvSpPr>
@@ -4284,7 +4194,7 @@
       </p:sp>
       <p:sp>
         <p:nvSpPr>
-          <p:cNvPr id="29" name="Rounded Rectangle 28"/>
+          <p:cNvPr id="27" name="Rounded Rectangle 26"/>
           <p:cNvSpPr/>
           <p:nvPr/>
         </p:nvSpPr>
@@ -4327,7 +4237,7 @@
       </p:sp>
       <p:sp>
         <p:nvSpPr>
-          <p:cNvPr id="30" name="TextBox 29"/>
+          <p:cNvPr id="28" name="TextBox 27"/>
           <p:cNvSpPr txBox="1"/>
           <p:nvPr/>
         </p:nvSpPr>
@@ -4372,7 +4282,7 @@
       </p:sp>
       <p:sp>
         <p:nvSpPr>
-          <p:cNvPr id="31" name="TextBox 30"/>
+          <p:cNvPr id="29" name="TextBox 28"/>
           <p:cNvSpPr txBox="1"/>
           <p:nvPr/>
         </p:nvSpPr>
@@ -4417,7 +4327,7 @@
       </p:sp>
       <p:sp>
         <p:nvSpPr>
-          <p:cNvPr id="32" name="Rounded Rectangle 31"/>
+          <p:cNvPr id="30" name="Rounded Rectangle 29"/>
           <p:cNvSpPr/>
           <p:nvPr/>
         </p:nvSpPr>
@@ -4460,7 +4370,7 @@
       </p:sp>
       <p:sp>
         <p:nvSpPr>
-          <p:cNvPr id="33" name="TextBox 32"/>
+          <p:cNvPr id="31" name="TextBox 30"/>
           <p:cNvSpPr txBox="1"/>
           <p:nvPr/>
         </p:nvSpPr>
@@ -4505,7 +4415,7 @@
       </p:sp>
       <p:sp>
         <p:nvSpPr>
-          <p:cNvPr id="34" name="TextBox 33"/>
+          <p:cNvPr id="32" name="TextBox 31"/>
           <p:cNvSpPr txBox="1"/>
           <p:nvPr/>
         </p:nvSpPr>
@@ -4550,7 +4460,7 @@
       </p:sp>
       <p:sp>
         <p:nvSpPr>
-          <p:cNvPr id="35" name="Rounded Rectangle 34"/>
+          <p:cNvPr id="33" name="Rounded Rectangle 32"/>
           <p:cNvSpPr/>
           <p:nvPr/>
         </p:nvSpPr>
@@ -4593,7 +4503,7 @@
       </p:sp>
       <p:sp>
         <p:nvSpPr>
-          <p:cNvPr id="36" name="TextBox 35"/>
+          <p:cNvPr id="34" name="TextBox 33"/>
           <p:cNvSpPr txBox="1"/>
           <p:nvPr/>
         </p:nvSpPr>
@@ -4638,7 +4548,7 @@
       </p:sp>
       <p:sp>
         <p:nvSpPr>
-          <p:cNvPr id="37" name="TextBox 36"/>
+          <p:cNvPr id="35" name="TextBox 34"/>
           <p:cNvSpPr txBox="1"/>
           <p:nvPr/>
         </p:nvSpPr>
@@ -4676,14 +4586,14 @@
                 </a:solidFill>
                 <a:latin typeface="Arial"/>
               </a:rPr>
-              <a:t>Study identity and protocol can dominate an unconstrained expression representation.</a:t>
-            </a:r>
-          </a:p>
-        </p:txBody>
-      </p:sp>
-      <p:sp>
-        <p:nvSpPr>
-          <p:cNvPr id="38" name="TextBox 37"/>
+              <a:t>Study identity and protocol can dominate an unconstrained expression representation. Tissue-matched</a:t>
+            </a:r>
+          </a:p>
+        </p:txBody>
+      </p:sp>
+      <p:sp>
+        <p:nvSpPr>
+          <p:cNvPr id="36" name="TextBox 35"/>
           <p:cNvSpPr txBox="1"/>
           <p:nvPr/>
         </p:nvSpPr>
@@ -4721,14 +4631,14 @@
                 </a:solidFill>
                 <a:latin typeface="Arial"/>
               </a:rPr>
-              <a:t>Tissue-matched reference mapping, accession conditioning, and equal project weighting</a:t>
-            </a:r>
-          </a:p>
-        </p:txBody>
-      </p:sp>
-      <p:sp>
-        <p:nvSpPr>
-          <p:cNvPr id="39" name="TextBox 38"/>
+              <a:t>reference mapping, accession conditioning, and equal project weighting reduce this bias without claiming</a:t>
+            </a:r>
+          </a:p>
+        </p:txBody>
+      </p:sp>
+      <p:sp>
+        <p:nvSpPr>
+          <p:cNvPr id="37" name="TextBox 36"/>
           <p:cNvSpPr txBox="1"/>
           <p:nvPr/>
         </p:nvSpPr>
@@ -4766,14 +4676,14 @@
                 </a:solidFill>
                 <a:latin typeface="Arial"/>
               </a:rPr>
-              <a:t>reduce this bias without claiming to remove all mission confounding.</a:t>
-            </a:r>
-          </a:p>
-        </p:txBody>
-      </p:sp>
-      <p:sp>
-        <p:nvSpPr>
-          <p:cNvPr id="40" name="TextBox 39"/>
+              <a:t>to remove all mission confounding.</a:t>
+            </a:r>
+          </a:p>
+        </p:txBody>
+      </p:sp>
+      <p:sp>
+        <p:nvSpPr>
+          <p:cNvPr id="38" name="TextBox 37"/>
           <p:cNvSpPr txBox="1"/>
           <p:nvPr/>
         </p:nvSpPr>
@@ -4818,7 +4728,7 @@
       </p:sp>
       <p:graphicFrame>
         <p:nvGraphicFramePr>
-          <p:cNvPr id="41" name="Table 40"/>
+          <p:cNvPr id="39" name="Table 38"/>
           <p:cNvGraphicFramePr>
             <a:graphicFrameLocks noGrp="1"/>
           </p:cNvGraphicFramePr>
@@ -5432,14 +5342,14 @@
       </p:graphicFrame>
       <p:sp>
         <p:nvSpPr>
-          <p:cNvPr id="42" name="TextBox 41"/>
+          <p:cNvPr id="40" name="TextBox 39"/>
           <p:cNvSpPr txBox="1"/>
           <p:nvPr/>
         </p:nvSpPr>
         <p:spPr>
           <a:xfrm>
             <a:off x="822960" y="18260568"/>
-            <a:ext cx="12847320" cy="251460"/>
+            <a:ext cx="12847320" cy="274320"/>
           </a:xfrm>
           <a:prstGeom prst="rect">
             <a:avLst/>
@@ -5470,21 +5380,21 @@
                 </a:solidFill>
                 <a:latin typeface="Arial"/>
               </a:rPr>
-              <a:t>OSDR counts are primary analysis samples.</a:t>
-            </a:r>
-          </a:p>
-        </p:txBody>
-      </p:sp>
-      <p:sp>
-        <p:nvSpPr>
-          <p:cNvPr id="43" name="TextBox 42"/>
+              <a:t>OSDR counts are primary analysis samples. Spleen excludes one condition-strain-confounded project.</a:t>
+            </a:r>
+          </a:p>
+        </p:txBody>
+      </p:sp>
+      <p:sp>
+        <p:nvSpPr>
+          <p:cNvPr id="41" name="TextBox 40"/>
           <p:cNvSpPr txBox="1"/>
           <p:nvPr/>
         </p:nvSpPr>
         <p:spPr>
           <a:xfrm>
-            <a:off x="822960" y="18512027"/>
-            <a:ext cx="12847320" cy="251460"/>
+            <a:off x="822960" y="18882360"/>
+            <a:ext cx="12847320" cy="365760"/>
           </a:xfrm>
           <a:prstGeom prst="rect">
             <a:avLst/>
@@ -5492,8 +5402,8 @@
           <a:noFill/>
         </p:spPr>
         <p:txBody>
-          <a:bodyPr wrap="none" lIns="0" rIns="0" tIns="0" bIns="0" anchor="ctr">
-            <a:noAutofit/>
+          <a:bodyPr wrap="square" lIns="0" rIns="0" tIns="0" bIns="0" anchor="t">
+            <a:spAutoFit/>
           </a:bodyPr>
           <a:lstStyle/>
           <a:p>
@@ -5509,51 +5419,6 @@
               </a:spcAft>
             </a:pPr>
             <a:r>
-              <a:rPr sz="1450" b="0" i="1">
-                <a:solidFill>
-                  <a:srgbClr val="697889"/>
-                </a:solidFill>
-                <a:latin typeface="Arial"/>
-              </a:rPr>
-              <a:t>Spleen excludes one condition-strain-confounded project.</a:t>
-            </a:r>
-          </a:p>
-        </p:txBody>
-      </p:sp>
-      <p:sp>
-        <p:nvSpPr>
-          <p:cNvPr id="44" name="TextBox 43"/>
-          <p:cNvSpPr txBox="1"/>
-          <p:nvPr/>
-        </p:nvSpPr>
-        <p:spPr>
-          <a:xfrm>
-            <a:off x="822960" y="18882360"/>
-            <a:ext cx="12847320" cy="365760"/>
-          </a:xfrm>
-          <a:prstGeom prst="rect">
-            <a:avLst/>
-          </a:prstGeom>
-          <a:noFill/>
-        </p:spPr>
-        <p:txBody>
-          <a:bodyPr wrap="square" lIns="0" rIns="0" tIns="0" bIns="0" anchor="t">
-            <a:spAutoFit/>
-          </a:bodyPr>
-          <a:lstStyle/>
-          <a:p>
-            <a:pPr algn="l" latinLnBrk="0" eaLnBrk="0" hangingPunct="0">
-              <a:lnSpc>
-                <a:spcPct val="100000"/>
-              </a:lnSpc>
-              <a:spcBef>
-                <a:spcPts val="0"/>
-              </a:spcBef>
-              <a:spcAft>
-                <a:spcPts val="0"/>
-              </a:spcAft>
-            </a:pPr>
-            <a:r>
               <a:rPr sz="1900" b="1" i="0">
                 <a:solidFill>
                   <a:srgbClr val="9A6D1D"/>
@@ -5567,7 +5432,7 @@
       </p:sp>
       <p:sp>
         <p:nvSpPr>
-          <p:cNvPr id="45" name="Rounded Rectangle 44"/>
+          <p:cNvPr id="42" name="Rounded Rectangle 41"/>
           <p:cNvSpPr/>
           <p:nvPr/>
         </p:nvSpPr>
@@ -5614,7 +5479,7 @@
       </p:sp>
       <p:sp>
         <p:nvSpPr>
-          <p:cNvPr id="46" name="TextBox 45"/>
+          <p:cNvPr id="43" name="TextBox 42"/>
           <p:cNvSpPr txBox="1"/>
           <p:nvPr/>
         </p:nvSpPr>
@@ -5659,7 +5524,7 @@
       </p:sp>
       <p:sp>
         <p:nvSpPr>
-          <p:cNvPr id="47" name="Rounded Rectangle 46"/>
+          <p:cNvPr id="44" name="Rounded Rectangle 43"/>
           <p:cNvSpPr/>
           <p:nvPr/>
         </p:nvSpPr>
@@ -5706,7 +5571,7 @@
       </p:sp>
       <p:sp>
         <p:nvSpPr>
-          <p:cNvPr id="48" name="TextBox 47"/>
+          <p:cNvPr id="45" name="TextBox 44"/>
           <p:cNvSpPr txBox="1"/>
           <p:nvPr/>
         </p:nvSpPr>
@@ -5751,7 +5616,7 @@
       </p:sp>
       <p:sp>
         <p:nvSpPr>
-          <p:cNvPr id="49" name="Rounded Rectangle 48"/>
+          <p:cNvPr id="46" name="Rounded Rectangle 45"/>
           <p:cNvSpPr/>
           <p:nvPr/>
         </p:nvSpPr>
@@ -5798,7 +5663,7 @@
       </p:sp>
       <p:sp>
         <p:nvSpPr>
-          <p:cNvPr id="50" name="TextBox 49"/>
+          <p:cNvPr id="47" name="TextBox 46"/>
           <p:cNvSpPr txBox="1"/>
           <p:nvPr/>
         </p:nvSpPr>
@@ -5843,7 +5708,7 @@
       </p:sp>
       <p:sp>
         <p:nvSpPr>
-          <p:cNvPr id="51" name="Rounded Rectangle 50"/>
+          <p:cNvPr id="48" name="Rounded Rectangle 47"/>
           <p:cNvSpPr/>
           <p:nvPr/>
         </p:nvSpPr>
@@ -5890,7 +5755,7 @@
       </p:sp>
       <p:sp>
         <p:nvSpPr>
-          <p:cNvPr id="52" name="TextBox 51"/>
+          <p:cNvPr id="49" name="TextBox 48"/>
           <p:cNvSpPr txBox="1"/>
           <p:nvPr/>
         </p:nvSpPr>
@@ -5935,7 +5800,7 @@
       </p:sp>
       <p:sp>
         <p:nvSpPr>
-          <p:cNvPr id="53" name="Rounded Rectangle 52"/>
+          <p:cNvPr id="50" name="Rounded Rectangle 49"/>
           <p:cNvSpPr/>
           <p:nvPr/>
         </p:nvSpPr>
@@ -5982,7 +5847,7 @@
       </p:sp>
       <p:sp>
         <p:nvSpPr>
-          <p:cNvPr id="54" name="TextBox 53"/>
+          <p:cNvPr id="51" name="TextBox 50"/>
           <p:cNvSpPr txBox="1"/>
           <p:nvPr/>
         </p:nvSpPr>
@@ -6027,7 +5892,7 @@
       </p:sp>
       <p:sp>
         <p:nvSpPr>
-          <p:cNvPr id="55" name="Rounded Rectangle 54"/>
+          <p:cNvPr id="52" name="Rounded Rectangle 51"/>
           <p:cNvSpPr/>
           <p:nvPr/>
         </p:nvSpPr>
@@ -6074,7 +5939,7 @@
       </p:sp>
       <p:sp>
         <p:nvSpPr>
-          <p:cNvPr id="56" name="TextBox 55"/>
+          <p:cNvPr id="53" name="TextBox 52"/>
           <p:cNvSpPr txBox="1"/>
           <p:nvPr/>
         </p:nvSpPr>
@@ -6119,14 +5984,14 @@
       </p:sp>
       <p:sp>
         <p:nvSpPr>
-          <p:cNvPr id="57" name="TextBox 56"/>
+          <p:cNvPr id="54" name="TextBox 53"/>
           <p:cNvSpPr txBox="1"/>
           <p:nvPr/>
         </p:nvSpPr>
         <p:spPr>
           <a:xfrm>
             <a:off x="822960" y="21104352"/>
-            <a:ext cx="12847320" cy="301752"/>
+            <a:ext cx="12847320" cy="256032"/>
           </a:xfrm>
           <a:prstGeom prst="rect">
             <a:avLst/>
@@ -6157,21 +6022,21 @@
                 </a:solidFill>
                 <a:latin typeface="Arial"/>
               </a:rPr>
-              <a:t>Complementary programs add a plausible perspective beyond the dominant phenotype</a:t>
-            </a:r>
-          </a:p>
-        </p:txBody>
-      </p:sp>
-      <p:sp>
-        <p:nvSpPr>
-          <p:cNvPr id="58" name="TextBox 57"/>
+              <a:t>Complementary programs add a plausible perspective beyond the dominant phenotype in prior literature. De novo</a:t>
+            </a:r>
+          </a:p>
+        </p:txBody>
+      </p:sp>
+      <p:sp>
+        <p:nvSpPr>
+          <p:cNvPr id="55" name="TextBox 54"/>
           <p:cNvSpPr txBox="1"/>
           <p:nvPr/>
         </p:nvSpPr>
         <p:spPr>
           <a:xfrm>
-            <a:off x="822960" y="21406103"/>
-            <a:ext cx="12847320" cy="301752"/>
+            <a:off x="822960" y="21360384"/>
+            <a:ext cx="12847320" cy="256032"/>
           </a:xfrm>
           <a:prstGeom prst="rect">
             <a:avLst/>
@@ -6202,14 +6067,14 @@
                 </a:solidFill>
                 <a:latin typeface="Arial"/>
               </a:rPr>
-              <a:t>in prior literature. De novo nodes were not retained in the final models.</a:t>
-            </a:r>
-          </a:p>
-        </p:txBody>
-      </p:sp>
-      <p:sp>
-        <p:nvSpPr>
-          <p:cNvPr id="59" name="Rectangle 58"/>
+              <a:t>nodes were not retained in the final models.</a:t>
+            </a:r>
+          </a:p>
+        </p:txBody>
+      </p:sp>
+      <p:sp>
+        <p:nvSpPr>
+          <p:cNvPr id="56" name="Rectangle 55"/>
           <p:cNvSpPr/>
           <p:nvPr/>
         </p:nvSpPr>
@@ -6252,7 +6117,7 @@
       </p:sp>
       <p:sp>
         <p:nvSpPr>
-          <p:cNvPr id="60" name="Rectangle 59"/>
+          <p:cNvPr id="57" name="Rectangle 56"/>
           <p:cNvSpPr/>
           <p:nvPr/>
         </p:nvSpPr>
@@ -6297,7 +6162,7 @@
       </p:sp>
       <p:sp>
         <p:nvSpPr>
-          <p:cNvPr id="61" name="TextBox 60"/>
+          <p:cNvPr id="58" name="TextBox 57"/>
           <p:cNvSpPr txBox="1"/>
           <p:nvPr/>
         </p:nvSpPr>
@@ -6342,7 +6207,7 @@
       </p:sp>
       <p:sp>
         <p:nvSpPr>
-          <p:cNvPr id="62" name="TextBox 61"/>
+          <p:cNvPr id="59" name="TextBox 58"/>
           <p:cNvSpPr txBox="1"/>
           <p:nvPr/>
         </p:nvSpPr>
@@ -6387,7 +6252,7 @@
       </p:sp>
       <p:sp>
         <p:nvSpPr>
-          <p:cNvPr id="63" name="TextBox 62"/>
+          <p:cNvPr id="60" name="TextBox 59"/>
           <p:cNvSpPr txBox="1"/>
           <p:nvPr/>
         </p:nvSpPr>
@@ -6432,7 +6297,7 @@
       </p:sp>
       <p:sp>
         <p:nvSpPr>
-          <p:cNvPr id="64" name="TextBox 63"/>
+          <p:cNvPr id="61" name="TextBox 60"/>
           <p:cNvSpPr txBox="1"/>
           <p:nvPr/>
         </p:nvSpPr>
@@ -6477,7 +6342,7 @@
       </p:sp>
       <p:sp>
         <p:nvSpPr>
-          <p:cNvPr id="65" name="Rounded Rectangle 64"/>
+          <p:cNvPr id="62" name="Rounded Rectangle 61"/>
           <p:cNvSpPr/>
           <p:nvPr/>
         </p:nvSpPr>
@@ -6556,7 +6421,7 @@
       </p:sp>
       <p:sp>
         <p:nvSpPr>
-          <p:cNvPr id="66" name="Right Arrow 65"/>
+          <p:cNvPr id="63" name="Right Arrow 62"/>
           <p:cNvSpPr/>
           <p:nvPr/>
         </p:nvSpPr>
@@ -6599,7 +6464,7 @@
       </p:sp>
       <p:sp>
         <p:nvSpPr>
-          <p:cNvPr id="67" name="Rounded Rectangle 66"/>
+          <p:cNvPr id="64" name="Rounded Rectangle 63"/>
           <p:cNvSpPr/>
           <p:nvPr/>
         </p:nvSpPr>
@@ -6646,7 +6511,7 @@
       </p:sp>
       <p:sp>
         <p:nvSpPr>
-          <p:cNvPr id="68" name="TextBox 67"/>
+          <p:cNvPr id="65" name="TextBox 64"/>
           <p:cNvSpPr txBox="1"/>
           <p:nvPr/>
         </p:nvSpPr>
@@ -6691,7 +6556,7 @@
       </p:sp>
       <p:sp>
         <p:nvSpPr>
-          <p:cNvPr id="69" name="Oval 68"/>
+          <p:cNvPr id="66" name="Oval 65"/>
           <p:cNvSpPr/>
           <p:nvPr/>
         </p:nvSpPr>
@@ -6734,7 +6599,7 @@
       </p:sp>
       <p:sp>
         <p:nvSpPr>
-          <p:cNvPr id="70" name="Oval 69"/>
+          <p:cNvPr id="67" name="Oval 66"/>
           <p:cNvSpPr/>
           <p:nvPr/>
         </p:nvSpPr>
@@ -6777,7 +6642,7 @@
       </p:sp>
       <p:sp>
         <p:nvSpPr>
-          <p:cNvPr id="71" name="Oval 70"/>
+          <p:cNvPr id="68" name="Oval 67"/>
           <p:cNvSpPr/>
           <p:nvPr/>
         </p:nvSpPr>
@@ -6820,7 +6685,7 @@
       </p:sp>
       <p:sp>
         <p:nvSpPr>
-          <p:cNvPr id="72" name="Oval 71"/>
+          <p:cNvPr id="69" name="Oval 68"/>
           <p:cNvSpPr/>
           <p:nvPr/>
         </p:nvSpPr>
@@ -6863,7 +6728,7 @@
       </p:sp>
       <p:sp>
         <p:nvSpPr>
-          <p:cNvPr id="73" name="Trapezoid 72"/>
+          <p:cNvPr id="70" name="Trapezoid 69"/>
           <p:cNvSpPr/>
           <p:nvPr/>
         </p:nvSpPr>
@@ -6908,7 +6773,7 @@
       </p:sp>
       <p:sp>
         <p:nvSpPr>
-          <p:cNvPr id="74" name="TextBox 73"/>
+          <p:cNvPr id="71" name="TextBox 70"/>
           <p:cNvSpPr txBox="1"/>
           <p:nvPr/>
         </p:nvSpPr>
@@ -6953,14 +6818,119 @@
       </p:sp>
       <p:cxnSp>
         <p:nvCxnSpPr>
+          <p:cNvPr id="72" name="Connector 71"/>
+          <p:cNvCxnSpPr/>
+          <p:nvPr/>
+        </p:nvCxnSpPr>
+        <p:spPr>
+          <a:xfrm>
+            <a:off x="19604735" y="7854695"/>
+            <a:ext cx="301753" cy="420625"/>
+          </a:xfrm>
+          <a:prstGeom prst="line">
+            <a:avLst/>
+          </a:prstGeom>
+          <a:ln w="10160">
+            <a:solidFill>
+              <a:srgbClr val="A9BBD0"/>
+            </a:solidFill>
+          </a:ln>
+        </p:spPr>
+        <p:style>
+          <a:lnRef idx="2">
+            <a:schemeClr val="accent1"/>
+          </a:lnRef>
+          <a:fillRef idx="0">
+            <a:schemeClr val="accent1"/>
+          </a:fillRef>
+          <a:effectRef idx="1">
+            <a:schemeClr val="accent1"/>
+          </a:effectRef>
+          <a:fontRef idx="minor">
+            <a:schemeClr val="tx1"/>
+          </a:fontRef>
+        </p:style>
+      </p:cxnSp>
+      <p:cxnSp>
+        <p:nvCxnSpPr>
+          <p:cNvPr id="73" name="Connector 72"/>
+          <p:cNvCxnSpPr/>
+          <p:nvPr/>
+        </p:nvCxnSpPr>
+        <p:spPr>
+          <a:xfrm>
+            <a:off x="19604735" y="8238743"/>
+            <a:ext cx="301753" cy="36577"/>
+          </a:xfrm>
+          <a:prstGeom prst="line">
+            <a:avLst/>
+          </a:prstGeom>
+          <a:ln w="10160">
+            <a:solidFill>
+              <a:srgbClr val="A9BBD0"/>
+            </a:solidFill>
+          </a:ln>
+        </p:spPr>
+        <p:style>
+          <a:lnRef idx="2">
+            <a:schemeClr val="accent1"/>
+          </a:lnRef>
+          <a:fillRef idx="0">
+            <a:schemeClr val="accent1"/>
+          </a:fillRef>
+          <a:effectRef idx="1">
+            <a:schemeClr val="accent1"/>
+          </a:effectRef>
+          <a:fontRef idx="minor">
+            <a:schemeClr val="tx1"/>
+          </a:fontRef>
+        </p:style>
+      </p:cxnSp>
+      <p:cxnSp>
+        <p:nvCxnSpPr>
+          <p:cNvPr id="74" name="Connector 73"/>
+          <p:cNvCxnSpPr/>
+          <p:nvPr/>
+        </p:nvCxnSpPr>
+        <p:spPr>
+          <a:xfrm flipV="1">
+            <a:off x="19604735" y="8275320"/>
+            <a:ext cx="301753" cy="347471"/>
+          </a:xfrm>
+          <a:prstGeom prst="line">
+            <a:avLst/>
+          </a:prstGeom>
+          <a:ln w="10160">
+            <a:solidFill>
+              <a:srgbClr val="A9BBD0"/>
+            </a:solidFill>
+          </a:ln>
+        </p:spPr>
+        <p:style>
+          <a:lnRef idx="2">
+            <a:schemeClr val="accent1"/>
+          </a:lnRef>
+          <a:fillRef idx="0">
+            <a:schemeClr val="accent1"/>
+          </a:fillRef>
+          <a:effectRef idx="1">
+            <a:schemeClr val="accent1"/>
+          </a:effectRef>
+          <a:fontRef idx="minor">
+            <a:schemeClr val="tx1"/>
+          </a:fontRef>
+        </p:style>
+      </p:cxnSp>
+      <p:cxnSp>
+        <p:nvCxnSpPr>
           <p:cNvPr id="75" name="Connector 74"/>
           <p:cNvCxnSpPr/>
           <p:nvPr/>
         </p:nvCxnSpPr>
         <p:spPr>
-          <a:xfrm>
-            <a:off x="19604735" y="7854695"/>
-            <a:ext cx="301753" cy="420625"/>
+          <a:xfrm flipV="1">
+            <a:off x="19604735" y="8275320"/>
+            <a:ext cx="301753" cy="731519"/>
           </a:xfrm>
           <a:prstGeom prst="line">
             <a:avLst/>
@@ -6993,16 +6963,526 @@
           <p:nvPr/>
         </p:nvCxnSpPr>
         <p:spPr>
-          <a:xfrm>
-            <a:off x="19604735" y="8238743"/>
-            <a:ext cx="301753" cy="36577"/>
+          <a:xfrm flipV="1">
+            <a:off x="21186648" y="7799831"/>
+            <a:ext cx="457200" cy="475489"/>
           </a:xfrm>
           <a:prstGeom prst="line">
             <a:avLst/>
           </a:prstGeom>
-          <a:ln w="10160">
+          <a:ln w="11430">
             <a:solidFill>
               <a:srgbClr val="A9BBD0"/>
+            </a:solidFill>
+          </a:ln>
+        </p:spPr>
+        <p:style>
+          <a:lnRef idx="2">
+            <a:schemeClr val="accent1"/>
+          </a:lnRef>
+          <a:fillRef idx="0">
+            <a:schemeClr val="accent1"/>
+          </a:fillRef>
+          <a:effectRef idx="1">
+            <a:schemeClr val="accent1"/>
+          </a:effectRef>
+          <a:fontRef idx="minor">
+            <a:schemeClr val="tx1"/>
+          </a:fontRef>
+        </p:style>
+      </p:cxnSp>
+      <p:sp>
+        <p:nvSpPr>
+          <p:cNvPr id="77" name="Oval 76"/>
+          <p:cNvSpPr/>
+          <p:nvPr/>
+        </p:nvSpPr>
+        <p:spPr>
+          <a:xfrm>
+            <a:off x="21643848" y="7653527"/>
+            <a:ext cx="292608" cy="292608"/>
+          </a:xfrm>
+          <a:prstGeom prst="ellipse">
+            <a:avLst/>
+          </a:prstGeom>
+          <a:solidFill>
+            <a:srgbClr val="6A4C93"/>
+          </a:solidFill>
+          <a:ln>
+            <a:noFill/>
+          </a:ln>
+        </p:spPr>
+        <p:style>
+          <a:lnRef idx="1">
+            <a:schemeClr val="accent1"/>
+          </a:lnRef>
+          <a:fillRef idx="3">
+            <a:schemeClr val="accent1"/>
+          </a:fillRef>
+          <a:effectRef idx="2">
+            <a:schemeClr val="accent1"/>
+          </a:effectRef>
+          <a:fontRef idx="minor">
+            <a:schemeClr val="lt1"/>
+          </a:fontRef>
+        </p:style>
+        <p:txBody>
+          <a:bodyPr rtlCol="0" anchor="ctr"/>
+          <a:lstStyle/>
+          <a:p>
+            <a:pPr algn="ctr"/>
+          </a:p>
+        </p:txBody>
+      </p:sp>
+      <p:sp>
+        <p:nvSpPr>
+          <p:cNvPr id="78" name="Rounded Rectangle 77"/>
+          <p:cNvSpPr/>
+          <p:nvPr/>
+        </p:nvSpPr>
+        <p:spPr>
+          <a:xfrm>
+            <a:off x="22009608" y="7635240"/>
+            <a:ext cx="2029968" cy="329184"/>
+          </a:xfrm>
+          <a:prstGeom prst="roundRect">
+            <a:avLst>
+              <a:gd name="adj" fmla="val 8000"/>
+            </a:avLst>
+          </a:prstGeom>
+          <a:solidFill>
+            <a:srgbClr val="F8FAFC"/>
+          </a:solidFill>
+          <a:ln w="11430">
+            <a:solidFill>
+              <a:srgbClr val="6A4C93"/>
+            </a:solidFill>
+          </a:ln>
+        </p:spPr>
+        <p:style>
+          <a:lnRef idx="1">
+            <a:schemeClr val="accent1"/>
+          </a:lnRef>
+          <a:fillRef idx="3">
+            <a:schemeClr val="accent1"/>
+          </a:fillRef>
+          <a:effectRef idx="2">
+            <a:schemeClr val="accent1"/>
+          </a:effectRef>
+          <a:fontRef idx="minor">
+            <a:schemeClr val="lt1"/>
+          </a:fontRef>
+        </p:style>
+        <p:txBody>
+          <a:bodyPr rtlCol="0" anchor="ctr"/>
+          <a:lstStyle/>
+          <a:p>
+            <a:pPr algn="ctr"/>
+          </a:p>
+        </p:txBody>
+      </p:sp>
+      <p:sp>
+        <p:nvSpPr>
+          <p:cNvPr id="79" name="TextBox 78"/>
+          <p:cNvSpPr txBox="1"/>
+          <p:nvPr/>
+        </p:nvSpPr>
+        <p:spPr>
+          <a:xfrm>
+            <a:off x="22101048" y="7635240"/>
+            <a:ext cx="1847088" cy="329184"/>
+          </a:xfrm>
+          <a:prstGeom prst="rect">
+            <a:avLst/>
+          </a:prstGeom>
+          <a:noFill/>
+        </p:spPr>
+        <p:txBody>
+          <a:bodyPr wrap="none" lIns="0" rIns="0" tIns="0" bIns="0" anchor="ctr">
+            <a:spAutoFit/>
+          </a:bodyPr>
+          <a:lstStyle/>
+          <a:p>
+            <a:pPr algn="ctr" latinLnBrk="0" eaLnBrk="0" hangingPunct="0">
+              <a:lnSpc>
+                <a:spcPct val="100000"/>
+              </a:lnSpc>
+              <a:spcBef>
+                <a:spcPts val="0"/>
+              </a:spcBef>
+              <a:spcAft>
+                <a:spcPts val="0"/>
+              </a:spcAft>
+            </a:pPr>
+            <a:r>
+              <a:rPr sz="1550" b="1" i="0">
+                <a:solidFill>
+                  <a:srgbClr val="6A4C93"/>
+                </a:solidFill>
+                <a:latin typeface="Arial"/>
+              </a:rPr>
+              <a:t>DNA repair</a:t>
+            </a:r>
+          </a:p>
+        </p:txBody>
+      </p:sp>
+      <p:cxnSp>
+        <p:nvCxnSpPr>
+          <p:cNvPr id="80" name="Connector 79"/>
+          <p:cNvCxnSpPr/>
+          <p:nvPr/>
+        </p:nvCxnSpPr>
+        <p:spPr>
+          <a:xfrm flipV="1">
+            <a:off x="21186648" y="8238744"/>
+            <a:ext cx="457200" cy="36576"/>
+          </a:xfrm>
+          <a:prstGeom prst="line">
+            <a:avLst/>
+          </a:prstGeom>
+          <a:ln w="11430">
+            <a:solidFill>
+              <a:srgbClr val="A9BBD0"/>
+            </a:solidFill>
+          </a:ln>
+        </p:spPr>
+        <p:style>
+          <a:lnRef idx="2">
+            <a:schemeClr val="accent1"/>
+          </a:lnRef>
+          <a:fillRef idx="0">
+            <a:schemeClr val="accent1"/>
+          </a:fillRef>
+          <a:effectRef idx="1">
+            <a:schemeClr val="accent1"/>
+          </a:effectRef>
+          <a:fontRef idx="minor">
+            <a:schemeClr val="tx1"/>
+          </a:fontRef>
+        </p:style>
+      </p:cxnSp>
+      <p:sp>
+        <p:nvSpPr>
+          <p:cNvPr id="81" name="Oval 80"/>
+          <p:cNvSpPr/>
+          <p:nvPr/>
+        </p:nvSpPr>
+        <p:spPr>
+          <a:xfrm>
+            <a:off x="21643848" y="8092440"/>
+            <a:ext cx="292608" cy="292608"/>
+          </a:xfrm>
+          <a:prstGeom prst="ellipse">
+            <a:avLst/>
+          </a:prstGeom>
+          <a:solidFill>
+            <a:srgbClr val="A64D67"/>
+          </a:solidFill>
+          <a:ln>
+            <a:noFill/>
+          </a:ln>
+        </p:spPr>
+        <p:style>
+          <a:lnRef idx="1">
+            <a:schemeClr val="accent1"/>
+          </a:lnRef>
+          <a:fillRef idx="3">
+            <a:schemeClr val="accent1"/>
+          </a:fillRef>
+          <a:effectRef idx="2">
+            <a:schemeClr val="accent1"/>
+          </a:effectRef>
+          <a:fontRef idx="minor">
+            <a:schemeClr val="lt1"/>
+          </a:fontRef>
+        </p:style>
+        <p:txBody>
+          <a:bodyPr rtlCol="0" anchor="ctr"/>
+          <a:lstStyle/>
+          <a:p>
+            <a:pPr algn="ctr"/>
+          </a:p>
+        </p:txBody>
+      </p:sp>
+      <p:sp>
+        <p:nvSpPr>
+          <p:cNvPr id="82" name="Rounded Rectangle 81"/>
+          <p:cNvSpPr/>
+          <p:nvPr/>
+        </p:nvSpPr>
+        <p:spPr>
+          <a:xfrm>
+            <a:off x="22009608" y="8074152"/>
+            <a:ext cx="2029968" cy="329184"/>
+          </a:xfrm>
+          <a:prstGeom prst="roundRect">
+            <a:avLst>
+              <a:gd name="adj" fmla="val 8000"/>
+            </a:avLst>
+          </a:prstGeom>
+          <a:solidFill>
+            <a:srgbClr val="F8FAFC"/>
+          </a:solidFill>
+          <a:ln w="11430">
+            <a:solidFill>
+              <a:srgbClr val="A64D67"/>
+            </a:solidFill>
+          </a:ln>
+        </p:spPr>
+        <p:style>
+          <a:lnRef idx="1">
+            <a:schemeClr val="accent1"/>
+          </a:lnRef>
+          <a:fillRef idx="3">
+            <a:schemeClr val="accent1"/>
+          </a:fillRef>
+          <a:effectRef idx="2">
+            <a:schemeClr val="accent1"/>
+          </a:effectRef>
+          <a:fontRef idx="minor">
+            <a:schemeClr val="lt1"/>
+          </a:fontRef>
+        </p:style>
+        <p:txBody>
+          <a:bodyPr rtlCol="0" anchor="ctr"/>
+          <a:lstStyle/>
+          <a:p>
+            <a:pPr algn="ctr"/>
+          </a:p>
+        </p:txBody>
+      </p:sp>
+      <p:sp>
+        <p:nvSpPr>
+          <p:cNvPr id="83" name="TextBox 82"/>
+          <p:cNvSpPr txBox="1"/>
+          <p:nvPr/>
+        </p:nvSpPr>
+        <p:spPr>
+          <a:xfrm>
+            <a:off x="22101048" y="8074152"/>
+            <a:ext cx="1847088" cy="329184"/>
+          </a:xfrm>
+          <a:prstGeom prst="rect">
+            <a:avLst/>
+          </a:prstGeom>
+          <a:noFill/>
+        </p:spPr>
+        <p:txBody>
+          <a:bodyPr wrap="none" lIns="0" rIns="0" tIns="0" bIns="0" anchor="ctr">
+            <a:spAutoFit/>
+          </a:bodyPr>
+          <a:lstStyle/>
+          <a:p>
+            <a:pPr algn="ctr" latinLnBrk="0" eaLnBrk="0" hangingPunct="0">
+              <a:lnSpc>
+                <a:spcPct val="100000"/>
+              </a:lnSpc>
+              <a:spcBef>
+                <a:spcPts val="0"/>
+              </a:spcBef>
+              <a:spcAft>
+                <a:spcPts val="0"/>
+              </a:spcAft>
+            </a:pPr>
+            <a:r>
+              <a:rPr sz="1550" b="1" i="0">
+                <a:solidFill>
+                  <a:srgbClr val="A64D67"/>
+                </a:solidFill>
+                <a:latin typeface="Arial"/>
+              </a:rPr>
+              <a:t>T-cell signaling</a:t>
+            </a:r>
+          </a:p>
+        </p:txBody>
+      </p:sp>
+      <p:cxnSp>
+        <p:nvCxnSpPr>
+          <p:cNvPr id="84" name="Connector 83"/>
+          <p:cNvCxnSpPr/>
+          <p:nvPr/>
+        </p:nvCxnSpPr>
+        <p:spPr>
+          <a:xfrm>
+            <a:off x="21186648" y="8275320"/>
+            <a:ext cx="457200" cy="402336"/>
+          </a:xfrm>
+          <a:prstGeom prst="line">
+            <a:avLst/>
+          </a:prstGeom>
+          <a:ln w="11430">
+            <a:solidFill>
+              <a:srgbClr val="A9BBD0"/>
+            </a:solidFill>
+          </a:ln>
+        </p:spPr>
+        <p:style>
+          <a:lnRef idx="2">
+            <a:schemeClr val="accent1"/>
+          </a:lnRef>
+          <a:fillRef idx="0">
+            <a:schemeClr val="accent1"/>
+          </a:fillRef>
+          <a:effectRef idx="1">
+            <a:schemeClr val="accent1"/>
+          </a:effectRef>
+          <a:fontRef idx="minor">
+            <a:schemeClr val="tx1"/>
+          </a:fontRef>
+        </p:style>
+      </p:cxnSp>
+      <p:sp>
+        <p:nvSpPr>
+          <p:cNvPr id="85" name="Oval 84"/>
+          <p:cNvSpPr/>
+          <p:nvPr/>
+        </p:nvSpPr>
+        <p:spPr>
+          <a:xfrm>
+            <a:off x="21643848" y="8531352"/>
+            <a:ext cx="292608" cy="292608"/>
+          </a:xfrm>
+          <a:prstGeom prst="ellipse">
+            <a:avLst/>
+          </a:prstGeom>
+          <a:solidFill>
+            <a:srgbClr val="C65D37"/>
+          </a:solidFill>
+          <a:ln>
+            <a:noFill/>
+          </a:ln>
+        </p:spPr>
+        <p:style>
+          <a:lnRef idx="1">
+            <a:schemeClr val="accent1"/>
+          </a:lnRef>
+          <a:fillRef idx="3">
+            <a:schemeClr val="accent1"/>
+          </a:fillRef>
+          <a:effectRef idx="2">
+            <a:schemeClr val="accent1"/>
+          </a:effectRef>
+          <a:fontRef idx="minor">
+            <a:schemeClr val="lt1"/>
+          </a:fontRef>
+        </p:style>
+        <p:txBody>
+          <a:bodyPr rtlCol="0" anchor="ctr"/>
+          <a:lstStyle/>
+          <a:p>
+            <a:pPr algn="ctr"/>
+          </a:p>
+        </p:txBody>
+      </p:sp>
+      <p:sp>
+        <p:nvSpPr>
+          <p:cNvPr id="86" name="Rounded Rectangle 85"/>
+          <p:cNvSpPr/>
+          <p:nvPr/>
+        </p:nvSpPr>
+        <p:spPr>
+          <a:xfrm>
+            <a:off x="22009608" y="8513064"/>
+            <a:ext cx="2029968" cy="329184"/>
+          </a:xfrm>
+          <a:prstGeom prst="roundRect">
+            <a:avLst>
+              <a:gd name="adj" fmla="val 8000"/>
+            </a:avLst>
+          </a:prstGeom>
+          <a:solidFill>
+            <a:srgbClr val="F8FAFC"/>
+          </a:solidFill>
+          <a:ln w="11430">
+            <a:solidFill>
+              <a:srgbClr val="C65D37"/>
+            </a:solidFill>
+          </a:ln>
+        </p:spPr>
+        <p:style>
+          <a:lnRef idx="1">
+            <a:schemeClr val="accent1"/>
+          </a:lnRef>
+          <a:fillRef idx="3">
+            <a:schemeClr val="accent1"/>
+          </a:fillRef>
+          <a:effectRef idx="2">
+            <a:schemeClr val="accent1"/>
+          </a:effectRef>
+          <a:fontRef idx="minor">
+            <a:schemeClr val="lt1"/>
+          </a:fontRef>
+        </p:style>
+        <p:txBody>
+          <a:bodyPr rtlCol="0" anchor="ctr"/>
+          <a:lstStyle/>
+          <a:p>
+            <a:pPr algn="ctr"/>
+          </a:p>
+        </p:txBody>
+      </p:sp>
+      <p:sp>
+        <p:nvSpPr>
+          <p:cNvPr id="87" name="TextBox 86"/>
+          <p:cNvSpPr txBox="1"/>
+          <p:nvPr/>
+        </p:nvSpPr>
+        <p:spPr>
+          <a:xfrm>
+            <a:off x="22101048" y="8513064"/>
+            <a:ext cx="1847088" cy="329184"/>
+          </a:xfrm>
+          <a:prstGeom prst="rect">
+            <a:avLst/>
+          </a:prstGeom>
+          <a:noFill/>
+        </p:spPr>
+        <p:txBody>
+          <a:bodyPr wrap="none" lIns="0" rIns="0" tIns="0" bIns="0" anchor="ctr">
+            <a:spAutoFit/>
+          </a:bodyPr>
+          <a:lstStyle/>
+          <a:p>
+            <a:pPr algn="ctr" latinLnBrk="0" eaLnBrk="0" hangingPunct="0">
+              <a:lnSpc>
+                <a:spcPct val="100000"/>
+              </a:lnSpc>
+              <a:spcBef>
+                <a:spcPts val="0"/>
+              </a:spcBef>
+              <a:spcAft>
+                <a:spcPts val="0"/>
+              </a:spcAft>
+            </a:pPr>
+            <a:r>
+              <a:rPr sz="1550" b="1" i="0">
+                <a:solidFill>
+                  <a:srgbClr val="C65D37"/>
+                </a:solidFill>
+                <a:latin typeface="Arial"/>
+              </a:rPr>
+              <a:t>Cell junctions</a:t>
+            </a:r>
+          </a:p>
+        </p:txBody>
+      </p:sp>
+      <p:cxnSp>
+        <p:nvCxnSpPr>
+          <p:cNvPr id="88" name="Connector 87"/>
+          <p:cNvCxnSpPr/>
+          <p:nvPr/>
+        </p:nvCxnSpPr>
+        <p:spPr>
+          <a:xfrm>
+            <a:off x="24039576" y="7799831"/>
+            <a:ext cx="3209544" cy="36576"/>
+          </a:xfrm>
+          <a:prstGeom prst="line">
+            <a:avLst/>
+          </a:prstGeom>
+          <a:ln w="15240">
+            <a:solidFill>
+              <a:srgbClr val="6A4C93"/>
             </a:solidFill>
           </a:ln>
         </p:spPr>
@@ -7023,21 +7503,21 @@
       </p:cxnSp>
       <p:cxnSp>
         <p:nvCxnSpPr>
-          <p:cNvPr id="77" name="Connector 76"/>
+          <p:cNvPr id="89" name="Connector 88"/>
           <p:cNvCxnSpPr/>
           <p:nvPr/>
         </p:nvCxnSpPr>
         <p:spPr>
-          <a:xfrm flipV="1">
-            <a:off x="19604735" y="8275320"/>
-            <a:ext cx="301753" cy="347471"/>
+          <a:xfrm>
+            <a:off x="24039576" y="7799831"/>
+            <a:ext cx="3209544" cy="731520"/>
           </a:xfrm>
           <a:prstGeom prst="line">
             <a:avLst/>
           </a:prstGeom>
-          <a:ln w="10160">
+          <a:ln w="15240">
             <a:solidFill>
-              <a:srgbClr val="A9BBD0"/>
+              <a:srgbClr val="6A4C93"/>
             </a:solidFill>
           </a:ln>
         </p:spPr>
@@ -7058,21 +7538,21 @@
       </p:cxnSp>
       <p:cxnSp>
         <p:nvCxnSpPr>
-          <p:cNvPr id="78" name="Connector 77"/>
+          <p:cNvPr id="90" name="Connector 89"/>
           <p:cNvCxnSpPr/>
           <p:nvPr/>
         </p:nvCxnSpPr>
         <p:spPr>
           <a:xfrm flipV="1">
-            <a:off x="19604735" y="8275320"/>
-            <a:ext cx="301753" cy="731519"/>
+            <a:off x="24039576" y="8183879"/>
+            <a:ext cx="3209544" cy="54865"/>
           </a:xfrm>
           <a:prstGeom prst="line">
             <a:avLst/>
           </a:prstGeom>
-          <a:ln w="10160">
+          <a:ln w="15240">
             <a:solidFill>
-              <a:srgbClr val="A9BBD0"/>
+              <a:srgbClr val="A64D67"/>
             </a:solidFill>
           </a:ln>
         </p:spPr>
@@ -7093,531 +7573,21 @@
       </p:cxnSp>
       <p:cxnSp>
         <p:nvCxnSpPr>
-          <p:cNvPr id="79" name="Connector 78"/>
+          <p:cNvPr id="91" name="Connector 90"/>
           <p:cNvCxnSpPr/>
           <p:nvPr/>
         </p:nvCxnSpPr>
         <p:spPr>
-          <a:xfrm flipV="1">
-            <a:off x="21186648" y="7799831"/>
-            <a:ext cx="457200" cy="475489"/>
+          <a:xfrm>
+            <a:off x="24039576" y="8238744"/>
+            <a:ext cx="3209544" cy="640080"/>
           </a:xfrm>
           <a:prstGeom prst="line">
             <a:avLst/>
           </a:prstGeom>
-          <a:ln w="11430">
-            <a:solidFill>
-              <a:srgbClr val="A9BBD0"/>
-            </a:solidFill>
-          </a:ln>
-        </p:spPr>
-        <p:style>
-          <a:lnRef idx="2">
-            <a:schemeClr val="accent1"/>
-          </a:lnRef>
-          <a:fillRef idx="0">
-            <a:schemeClr val="accent1"/>
-          </a:fillRef>
-          <a:effectRef idx="1">
-            <a:schemeClr val="accent1"/>
-          </a:effectRef>
-          <a:fontRef idx="minor">
-            <a:schemeClr val="tx1"/>
-          </a:fontRef>
-        </p:style>
-      </p:cxnSp>
-      <p:sp>
-        <p:nvSpPr>
-          <p:cNvPr id="80" name="Oval 79"/>
-          <p:cNvSpPr/>
-          <p:nvPr/>
-        </p:nvSpPr>
-        <p:spPr>
-          <a:xfrm>
-            <a:off x="21643848" y="7653527"/>
-            <a:ext cx="292608" cy="292608"/>
-          </a:xfrm>
-          <a:prstGeom prst="ellipse">
-            <a:avLst/>
-          </a:prstGeom>
-          <a:solidFill>
-            <a:srgbClr val="6A4C93"/>
-          </a:solidFill>
-          <a:ln>
-            <a:noFill/>
-          </a:ln>
-        </p:spPr>
-        <p:style>
-          <a:lnRef idx="1">
-            <a:schemeClr val="accent1"/>
-          </a:lnRef>
-          <a:fillRef idx="3">
-            <a:schemeClr val="accent1"/>
-          </a:fillRef>
-          <a:effectRef idx="2">
-            <a:schemeClr val="accent1"/>
-          </a:effectRef>
-          <a:fontRef idx="minor">
-            <a:schemeClr val="lt1"/>
-          </a:fontRef>
-        </p:style>
-        <p:txBody>
-          <a:bodyPr rtlCol="0" anchor="ctr"/>
-          <a:lstStyle/>
-          <a:p>
-            <a:pPr algn="ctr"/>
-          </a:p>
-        </p:txBody>
-      </p:sp>
-      <p:sp>
-        <p:nvSpPr>
-          <p:cNvPr id="81" name="Rounded Rectangle 80"/>
-          <p:cNvSpPr/>
-          <p:nvPr/>
-        </p:nvSpPr>
-        <p:spPr>
-          <a:xfrm>
-            <a:off x="22009608" y="7635240"/>
-            <a:ext cx="2029968" cy="329184"/>
-          </a:xfrm>
-          <a:prstGeom prst="roundRect">
-            <a:avLst>
-              <a:gd name="adj" fmla="val 8000"/>
-            </a:avLst>
-          </a:prstGeom>
-          <a:solidFill>
-            <a:srgbClr val="F8FAFC"/>
-          </a:solidFill>
-          <a:ln w="11430">
-            <a:solidFill>
-              <a:srgbClr val="6A4C93"/>
-            </a:solidFill>
-          </a:ln>
-        </p:spPr>
-        <p:style>
-          <a:lnRef idx="1">
-            <a:schemeClr val="accent1"/>
-          </a:lnRef>
-          <a:fillRef idx="3">
-            <a:schemeClr val="accent1"/>
-          </a:fillRef>
-          <a:effectRef idx="2">
-            <a:schemeClr val="accent1"/>
-          </a:effectRef>
-          <a:fontRef idx="minor">
-            <a:schemeClr val="lt1"/>
-          </a:fontRef>
-        </p:style>
-        <p:txBody>
-          <a:bodyPr rtlCol="0" anchor="ctr"/>
-          <a:lstStyle/>
-          <a:p>
-            <a:pPr algn="ctr"/>
-          </a:p>
-        </p:txBody>
-      </p:sp>
-      <p:sp>
-        <p:nvSpPr>
-          <p:cNvPr id="82" name="TextBox 81"/>
-          <p:cNvSpPr txBox="1"/>
-          <p:nvPr/>
-        </p:nvSpPr>
-        <p:spPr>
-          <a:xfrm>
-            <a:off x="22101048" y="7635240"/>
-            <a:ext cx="1847088" cy="329184"/>
-          </a:xfrm>
-          <a:prstGeom prst="rect">
-            <a:avLst/>
-          </a:prstGeom>
-          <a:noFill/>
-        </p:spPr>
-        <p:txBody>
-          <a:bodyPr wrap="none" lIns="0" rIns="0" tIns="0" bIns="0" anchor="ctr">
-            <a:spAutoFit/>
-          </a:bodyPr>
-          <a:lstStyle/>
-          <a:p>
-            <a:pPr algn="ctr" latinLnBrk="0" eaLnBrk="0" hangingPunct="0">
-              <a:lnSpc>
-                <a:spcPct val="100000"/>
-              </a:lnSpc>
-              <a:spcBef>
-                <a:spcPts val="0"/>
-              </a:spcBef>
-              <a:spcAft>
-                <a:spcPts val="0"/>
-              </a:spcAft>
-            </a:pPr>
-            <a:r>
-              <a:rPr sz="1550" b="1" i="0">
-                <a:solidFill>
-                  <a:srgbClr val="6A4C93"/>
-                </a:solidFill>
-                <a:latin typeface="Arial"/>
-              </a:rPr>
-              <a:t>DNA repair</a:t>
-            </a:r>
-          </a:p>
-        </p:txBody>
-      </p:sp>
-      <p:cxnSp>
-        <p:nvCxnSpPr>
-          <p:cNvPr id="83" name="Connector 82"/>
-          <p:cNvCxnSpPr/>
-          <p:nvPr/>
-        </p:nvCxnSpPr>
-        <p:spPr>
-          <a:xfrm flipV="1">
-            <a:off x="21186648" y="8238744"/>
-            <a:ext cx="457200" cy="36576"/>
-          </a:xfrm>
-          <a:prstGeom prst="line">
-            <a:avLst/>
-          </a:prstGeom>
-          <a:ln w="11430">
-            <a:solidFill>
-              <a:srgbClr val="A9BBD0"/>
-            </a:solidFill>
-          </a:ln>
-        </p:spPr>
-        <p:style>
-          <a:lnRef idx="2">
-            <a:schemeClr val="accent1"/>
-          </a:lnRef>
-          <a:fillRef idx="0">
-            <a:schemeClr val="accent1"/>
-          </a:fillRef>
-          <a:effectRef idx="1">
-            <a:schemeClr val="accent1"/>
-          </a:effectRef>
-          <a:fontRef idx="minor">
-            <a:schemeClr val="tx1"/>
-          </a:fontRef>
-        </p:style>
-      </p:cxnSp>
-      <p:sp>
-        <p:nvSpPr>
-          <p:cNvPr id="84" name="Oval 83"/>
-          <p:cNvSpPr/>
-          <p:nvPr/>
-        </p:nvSpPr>
-        <p:spPr>
-          <a:xfrm>
-            <a:off x="21643848" y="8092440"/>
-            <a:ext cx="292608" cy="292608"/>
-          </a:xfrm>
-          <a:prstGeom prst="ellipse">
-            <a:avLst/>
-          </a:prstGeom>
-          <a:solidFill>
-            <a:srgbClr val="A64D67"/>
-          </a:solidFill>
-          <a:ln>
-            <a:noFill/>
-          </a:ln>
-        </p:spPr>
-        <p:style>
-          <a:lnRef idx="1">
-            <a:schemeClr val="accent1"/>
-          </a:lnRef>
-          <a:fillRef idx="3">
-            <a:schemeClr val="accent1"/>
-          </a:fillRef>
-          <a:effectRef idx="2">
-            <a:schemeClr val="accent1"/>
-          </a:effectRef>
-          <a:fontRef idx="minor">
-            <a:schemeClr val="lt1"/>
-          </a:fontRef>
-        </p:style>
-        <p:txBody>
-          <a:bodyPr rtlCol="0" anchor="ctr"/>
-          <a:lstStyle/>
-          <a:p>
-            <a:pPr algn="ctr"/>
-          </a:p>
-        </p:txBody>
-      </p:sp>
-      <p:sp>
-        <p:nvSpPr>
-          <p:cNvPr id="85" name="Rounded Rectangle 84"/>
-          <p:cNvSpPr/>
-          <p:nvPr/>
-        </p:nvSpPr>
-        <p:spPr>
-          <a:xfrm>
-            <a:off x="22009608" y="8074152"/>
-            <a:ext cx="2029968" cy="329184"/>
-          </a:xfrm>
-          <a:prstGeom prst="roundRect">
-            <a:avLst>
-              <a:gd name="adj" fmla="val 8000"/>
-            </a:avLst>
-          </a:prstGeom>
-          <a:solidFill>
-            <a:srgbClr val="F8FAFC"/>
-          </a:solidFill>
-          <a:ln w="11430">
+          <a:ln w="15240">
             <a:solidFill>
               <a:srgbClr val="A64D67"/>
-            </a:solidFill>
-          </a:ln>
-        </p:spPr>
-        <p:style>
-          <a:lnRef idx="1">
-            <a:schemeClr val="accent1"/>
-          </a:lnRef>
-          <a:fillRef idx="3">
-            <a:schemeClr val="accent1"/>
-          </a:fillRef>
-          <a:effectRef idx="2">
-            <a:schemeClr val="accent1"/>
-          </a:effectRef>
-          <a:fontRef idx="minor">
-            <a:schemeClr val="lt1"/>
-          </a:fontRef>
-        </p:style>
-        <p:txBody>
-          <a:bodyPr rtlCol="0" anchor="ctr"/>
-          <a:lstStyle/>
-          <a:p>
-            <a:pPr algn="ctr"/>
-          </a:p>
-        </p:txBody>
-      </p:sp>
-      <p:sp>
-        <p:nvSpPr>
-          <p:cNvPr id="86" name="TextBox 85"/>
-          <p:cNvSpPr txBox="1"/>
-          <p:nvPr/>
-        </p:nvSpPr>
-        <p:spPr>
-          <a:xfrm>
-            <a:off x="22101048" y="8074152"/>
-            <a:ext cx="1847088" cy="329184"/>
-          </a:xfrm>
-          <a:prstGeom prst="rect">
-            <a:avLst/>
-          </a:prstGeom>
-          <a:noFill/>
-        </p:spPr>
-        <p:txBody>
-          <a:bodyPr wrap="none" lIns="0" rIns="0" tIns="0" bIns="0" anchor="ctr">
-            <a:spAutoFit/>
-          </a:bodyPr>
-          <a:lstStyle/>
-          <a:p>
-            <a:pPr algn="ctr" latinLnBrk="0" eaLnBrk="0" hangingPunct="0">
-              <a:lnSpc>
-                <a:spcPct val="100000"/>
-              </a:lnSpc>
-              <a:spcBef>
-                <a:spcPts val="0"/>
-              </a:spcBef>
-              <a:spcAft>
-                <a:spcPts val="0"/>
-              </a:spcAft>
-            </a:pPr>
-            <a:r>
-              <a:rPr sz="1550" b="1" i="0">
-                <a:solidFill>
-                  <a:srgbClr val="A64D67"/>
-                </a:solidFill>
-                <a:latin typeface="Arial"/>
-              </a:rPr>
-              <a:t>T-cell signaling</a:t>
-            </a:r>
-          </a:p>
-        </p:txBody>
-      </p:sp>
-      <p:cxnSp>
-        <p:nvCxnSpPr>
-          <p:cNvPr id="87" name="Connector 86"/>
-          <p:cNvCxnSpPr/>
-          <p:nvPr/>
-        </p:nvCxnSpPr>
-        <p:spPr>
-          <a:xfrm>
-            <a:off x="21186648" y="8275320"/>
-            <a:ext cx="457200" cy="402336"/>
-          </a:xfrm>
-          <a:prstGeom prst="line">
-            <a:avLst/>
-          </a:prstGeom>
-          <a:ln w="11430">
-            <a:solidFill>
-              <a:srgbClr val="A9BBD0"/>
-            </a:solidFill>
-          </a:ln>
-        </p:spPr>
-        <p:style>
-          <a:lnRef idx="2">
-            <a:schemeClr val="accent1"/>
-          </a:lnRef>
-          <a:fillRef idx="0">
-            <a:schemeClr val="accent1"/>
-          </a:fillRef>
-          <a:effectRef idx="1">
-            <a:schemeClr val="accent1"/>
-          </a:effectRef>
-          <a:fontRef idx="minor">
-            <a:schemeClr val="tx1"/>
-          </a:fontRef>
-        </p:style>
-      </p:cxnSp>
-      <p:sp>
-        <p:nvSpPr>
-          <p:cNvPr id="88" name="Oval 87"/>
-          <p:cNvSpPr/>
-          <p:nvPr/>
-        </p:nvSpPr>
-        <p:spPr>
-          <a:xfrm>
-            <a:off x="21643848" y="8531352"/>
-            <a:ext cx="292608" cy="292608"/>
-          </a:xfrm>
-          <a:prstGeom prst="ellipse">
-            <a:avLst/>
-          </a:prstGeom>
-          <a:solidFill>
-            <a:srgbClr val="C65D37"/>
-          </a:solidFill>
-          <a:ln>
-            <a:noFill/>
-          </a:ln>
-        </p:spPr>
-        <p:style>
-          <a:lnRef idx="1">
-            <a:schemeClr val="accent1"/>
-          </a:lnRef>
-          <a:fillRef idx="3">
-            <a:schemeClr val="accent1"/>
-          </a:fillRef>
-          <a:effectRef idx="2">
-            <a:schemeClr val="accent1"/>
-          </a:effectRef>
-          <a:fontRef idx="minor">
-            <a:schemeClr val="lt1"/>
-          </a:fontRef>
-        </p:style>
-        <p:txBody>
-          <a:bodyPr rtlCol="0" anchor="ctr"/>
-          <a:lstStyle/>
-          <a:p>
-            <a:pPr algn="ctr"/>
-          </a:p>
-        </p:txBody>
-      </p:sp>
-      <p:sp>
-        <p:nvSpPr>
-          <p:cNvPr id="89" name="Rounded Rectangle 88"/>
-          <p:cNvSpPr/>
-          <p:nvPr/>
-        </p:nvSpPr>
-        <p:spPr>
-          <a:xfrm>
-            <a:off x="22009608" y="8513064"/>
-            <a:ext cx="2029968" cy="329184"/>
-          </a:xfrm>
-          <a:prstGeom prst="roundRect">
-            <a:avLst>
-              <a:gd name="adj" fmla="val 8000"/>
-            </a:avLst>
-          </a:prstGeom>
-          <a:solidFill>
-            <a:srgbClr val="F8FAFC"/>
-          </a:solidFill>
-          <a:ln w="11430">
-            <a:solidFill>
-              <a:srgbClr val="C65D37"/>
-            </a:solidFill>
-          </a:ln>
-        </p:spPr>
-        <p:style>
-          <a:lnRef idx="1">
-            <a:schemeClr val="accent1"/>
-          </a:lnRef>
-          <a:fillRef idx="3">
-            <a:schemeClr val="accent1"/>
-          </a:fillRef>
-          <a:effectRef idx="2">
-            <a:schemeClr val="accent1"/>
-          </a:effectRef>
-          <a:fontRef idx="minor">
-            <a:schemeClr val="lt1"/>
-          </a:fontRef>
-        </p:style>
-        <p:txBody>
-          <a:bodyPr rtlCol="0" anchor="ctr"/>
-          <a:lstStyle/>
-          <a:p>
-            <a:pPr algn="ctr"/>
-          </a:p>
-        </p:txBody>
-      </p:sp>
-      <p:sp>
-        <p:nvSpPr>
-          <p:cNvPr id="90" name="TextBox 89"/>
-          <p:cNvSpPr txBox="1"/>
-          <p:nvPr/>
-        </p:nvSpPr>
-        <p:spPr>
-          <a:xfrm>
-            <a:off x="22101048" y="8513064"/>
-            <a:ext cx="1847088" cy="329184"/>
-          </a:xfrm>
-          <a:prstGeom prst="rect">
-            <a:avLst/>
-          </a:prstGeom>
-          <a:noFill/>
-        </p:spPr>
-        <p:txBody>
-          <a:bodyPr wrap="none" lIns="0" rIns="0" tIns="0" bIns="0" anchor="ctr">
-            <a:spAutoFit/>
-          </a:bodyPr>
-          <a:lstStyle/>
-          <a:p>
-            <a:pPr algn="ctr" latinLnBrk="0" eaLnBrk="0" hangingPunct="0">
-              <a:lnSpc>
-                <a:spcPct val="100000"/>
-              </a:lnSpc>
-              <a:spcBef>
-                <a:spcPts val="0"/>
-              </a:spcBef>
-              <a:spcAft>
-                <a:spcPts val="0"/>
-              </a:spcAft>
-            </a:pPr>
-            <a:r>
-              <a:rPr sz="1550" b="1" i="0">
-                <a:solidFill>
-                  <a:srgbClr val="C65D37"/>
-                </a:solidFill>
-                <a:latin typeface="Arial"/>
-              </a:rPr>
-              <a:t>Cell junctions</a:t>
-            </a:r>
-          </a:p>
-        </p:txBody>
-      </p:sp>
-      <p:cxnSp>
-        <p:nvCxnSpPr>
-          <p:cNvPr id="91" name="Connector 90"/>
-          <p:cNvCxnSpPr/>
-          <p:nvPr/>
-        </p:nvCxnSpPr>
-        <p:spPr>
-          <a:xfrm>
-            <a:off x="24039576" y="7799831"/>
-            <a:ext cx="3209544" cy="36576"/>
-          </a:xfrm>
-          <a:prstGeom prst="line">
-            <a:avLst/>
-          </a:prstGeom>
-          <a:ln w="15240">
-            <a:solidFill>
-              <a:srgbClr val="6A4C93"/>
             </a:solidFill>
           </a:ln>
         </p:spPr>
@@ -7643,16 +7613,16 @@
           <p:nvPr/>
         </p:nvCxnSpPr>
         <p:spPr>
-          <a:xfrm>
-            <a:off x="24039576" y="7799831"/>
-            <a:ext cx="3209544" cy="731520"/>
+          <a:xfrm flipV="1">
+            <a:off x="24039576" y="8531351"/>
+            <a:ext cx="3209544" cy="146305"/>
           </a:xfrm>
           <a:prstGeom prst="line">
             <a:avLst/>
           </a:prstGeom>
           <a:ln w="15240">
             <a:solidFill>
-              <a:srgbClr val="6A4C93"/>
+              <a:srgbClr val="C65D37"/>
             </a:solidFill>
           </a:ln>
         </p:spPr>
@@ -7678,16 +7648,16 @@
           <p:nvPr/>
         </p:nvCxnSpPr>
         <p:spPr>
-          <a:xfrm flipV="1">
-            <a:off x="24039576" y="8183879"/>
-            <a:ext cx="3209544" cy="54865"/>
+          <a:xfrm>
+            <a:off x="24039576" y="8677656"/>
+            <a:ext cx="3209544" cy="201168"/>
           </a:xfrm>
           <a:prstGeom prst="line">
             <a:avLst/>
           </a:prstGeom>
           <a:ln w="15240">
             <a:solidFill>
-              <a:srgbClr val="A64D67"/>
+              <a:srgbClr val="C65D37"/>
             </a:solidFill>
           </a:ln>
         </p:spPr>
@@ -7706,114 +7676,9 @@
           </a:fontRef>
         </p:style>
       </p:cxnSp>
-      <p:cxnSp>
-        <p:nvCxnSpPr>
-          <p:cNvPr id="94" name="Connector 93"/>
-          <p:cNvCxnSpPr/>
-          <p:nvPr/>
-        </p:nvCxnSpPr>
-        <p:spPr>
-          <a:xfrm>
-            <a:off x="24039576" y="8238744"/>
-            <a:ext cx="3209544" cy="640080"/>
-          </a:xfrm>
-          <a:prstGeom prst="line">
-            <a:avLst/>
-          </a:prstGeom>
-          <a:ln w="15240">
-            <a:solidFill>
-              <a:srgbClr val="A64D67"/>
-            </a:solidFill>
-          </a:ln>
-        </p:spPr>
-        <p:style>
-          <a:lnRef idx="2">
-            <a:schemeClr val="accent1"/>
-          </a:lnRef>
-          <a:fillRef idx="0">
-            <a:schemeClr val="accent1"/>
-          </a:fillRef>
-          <a:effectRef idx="1">
-            <a:schemeClr val="accent1"/>
-          </a:effectRef>
-          <a:fontRef idx="minor">
-            <a:schemeClr val="tx1"/>
-          </a:fontRef>
-        </p:style>
-      </p:cxnSp>
-      <p:cxnSp>
-        <p:nvCxnSpPr>
-          <p:cNvPr id="95" name="Connector 94"/>
-          <p:cNvCxnSpPr/>
-          <p:nvPr/>
-        </p:nvCxnSpPr>
-        <p:spPr>
-          <a:xfrm flipV="1">
-            <a:off x="24039576" y="8531351"/>
-            <a:ext cx="3209544" cy="146305"/>
-          </a:xfrm>
-          <a:prstGeom prst="line">
-            <a:avLst/>
-          </a:prstGeom>
-          <a:ln w="15240">
-            <a:solidFill>
-              <a:srgbClr val="C65D37"/>
-            </a:solidFill>
-          </a:ln>
-        </p:spPr>
-        <p:style>
-          <a:lnRef idx="2">
-            <a:schemeClr val="accent1"/>
-          </a:lnRef>
-          <a:fillRef idx="0">
-            <a:schemeClr val="accent1"/>
-          </a:fillRef>
-          <a:effectRef idx="1">
-            <a:schemeClr val="accent1"/>
-          </a:effectRef>
-          <a:fontRef idx="minor">
-            <a:schemeClr val="tx1"/>
-          </a:fontRef>
-        </p:style>
-      </p:cxnSp>
-      <p:cxnSp>
-        <p:nvCxnSpPr>
-          <p:cNvPr id="96" name="Connector 95"/>
-          <p:cNvCxnSpPr/>
-          <p:nvPr/>
-        </p:nvCxnSpPr>
-        <p:spPr>
-          <a:xfrm>
-            <a:off x="24039576" y="8677656"/>
-            <a:ext cx="3209544" cy="201168"/>
-          </a:xfrm>
-          <a:prstGeom prst="line">
-            <a:avLst/>
-          </a:prstGeom>
-          <a:ln w="15240">
-            <a:solidFill>
-              <a:srgbClr val="C65D37"/>
-            </a:solidFill>
-          </a:ln>
-        </p:spPr>
-        <p:style>
-          <a:lnRef idx="2">
-            <a:schemeClr val="accent1"/>
-          </a:lnRef>
-          <a:fillRef idx="0">
-            <a:schemeClr val="accent1"/>
-          </a:fillRef>
-          <a:effectRef idx="1">
-            <a:schemeClr val="accent1"/>
-          </a:effectRef>
-          <a:fontRef idx="minor">
-            <a:schemeClr val="tx1"/>
-          </a:fontRef>
-        </p:style>
-      </p:cxnSp>
-      <p:sp>
-        <p:nvSpPr>
-          <p:cNvPr id="97" name="Trapezoid 96"/>
+      <p:sp>
+        <p:nvSpPr>
+          <p:cNvPr id="94" name="Trapezoid 93"/>
           <p:cNvSpPr/>
           <p:nvPr/>
         </p:nvSpPr>
@@ -7856,7 +7721,7 @@
       </p:sp>
       <p:sp>
         <p:nvSpPr>
-          <p:cNvPr id="98" name="Rectangle 97"/>
+          <p:cNvPr id="95" name="Rectangle 94"/>
           <p:cNvSpPr/>
           <p:nvPr/>
         </p:nvSpPr>
@@ -7899,7 +7764,7 @@
       </p:sp>
       <p:sp>
         <p:nvSpPr>
-          <p:cNvPr id="99" name="TextBox 98"/>
+          <p:cNvPr id="96" name="TextBox 95"/>
           <p:cNvSpPr txBox="1"/>
           <p:nvPr/>
         </p:nvSpPr>
@@ -7944,7 +7809,7 @@
       </p:sp>
       <p:sp>
         <p:nvSpPr>
-          <p:cNvPr id="100" name="Oval 99"/>
+          <p:cNvPr id="97" name="Oval 96"/>
           <p:cNvSpPr/>
           <p:nvPr/>
         </p:nvSpPr>
@@ -7987,7 +7852,7 @@
       </p:sp>
       <p:sp>
         <p:nvSpPr>
-          <p:cNvPr id="101" name="Oval 100"/>
+          <p:cNvPr id="98" name="Oval 97"/>
           <p:cNvSpPr/>
           <p:nvPr/>
         </p:nvSpPr>
@@ -8030,7 +7895,7 @@
       </p:sp>
       <p:sp>
         <p:nvSpPr>
-          <p:cNvPr id="102" name="Oval 101"/>
+          <p:cNvPr id="99" name="Oval 98"/>
           <p:cNvSpPr/>
           <p:nvPr/>
         </p:nvSpPr>
@@ -8073,7 +7938,7 @@
       </p:sp>
       <p:sp>
         <p:nvSpPr>
-          <p:cNvPr id="103" name="Oval 102"/>
+          <p:cNvPr id="100" name="Oval 99"/>
           <p:cNvSpPr/>
           <p:nvPr/>
         </p:nvSpPr>
@@ -8116,7 +7981,7 @@
       </p:sp>
       <p:sp>
         <p:nvSpPr>
-          <p:cNvPr id="104" name="Rounded Rectangle 103"/>
+          <p:cNvPr id="101" name="Rounded Rectangle 100"/>
           <p:cNvSpPr/>
           <p:nvPr/>
         </p:nvSpPr>
@@ -8161,7 +8026,7 @@
       </p:sp>
       <p:sp>
         <p:nvSpPr>
-          <p:cNvPr id="105" name="TextBox 104"/>
+          <p:cNvPr id="102" name="TextBox 101"/>
           <p:cNvSpPr txBox="1"/>
           <p:nvPr/>
         </p:nvSpPr>
@@ -8206,7 +8071,7 @@
       </p:sp>
       <p:sp>
         <p:nvSpPr>
-          <p:cNvPr id="106" name="Down Arrow 105"/>
+          <p:cNvPr id="103" name="Down Arrow 102"/>
           <p:cNvSpPr/>
           <p:nvPr/>
         </p:nvSpPr>
@@ -8249,7 +8114,7 @@
       </p:sp>
       <p:sp>
         <p:nvSpPr>
-          <p:cNvPr id="107" name="TextBox 106"/>
+          <p:cNvPr id="104" name="TextBox 103"/>
           <p:cNvSpPr txBox="1"/>
           <p:nvPr/>
         </p:nvSpPr>
@@ -8294,7 +8159,7 @@
       </p:sp>
       <p:sp>
         <p:nvSpPr>
-          <p:cNvPr id="108" name="TextBox 107"/>
+          <p:cNvPr id="105" name="TextBox 104"/>
           <p:cNvSpPr txBox="1"/>
           <p:nvPr/>
         </p:nvSpPr>
@@ -8339,7 +8204,7 @@
       </p:sp>
       <p:sp>
         <p:nvSpPr>
-          <p:cNvPr id="109" name="TextBox 108"/>
+          <p:cNvPr id="106" name="TextBox 105"/>
           <p:cNvSpPr txBox="1"/>
           <p:nvPr/>
         </p:nvSpPr>
@@ -8384,7 +8249,7 @@
       </p:sp>
       <p:sp>
         <p:nvSpPr>
-          <p:cNvPr id="110" name="TextBox 109"/>
+          <p:cNvPr id="107" name="TextBox 106"/>
           <p:cNvSpPr txBox="1"/>
           <p:nvPr/>
         </p:nvSpPr>
@@ -8429,7 +8294,7 @@
       </p:sp>
       <p:sp>
         <p:nvSpPr>
-          <p:cNvPr id="111" name="TextBox 110"/>
+          <p:cNvPr id="108" name="TextBox 107"/>
           <p:cNvSpPr txBox="1"/>
           <p:nvPr/>
         </p:nvSpPr>
@@ -8474,7 +8339,7 @@
       </p:sp>
       <p:sp>
         <p:nvSpPr>
-          <p:cNvPr id="112" name="Rounded Rectangle 111"/>
+          <p:cNvPr id="109" name="Rounded Rectangle 108"/>
           <p:cNvSpPr/>
           <p:nvPr/>
         </p:nvSpPr>
@@ -8553,7 +8418,7 @@
       </p:sp>
       <p:sp>
         <p:nvSpPr>
-          <p:cNvPr id="113" name="Right Arrow 112"/>
+          <p:cNvPr id="110" name="Right Arrow 109"/>
           <p:cNvSpPr/>
           <p:nvPr/>
         </p:nvSpPr>
@@ -8596,7 +8461,7 @@
       </p:sp>
       <p:sp>
         <p:nvSpPr>
-          <p:cNvPr id="114" name="Rounded Rectangle 113"/>
+          <p:cNvPr id="111" name="Rounded Rectangle 110"/>
           <p:cNvSpPr/>
           <p:nvPr/>
         </p:nvSpPr>
@@ -8675,7 +8540,7 @@
       </p:sp>
       <p:sp>
         <p:nvSpPr>
-          <p:cNvPr id="115" name="Right Arrow 114"/>
+          <p:cNvPr id="112" name="Right Arrow 111"/>
           <p:cNvSpPr/>
           <p:nvPr/>
         </p:nvSpPr>
@@ -8718,7 +8583,7 @@
       </p:sp>
       <p:sp>
         <p:nvSpPr>
-          <p:cNvPr id="116" name="Rounded Rectangle 115"/>
+          <p:cNvPr id="113" name="Rounded Rectangle 112"/>
           <p:cNvSpPr/>
           <p:nvPr/>
         </p:nvSpPr>
@@ -8797,7 +8662,7 @@
       </p:sp>
       <p:sp>
         <p:nvSpPr>
-          <p:cNvPr id="117" name="Right Arrow 116"/>
+          <p:cNvPr id="114" name="Right Arrow 113"/>
           <p:cNvSpPr/>
           <p:nvPr/>
         </p:nvSpPr>
@@ -8840,7 +8705,7 @@
       </p:sp>
       <p:sp>
         <p:nvSpPr>
-          <p:cNvPr id="118" name="Rounded Rectangle 117"/>
+          <p:cNvPr id="115" name="Rounded Rectangle 114"/>
           <p:cNvSpPr/>
           <p:nvPr/>
         </p:nvSpPr>
@@ -8919,7 +8784,7 @@
       </p:sp>
       <p:sp>
         <p:nvSpPr>
-          <p:cNvPr id="119" name="Down Arrow 118"/>
+          <p:cNvPr id="116" name="Down Arrow 115"/>
           <p:cNvSpPr/>
           <p:nvPr/>
         </p:nvSpPr>
@@ -8962,7 +8827,7 @@
       </p:sp>
       <p:sp>
         <p:nvSpPr>
-          <p:cNvPr id="120" name="Rounded Rectangle 119"/>
+          <p:cNvPr id="117" name="Rounded Rectangle 116"/>
           <p:cNvSpPr/>
           <p:nvPr/>
         </p:nvSpPr>
@@ -9041,7 +8906,7 @@
       </p:sp>
       <p:sp>
         <p:nvSpPr>
-          <p:cNvPr id="121" name="TextBox 120"/>
+          <p:cNvPr id="118" name="TextBox 117"/>
           <p:cNvSpPr txBox="1"/>
           <p:nvPr/>
         </p:nvSpPr>
@@ -9086,7 +8951,7 @@
       </p:sp>
       <p:sp>
         <p:nvSpPr>
-          <p:cNvPr id="122" name="Rectangle 121"/>
+          <p:cNvPr id="119" name="Rectangle 118"/>
           <p:cNvSpPr/>
           <p:nvPr/>
         </p:nvSpPr>
@@ -9129,7 +8994,7 @@
       </p:sp>
       <p:sp>
         <p:nvSpPr>
-          <p:cNvPr id="123" name="Rectangle 122"/>
+          <p:cNvPr id="120" name="Rectangle 119"/>
           <p:cNvSpPr/>
           <p:nvPr/>
         </p:nvSpPr>
@@ -9174,7 +9039,7 @@
       </p:sp>
       <p:sp>
         <p:nvSpPr>
-          <p:cNvPr id="124" name="TextBox 123"/>
+          <p:cNvPr id="121" name="TextBox 120"/>
           <p:cNvSpPr txBox="1"/>
           <p:nvPr/>
         </p:nvSpPr>
@@ -9219,7 +9084,7 @@
       </p:sp>
       <p:pic>
         <p:nvPicPr>
-          <p:cNvPr id="125" name="Retained pathway shifts" descr="Literature-aligned anchors and retained expiMap pathway shifts for thymus, skin, liver, and spleen, with project effects and three-training ranges."/>
+          <p:cNvPr id="122" name="Retained pathway shifts" descr="Literature-aligned anchors and retained expiMap pathway shifts for thymus, skin, liver, and spleen, with project effects and three-training ranges."/>
           <p:cNvPicPr>
             <a:picLocks noChangeAspect="1"/>
           </p:cNvPicPr>
@@ -9243,14 +9108,14 @@
       </p:pic>
       <p:sp>
         <p:nvSpPr>
-          <p:cNvPr id="126" name="TextBox 125"/>
+          <p:cNvPr id="123" name="TextBox 122"/>
           <p:cNvSpPr txBox="1"/>
           <p:nvPr/>
         </p:nvSpPr>
         <p:spPr>
           <a:xfrm>
             <a:off x="15041880" y="21598128"/>
-            <a:ext cx="13304520" cy="237744"/>
+            <a:ext cx="13304520" cy="256032"/>
           </a:xfrm>
           <a:prstGeom prst="rect">
             <a:avLst/>
@@ -9281,21 +9146,21 @@
                 </a:solidFill>
                 <a:latin typeface="Arial"/>
               </a:rPr>
-              <a:t>Filled markers show 13 retained programs. Open diamonds are literature-aligned context only,</a:t>
-            </a:r>
-          </a:p>
-        </p:txBody>
-      </p:sp>
-      <p:sp>
-        <p:nvSpPr>
-          <p:cNvPr id="127" name="TextBox 126"/>
+              <a:t>Filled markers show 13 retained programs. Open diamonds are literature-aligned context only, not retained findings;</a:t>
+            </a:r>
+          </a:p>
+        </p:txBody>
+      </p:sp>
+      <p:sp>
+        <p:nvSpPr>
+          <p:cNvPr id="124" name="TextBox 123"/>
           <p:cNvSpPr txBox="1"/>
           <p:nvPr/>
         </p:nvSpPr>
         <p:spPr>
           <a:xfrm>
-            <a:off x="15041880" y="21835872"/>
-            <a:ext cx="13304520" cy="237744"/>
+            <a:off x="15041880" y="21854160"/>
+            <a:ext cx="13304520" cy="256032"/>
           </a:xfrm>
           <a:prstGeom prst="rect">
             <a:avLst/>
@@ -9326,59 +9191,14 @@
                 </a:solidFill>
                 <a:latin typeface="Arial"/>
               </a:rPr>
-              <a:t>not retained findings; keratinization reversed in one of three trainings.</a:t>
-            </a:r>
-          </a:p>
-        </p:txBody>
-      </p:sp>
-      <p:sp>
-        <p:nvSpPr>
-          <p:cNvPr id="128" name="TextBox 127"/>
-          <p:cNvSpPr txBox="1"/>
-          <p:nvPr/>
-        </p:nvSpPr>
-        <p:spPr>
-          <a:xfrm>
-            <a:off x="15041880" y="22073616"/>
-            <a:ext cx="13304520" cy="237744"/>
-          </a:xfrm>
-          <a:prstGeom prst="rect">
-            <a:avLst/>
-          </a:prstGeom>
-          <a:noFill/>
-        </p:spPr>
-        <p:txBody>
-          <a:bodyPr wrap="none" lIns="0" rIns="0" tIns="0" bIns="0" anchor="ctr">
-            <a:noAutofit/>
-          </a:bodyPr>
-          <a:lstStyle/>
-          <a:p>
-            <a:pPr algn="ctr" latinLnBrk="0" eaLnBrk="0" hangingPunct="0">
-              <a:lnSpc>
-                <a:spcPct val="100000"/>
-              </a:lnSpc>
-              <a:spcBef>
-                <a:spcPts val="0"/>
-              </a:spcBef>
-              <a:spcAft>
-                <a:spcPts val="0"/>
-              </a:spcAft>
-            </a:pPr>
-            <a:r>
-              <a:rPr sz="1450" b="0" i="1">
-                <a:solidFill>
-                  <a:srgbClr val="697889"/>
-                </a:solidFill>
-                <a:latin typeface="Arial"/>
-              </a:rPr>
-              <a:t>Colored ranges span three complete trainings; axes are tissue specific.</a:t>
-            </a:r>
-          </a:p>
-        </p:txBody>
-      </p:sp>
-      <p:sp>
-        <p:nvSpPr>
-          <p:cNvPr id="129" name="Rectangle 128"/>
+              <a:t>keratinization reversed in one of three trainings. Colored ranges span three complete trainings; axes are tissue specific.</a:t>
+            </a:r>
+          </a:p>
+        </p:txBody>
+      </p:sp>
+      <p:sp>
+        <p:nvSpPr>
+          <p:cNvPr id="125" name="Rectangle 124"/>
           <p:cNvSpPr/>
           <p:nvPr/>
         </p:nvSpPr>
@@ -9421,7 +9241,7 @@
       </p:sp>
       <p:sp>
         <p:nvSpPr>
-          <p:cNvPr id="130" name="Rectangle 129"/>
+          <p:cNvPr id="126" name="Rectangle 125"/>
           <p:cNvSpPr/>
           <p:nvPr/>
         </p:nvSpPr>
@@ -9466,7 +9286,7 @@
       </p:sp>
       <p:sp>
         <p:nvSpPr>
-          <p:cNvPr id="131" name="TextBox 130"/>
+          <p:cNvPr id="127" name="TextBox 126"/>
           <p:cNvSpPr txBox="1"/>
           <p:nvPr/>
         </p:nvSpPr>
@@ -9511,7 +9331,7 @@
       </p:sp>
       <p:sp>
         <p:nvSpPr>
-          <p:cNvPr id="132" name="TextBox 131"/>
+          <p:cNvPr id="128" name="TextBox 127"/>
           <p:cNvSpPr txBox="1"/>
           <p:nvPr/>
         </p:nvSpPr>
@@ -9556,7 +9376,7 @@
       </p:sp>
       <p:pic>
         <p:nvPicPr>
-          <p:cNvPr id="133" name="Tissue-state hypotheses" descr="Prior-literature phenotypes, observed lower expiMap program scores, and complementary hypotheses for thymus, skin, liver, and spleen."/>
+          <p:cNvPr id="129" name="Tissue-state hypotheses" descr="Prior-literature phenotypes, observed lower expiMap program scores, and complementary hypotheses for thymus, skin, liver, and spleen."/>
           <p:cNvPicPr>
             <a:picLocks noChangeAspect="1"/>
           </p:cNvPicPr>
@@ -9580,7 +9400,7 @@
       </p:pic>
       <p:sp>
         <p:nvSpPr>
-          <p:cNvPr id="134" name="Rectangle 133"/>
+          <p:cNvPr id="130" name="Rectangle 129"/>
           <p:cNvSpPr/>
           <p:nvPr/>
         </p:nvSpPr>
@@ -9623,7 +9443,7 @@
       </p:sp>
       <p:sp>
         <p:nvSpPr>
-          <p:cNvPr id="135" name="Rectangle 134"/>
+          <p:cNvPr id="131" name="Rectangle 130"/>
           <p:cNvSpPr/>
           <p:nvPr/>
         </p:nvSpPr>
@@ -9668,7 +9488,7 @@
       </p:sp>
       <p:sp>
         <p:nvSpPr>
-          <p:cNvPr id="136" name="TextBox 135"/>
+          <p:cNvPr id="132" name="TextBox 131"/>
           <p:cNvSpPr txBox="1"/>
           <p:nvPr/>
         </p:nvSpPr>
@@ -9713,7 +9533,7 @@
       </p:sp>
       <p:sp>
         <p:nvSpPr>
-          <p:cNvPr id="137" name="TextBox 136"/>
+          <p:cNvPr id="133" name="TextBox 132"/>
           <p:cNvSpPr txBox="1"/>
           <p:nvPr/>
         </p:nvSpPr>
@@ -9758,7 +9578,7 @@
       </p:sp>
       <p:sp>
         <p:nvSpPr>
-          <p:cNvPr id="138" name="TextBox 137"/>
+          <p:cNvPr id="134" name="TextBox 133"/>
           <p:cNvSpPr txBox="1"/>
           <p:nvPr/>
         </p:nvSpPr>
@@ -9803,7 +9623,7 @@
       </p:sp>
       <p:sp>
         <p:nvSpPr>
-          <p:cNvPr id="139" name="TextBox 138"/>
+          <p:cNvPr id="135" name="TextBox 134"/>
           <p:cNvSpPr txBox="1"/>
           <p:nvPr/>
         </p:nvSpPr>
@@ -9848,7 +9668,7 @@
       </p:sp>
       <p:sp>
         <p:nvSpPr>
-          <p:cNvPr id="140" name="TextBox 139"/>
+          <p:cNvPr id="136" name="TextBox 135"/>
           <p:cNvSpPr txBox="1"/>
           <p:nvPr/>
         </p:nvSpPr>
@@ -9893,7 +9713,7 @@
       </p:sp>
       <p:sp>
         <p:nvSpPr>
-          <p:cNvPr id="141" name="TextBox 140"/>
+          <p:cNvPr id="137" name="TextBox 136"/>
           <p:cNvSpPr txBox="1"/>
           <p:nvPr/>
         </p:nvSpPr>
@@ -9938,7 +9758,7 @@
       </p:sp>
       <p:sp>
         <p:nvSpPr>
-          <p:cNvPr id="142" name="TextBox 141"/>
+          <p:cNvPr id="138" name="TextBox 137"/>
           <p:cNvSpPr txBox="1"/>
           <p:nvPr/>
         </p:nvSpPr>
@@ -9983,7 +9803,7 @@
       </p:sp>
       <p:sp>
         <p:nvSpPr>
-          <p:cNvPr id="143" name="Rectangle 142"/>
+          <p:cNvPr id="139" name="Rectangle 138"/>
           <p:cNvSpPr/>
           <p:nvPr/>
         </p:nvSpPr>
@@ -10026,7 +9846,7 @@
       </p:sp>
       <p:sp>
         <p:nvSpPr>
-          <p:cNvPr id="144" name="Rectangle 143"/>
+          <p:cNvPr id="140" name="Rectangle 139"/>
           <p:cNvSpPr/>
           <p:nvPr/>
         </p:nvSpPr>
@@ -10071,7 +9891,7 @@
       </p:sp>
       <p:sp>
         <p:nvSpPr>
-          <p:cNvPr id="145" name="TextBox 144"/>
+          <p:cNvPr id="141" name="TextBox 140"/>
           <p:cNvSpPr txBox="1"/>
           <p:nvPr/>
         </p:nvSpPr>
@@ -10116,7 +9936,7 @@
       </p:sp>
       <p:sp>
         <p:nvSpPr>
-          <p:cNvPr id="146" name="TextBox 145"/>
+          <p:cNvPr id="142" name="TextBox 141"/>
           <p:cNvSpPr txBox="1"/>
           <p:nvPr/>
         </p:nvSpPr>
@@ -10161,7 +9981,7 @@
       </p:sp>
       <p:sp>
         <p:nvSpPr>
-          <p:cNvPr id="147" name="TextBox 146"/>
+          <p:cNvPr id="143" name="TextBox 142"/>
           <p:cNvSpPr txBox="1"/>
           <p:nvPr/>
         </p:nvSpPr>
@@ -10206,7 +10026,7 @@
       </p:sp>
       <p:sp>
         <p:nvSpPr>
-          <p:cNvPr id="148" name="TextBox 147"/>
+          <p:cNvPr id="144" name="TextBox 143"/>
           <p:cNvSpPr txBox="1"/>
           <p:nvPr/>
         </p:nvSpPr>
@@ -10251,7 +10071,7 @@
       </p:sp>
       <p:sp>
         <p:nvSpPr>
-          <p:cNvPr id="149" name="TextBox 148"/>
+          <p:cNvPr id="145" name="TextBox 144"/>
           <p:cNvSpPr txBox="1"/>
           <p:nvPr/>
         </p:nvSpPr>
@@ -10296,7 +10116,7 @@
       </p:sp>
       <p:sp>
         <p:nvSpPr>
-          <p:cNvPr id="150" name="Rectangle 149"/>
+          <p:cNvPr id="146" name="Rectangle 145"/>
           <p:cNvSpPr/>
           <p:nvPr/>
         </p:nvSpPr>
@@ -10339,7 +10159,7 @@
       </p:sp>
       <p:sp>
         <p:nvSpPr>
-          <p:cNvPr id="151" name="TextBox 150"/>
+          <p:cNvPr id="147" name="TextBox 146"/>
           <p:cNvSpPr txBox="1"/>
           <p:nvPr/>
         </p:nvSpPr>
@@ -10384,7 +10204,7 @@
       </p:sp>
       <p:sp>
         <p:nvSpPr>
-          <p:cNvPr id="152" name="TextBox 151"/>
+          <p:cNvPr id="148" name="TextBox 147"/>
           <p:cNvSpPr txBox="1"/>
           <p:nvPr/>
         </p:nvSpPr>
@@ -10429,7 +10249,7 @@
       </p:sp>
       <p:sp>
         <p:nvSpPr>
-          <p:cNvPr id="153" name="TextBox 152"/>
+          <p:cNvPr id="149" name="TextBox 148"/>
           <p:cNvSpPr txBox="1"/>
           <p:nvPr/>
         </p:nvSpPr>
@@ -10474,7 +10294,7 @@
       </p:sp>
       <p:sp>
         <p:nvSpPr>
-          <p:cNvPr id="154" name="TextBox 153"/>
+          <p:cNvPr id="150" name="TextBox 149"/>
           <p:cNvSpPr txBox="1"/>
           <p:nvPr/>
         </p:nvSpPr>
@@ -10520,7 +10340,7 @@
       </p:sp>
       <p:sp>
         <p:nvSpPr>
-          <p:cNvPr id="155" name="TextBox 154"/>
+          <p:cNvPr id="151" name="TextBox 150"/>
           <p:cNvSpPr txBox="1"/>
           <p:nvPr/>
         </p:nvSpPr>

</xml_diff>

<commit_message>
use title case for ASGSR deliverables
</commit_message>
<xml_diff>
--- a/paper/asgsr_expimap_hvg/poster/asgsr_expimap_poster.pptx
+++ b/paper/asgsr_expimap_hvg/poster/asgsr_expimap_poster.pptx
@@ -3224,7 +3224,7 @@
                 </a:solidFill>
                 <a:latin typeface="Arial"/>
               </a:rPr>
-              <a:t>Cross-mission expiMap analysis recovers established tissue responses</a:t>
+              <a:t>Cross-Mission expiMap Analysis Recovers Established Tissue Responses</a:t>
             </a:r>
           </a:p>
         </p:txBody>
@@ -3269,7 +3269,7 @@
                 </a:solidFill>
                 <a:latin typeface="Arial"/>
               </a:rPr>
-              <a:t>and identifies complementary pathway shifts in mouse spaceflight transcriptomes</a:t>
+              <a:t>and Identifies Complementary Pathway Shifts in Mouse Spaceflight Transcriptomes</a:t>
             </a:r>
           </a:p>
         </p:txBody>

</xml_diff>